<commit_message>
data: update 2026-09-15 ( data.json despidos.json scraper/historical_despidos.json publicaciones_semana.pptx rrii_brutas.xlsx)
</commit_message>
<xml_diff>
--- a/publicaciones_semana.pptx
+++ b/publicaciones_semana.pptx
@@ -7,8 +7,6 @@
   <p:sldIdLst>
     <p:sldId id="256" r:id="rId7"/>
     <p:sldId id="257" r:id="rId8"/>
-    <p:sldId id="258" r:id="rId9"/>
-    <p:sldId id="259" r:id="rId10"/>
   </p:sldIdLst>
   <p:sldSz cx="12191695" cy="6858000" type="screen4x3"/>
   <p:notesSz cx="6858000" cy="9144000"/>
@@ -3240,7 +3238,7 @@
                 </a:solidFill>
                 <a:latin typeface="Encode Sans"/>
               </a:rPr>
-              <a:t>Publicaciones de la semana del 07 de septiembre de 2026</a:t>
+              <a:t>Publicaciones de la semana del 14 de septiembre de 2026</a:t>
             </a:r>
           </a:p>
         </p:txBody>
@@ -3274,7 +3272,7 @@
                 </a:solidFill>
                 <a:latin typeface="Encode Sans"/>
               </a:rPr>
-              <a:t>3 publicaciones · datos oficiales INDEC / BCRA / Hacienda</a:t>
+              <a:t>1 publicaciones · datos oficiales INDEC / BCRA / Hacienda</a:t>
             </a:r>
           </a:p>
         </p:txBody>
@@ -3370,7 +3368,7 @@
                 </a:solidFill>
                 <a:latin typeface="Encode Sans"/>
               </a:rPr>
-              <a:t>INDUSTRIA JULIO 2026: IPI CAYÓ -4.9% I.A.</a:t>
+              <a:t>INDUSTRIA JULIO 2026: IPI CRECIÓ +0.0% I.A.</a:t>
             </a:r>
           </a:p>
         </p:txBody>
@@ -3439,7 +3437,7 @@
                 </a:solidFill>
                 <a:latin typeface="Encode Sans"/>
               </a:rPr>
-              <a:t>El Índice de Producción Industrial Manufacturero (IPI) registró una variación interanual de -4.9% en julio 2026.</a:t>
+              <a:t>El Índice de Producción Industrial Manufacturero (IPI) registró una variación interanual de +0.0% en julio 2026.</a:t>
             </a:r>
           </a:p>
         </p:txBody>
@@ -3487,7 +3485,7 @@
                 </a:solidFill>
                 <a:latin typeface="Encode Sans"/>
               </a:rPr>
-              <a:t>Variación interanual: -4.9%</a:t>
+              <a:t>Variación interanual: +0.0%</a:t>
             </a:r>
           </a:p>
           <a:p>
@@ -4107,1671 +4105,6 @@
 </p:sld>
 </file>
 
-<file path=ppt/slides/slide3.xml><?xml version="1.0" encoding="utf-8"?>
-<p:sld xmlns:a="http://schemas.openxmlformats.org/drawingml/2006/main" xmlns:p="http://schemas.openxmlformats.org/presentationml/2006/main" xmlns:r="http://schemas.openxmlformats.org/officeDocument/2006/relationships">
-  <p:cSld>
-    <p:spTree>
-      <p:nvGrpSpPr>
-        <p:cNvPr id="1" name=""/>
-        <p:cNvGrpSpPr/>
-        <p:nvPr/>
-      </p:nvGrpSpPr>
-      <p:grpSpPr/>
-      <p:sp>
-        <p:nvSpPr>
-          <p:cNvPr id="2" name="Rectangle 1"/>
-          <p:cNvSpPr/>
-          <p:nvPr/>
-        </p:nvSpPr>
-        <p:spPr>
-          <a:xfrm>
-            <a:off x="0" y="0"/>
-            <a:ext cx="12191695" cy="274320"/>
-          </a:xfrm>
-          <a:prstGeom prst="rect">
-            <a:avLst/>
-          </a:prstGeom>
-          <a:solidFill>
-            <a:srgbClr val="00B2C9"/>
-          </a:solidFill>
-          <a:ln>
-            <a:noFill/>
-          </a:ln>
-        </p:spPr>
-        <p:style>
-          <a:lnRef idx="1">
-            <a:schemeClr val="accent1"/>
-          </a:lnRef>
-          <a:fillRef idx="3">
-            <a:schemeClr val="accent1"/>
-          </a:fillRef>
-          <a:effectRef idx="2">
-            <a:schemeClr val="accent1"/>
-          </a:effectRef>
-          <a:fontRef idx="minor">
-            <a:schemeClr val="lt1"/>
-          </a:fontRef>
-        </p:style>
-        <p:txBody>
-          <a:bodyPr rtlCol="0" anchor="ctr"/>
-          <a:lstStyle/>
-          <a:p>
-            <a:pPr algn="ctr"/>
-          </a:p>
-        </p:txBody>
-      </p:sp>
-      <p:sp>
-        <p:nvSpPr>
-          <p:cNvPr id="3" name="TextBox 2"/>
-          <p:cNvSpPr txBox="1"/>
-          <p:nvPr/>
-        </p:nvSpPr>
-        <p:spPr>
-          <a:xfrm>
-            <a:off x="411480" y="457200"/>
-            <a:ext cx="11368735" cy="914400"/>
-          </a:xfrm>
-          <a:prstGeom prst="rect">
-            <a:avLst/>
-          </a:prstGeom>
-          <a:noFill/>
-        </p:spPr>
-        <p:txBody>
-          <a:bodyPr wrap="square" lIns="0" rIns="0">
-            <a:spAutoFit/>
-          </a:bodyPr>
-          <a:lstStyle/>
-          <a:p>
-            <a:pPr algn="l"/>
-            <a:r>
-              <a:rPr sz="2600" b="1" i="0">
-                <a:solidFill>
-                  <a:srgbClr val="00B2C9"/>
-                </a:solidFill>
-                <a:latin typeface="Encode Sans"/>
-              </a:rPr>
-              <a:t>INDUSTRIA JULIO 2026: IPI CRECIÓ +0.0% I.A.</a:t>
-            </a:r>
-          </a:p>
-        </p:txBody>
-      </p:sp>
-      <p:sp>
-        <p:nvSpPr>
-          <p:cNvPr id="4" name="TextBox 3"/>
-          <p:cNvSpPr txBox="1"/>
-          <p:nvPr/>
-        </p:nvSpPr>
-        <p:spPr>
-          <a:xfrm>
-            <a:off x="411480" y="1280160"/>
-            <a:ext cx="11368735" cy="274320"/>
-          </a:xfrm>
-          <a:prstGeom prst="rect">
-            <a:avLst/>
-          </a:prstGeom>
-          <a:noFill/>
-        </p:spPr>
-        <p:txBody>
-          <a:bodyPr wrap="none">
-            <a:spAutoFit/>
-          </a:bodyPr>
-          <a:lstStyle/>
-          <a:p>
-            <a:r>
-              <a:rPr sz="1100" b="0" i="1">
-                <a:solidFill>
-                  <a:srgbClr val="6A6760"/>
-                </a:solidFill>
-                <a:latin typeface="Encode Sans"/>
-              </a:rPr>
-              <a:t>INDEC · período 2026-07</a:t>
-            </a:r>
-          </a:p>
-        </p:txBody>
-      </p:sp>
-      <p:sp>
-        <p:nvSpPr>
-          <p:cNvPr id="5" name="TextBox 4"/>
-          <p:cNvSpPr txBox="1"/>
-          <p:nvPr/>
-        </p:nvSpPr>
-        <p:spPr>
-          <a:xfrm>
-            <a:off x="411480" y="1691640"/>
-            <a:ext cx="5486400" cy="1645920"/>
-          </a:xfrm>
-          <a:prstGeom prst="rect">
-            <a:avLst/>
-          </a:prstGeom>
-          <a:noFill/>
-        </p:spPr>
-        <p:txBody>
-          <a:bodyPr wrap="square" lIns="0" rIns="0">
-            <a:spAutoFit/>
-          </a:bodyPr>
-          <a:lstStyle/>
-          <a:p>
-            <a:pPr algn="just"/>
-            <a:r>
-              <a:rPr sz="1300" b="0" i="0">
-                <a:solidFill>
-                  <a:srgbClr val="3F3F3F"/>
-                </a:solidFill>
-                <a:latin typeface="Encode Sans"/>
-              </a:rPr>
-              <a:t>El Índice de Producción Industrial Manufacturero (IPI) registró una variación interanual de +0.0% en julio 2026.</a:t>
-            </a:r>
-          </a:p>
-        </p:txBody>
-      </p:sp>
-      <p:sp>
-        <p:nvSpPr>
-          <p:cNvPr id="6" name="TextBox 5"/>
-          <p:cNvSpPr txBox="1"/>
-          <p:nvPr/>
-        </p:nvSpPr>
-        <p:spPr>
-          <a:xfrm>
-            <a:off x="411480" y="3520440"/>
-            <a:ext cx="5486400" cy="2743200"/>
-          </a:xfrm>
-          <a:prstGeom prst="rect">
-            <a:avLst/>
-          </a:prstGeom>
-          <a:noFill/>
-        </p:spPr>
-        <p:txBody>
-          <a:bodyPr wrap="square" lIns="0" rIns="0">
-            <a:spAutoFit/>
-          </a:bodyPr>
-          <a:lstStyle/>
-          <a:p>
-            <a:pPr algn="l">
-              <a:spcAft>
-                <a:spcPts val="800"/>
-              </a:spcAft>
-            </a:pPr>
-            <a:r>
-              <a:rPr sz="1300" b="1" i="0">
-                <a:solidFill>
-                  <a:srgbClr val="00B2C9"/>
-                </a:solidFill>
-                <a:latin typeface="Encode Sans"/>
-              </a:rPr>
-              <a:t>●  </a:t>
-            </a:r>
-            <a:r>
-              <a:rPr sz="1300" b="0" i="0">
-                <a:solidFill>
-                  <a:srgbClr val="3F3F3F"/>
-                </a:solidFill>
-                <a:latin typeface="Encode Sans"/>
-              </a:rPr>
-              <a:t>Variación interanual: +0.0%</a:t>
-            </a:r>
-          </a:p>
-          <a:p>
-            <a:pPr algn="l">
-              <a:spcAft>
-                <a:spcPts val="800"/>
-              </a:spcAft>
-            </a:pPr>
-            <a:r>
-              <a:rPr sz="1300" b="1" i="0">
-                <a:solidFill>
-                  <a:srgbClr val="00B2C9"/>
-                </a:solidFill>
-                <a:latin typeface="Encode Sans"/>
-              </a:rPr>
-              <a:t>●  </a:t>
-            </a:r>
-            <a:r>
-              <a:rPr sz="1300" b="0" i="0">
-                <a:solidFill>
-                  <a:srgbClr val="3F3F3F"/>
-                </a:solidFill>
-                <a:latin typeface="Encode Sans"/>
-              </a:rPr>
-              <a:t>Serie INDEC, base 2004=100. Mide la producción manufacturera (16 ramas).</a:t>
-            </a:r>
-          </a:p>
-        </p:txBody>
-      </p:sp>
-      <p:pic>
-        <p:nvPicPr>
-          <p:cNvPr id="7" name="Picture 6" descr="image.png"/>
-          <p:cNvPicPr>
-            <a:picLocks noChangeAspect="1"/>
-          </p:cNvPicPr>
-          <p:nvPr/>
-        </p:nvPicPr>
-        <p:blipFill>
-          <a:blip r:embed="rId2"/>
-          <a:stretch>
-            <a:fillRect/>
-          </a:stretch>
-        </p:blipFill>
-        <p:spPr>
-          <a:xfrm>
-            <a:off x="6080760" y="1691640"/>
-            <a:ext cx="5669280" cy="2560320"/>
-          </a:xfrm>
-          <a:prstGeom prst="rect">
-            <a:avLst/>
-          </a:prstGeom>
-        </p:spPr>
-      </p:pic>
-      <p:graphicFrame>
-        <p:nvGraphicFramePr>
-          <p:cNvPr id="8" name="Table 7"/>
-          <p:cNvGraphicFramePr>
-            <a:graphicFrameLocks noGrp="1"/>
-          </p:cNvGraphicFramePr>
-          <p:nvPr/>
-        </p:nvGraphicFramePr>
-        <p:xfrm>
-          <a:off x="6080760" y="4434840"/>
-          <a:ext cx="5669280" cy="2048256"/>
-        </p:xfrm>
-        <a:graphic>
-          <a:graphicData uri="http://schemas.openxmlformats.org/drawingml/2006/table">
-            <a:tbl>
-              <a:tblPr firstRow="1" bandRow="1">
-                <a:tableStyleId>{5C22544A-7EE6-4342-B048-85BDC9FD1C3A}</a:tableStyleId>
-              </a:tblPr>
-              <a:tblGrid>
-                <a:gridCol w="1889760"/>
-                <a:gridCol w="1889760"/>
-                <a:gridCol w="1889760"/>
-              </a:tblGrid>
-              <a:tr h="292608">
-                <a:tc>
-                  <a:txBody>
-                    <a:bodyPr/>
-                    <a:lstStyle/>
-                    <a:p>
-                      <a:pPr algn="l"/>
-                      <a:r>
-                        <a:rPr sz="1000" b="1">
-                          <a:solidFill>
-                            <a:srgbClr val="FFFFFF"/>
-                          </a:solidFill>
-                          <a:latin typeface="Encode Sans"/>
-                        </a:rPr>
-                        <a:t>Mes</a:t>
-                      </a:r>
-                    </a:p>
-                  </a:txBody>
-                  <a:tcPr marL="36576" marR="36576" marT="18288" marB="18288">
-                    <a:solidFill>
-                      <a:srgbClr val="00B2C9"/>
-                    </a:solidFill>
-                  </a:tcPr>
-                </a:tc>
-                <a:tc>
-                  <a:txBody>
-                    <a:bodyPr/>
-                    <a:lstStyle/>
-                    <a:p>
-                      <a:pPr algn="r"/>
-                      <a:r>
-                        <a:rPr sz="1000" b="1">
-                          <a:solidFill>
-                            <a:srgbClr val="FFFFFF"/>
-                          </a:solidFill>
-                          <a:latin typeface="Encode Sans"/>
-                        </a:rPr>
-                        <a:t>Original</a:t>
-                      </a:r>
-                    </a:p>
-                  </a:txBody>
-                  <a:tcPr marL="36576" marR="36576" marT="18288" marB="18288">
-                    <a:solidFill>
-                      <a:srgbClr val="00B2C9"/>
-                    </a:solidFill>
-                  </a:tcPr>
-                </a:tc>
-                <a:tc>
-                  <a:txBody>
-                    <a:bodyPr/>
-                    <a:lstStyle/>
-                    <a:p>
-                      <a:pPr algn="r"/>
-                      <a:r>
-                        <a:rPr sz="1000" b="1">
-                          <a:solidFill>
-                            <a:srgbClr val="FFFFFF"/>
-                          </a:solidFill>
-                          <a:latin typeface="Encode Sans"/>
-                        </a:rPr>
-                        <a:t>VIA %</a:t>
-                      </a:r>
-                    </a:p>
-                  </a:txBody>
-                  <a:tcPr marL="36576" marR="36576" marT="18288" marB="18288">
-                    <a:solidFill>
-                      <a:srgbClr val="00B2C9"/>
-                    </a:solidFill>
-                  </a:tcPr>
-                </a:tc>
-              </a:tr>
-              <a:tr h="292608">
-                <a:tc>
-                  <a:txBody>
-                    <a:bodyPr/>
-                    <a:lstStyle/>
-                    <a:p>
-                      <a:pPr algn="l"/>
-                      <a:r>
-                        <a:rPr sz="1000">
-                          <a:solidFill>
-                            <a:srgbClr val="3F3F3F"/>
-                          </a:solidFill>
-                          <a:latin typeface="Encode Sans"/>
-                        </a:rPr>
-                        <a:t>Julio 2026</a:t>
-                      </a:r>
-                    </a:p>
-                  </a:txBody>
-                  <a:tcPr marL="36576" marR="36576" marT="18288" marB="18288">
-                    <a:solidFill>
-                      <a:srgbClr val="FFFFFF"/>
-                    </a:solidFill>
-                  </a:tcPr>
-                </a:tc>
-                <a:tc>
-                  <a:txBody>
-                    <a:bodyPr/>
-                    <a:lstStyle/>
-                    <a:p>
-                      <a:pPr algn="r"/>
-                      <a:r>
-                        <a:rPr sz="1000">
-                          <a:solidFill>
-                            <a:srgbClr val="3F3F3F"/>
-                          </a:solidFill>
-                          <a:latin typeface="Encode Sans"/>
-                        </a:rPr>
-                        <a:t>118,2</a:t>
-                      </a:r>
-                    </a:p>
-                  </a:txBody>
-                  <a:tcPr marL="36576" marR="36576" marT="18288" marB="18288">
-                    <a:solidFill>
-                      <a:srgbClr val="FFFFFF"/>
-                    </a:solidFill>
-                  </a:tcPr>
-                </a:tc>
-                <a:tc>
-                  <a:txBody>
-                    <a:bodyPr/>
-                    <a:lstStyle/>
-                    <a:p>
-                      <a:pPr algn="r"/>
-                      <a:r>
-                        <a:rPr sz="1000">
-                          <a:solidFill>
-                            <a:srgbClr val="3F3F3F"/>
-                          </a:solidFill>
-                          <a:latin typeface="Encode Sans"/>
-                        </a:rPr>
-                        <a:t>-4.9%</a:t>
-                      </a:r>
-                    </a:p>
-                  </a:txBody>
-                  <a:tcPr marL="36576" marR="36576" marT="18288" marB="18288">
-                    <a:solidFill>
-                      <a:srgbClr val="FFFFFF"/>
-                    </a:solidFill>
-                  </a:tcPr>
-                </a:tc>
-              </a:tr>
-              <a:tr h="292608">
-                <a:tc>
-                  <a:txBody>
-                    <a:bodyPr/>
-                    <a:lstStyle/>
-                    <a:p>
-                      <a:pPr algn="l"/>
-                      <a:r>
-                        <a:rPr sz="1000">
-                          <a:solidFill>
-                            <a:srgbClr val="3F3F3F"/>
-                          </a:solidFill>
-                          <a:latin typeface="Encode Sans"/>
-                        </a:rPr>
-                        <a:t>Junio 2026</a:t>
-                      </a:r>
-                    </a:p>
-                  </a:txBody>
-                  <a:tcPr marL="36576" marR="36576" marT="18288" marB="18288">
-                    <a:solidFill>
-                      <a:srgbClr val="F8F8F6"/>
-                    </a:solidFill>
-                  </a:tcPr>
-                </a:tc>
-                <a:tc>
-                  <a:txBody>
-                    <a:bodyPr/>
-                    <a:lstStyle/>
-                    <a:p>
-                      <a:pPr algn="r"/>
-                      <a:r>
-                        <a:rPr sz="1000">
-                          <a:solidFill>
-                            <a:srgbClr val="3F3F3F"/>
-                          </a:solidFill>
-                          <a:latin typeface="Encode Sans"/>
-                        </a:rPr>
-                        <a:t>120,0</a:t>
-                      </a:r>
-                    </a:p>
-                  </a:txBody>
-                  <a:tcPr marL="36576" marR="36576" marT="18288" marB="18288">
-                    <a:solidFill>
-                      <a:srgbClr val="F8F8F6"/>
-                    </a:solidFill>
-                  </a:tcPr>
-                </a:tc>
-                <a:tc>
-                  <a:txBody>
-                    <a:bodyPr/>
-                    <a:lstStyle/>
-                    <a:p>
-                      <a:pPr algn="r"/>
-                      <a:r>
-                        <a:rPr sz="1000">
-                          <a:solidFill>
-                            <a:srgbClr val="3F3F3F"/>
-                          </a:solidFill>
-                          <a:latin typeface="Encode Sans"/>
-                        </a:rPr>
-                        <a:t>+2.1%</a:t>
-                      </a:r>
-                    </a:p>
-                  </a:txBody>
-                  <a:tcPr marL="36576" marR="36576" marT="18288" marB="18288">
-                    <a:solidFill>
-                      <a:srgbClr val="F8F8F6"/>
-                    </a:solidFill>
-                  </a:tcPr>
-                </a:tc>
-              </a:tr>
-              <a:tr h="292608">
-                <a:tc>
-                  <a:txBody>
-                    <a:bodyPr/>
-                    <a:lstStyle/>
-                    <a:p>
-                      <a:pPr algn="l"/>
-                      <a:r>
-                        <a:rPr sz="1000">
-                          <a:solidFill>
-                            <a:srgbClr val="3F3F3F"/>
-                          </a:solidFill>
-                          <a:latin typeface="Encode Sans"/>
-                        </a:rPr>
-                        <a:t>Mayo 2026</a:t>
-                      </a:r>
-                    </a:p>
-                  </a:txBody>
-                  <a:tcPr marL="36576" marR="36576" marT="18288" marB="18288">
-                    <a:solidFill>
-                      <a:srgbClr val="FFFFFF"/>
-                    </a:solidFill>
-                  </a:tcPr>
-                </a:tc>
-                <a:tc>
-                  <a:txBody>
-                    <a:bodyPr/>
-                    <a:lstStyle/>
-                    <a:p>
-                      <a:pPr algn="r"/>
-                      <a:r>
-                        <a:rPr sz="1000">
-                          <a:solidFill>
-                            <a:srgbClr val="3F3F3F"/>
-                          </a:solidFill>
-                          <a:latin typeface="Encode Sans"/>
-                        </a:rPr>
-                        <a:t>117,0</a:t>
-                      </a:r>
-                    </a:p>
-                  </a:txBody>
-                  <a:tcPr marL="36576" marR="36576" marT="18288" marB="18288">
-                    <a:solidFill>
-                      <a:srgbClr val="FFFFFF"/>
-                    </a:solidFill>
-                  </a:tcPr>
-                </a:tc>
-                <a:tc>
-                  <a:txBody>
-                    <a:bodyPr/>
-                    <a:lstStyle/>
-                    <a:p>
-                      <a:pPr algn="r"/>
-                      <a:r>
-                        <a:rPr sz="1000">
-                          <a:solidFill>
-                            <a:srgbClr val="3F3F3F"/>
-                          </a:solidFill>
-                          <a:latin typeface="Encode Sans"/>
-                        </a:rPr>
-                        <a:t>-5.7%</a:t>
-                      </a:r>
-                    </a:p>
-                  </a:txBody>
-                  <a:tcPr marL="36576" marR="36576" marT="18288" marB="18288">
-                    <a:solidFill>
-                      <a:srgbClr val="FFFFFF"/>
-                    </a:solidFill>
-                  </a:tcPr>
-                </a:tc>
-              </a:tr>
-              <a:tr h="292608">
-                <a:tc>
-                  <a:txBody>
-                    <a:bodyPr/>
-                    <a:lstStyle/>
-                    <a:p>
-                      <a:pPr algn="l"/>
-                      <a:r>
-                        <a:rPr sz="1000">
-                          <a:solidFill>
-                            <a:srgbClr val="3F3F3F"/>
-                          </a:solidFill>
-                          <a:latin typeface="Encode Sans"/>
-                        </a:rPr>
-                        <a:t>Abril 2026</a:t>
-                      </a:r>
-                    </a:p>
-                  </a:txBody>
-                  <a:tcPr marL="36576" marR="36576" marT="18288" marB="18288">
-                    <a:solidFill>
-                      <a:srgbClr val="F8F8F6"/>
-                    </a:solidFill>
-                  </a:tcPr>
-                </a:tc>
-                <a:tc>
-                  <a:txBody>
-                    <a:bodyPr/>
-                    <a:lstStyle/>
-                    <a:p>
-                      <a:pPr algn="r"/>
-                      <a:r>
-                        <a:rPr sz="1000">
-                          <a:solidFill>
-                            <a:srgbClr val="3F3F3F"/>
-                          </a:solidFill>
-                          <a:latin typeface="Encode Sans"/>
-                        </a:rPr>
-                        <a:t>118,6</a:t>
-                      </a:r>
-                    </a:p>
-                  </a:txBody>
-                  <a:tcPr marL="36576" marR="36576" marT="18288" marB="18288">
-                    <a:solidFill>
-                      <a:srgbClr val="F8F8F6"/>
-                    </a:solidFill>
-                  </a:tcPr>
-                </a:tc>
-                <a:tc>
-                  <a:txBody>
-                    <a:bodyPr/>
-                    <a:lstStyle/>
-                    <a:p>
-                      <a:pPr algn="r"/>
-                      <a:r>
-                        <a:rPr sz="1000">
-                          <a:solidFill>
-                            <a:srgbClr val="3F3F3F"/>
-                          </a:solidFill>
-                          <a:latin typeface="Encode Sans"/>
-                        </a:rPr>
-                        <a:t>-2.4%</a:t>
-                      </a:r>
-                    </a:p>
-                  </a:txBody>
-                  <a:tcPr marL="36576" marR="36576" marT="18288" marB="18288">
-                    <a:solidFill>
-                      <a:srgbClr val="F8F8F6"/>
-                    </a:solidFill>
-                  </a:tcPr>
-                </a:tc>
-              </a:tr>
-              <a:tr h="292608">
-                <a:tc>
-                  <a:txBody>
-                    <a:bodyPr/>
-                    <a:lstStyle/>
-                    <a:p>
-                      <a:pPr algn="l"/>
-                      <a:r>
-                        <a:rPr sz="1000">
-                          <a:solidFill>
-                            <a:srgbClr val="3F3F3F"/>
-                          </a:solidFill>
-                          <a:latin typeface="Encode Sans"/>
-                        </a:rPr>
-                        <a:t>Marzo 2026</a:t>
-                      </a:r>
-                    </a:p>
-                  </a:txBody>
-                  <a:tcPr marL="36576" marR="36576" marT="18288" marB="18288">
-                    <a:solidFill>
-                      <a:srgbClr val="FFFFFF"/>
-                    </a:solidFill>
-                  </a:tcPr>
-                </a:tc>
-                <a:tc>
-                  <a:txBody>
-                    <a:bodyPr/>
-                    <a:lstStyle/>
-                    <a:p>
-                      <a:pPr algn="r"/>
-                      <a:r>
-                        <a:rPr sz="1000">
-                          <a:solidFill>
-                            <a:srgbClr val="3F3F3F"/>
-                          </a:solidFill>
-                          <a:latin typeface="Encode Sans"/>
-                        </a:rPr>
-                        <a:t>122,2</a:t>
-                      </a:r>
-                    </a:p>
-                  </a:txBody>
-                  <a:tcPr marL="36576" marR="36576" marT="18288" marB="18288">
-                    <a:solidFill>
-                      <a:srgbClr val="FFFFFF"/>
-                    </a:solidFill>
-                  </a:tcPr>
-                </a:tc>
-                <a:tc>
-                  <a:txBody>
-                    <a:bodyPr/>
-                    <a:lstStyle/>
-                    <a:p>
-                      <a:pPr algn="r"/>
-                      <a:r>
-                        <a:rPr sz="1000">
-                          <a:solidFill>
-                            <a:srgbClr val="3F3F3F"/>
-                          </a:solidFill>
-                          <a:latin typeface="Encode Sans"/>
-                        </a:rPr>
-                        <a:t>+5.1%</a:t>
-                      </a:r>
-                    </a:p>
-                  </a:txBody>
-                  <a:tcPr marL="36576" marR="36576" marT="18288" marB="18288">
-                    <a:solidFill>
-                      <a:srgbClr val="FFFFFF"/>
-                    </a:solidFill>
-                  </a:tcPr>
-                </a:tc>
-              </a:tr>
-              <a:tr h="292608">
-                <a:tc>
-                  <a:txBody>
-                    <a:bodyPr/>
-                    <a:lstStyle/>
-                    <a:p>
-                      <a:pPr algn="l"/>
-                      <a:r>
-                        <a:rPr sz="1000">
-                          <a:solidFill>
-                            <a:srgbClr val="3F3F3F"/>
-                          </a:solidFill>
-                          <a:latin typeface="Encode Sans"/>
-                        </a:rPr>
-                        <a:t>Febrero 2026</a:t>
-                      </a:r>
-                    </a:p>
-                  </a:txBody>
-                  <a:tcPr marL="36576" marR="36576" marT="18288" marB="18288">
-                    <a:solidFill>
-                      <a:srgbClr val="F8F8F6"/>
-                    </a:solidFill>
-                  </a:tcPr>
-                </a:tc>
-                <a:tc>
-                  <a:txBody>
-                    <a:bodyPr/>
-                    <a:lstStyle/>
-                    <a:p>
-                      <a:pPr algn="r"/>
-                      <a:r>
-                        <a:rPr sz="1000">
-                          <a:solidFill>
-                            <a:srgbClr val="3F3F3F"/>
-                          </a:solidFill>
-                          <a:latin typeface="Encode Sans"/>
-                        </a:rPr>
-                        <a:t>100,3</a:t>
-                      </a:r>
-                    </a:p>
-                  </a:txBody>
-                  <a:tcPr marL="36576" marR="36576" marT="18288" marB="18288">
-                    <a:solidFill>
-                      <a:srgbClr val="F8F8F6"/>
-                    </a:solidFill>
-                  </a:tcPr>
-                </a:tc>
-                <a:tc>
-                  <a:txBody>
-                    <a:bodyPr/>
-                    <a:lstStyle/>
-                    <a:p>
-                      <a:pPr algn="r"/>
-                      <a:r>
-                        <a:rPr sz="1000">
-                          <a:solidFill>
-                            <a:srgbClr val="3F3F3F"/>
-                          </a:solidFill>
-                          <a:latin typeface="Encode Sans"/>
-                        </a:rPr>
-                        <a:t>-8.8%</a:t>
-                      </a:r>
-                    </a:p>
-                  </a:txBody>
-                  <a:tcPr marL="36576" marR="36576" marT="18288" marB="18288">
-                    <a:solidFill>
-                      <a:srgbClr val="F8F8F6"/>
-                    </a:solidFill>
-                  </a:tcPr>
-                </a:tc>
-              </a:tr>
-            </a:tbl>
-          </a:graphicData>
-        </a:graphic>
-      </p:graphicFrame>
-      <p:sp>
-        <p:nvSpPr>
-          <p:cNvPr id="9" name="TextBox 8"/>
-          <p:cNvSpPr txBox="1"/>
-          <p:nvPr/>
-        </p:nvSpPr>
-        <p:spPr>
-          <a:xfrm>
-            <a:off x="411480" y="6492240"/>
-            <a:ext cx="11368735" cy="274320"/>
-          </a:xfrm>
-          <a:prstGeom prst="rect">
-            <a:avLst/>
-          </a:prstGeom>
-          <a:noFill/>
-        </p:spPr>
-        <p:txBody>
-          <a:bodyPr wrap="none">
-            <a:spAutoFit/>
-          </a:bodyPr>
-          <a:lstStyle/>
-          <a:p>
-            <a:r>
-              <a:rPr sz="1000" b="0" i="1">
-                <a:solidFill>
-                  <a:srgbClr val="6A6760"/>
-                </a:solidFill>
-                <a:latin typeface="Encode Sans"/>
-              </a:rPr>
-              <a:t>Fuente: elaboración propia en base a INDEC</a:t>
-            </a:r>
-          </a:p>
-        </p:txBody>
-      </p:sp>
-    </p:spTree>
-  </p:cSld>
-  <p:clrMapOvr>
-    <a:masterClrMapping/>
-  </p:clrMapOvr>
-</p:sld>
-</file>
-
-<file path=ppt/slides/slide4.xml><?xml version="1.0" encoding="utf-8"?>
-<p:sld xmlns:a="http://schemas.openxmlformats.org/drawingml/2006/main" xmlns:p="http://schemas.openxmlformats.org/presentationml/2006/main" xmlns:r="http://schemas.openxmlformats.org/officeDocument/2006/relationships">
-  <p:cSld>
-    <p:spTree>
-      <p:nvGrpSpPr>
-        <p:cNvPr id="1" name=""/>
-        <p:cNvGrpSpPr/>
-        <p:nvPr/>
-      </p:nvGrpSpPr>
-      <p:grpSpPr/>
-      <p:sp>
-        <p:nvSpPr>
-          <p:cNvPr id="2" name="Rectangle 1"/>
-          <p:cNvSpPr/>
-          <p:nvPr/>
-        </p:nvSpPr>
-        <p:spPr>
-          <a:xfrm>
-            <a:off x="0" y="0"/>
-            <a:ext cx="12191695" cy="274320"/>
-          </a:xfrm>
-          <a:prstGeom prst="rect">
-            <a:avLst/>
-          </a:prstGeom>
-          <a:solidFill>
-            <a:srgbClr val="00B2C9"/>
-          </a:solidFill>
-          <a:ln>
-            <a:noFill/>
-          </a:ln>
-        </p:spPr>
-        <p:style>
-          <a:lnRef idx="1">
-            <a:schemeClr val="accent1"/>
-          </a:lnRef>
-          <a:fillRef idx="3">
-            <a:schemeClr val="accent1"/>
-          </a:fillRef>
-          <a:effectRef idx="2">
-            <a:schemeClr val="accent1"/>
-          </a:effectRef>
-          <a:fontRef idx="minor">
-            <a:schemeClr val="lt1"/>
-          </a:fontRef>
-        </p:style>
-        <p:txBody>
-          <a:bodyPr rtlCol="0" anchor="ctr"/>
-          <a:lstStyle/>
-          <a:p>
-            <a:pPr algn="ctr"/>
-          </a:p>
-        </p:txBody>
-      </p:sp>
-      <p:sp>
-        <p:nvSpPr>
-          <p:cNvPr id="3" name="TextBox 2"/>
-          <p:cNvSpPr txBox="1"/>
-          <p:nvPr/>
-        </p:nvSpPr>
-        <p:spPr>
-          <a:xfrm>
-            <a:off x="411480" y="457200"/>
-            <a:ext cx="11368735" cy="914400"/>
-          </a:xfrm>
-          <a:prstGeom prst="rect">
-            <a:avLst/>
-          </a:prstGeom>
-          <a:noFill/>
-        </p:spPr>
-        <p:txBody>
-          <a:bodyPr wrap="square" lIns="0" rIns="0">
-            <a:spAutoFit/>
-          </a:bodyPr>
-          <a:lstStyle/>
-          <a:p>
-            <a:pPr algn="l"/>
-            <a:r>
-              <a:rPr sz="2600" b="1" i="0">
-                <a:solidFill>
-                  <a:srgbClr val="00B2C9"/>
-                </a:solidFill>
-                <a:latin typeface="Encode Sans"/>
-              </a:rPr>
-              <a:t>INFLACIÓN AGOSTO 2026: +1.7%</a:t>
-            </a:r>
-          </a:p>
-        </p:txBody>
-      </p:sp>
-      <p:sp>
-        <p:nvSpPr>
-          <p:cNvPr id="4" name="TextBox 3"/>
-          <p:cNvSpPr txBox="1"/>
-          <p:nvPr/>
-        </p:nvSpPr>
-        <p:spPr>
-          <a:xfrm>
-            <a:off x="411480" y="1280160"/>
-            <a:ext cx="11368735" cy="274320"/>
-          </a:xfrm>
-          <a:prstGeom prst="rect">
-            <a:avLst/>
-          </a:prstGeom>
-          <a:noFill/>
-        </p:spPr>
-        <p:txBody>
-          <a:bodyPr wrap="none">
-            <a:spAutoFit/>
-          </a:bodyPr>
-          <a:lstStyle/>
-          <a:p>
-            <a:r>
-              <a:rPr sz="1100" b="0" i="1">
-                <a:solidFill>
-                  <a:srgbClr val="6A6760"/>
-                </a:solidFill>
-                <a:latin typeface="Encode Sans"/>
-              </a:rPr>
-              <a:t>INDEC · período 2026-08</a:t>
-            </a:r>
-          </a:p>
-        </p:txBody>
-      </p:sp>
-      <p:sp>
-        <p:nvSpPr>
-          <p:cNvPr id="5" name="TextBox 4"/>
-          <p:cNvSpPr txBox="1"/>
-          <p:nvPr/>
-        </p:nvSpPr>
-        <p:spPr>
-          <a:xfrm>
-            <a:off x="411480" y="1691640"/>
-            <a:ext cx="5486400" cy="1645920"/>
-          </a:xfrm>
-          <a:prstGeom prst="rect">
-            <a:avLst/>
-          </a:prstGeom>
-          <a:noFill/>
-        </p:spPr>
-        <p:txBody>
-          <a:bodyPr wrap="square" lIns="0" rIns="0">
-            <a:spAutoFit/>
-          </a:bodyPr>
-          <a:lstStyle/>
-          <a:p>
-            <a:pPr algn="just"/>
-            <a:r>
-              <a:rPr sz="1300" b="0" i="0">
-                <a:solidFill>
-                  <a:srgbClr val="3F3F3F"/>
-                </a:solidFill>
-                <a:latin typeface="Encode Sans"/>
-              </a:rPr>
-              <a:t>El IPC nivel general aumentó +1.7% mensual en agosto 2026, acumulando 33.54% interanual. INDEC publicó el indicador con la metodología vigente.</a:t>
-            </a:r>
-          </a:p>
-        </p:txBody>
-      </p:sp>
-      <p:sp>
-        <p:nvSpPr>
-          <p:cNvPr id="6" name="TextBox 5"/>
-          <p:cNvSpPr txBox="1"/>
-          <p:nvPr/>
-        </p:nvSpPr>
-        <p:spPr>
-          <a:xfrm>
-            <a:off x="411480" y="3520440"/>
-            <a:ext cx="5486400" cy="2743200"/>
-          </a:xfrm>
-          <a:prstGeom prst="rect">
-            <a:avLst/>
-          </a:prstGeom>
-          <a:noFill/>
-        </p:spPr>
-        <p:txBody>
-          <a:bodyPr wrap="square" lIns="0" rIns="0">
-            <a:spAutoFit/>
-          </a:bodyPr>
-          <a:lstStyle/>
-          <a:p>
-            <a:pPr algn="l">
-              <a:spcAft>
-                <a:spcPts val="800"/>
-              </a:spcAft>
-            </a:pPr>
-            <a:r>
-              <a:rPr sz="1300" b="1" i="0">
-                <a:solidFill>
-                  <a:srgbClr val="00B2C9"/>
-                </a:solidFill>
-                <a:latin typeface="Encode Sans"/>
-              </a:rPr>
-              <a:t>●  </a:t>
-            </a:r>
-            <a:r>
-              <a:rPr sz="1300" b="0" i="0">
-                <a:solidFill>
-                  <a:srgbClr val="3F3F3F"/>
-                </a:solidFill>
-                <a:latin typeface="Encode Sans"/>
-              </a:rPr>
-              <a:t>Variación mensual: +1.7%</a:t>
-            </a:r>
-          </a:p>
-          <a:p>
-            <a:pPr algn="l">
-              <a:spcAft>
-                <a:spcPts val="800"/>
-              </a:spcAft>
-            </a:pPr>
-            <a:r>
-              <a:rPr sz="1300" b="1" i="0">
-                <a:solidFill>
-                  <a:srgbClr val="00B2C9"/>
-                </a:solidFill>
-                <a:latin typeface="Encode Sans"/>
-              </a:rPr>
-              <a:t>●  </a:t>
-            </a:r>
-            <a:r>
-              <a:rPr sz="1300" b="0" i="0">
-                <a:solidFill>
-                  <a:srgbClr val="3F3F3F"/>
-                </a:solidFill>
-                <a:latin typeface="Encode Sans"/>
-              </a:rPr>
-              <a:t>Variación interanual: 33.54%</a:t>
-            </a:r>
-          </a:p>
-          <a:p>
-            <a:pPr algn="l">
-              <a:spcAft>
-                <a:spcPts val="800"/>
-              </a:spcAft>
-            </a:pPr>
-            <a:r>
-              <a:rPr sz="1300" b="1" i="0">
-                <a:solidFill>
-                  <a:srgbClr val="00B2C9"/>
-                </a:solidFill>
-                <a:latin typeface="Encode Sans"/>
-              </a:rPr>
-              <a:t>●  </a:t>
-            </a:r>
-            <a:r>
-              <a:rPr sz="1300" b="0" i="0">
-                <a:solidFill>
-                  <a:srgbClr val="3F3F3F"/>
-                </a:solidFill>
-                <a:latin typeface="Encode Sans"/>
-              </a:rPr>
-              <a:t>Acumulado últimos 6 meses: 13.8% (suma simple)</a:t>
-            </a:r>
-          </a:p>
-        </p:txBody>
-      </p:sp>
-      <p:pic>
-        <p:nvPicPr>
-          <p:cNvPr id="7" name="Picture 6" descr="image.png"/>
-          <p:cNvPicPr>
-            <a:picLocks noChangeAspect="1"/>
-          </p:cNvPicPr>
-          <p:nvPr/>
-        </p:nvPicPr>
-        <p:blipFill>
-          <a:blip r:embed="rId2"/>
-          <a:stretch>
-            <a:fillRect/>
-          </a:stretch>
-        </p:blipFill>
-        <p:spPr>
-          <a:xfrm>
-            <a:off x="6080760" y="1691640"/>
-            <a:ext cx="5669280" cy="2560320"/>
-          </a:xfrm>
-          <a:prstGeom prst="rect">
-            <a:avLst/>
-          </a:prstGeom>
-        </p:spPr>
-      </p:pic>
-      <p:graphicFrame>
-        <p:nvGraphicFramePr>
-          <p:cNvPr id="8" name="Table 7"/>
-          <p:cNvGraphicFramePr>
-            <a:graphicFrameLocks noGrp="1"/>
-          </p:cNvGraphicFramePr>
-          <p:nvPr/>
-        </p:nvGraphicFramePr>
-        <p:xfrm>
-          <a:off x="6080760" y="4434840"/>
-          <a:ext cx="5669280" cy="2048256"/>
-        </p:xfrm>
-        <a:graphic>
-          <a:graphicData uri="http://schemas.openxmlformats.org/drawingml/2006/table">
-            <a:tbl>
-              <a:tblPr firstRow="1" bandRow="1">
-                <a:tableStyleId>{5C22544A-7EE6-4342-B048-85BDC9FD1C3A}</a:tableStyleId>
-              </a:tblPr>
-              <a:tblGrid>
-                <a:gridCol w="1889760"/>
-                <a:gridCol w="1889760"/>
-                <a:gridCol w="1889760"/>
-              </a:tblGrid>
-              <a:tr h="292608">
-                <a:tc>
-                  <a:txBody>
-                    <a:bodyPr/>
-                    <a:lstStyle/>
-                    <a:p>
-                      <a:pPr algn="l"/>
-                      <a:r>
-                        <a:rPr sz="1000" b="1">
-                          <a:solidFill>
-                            <a:srgbClr val="FFFFFF"/>
-                          </a:solidFill>
-                          <a:latin typeface="Encode Sans"/>
-                        </a:rPr>
-                        <a:t>Mes</a:t>
-                      </a:r>
-                    </a:p>
-                  </a:txBody>
-                  <a:tcPr marL="36576" marR="36576" marT="18288" marB="18288">
-                    <a:solidFill>
-                      <a:srgbClr val="00B2C9"/>
-                    </a:solidFill>
-                  </a:tcPr>
-                </a:tc>
-                <a:tc>
-                  <a:txBody>
-                    <a:bodyPr/>
-                    <a:lstStyle/>
-                    <a:p>
-                      <a:pPr algn="r"/>
-                      <a:r>
-                        <a:rPr sz="1000" b="1">
-                          <a:solidFill>
-                            <a:srgbClr val="FFFFFF"/>
-                          </a:solidFill>
-                          <a:latin typeface="Encode Sans"/>
-                        </a:rPr>
-                        <a:t>VM %</a:t>
-                      </a:r>
-                    </a:p>
-                  </a:txBody>
-                  <a:tcPr marL="36576" marR="36576" marT="18288" marB="18288">
-                    <a:solidFill>
-                      <a:srgbClr val="00B2C9"/>
-                    </a:solidFill>
-                  </a:tcPr>
-                </a:tc>
-                <a:tc>
-                  <a:txBody>
-                    <a:bodyPr/>
-                    <a:lstStyle/>
-                    <a:p>
-                      <a:pPr algn="r"/>
-                      <a:r>
-                        <a:rPr sz="1000" b="1">
-                          <a:solidFill>
-                            <a:srgbClr val="FFFFFF"/>
-                          </a:solidFill>
-                          <a:latin typeface="Encode Sans"/>
-                        </a:rPr>
-                        <a:t>VIA %</a:t>
-                      </a:r>
-                    </a:p>
-                  </a:txBody>
-                  <a:tcPr marL="36576" marR="36576" marT="18288" marB="18288">
-                    <a:solidFill>
-                      <a:srgbClr val="00B2C9"/>
-                    </a:solidFill>
-                  </a:tcPr>
-                </a:tc>
-              </a:tr>
-              <a:tr h="292608">
-                <a:tc>
-                  <a:txBody>
-                    <a:bodyPr/>
-                    <a:lstStyle/>
-                    <a:p>
-                      <a:pPr algn="l"/>
-                      <a:r>
-                        <a:rPr sz="1000">
-                          <a:solidFill>
-                            <a:srgbClr val="3F3F3F"/>
-                          </a:solidFill>
-                          <a:latin typeface="Encode Sans"/>
-                        </a:rPr>
-                        <a:t>Agosto 2026</a:t>
-                      </a:r>
-                    </a:p>
-                  </a:txBody>
-                  <a:tcPr marL="36576" marR="36576" marT="18288" marB="18288">
-                    <a:solidFill>
-                      <a:srgbClr val="FFFFFF"/>
-                    </a:solidFill>
-                  </a:tcPr>
-                </a:tc>
-                <a:tc>
-                  <a:txBody>
-                    <a:bodyPr/>
-                    <a:lstStyle/>
-                    <a:p>
-                      <a:pPr algn="r"/>
-                      <a:r>
-                        <a:rPr sz="1000">
-                          <a:solidFill>
-                            <a:srgbClr val="3F3F3F"/>
-                          </a:solidFill>
-                          <a:latin typeface="Encode Sans"/>
-                        </a:rPr>
-                        <a:t>+1.7%</a:t>
-                      </a:r>
-                    </a:p>
-                  </a:txBody>
-                  <a:tcPr marL="36576" marR="36576" marT="18288" marB="18288">
-                    <a:solidFill>
-                      <a:srgbClr val="FFFFFF"/>
-                    </a:solidFill>
-                  </a:tcPr>
-                </a:tc>
-                <a:tc>
-                  <a:txBody>
-                    <a:bodyPr/>
-                    <a:lstStyle/>
-                    <a:p>
-                      <a:pPr algn="r"/>
-                      <a:r>
-                        <a:rPr sz="1000">
-                          <a:solidFill>
-                            <a:srgbClr val="3F3F3F"/>
-                          </a:solidFill>
-                          <a:latin typeface="Encode Sans"/>
-                        </a:rPr>
-                        <a:t>+33.5%</a:t>
-                      </a:r>
-                    </a:p>
-                  </a:txBody>
-                  <a:tcPr marL="36576" marR="36576" marT="18288" marB="18288">
-                    <a:solidFill>
-                      <a:srgbClr val="FFFFFF"/>
-                    </a:solidFill>
-                  </a:tcPr>
-                </a:tc>
-              </a:tr>
-              <a:tr h="292608">
-                <a:tc>
-                  <a:txBody>
-                    <a:bodyPr/>
-                    <a:lstStyle/>
-                    <a:p>
-                      <a:pPr algn="l"/>
-                      <a:r>
-                        <a:rPr sz="1000">
-                          <a:solidFill>
-                            <a:srgbClr val="3F3F3F"/>
-                          </a:solidFill>
-                          <a:latin typeface="Encode Sans"/>
-                        </a:rPr>
-                        <a:t>Julio 2026</a:t>
-                      </a:r>
-                    </a:p>
-                  </a:txBody>
-                  <a:tcPr marL="36576" marR="36576" marT="18288" marB="18288">
-                    <a:solidFill>
-                      <a:srgbClr val="F8F8F6"/>
-                    </a:solidFill>
-                  </a:tcPr>
-                </a:tc>
-                <a:tc>
-                  <a:txBody>
-                    <a:bodyPr/>
-                    <a:lstStyle/>
-                    <a:p>
-                      <a:pPr algn="r"/>
-                      <a:r>
-                        <a:rPr sz="1000">
-                          <a:solidFill>
-                            <a:srgbClr val="3F3F3F"/>
-                          </a:solidFill>
-                          <a:latin typeface="Encode Sans"/>
-                        </a:rPr>
-                        <a:t>+2.1%</a:t>
-                      </a:r>
-                    </a:p>
-                  </a:txBody>
-                  <a:tcPr marL="36576" marR="36576" marT="18288" marB="18288">
-                    <a:solidFill>
-                      <a:srgbClr val="F8F8F6"/>
-                    </a:solidFill>
-                  </a:tcPr>
-                </a:tc>
-                <a:tc>
-                  <a:txBody>
-                    <a:bodyPr/>
-                    <a:lstStyle/>
-                    <a:p>
-                      <a:pPr algn="r"/>
-                      <a:r>
-                        <a:rPr sz="1000">
-                          <a:solidFill>
-                            <a:srgbClr val="3F3F3F"/>
-                          </a:solidFill>
-                          <a:latin typeface="Encode Sans"/>
-                        </a:rPr>
-                        <a:t>+33.8%</a:t>
-                      </a:r>
-                    </a:p>
-                  </a:txBody>
-                  <a:tcPr marL="36576" marR="36576" marT="18288" marB="18288">
-                    <a:solidFill>
-                      <a:srgbClr val="F8F8F6"/>
-                    </a:solidFill>
-                  </a:tcPr>
-                </a:tc>
-              </a:tr>
-              <a:tr h="292608">
-                <a:tc>
-                  <a:txBody>
-                    <a:bodyPr/>
-                    <a:lstStyle/>
-                    <a:p>
-                      <a:pPr algn="l"/>
-                      <a:r>
-                        <a:rPr sz="1000">
-                          <a:solidFill>
-                            <a:srgbClr val="3F3F3F"/>
-                          </a:solidFill>
-                          <a:latin typeface="Encode Sans"/>
-                        </a:rPr>
-                        <a:t>Junio 2026</a:t>
-                      </a:r>
-                    </a:p>
-                  </a:txBody>
-                  <a:tcPr marL="36576" marR="36576" marT="18288" marB="18288">
-                    <a:solidFill>
-                      <a:srgbClr val="FFFFFF"/>
-                    </a:solidFill>
-                  </a:tcPr>
-                </a:tc>
-                <a:tc>
-                  <a:txBody>
-                    <a:bodyPr/>
-                    <a:lstStyle/>
-                    <a:p>
-                      <a:pPr algn="r"/>
-                      <a:r>
-                        <a:rPr sz="1000">
-                          <a:solidFill>
-                            <a:srgbClr val="3F3F3F"/>
-                          </a:solidFill>
-                          <a:latin typeface="Encode Sans"/>
-                        </a:rPr>
-                        <a:t>+1.9%</a:t>
-                      </a:r>
-                    </a:p>
-                  </a:txBody>
-                  <a:tcPr marL="36576" marR="36576" marT="18288" marB="18288">
-                    <a:solidFill>
-                      <a:srgbClr val="FFFFFF"/>
-                    </a:solidFill>
-                  </a:tcPr>
-                </a:tc>
-                <a:tc>
-                  <a:txBody>
-                    <a:bodyPr/>
-                    <a:lstStyle/>
-                    <a:p>
-                      <a:pPr algn="r"/>
-                      <a:r>
-                        <a:rPr sz="1000">
-                          <a:solidFill>
-                            <a:srgbClr val="3F3F3F"/>
-                          </a:solidFill>
-                          <a:latin typeface="Encode Sans"/>
-                        </a:rPr>
-                        <a:t>+33.5%</a:t>
-                      </a:r>
-                    </a:p>
-                  </a:txBody>
-                  <a:tcPr marL="36576" marR="36576" marT="18288" marB="18288">
-                    <a:solidFill>
-                      <a:srgbClr val="FFFFFF"/>
-                    </a:solidFill>
-                  </a:tcPr>
-                </a:tc>
-              </a:tr>
-              <a:tr h="292608">
-                <a:tc>
-                  <a:txBody>
-                    <a:bodyPr/>
-                    <a:lstStyle/>
-                    <a:p>
-                      <a:pPr algn="l"/>
-                      <a:r>
-                        <a:rPr sz="1000">
-                          <a:solidFill>
-                            <a:srgbClr val="3F3F3F"/>
-                          </a:solidFill>
-                          <a:latin typeface="Encode Sans"/>
-                        </a:rPr>
-                        <a:t>Mayo 2026</a:t>
-                      </a:r>
-                    </a:p>
-                  </a:txBody>
-                  <a:tcPr marL="36576" marR="36576" marT="18288" marB="18288">
-                    <a:solidFill>
-                      <a:srgbClr val="F8F8F6"/>
-                    </a:solidFill>
-                  </a:tcPr>
-                </a:tc>
-                <a:tc>
-                  <a:txBody>
-                    <a:bodyPr/>
-                    <a:lstStyle/>
-                    <a:p>
-                      <a:pPr algn="r"/>
-                      <a:r>
-                        <a:rPr sz="1000">
-                          <a:solidFill>
-                            <a:srgbClr val="3F3F3F"/>
-                          </a:solidFill>
-                          <a:latin typeface="Encode Sans"/>
-                        </a:rPr>
-                        <a:t>+2.1%</a:t>
-                      </a:r>
-                    </a:p>
-                  </a:txBody>
-                  <a:tcPr marL="36576" marR="36576" marT="18288" marB="18288">
-                    <a:solidFill>
-                      <a:srgbClr val="F8F8F6"/>
-                    </a:solidFill>
-                  </a:tcPr>
-                </a:tc>
-                <a:tc>
-                  <a:txBody>
-                    <a:bodyPr/>
-                    <a:lstStyle/>
-                    <a:p>
-                      <a:pPr algn="r"/>
-                      <a:r>
-                        <a:rPr sz="1000">
-                          <a:solidFill>
-                            <a:srgbClr val="3F3F3F"/>
-                          </a:solidFill>
-                          <a:latin typeface="Encode Sans"/>
-                        </a:rPr>
-                        <a:t>+33.2%</a:t>
-                      </a:r>
-                    </a:p>
-                  </a:txBody>
-                  <a:tcPr marL="36576" marR="36576" marT="18288" marB="18288">
-                    <a:solidFill>
-                      <a:srgbClr val="F8F8F6"/>
-                    </a:solidFill>
-                  </a:tcPr>
-                </a:tc>
-              </a:tr>
-              <a:tr h="292608">
-                <a:tc>
-                  <a:txBody>
-                    <a:bodyPr/>
-                    <a:lstStyle/>
-                    <a:p>
-                      <a:pPr algn="l"/>
-                      <a:r>
-                        <a:rPr sz="1000">
-                          <a:solidFill>
-                            <a:srgbClr val="3F3F3F"/>
-                          </a:solidFill>
-                          <a:latin typeface="Encode Sans"/>
-                        </a:rPr>
-                        <a:t>Abril 2026</a:t>
-                      </a:r>
-                    </a:p>
-                  </a:txBody>
-                  <a:tcPr marL="36576" marR="36576" marT="18288" marB="18288">
-                    <a:solidFill>
-                      <a:srgbClr val="FFFFFF"/>
-                    </a:solidFill>
-                  </a:tcPr>
-                </a:tc>
-                <a:tc>
-                  <a:txBody>
-                    <a:bodyPr/>
-                    <a:lstStyle/>
-                    <a:p>
-                      <a:pPr algn="r"/>
-                      <a:r>
-                        <a:rPr sz="1000">
-                          <a:solidFill>
-                            <a:srgbClr val="3F3F3F"/>
-                          </a:solidFill>
-                          <a:latin typeface="Encode Sans"/>
-                        </a:rPr>
-                        <a:t>+2.6%</a:t>
-                      </a:r>
-                    </a:p>
-                  </a:txBody>
-                  <a:tcPr marL="36576" marR="36576" marT="18288" marB="18288">
-                    <a:solidFill>
-                      <a:srgbClr val="FFFFFF"/>
-                    </a:solidFill>
-                  </a:tcPr>
-                </a:tc>
-                <a:tc>
-                  <a:txBody>
-                    <a:bodyPr/>
-                    <a:lstStyle/>
-                    <a:p>
-                      <a:pPr algn="r"/>
-                      <a:r>
-                        <a:rPr sz="1000">
-                          <a:solidFill>
-                            <a:srgbClr val="3F3F3F"/>
-                          </a:solidFill>
-                          <a:latin typeface="Encode Sans"/>
-                        </a:rPr>
-                        <a:t>+32.4%</a:t>
-                      </a:r>
-                    </a:p>
-                  </a:txBody>
-                  <a:tcPr marL="36576" marR="36576" marT="18288" marB="18288">
-                    <a:solidFill>
-                      <a:srgbClr val="FFFFFF"/>
-                    </a:solidFill>
-                  </a:tcPr>
-                </a:tc>
-              </a:tr>
-              <a:tr h="292608">
-                <a:tc>
-                  <a:txBody>
-                    <a:bodyPr/>
-                    <a:lstStyle/>
-                    <a:p>
-                      <a:pPr algn="l"/>
-                      <a:r>
-                        <a:rPr sz="1000">
-                          <a:solidFill>
-                            <a:srgbClr val="3F3F3F"/>
-                          </a:solidFill>
-                          <a:latin typeface="Encode Sans"/>
-                        </a:rPr>
-                        <a:t>Marzo 2026</a:t>
-                      </a:r>
-                    </a:p>
-                  </a:txBody>
-                  <a:tcPr marL="36576" marR="36576" marT="18288" marB="18288">
-                    <a:solidFill>
-                      <a:srgbClr val="F8F8F6"/>
-                    </a:solidFill>
-                  </a:tcPr>
-                </a:tc>
-                <a:tc>
-                  <a:txBody>
-                    <a:bodyPr/>
-                    <a:lstStyle/>
-                    <a:p>
-                      <a:pPr algn="r"/>
-                      <a:r>
-                        <a:rPr sz="1000">
-                          <a:solidFill>
-                            <a:srgbClr val="3F3F3F"/>
-                          </a:solidFill>
-                          <a:latin typeface="Encode Sans"/>
-                        </a:rPr>
-                        <a:t>+3.4%</a:t>
-                      </a:r>
-                    </a:p>
-                  </a:txBody>
-                  <a:tcPr marL="36576" marR="36576" marT="18288" marB="18288">
-                    <a:solidFill>
-                      <a:srgbClr val="F8F8F6"/>
-                    </a:solidFill>
-                  </a:tcPr>
-                </a:tc>
-                <a:tc>
-                  <a:txBody>
-                    <a:bodyPr/>
-                    <a:lstStyle/>
-                    <a:p>
-                      <a:pPr algn="r"/>
-                      <a:r>
-                        <a:rPr sz="1000">
-                          <a:solidFill>
-                            <a:srgbClr val="3F3F3F"/>
-                          </a:solidFill>
-                          <a:latin typeface="Encode Sans"/>
-                        </a:rPr>
-                        <a:t>+32.6%</a:t>
-                      </a:r>
-                    </a:p>
-                  </a:txBody>
-                  <a:tcPr marL="36576" marR="36576" marT="18288" marB="18288">
-                    <a:solidFill>
-                      <a:srgbClr val="F8F8F6"/>
-                    </a:solidFill>
-                  </a:tcPr>
-                </a:tc>
-              </a:tr>
-            </a:tbl>
-          </a:graphicData>
-        </a:graphic>
-      </p:graphicFrame>
-      <p:sp>
-        <p:nvSpPr>
-          <p:cNvPr id="9" name="TextBox 8"/>
-          <p:cNvSpPr txBox="1"/>
-          <p:nvPr/>
-        </p:nvSpPr>
-        <p:spPr>
-          <a:xfrm>
-            <a:off x="411480" y="6492240"/>
-            <a:ext cx="11368735" cy="274320"/>
-          </a:xfrm>
-          <a:prstGeom prst="rect">
-            <a:avLst/>
-          </a:prstGeom>
-          <a:noFill/>
-        </p:spPr>
-        <p:txBody>
-          <a:bodyPr wrap="none">
-            <a:spAutoFit/>
-          </a:bodyPr>
-          <a:lstStyle/>
-          <a:p>
-            <a:r>
-              <a:rPr sz="1000" b="0" i="1">
-                <a:solidFill>
-                  <a:srgbClr val="6A6760"/>
-                </a:solidFill>
-                <a:latin typeface="Encode Sans"/>
-              </a:rPr>
-              <a:t>Fuente: elaboración propia en base a INDEC</a:t>
-            </a:r>
-          </a:p>
-        </p:txBody>
-      </p:sp>
-    </p:spTree>
-  </p:cSld>
-  <p:clrMapOvr>
-    <a:masterClrMapping/>
-  </p:clrMapOvr>
-</p:sld>
-</file>
-
 <file path=ppt/theme/theme1.xml><?xml version="1.0" encoding="utf-8"?>
 <a:theme xmlns:a="http://schemas.openxmlformats.org/drawingml/2006/main" name="Office Theme">
   <a:themeElements>

</xml_diff>

<commit_message>
data: update 2026-09-16 ( data.json despidos.json scraper/historical_despidos.json publicaciones_semana.pptx rrii_brutas.xlsx)
</commit_message>
<xml_diff>
--- a/publicaciones_semana.pptx
+++ b/publicaciones_semana.pptx
@@ -7,6 +7,11 @@
   <p:sldIdLst>
     <p:sldId id="256" r:id="rId7"/>
     <p:sldId id="257" r:id="rId8"/>
+    <p:sldId id="258" r:id="rId9"/>
+    <p:sldId id="259" r:id="rId10"/>
+    <p:sldId id="260" r:id="rId11"/>
+    <p:sldId id="261" r:id="rId12"/>
+    <p:sldId id="262" r:id="rId13"/>
   </p:sldIdLst>
   <p:sldSz cx="12191695" cy="6858000" type="screen4x3"/>
   <p:notesSz cx="6858000" cy="9144000"/>
@@ -3272,7 +3277,7 @@
                 </a:solidFill>
                 <a:latin typeface="Encode Sans"/>
               </a:rPr>
-              <a:t>1 publicaciones · datos oficiales INDEC / BCRA / Hacienda</a:t>
+              <a:t>6 publicaciones · datos oficiales INDEC / BCRA / Hacienda</a:t>
             </a:r>
           </a:p>
         </p:txBody>
@@ -4049,6 +4054,4231 @@
                           <a:latin typeface="Encode Sans"/>
                         </a:rPr>
                         <a:t>-8.8%</a:t>
+                      </a:r>
+                    </a:p>
+                  </a:txBody>
+                  <a:tcPr marL="36576" marR="36576" marT="18288" marB="18288">
+                    <a:solidFill>
+                      <a:srgbClr val="F8F8F6"/>
+                    </a:solidFill>
+                  </a:tcPr>
+                </a:tc>
+              </a:tr>
+            </a:tbl>
+          </a:graphicData>
+        </a:graphic>
+      </p:graphicFrame>
+      <p:sp>
+        <p:nvSpPr>
+          <p:cNvPr id="9" name="TextBox 8"/>
+          <p:cNvSpPr txBox="1"/>
+          <p:nvPr/>
+        </p:nvSpPr>
+        <p:spPr>
+          <a:xfrm>
+            <a:off x="411480" y="6492240"/>
+            <a:ext cx="11368735" cy="274320"/>
+          </a:xfrm>
+          <a:prstGeom prst="rect">
+            <a:avLst/>
+          </a:prstGeom>
+          <a:noFill/>
+        </p:spPr>
+        <p:txBody>
+          <a:bodyPr wrap="none">
+            <a:spAutoFit/>
+          </a:bodyPr>
+          <a:lstStyle/>
+          <a:p>
+            <a:r>
+              <a:rPr sz="1000" b="0" i="1">
+                <a:solidFill>
+                  <a:srgbClr val="6A6760"/>
+                </a:solidFill>
+                <a:latin typeface="Encode Sans"/>
+              </a:rPr>
+              <a:t>Fuente: elaboración propia en base a INDEC</a:t>
+            </a:r>
+          </a:p>
+        </p:txBody>
+      </p:sp>
+    </p:spTree>
+  </p:cSld>
+  <p:clrMapOvr>
+    <a:masterClrMapping/>
+  </p:clrMapOvr>
+</p:sld>
+</file>
+
+<file path=ppt/slides/slide3.xml><?xml version="1.0" encoding="utf-8"?>
+<p:sld xmlns:a="http://schemas.openxmlformats.org/drawingml/2006/main" xmlns:p="http://schemas.openxmlformats.org/presentationml/2006/main" xmlns:r="http://schemas.openxmlformats.org/officeDocument/2006/relationships">
+  <p:cSld>
+    <p:spTree>
+      <p:nvGrpSpPr>
+        <p:cNvPr id="1" name=""/>
+        <p:cNvGrpSpPr/>
+        <p:nvPr/>
+      </p:nvGrpSpPr>
+      <p:grpSpPr/>
+      <p:sp>
+        <p:nvSpPr>
+          <p:cNvPr id="2" name="Rectangle 1"/>
+          <p:cNvSpPr/>
+          <p:nvPr/>
+        </p:nvSpPr>
+        <p:spPr>
+          <a:xfrm>
+            <a:off x="0" y="0"/>
+            <a:ext cx="12191695" cy="274320"/>
+          </a:xfrm>
+          <a:prstGeom prst="rect">
+            <a:avLst/>
+          </a:prstGeom>
+          <a:solidFill>
+            <a:srgbClr val="00B2C9"/>
+          </a:solidFill>
+          <a:ln>
+            <a:noFill/>
+          </a:ln>
+        </p:spPr>
+        <p:style>
+          <a:lnRef idx="1">
+            <a:schemeClr val="accent1"/>
+          </a:lnRef>
+          <a:fillRef idx="3">
+            <a:schemeClr val="accent1"/>
+          </a:fillRef>
+          <a:effectRef idx="2">
+            <a:schemeClr val="accent1"/>
+          </a:effectRef>
+          <a:fontRef idx="minor">
+            <a:schemeClr val="lt1"/>
+          </a:fontRef>
+        </p:style>
+        <p:txBody>
+          <a:bodyPr rtlCol="0" anchor="ctr"/>
+          <a:lstStyle/>
+          <a:p>
+            <a:pPr algn="ctr"/>
+          </a:p>
+        </p:txBody>
+      </p:sp>
+      <p:sp>
+        <p:nvSpPr>
+          <p:cNvPr id="3" name="TextBox 2"/>
+          <p:cNvSpPr txBox="1"/>
+          <p:nvPr/>
+        </p:nvSpPr>
+        <p:spPr>
+          <a:xfrm>
+            <a:off x="411480" y="457200"/>
+            <a:ext cx="11368735" cy="914400"/>
+          </a:xfrm>
+          <a:prstGeom prst="rect">
+            <a:avLst/>
+          </a:prstGeom>
+          <a:noFill/>
+        </p:spPr>
+        <p:txBody>
+          <a:bodyPr wrap="square" lIns="0" rIns="0">
+            <a:spAutoFit/>
+          </a:bodyPr>
+          <a:lstStyle/>
+          <a:p>
+            <a:pPr algn="l"/>
+            <a:r>
+              <a:rPr sz="2600" b="1" i="0">
+                <a:solidFill>
+                  <a:srgbClr val="00B2C9"/>
+                </a:solidFill>
+                <a:latin typeface="Encode Sans"/>
+              </a:rPr>
+              <a:t>IPIM MAYORISTA AGOSTO 2026: +2.14%</a:t>
+            </a:r>
+          </a:p>
+        </p:txBody>
+      </p:sp>
+      <p:sp>
+        <p:nvSpPr>
+          <p:cNvPr id="4" name="TextBox 3"/>
+          <p:cNvSpPr txBox="1"/>
+          <p:nvPr/>
+        </p:nvSpPr>
+        <p:spPr>
+          <a:xfrm>
+            <a:off x="411480" y="1280160"/>
+            <a:ext cx="11368735" cy="274320"/>
+          </a:xfrm>
+          <a:prstGeom prst="rect">
+            <a:avLst/>
+          </a:prstGeom>
+          <a:noFill/>
+        </p:spPr>
+        <p:txBody>
+          <a:bodyPr wrap="none">
+            <a:spAutoFit/>
+          </a:bodyPr>
+          <a:lstStyle/>
+          <a:p>
+            <a:r>
+              <a:rPr sz="1100" b="0" i="1">
+                <a:solidFill>
+                  <a:srgbClr val="6A6760"/>
+                </a:solidFill>
+                <a:latin typeface="Encode Sans"/>
+              </a:rPr>
+              <a:t>INDEC · período 2026-08</a:t>
+            </a:r>
+          </a:p>
+        </p:txBody>
+      </p:sp>
+      <p:sp>
+        <p:nvSpPr>
+          <p:cNvPr id="5" name="TextBox 4"/>
+          <p:cNvSpPr txBox="1"/>
+          <p:nvPr/>
+        </p:nvSpPr>
+        <p:spPr>
+          <a:xfrm>
+            <a:off x="411480" y="1691640"/>
+            <a:ext cx="5486400" cy="1645920"/>
+          </a:xfrm>
+          <a:prstGeom prst="rect">
+            <a:avLst/>
+          </a:prstGeom>
+          <a:noFill/>
+        </p:spPr>
+        <p:txBody>
+          <a:bodyPr wrap="square" lIns="0" rIns="0">
+            <a:spAutoFit/>
+          </a:bodyPr>
+          <a:lstStyle/>
+          <a:p>
+            <a:pPr algn="just"/>
+            <a:r>
+              <a:rPr sz="1300" b="0" i="0">
+                <a:solidFill>
+                  <a:srgbClr val="3F3F3F"/>
+                </a:solidFill>
+                <a:latin typeface="Encode Sans"/>
+              </a:rPr>
+              <a:t>El IPIM mayorista registró un aumento de +2.14% mensual en agosto 2026, acumulando 29.82% interanual. Suele anticipar el IPC minorista.</a:t>
+            </a:r>
+          </a:p>
+        </p:txBody>
+      </p:sp>
+      <p:sp>
+        <p:nvSpPr>
+          <p:cNvPr id="6" name="TextBox 5"/>
+          <p:cNvSpPr txBox="1"/>
+          <p:nvPr/>
+        </p:nvSpPr>
+        <p:spPr>
+          <a:xfrm>
+            <a:off x="411480" y="3520440"/>
+            <a:ext cx="5486400" cy="2743200"/>
+          </a:xfrm>
+          <a:prstGeom prst="rect">
+            <a:avLst/>
+          </a:prstGeom>
+          <a:noFill/>
+        </p:spPr>
+        <p:txBody>
+          <a:bodyPr wrap="square" lIns="0" rIns="0">
+            <a:spAutoFit/>
+          </a:bodyPr>
+          <a:lstStyle/>
+          <a:p>
+            <a:pPr algn="l">
+              <a:spcAft>
+                <a:spcPts val="800"/>
+              </a:spcAft>
+            </a:pPr>
+            <a:r>
+              <a:rPr sz="1300" b="1" i="0">
+                <a:solidFill>
+                  <a:srgbClr val="00B2C9"/>
+                </a:solidFill>
+                <a:latin typeface="Encode Sans"/>
+              </a:rPr>
+              <a:t>●  </a:t>
+            </a:r>
+            <a:r>
+              <a:rPr sz="1300" b="0" i="0">
+                <a:solidFill>
+                  <a:srgbClr val="3F3F3F"/>
+                </a:solidFill>
+                <a:latin typeface="Encode Sans"/>
+              </a:rPr>
+              <a:t>Nivel general: +2.14% mensual</a:t>
+            </a:r>
+          </a:p>
+          <a:p>
+            <a:pPr algn="l">
+              <a:spcAft>
+                <a:spcPts val="800"/>
+              </a:spcAft>
+            </a:pPr>
+            <a:r>
+              <a:rPr sz="1300" b="1" i="0">
+                <a:solidFill>
+                  <a:srgbClr val="00B2C9"/>
+                </a:solidFill>
+                <a:latin typeface="Encode Sans"/>
+              </a:rPr>
+              <a:t>●  </a:t>
+            </a:r>
+            <a:r>
+              <a:rPr sz="1300" b="0" i="0">
+                <a:solidFill>
+                  <a:srgbClr val="3F3F3F"/>
+                </a:solidFill>
+                <a:latin typeface="Encode Sans"/>
+              </a:rPr>
+              <a:t>Interanual: 29.82%</a:t>
+            </a:r>
+          </a:p>
+          <a:p>
+            <a:pPr algn="l">
+              <a:spcAft>
+                <a:spcPts val="800"/>
+              </a:spcAft>
+            </a:pPr>
+            <a:r>
+              <a:rPr sz="1300" b="1" i="0">
+                <a:solidFill>
+                  <a:srgbClr val="00B2C9"/>
+                </a:solidFill>
+                <a:latin typeface="Encode Sans"/>
+              </a:rPr>
+              <a:t>●  </a:t>
+            </a:r>
+            <a:r>
+              <a:rPr sz="1300" b="0" i="0">
+                <a:solidFill>
+                  <a:srgbClr val="3F3F3F"/>
+                </a:solidFill>
+                <a:latin typeface="Encode Sans"/>
+              </a:rPr>
+              <a:t>Brecha vs IPC minorista: +0.5% pp (IPC +1.7%)</a:t>
+            </a:r>
+          </a:p>
+        </p:txBody>
+      </p:sp>
+      <p:pic>
+        <p:nvPicPr>
+          <p:cNvPr id="7" name="Picture 6" descr="image.png"/>
+          <p:cNvPicPr>
+            <a:picLocks noChangeAspect="1"/>
+          </p:cNvPicPr>
+          <p:nvPr/>
+        </p:nvPicPr>
+        <p:blipFill>
+          <a:blip r:embed="rId2"/>
+          <a:stretch>
+            <a:fillRect/>
+          </a:stretch>
+        </p:blipFill>
+        <p:spPr>
+          <a:xfrm>
+            <a:off x="6080760" y="1691640"/>
+            <a:ext cx="5669280" cy="2560320"/>
+          </a:xfrm>
+          <a:prstGeom prst="rect">
+            <a:avLst/>
+          </a:prstGeom>
+        </p:spPr>
+      </p:pic>
+      <p:graphicFrame>
+        <p:nvGraphicFramePr>
+          <p:cNvPr id="8" name="Table 7"/>
+          <p:cNvGraphicFramePr>
+            <a:graphicFrameLocks noGrp="1"/>
+          </p:cNvGraphicFramePr>
+          <p:nvPr/>
+        </p:nvGraphicFramePr>
+        <p:xfrm>
+          <a:off x="6080760" y="4434840"/>
+          <a:ext cx="5669280" cy="2048256"/>
+        </p:xfrm>
+        <a:graphic>
+          <a:graphicData uri="http://schemas.openxmlformats.org/drawingml/2006/table">
+            <a:tbl>
+              <a:tblPr firstRow="1" bandRow="1">
+                <a:tableStyleId>{5C22544A-7EE6-4342-B048-85BDC9FD1C3A}</a:tableStyleId>
+              </a:tblPr>
+              <a:tblGrid>
+                <a:gridCol w="1889760"/>
+                <a:gridCol w="1889760"/>
+                <a:gridCol w="1889760"/>
+              </a:tblGrid>
+              <a:tr h="292608">
+                <a:tc>
+                  <a:txBody>
+                    <a:bodyPr/>
+                    <a:lstStyle/>
+                    <a:p>
+                      <a:pPr algn="l"/>
+                      <a:r>
+                        <a:rPr sz="1000" b="1">
+                          <a:solidFill>
+                            <a:srgbClr val="FFFFFF"/>
+                          </a:solidFill>
+                          <a:latin typeface="Encode Sans"/>
+                        </a:rPr>
+                        <a:t>Mes</a:t>
+                      </a:r>
+                    </a:p>
+                  </a:txBody>
+                  <a:tcPr marL="36576" marR="36576" marT="18288" marB="18288">
+                    <a:solidFill>
+                      <a:srgbClr val="00B2C9"/>
+                    </a:solidFill>
+                  </a:tcPr>
+                </a:tc>
+                <a:tc>
+                  <a:txBody>
+                    <a:bodyPr/>
+                    <a:lstStyle/>
+                    <a:p>
+                      <a:pPr algn="r"/>
+                      <a:r>
+                        <a:rPr sz="1000" b="1">
+                          <a:solidFill>
+                            <a:srgbClr val="FFFFFF"/>
+                          </a:solidFill>
+                          <a:latin typeface="Encode Sans"/>
+                        </a:rPr>
+                        <a:t>VM %</a:t>
+                      </a:r>
+                    </a:p>
+                  </a:txBody>
+                  <a:tcPr marL="36576" marR="36576" marT="18288" marB="18288">
+                    <a:solidFill>
+                      <a:srgbClr val="00B2C9"/>
+                    </a:solidFill>
+                  </a:tcPr>
+                </a:tc>
+                <a:tc>
+                  <a:txBody>
+                    <a:bodyPr/>
+                    <a:lstStyle/>
+                    <a:p>
+                      <a:pPr algn="r"/>
+                      <a:r>
+                        <a:rPr sz="1000" b="1">
+                          <a:solidFill>
+                            <a:srgbClr val="FFFFFF"/>
+                          </a:solidFill>
+                          <a:latin typeface="Encode Sans"/>
+                        </a:rPr>
+                        <a:t>VIA %</a:t>
+                      </a:r>
+                    </a:p>
+                  </a:txBody>
+                  <a:tcPr marL="36576" marR="36576" marT="18288" marB="18288">
+                    <a:solidFill>
+                      <a:srgbClr val="00B2C9"/>
+                    </a:solidFill>
+                  </a:tcPr>
+                </a:tc>
+              </a:tr>
+              <a:tr h="292608">
+                <a:tc>
+                  <a:txBody>
+                    <a:bodyPr/>
+                    <a:lstStyle/>
+                    <a:p>
+                      <a:pPr algn="l"/>
+                      <a:r>
+                        <a:rPr sz="1000">
+                          <a:solidFill>
+                            <a:srgbClr val="3F3F3F"/>
+                          </a:solidFill>
+                          <a:latin typeface="Encode Sans"/>
+                        </a:rPr>
+                        <a:t>Agosto 2026</a:t>
+                      </a:r>
+                    </a:p>
+                  </a:txBody>
+                  <a:tcPr marL="36576" marR="36576" marT="18288" marB="18288">
+                    <a:solidFill>
+                      <a:srgbClr val="FFFFFF"/>
+                    </a:solidFill>
+                  </a:tcPr>
+                </a:tc>
+                <a:tc>
+                  <a:txBody>
+                    <a:bodyPr/>
+                    <a:lstStyle/>
+                    <a:p>
+                      <a:pPr algn="r"/>
+                      <a:r>
+                        <a:rPr sz="1000">
+                          <a:solidFill>
+                            <a:srgbClr val="3F3F3F"/>
+                          </a:solidFill>
+                          <a:latin typeface="Encode Sans"/>
+                        </a:rPr>
+                        <a:t>+2.14%</a:t>
+                      </a:r>
+                    </a:p>
+                  </a:txBody>
+                  <a:tcPr marL="36576" marR="36576" marT="18288" marB="18288">
+                    <a:solidFill>
+                      <a:srgbClr val="FFFFFF"/>
+                    </a:solidFill>
+                  </a:tcPr>
+                </a:tc>
+                <a:tc>
+                  <a:txBody>
+                    <a:bodyPr/>
+                    <a:lstStyle/>
+                    <a:p>
+                      <a:pPr algn="r"/>
+                      <a:r>
+                        <a:rPr sz="1000">
+                          <a:solidFill>
+                            <a:srgbClr val="3F3F3F"/>
+                          </a:solidFill>
+                          <a:latin typeface="Encode Sans"/>
+                        </a:rPr>
+                        <a:t>+29.8%</a:t>
+                      </a:r>
+                    </a:p>
+                  </a:txBody>
+                  <a:tcPr marL="36576" marR="36576" marT="18288" marB="18288">
+                    <a:solidFill>
+                      <a:srgbClr val="FFFFFF"/>
+                    </a:solidFill>
+                  </a:tcPr>
+                </a:tc>
+              </a:tr>
+              <a:tr h="292608">
+                <a:tc>
+                  <a:txBody>
+                    <a:bodyPr/>
+                    <a:lstStyle/>
+                    <a:p>
+                      <a:pPr algn="l"/>
+                      <a:r>
+                        <a:rPr sz="1000">
+                          <a:solidFill>
+                            <a:srgbClr val="3F3F3F"/>
+                          </a:solidFill>
+                          <a:latin typeface="Encode Sans"/>
+                        </a:rPr>
+                        <a:t>Julio 2026</a:t>
+                      </a:r>
+                    </a:p>
+                  </a:txBody>
+                  <a:tcPr marL="36576" marR="36576" marT="18288" marB="18288">
+                    <a:solidFill>
+                      <a:srgbClr val="F8F8F6"/>
+                    </a:solidFill>
+                  </a:tcPr>
+                </a:tc>
+                <a:tc>
+                  <a:txBody>
+                    <a:bodyPr/>
+                    <a:lstStyle/>
+                    <a:p>
+                      <a:pPr algn="r"/>
+                      <a:r>
+                        <a:rPr sz="1000">
+                          <a:solidFill>
+                            <a:srgbClr val="3F3F3F"/>
+                          </a:solidFill>
+                          <a:latin typeface="Encode Sans"/>
+                        </a:rPr>
+                        <a:t>+0.80%</a:t>
+                      </a:r>
+                    </a:p>
+                  </a:txBody>
+                  <a:tcPr marL="36576" marR="36576" marT="18288" marB="18288">
+                    <a:solidFill>
+                      <a:srgbClr val="F8F8F6"/>
+                    </a:solidFill>
+                  </a:tcPr>
+                </a:tc>
+                <a:tc>
+                  <a:txBody>
+                    <a:bodyPr/>
+                    <a:lstStyle/>
+                    <a:p>
+                      <a:pPr algn="r"/>
+                      <a:r>
+                        <a:rPr sz="1000">
+                          <a:solidFill>
+                            <a:srgbClr val="3F3F3F"/>
+                          </a:solidFill>
+                          <a:latin typeface="Encode Sans"/>
+                        </a:rPr>
+                        <a:t>+31.1%</a:t>
+                      </a:r>
+                    </a:p>
+                  </a:txBody>
+                  <a:tcPr marL="36576" marR="36576" marT="18288" marB="18288">
+                    <a:solidFill>
+                      <a:srgbClr val="F8F8F6"/>
+                    </a:solidFill>
+                  </a:tcPr>
+                </a:tc>
+              </a:tr>
+              <a:tr h="292608">
+                <a:tc>
+                  <a:txBody>
+                    <a:bodyPr/>
+                    <a:lstStyle/>
+                    <a:p>
+                      <a:pPr algn="l"/>
+                      <a:r>
+                        <a:rPr sz="1000">
+                          <a:solidFill>
+                            <a:srgbClr val="3F3F3F"/>
+                          </a:solidFill>
+                          <a:latin typeface="Encode Sans"/>
+                        </a:rPr>
+                        <a:t>Junio 2026</a:t>
+                      </a:r>
+                    </a:p>
+                  </a:txBody>
+                  <a:tcPr marL="36576" marR="36576" marT="18288" marB="18288">
+                    <a:solidFill>
+                      <a:srgbClr val="FFFFFF"/>
+                    </a:solidFill>
+                  </a:tcPr>
+                </a:tc>
+                <a:tc>
+                  <a:txBody>
+                    <a:bodyPr/>
+                    <a:lstStyle/>
+                    <a:p>
+                      <a:pPr algn="r"/>
+                      <a:r>
+                        <a:rPr sz="1000">
+                          <a:solidFill>
+                            <a:srgbClr val="3F3F3F"/>
+                          </a:solidFill>
+                          <a:latin typeface="Encode Sans"/>
+                        </a:rPr>
+                        <a:t>+1.08%</a:t>
+                      </a:r>
+                    </a:p>
+                  </a:txBody>
+                  <a:tcPr marL="36576" marR="36576" marT="18288" marB="18288">
+                    <a:solidFill>
+                      <a:srgbClr val="FFFFFF"/>
+                    </a:solidFill>
+                  </a:tcPr>
+                </a:tc>
+                <a:tc>
+                  <a:txBody>
+                    <a:bodyPr/>
+                    <a:lstStyle/>
+                    <a:p>
+                      <a:pPr algn="r"/>
+                      <a:r>
+                        <a:rPr sz="1000">
+                          <a:solidFill>
+                            <a:srgbClr val="3F3F3F"/>
+                          </a:solidFill>
+                          <a:latin typeface="Encode Sans"/>
+                        </a:rPr>
+                        <a:t>+33.7%</a:t>
+                      </a:r>
+                    </a:p>
+                  </a:txBody>
+                  <a:tcPr marL="36576" marR="36576" marT="18288" marB="18288">
+                    <a:solidFill>
+                      <a:srgbClr val="FFFFFF"/>
+                    </a:solidFill>
+                  </a:tcPr>
+                </a:tc>
+              </a:tr>
+              <a:tr h="292608">
+                <a:tc>
+                  <a:txBody>
+                    <a:bodyPr/>
+                    <a:lstStyle/>
+                    <a:p>
+                      <a:pPr algn="l"/>
+                      <a:r>
+                        <a:rPr sz="1000">
+                          <a:solidFill>
+                            <a:srgbClr val="3F3F3F"/>
+                          </a:solidFill>
+                          <a:latin typeface="Encode Sans"/>
+                        </a:rPr>
+                        <a:t>Mayo 2026</a:t>
+                      </a:r>
+                    </a:p>
+                  </a:txBody>
+                  <a:tcPr marL="36576" marR="36576" marT="18288" marB="18288">
+                    <a:solidFill>
+                      <a:srgbClr val="F8F8F6"/>
+                    </a:solidFill>
+                  </a:tcPr>
+                </a:tc>
+                <a:tc>
+                  <a:txBody>
+                    <a:bodyPr/>
+                    <a:lstStyle/>
+                    <a:p>
+                      <a:pPr algn="r"/>
+                      <a:r>
+                        <a:rPr sz="1000">
+                          <a:solidFill>
+                            <a:srgbClr val="3F3F3F"/>
+                          </a:solidFill>
+                          <a:latin typeface="Encode Sans"/>
+                        </a:rPr>
+                        <a:t>+2.51%</a:t>
+                      </a:r>
+                    </a:p>
+                  </a:txBody>
+                  <a:tcPr marL="36576" marR="36576" marT="18288" marB="18288">
+                    <a:solidFill>
+                      <a:srgbClr val="F8F8F6"/>
+                    </a:solidFill>
+                  </a:tcPr>
+                </a:tc>
+                <a:tc>
+                  <a:txBody>
+                    <a:bodyPr/>
+                    <a:lstStyle/>
+                    <a:p>
+                      <a:pPr algn="r"/>
+                      <a:r>
+                        <a:rPr sz="1000">
+                          <a:solidFill>
+                            <a:srgbClr val="3F3F3F"/>
+                          </a:solidFill>
+                          <a:latin typeface="Encode Sans"/>
+                        </a:rPr>
+                        <a:t>+34.5%</a:t>
+                      </a:r>
+                    </a:p>
+                  </a:txBody>
+                  <a:tcPr marL="36576" marR="36576" marT="18288" marB="18288">
+                    <a:solidFill>
+                      <a:srgbClr val="F8F8F6"/>
+                    </a:solidFill>
+                  </a:tcPr>
+                </a:tc>
+              </a:tr>
+              <a:tr h="292608">
+                <a:tc>
+                  <a:txBody>
+                    <a:bodyPr/>
+                    <a:lstStyle/>
+                    <a:p>
+                      <a:pPr algn="l"/>
+                      <a:r>
+                        <a:rPr sz="1000">
+                          <a:solidFill>
+                            <a:srgbClr val="3F3F3F"/>
+                          </a:solidFill>
+                          <a:latin typeface="Encode Sans"/>
+                        </a:rPr>
+                        <a:t>Abril 2026</a:t>
+                      </a:r>
+                    </a:p>
+                  </a:txBody>
+                  <a:tcPr marL="36576" marR="36576" marT="18288" marB="18288">
+                    <a:solidFill>
+                      <a:srgbClr val="FFFFFF"/>
+                    </a:solidFill>
+                  </a:tcPr>
+                </a:tc>
+                <a:tc>
+                  <a:txBody>
+                    <a:bodyPr/>
+                    <a:lstStyle/>
+                    <a:p>
+                      <a:pPr algn="r"/>
+                      <a:r>
+                        <a:rPr sz="1000">
+                          <a:solidFill>
+                            <a:srgbClr val="3F3F3F"/>
+                          </a:solidFill>
+                          <a:latin typeface="Encode Sans"/>
+                        </a:rPr>
+                        <a:t>+5.16%</a:t>
+                      </a:r>
+                    </a:p>
+                  </a:txBody>
+                  <a:tcPr marL="36576" marR="36576" marT="18288" marB="18288">
+                    <a:solidFill>
+                      <a:srgbClr val="FFFFFF"/>
+                    </a:solidFill>
+                  </a:tcPr>
+                </a:tc>
+                <a:tc>
+                  <a:txBody>
+                    <a:bodyPr/>
+                    <a:lstStyle/>
+                    <a:p>
+                      <a:pPr algn="r"/>
+                      <a:r>
+                        <a:rPr sz="1000">
+                          <a:solidFill>
+                            <a:srgbClr val="3F3F3F"/>
+                          </a:solidFill>
+                          <a:latin typeface="Encode Sans"/>
+                        </a:rPr>
+                        <a:t>+30.8%</a:t>
+                      </a:r>
+                    </a:p>
+                  </a:txBody>
+                  <a:tcPr marL="36576" marR="36576" marT="18288" marB="18288">
+                    <a:solidFill>
+                      <a:srgbClr val="FFFFFF"/>
+                    </a:solidFill>
+                  </a:tcPr>
+                </a:tc>
+              </a:tr>
+              <a:tr h="292608">
+                <a:tc>
+                  <a:txBody>
+                    <a:bodyPr/>
+                    <a:lstStyle/>
+                    <a:p>
+                      <a:pPr algn="l"/>
+                      <a:r>
+                        <a:rPr sz="1000">
+                          <a:solidFill>
+                            <a:srgbClr val="3F3F3F"/>
+                          </a:solidFill>
+                          <a:latin typeface="Encode Sans"/>
+                        </a:rPr>
+                        <a:t>Marzo 2026</a:t>
+                      </a:r>
+                    </a:p>
+                  </a:txBody>
+                  <a:tcPr marL="36576" marR="36576" marT="18288" marB="18288">
+                    <a:solidFill>
+                      <a:srgbClr val="F8F8F6"/>
+                    </a:solidFill>
+                  </a:tcPr>
+                </a:tc>
+                <a:tc>
+                  <a:txBody>
+                    <a:bodyPr/>
+                    <a:lstStyle/>
+                    <a:p>
+                      <a:pPr algn="r"/>
+                      <a:r>
+                        <a:rPr sz="1000">
+                          <a:solidFill>
+                            <a:srgbClr val="3F3F3F"/>
+                          </a:solidFill>
+                          <a:latin typeface="Encode Sans"/>
+                        </a:rPr>
+                        <a:t>+3.38%</a:t>
+                      </a:r>
+                    </a:p>
+                  </a:txBody>
+                  <a:tcPr marL="36576" marR="36576" marT="18288" marB="18288">
+                    <a:solidFill>
+                      <a:srgbClr val="F8F8F6"/>
+                    </a:solidFill>
+                  </a:tcPr>
+                </a:tc>
+                <a:tc>
+                  <a:txBody>
+                    <a:bodyPr/>
+                    <a:lstStyle/>
+                    <a:p>
+                      <a:pPr algn="r"/>
+                      <a:r>
+                        <a:rPr sz="1000">
+                          <a:solidFill>
+                            <a:srgbClr val="3F3F3F"/>
+                          </a:solidFill>
+                          <a:latin typeface="Encode Sans"/>
+                        </a:rPr>
+                        <a:t>+27.9%</a:t>
+                      </a:r>
+                    </a:p>
+                  </a:txBody>
+                  <a:tcPr marL="36576" marR="36576" marT="18288" marB="18288">
+                    <a:solidFill>
+                      <a:srgbClr val="F8F8F6"/>
+                    </a:solidFill>
+                  </a:tcPr>
+                </a:tc>
+              </a:tr>
+            </a:tbl>
+          </a:graphicData>
+        </a:graphic>
+      </p:graphicFrame>
+      <p:sp>
+        <p:nvSpPr>
+          <p:cNvPr id="9" name="TextBox 8"/>
+          <p:cNvSpPr txBox="1"/>
+          <p:nvPr/>
+        </p:nvSpPr>
+        <p:spPr>
+          <a:xfrm>
+            <a:off x="411480" y="6492240"/>
+            <a:ext cx="11368735" cy="274320"/>
+          </a:xfrm>
+          <a:prstGeom prst="rect">
+            <a:avLst/>
+          </a:prstGeom>
+          <a:noFill/>
+        </p:spPr>
+        <p:txBody>
+          <a:bodyPr wrap="none">
+            <a:spAutoFit/>
+          </a:bodyPr>
+          <a:lstStyle/>
+          <a:p>
+            <a:r>
+              <a:rPr sz="1000" b="0" i="1">
+                <a:solidFill>
+                  <a:srgbClr val="6A6760"/>
+                </a:solidFill>
+                <a:latin typeface="Encode Sans"/>
+              </a:rPr>
+              <a:t>Fuente: elaboración propia en base a INDEC</a:t>
+            </a:r>
+          </a:p>
+        </p:txBody>
+      </p:sp>
+    </p:spTree>
+  </p:cSld>
+  <p:clrMapOvr>
+    <a:masterClrMapping/>
+  </p:clrMapOvr>
+</p:sld>
+</file>
+
+<file path=ppt/slides/slide4.xml><?xml version="1.0" encoding="utf-8"?>
+<p:sld xmlns:a="http://schemas.openxmlformats.org/drawingml/2006/main" xmlns:p="http://schemas.openxmlformats.org/presentationml/2006/main" xmlns:r="http://schemas.openxmlformats.org/officeDocument/2006/relationships">
+  <p:cSld>
+    <p:spTree>
+      <p:nvGrpSpPr>
+        <p:cNvPr id="1" name=""/>
+        <p:cNvGrpSpPr/>
+        <p:nvPr/>
+      </p:nvGrpSpPr>
+      <p:grpSpPr/>
+      <p:sp>
+        <p:nvSpPr>
+          <p:cNvPr id="2" name="Rectangle 1"/>
+          <p:cNvSpPr/>
+          <p:nvPr/>
+        </p:nvSpPr>
+        <p:spPr>
+          <a:xfrm>
+            <a:off x="0" y="0"/>
+            <a:ext cx="12191695" cy="274320"/>
+          </a:xfrm>
+          <a:prstGeom prst="rect">
+            <a:avLst/>
+          </a:prstGeom>
+          <a:solidFill>
+            <a:srgbClr val="00B2C9"/>
+          </a:solidFill>
+          <a:ln>
+            <a:noFill/>
+          </a:ln>
+        </p:spPr>
+        <p:style>
+          <a:lnRef idx="1">
+            <a:schemeClr val="accent1"/>
+          </a:lnRef>
+          <a:fillRef idx="3">
+            <a:schemeClr val="accent1"/>
+          </a:fillRef>
+          <a:effectRef idx="2">
+            <a:schemeClr val="accent1"/>
+          </a:effectRef>
+          <a:fontRef idx="minor">
+            <a:schemeClr val="lt1"/>
+          </a:fontRef>
+        </p:style>
+        <p:txBody>
+          <a:bodyPr rtlCol="0" anchor="ctr"/>
+          <a:lstStyle/>
+          <a:p>
+            <a:pPr algn="ctr"/>
+          </a:p>
+        </p:txBody>
+      </p:sp>
+      <p:sp>
+        <p:nvSpPr>
+          <p:cNvPr id="3" name="TextBox 2"/>
+          <p:cNvSpPr txBox="1"/>
+          <p:nvPr/>
+        </p:nvSpPr>
+        <p:spPr>
+          <a:xfrm>
+            <a:off x="411480" y="457200"/>
+            <a:ext cx="11368735" cy="914400"/>
+          </a:xfrm>
+          <a:prstGeom prst="rect">
+            <a:avLst/>
+          </a:prstGeom>
+          <a:noFill/>
+        </p:spPr>
+        <p:txBody>
+          <a:bodyPr wrap="square" lIns="0" rIns="0">
+            <a:spAutoFit/>
+          </a:bodyPr>
+          <a:lstStyle/>
+          <a:p>
+            <a:pPr algn="l"/>
+            <a:r>
+              <a:rPr sz="2600" b="1" i="0">
+                <a:solidFill>
+                  <a:srgbClr val="00B2C9"/>
+                </a:solidFill>
+                <a:latin typeface="Encode Sans"/>
+              </a:rPr>
+              <a:t>IPIB BÁSICOS JULIO 2026: +0.85%</a:t>
+            </a:r>
+          </a:p>
+        </p:txBody>
+      </p:sp>
+      <p:sp>
+        <p:nvSpPr>
+          <p:cNvPr id="4" name="TextBox 3"/>
+          <p:cNvSpPr txBox="1"/>
+          <p:nvPr/>
+        </p:nvSpPr>
+        <p:spPr>
+          <a:xfrm>
+            <a:off x="411480" y="1280160"/>
+            <a:ext cx="11368735" cy="274320"/>
+          </a:xfrm>
+          <a:prstGeom prst="rect">
+            <a:avLst/>
+          </a:prstGeom>
+          <a:noFill/>
+        </p:spPr>
+        <p:txBody>
+          <a:bodyPr wrap="none">
+            <a:spAutoFit/>
+          </a:bodyPr>
+          <a:lstStyle/>
+          <a:p>
+            <a:r>
+              <a:rPr sz="1100" b="0" i="1">
+                <a:solidFill>
+                  <a:srgbClr val="6A6760"/>
+                </a:solidFill>
+                <a:latin typeface="Encode Sans"/>
+              </a:rPr>
+              <a:t>INDEC · período 2026-07</a:t>
+            </a:r>
+          </a:p>
+        </p:txBody>
+      </p:sp>
+      <p:sp>
+        <p:nvSpPr>
+          <p:cNvPr id="5" name="TextBox 4"/>
+          <p:cNvSpPr txBox="1"/>
+          <p:nvPr/>
+        </p:nvSpPr>
+        <p:spPr>
+          <a:xfrm>
+            <a:off x="411480" y="1691640"/>
+            <a:ext cx="5486400" cy="1645920"/>
+          </a:xfrm>
+          <a:prstGeom prst="rect">
+            <a:avLst/>
+          </a:prstGeom>
+          <a:noFill/>
+        </p:spPr>
+        <p:txBody>
+          <a:bodyPr wrap="square" lIns="0" rIns="0">
+            <a:spAutoFit/>
+          </a:bodyPr>
+          <a:lstStyle/>
+          <a:p>
+            <a:pPr algn="just"/>
+            <a:r>
+              <a:rPr sz="1300" b="0" i="0">
+                <a:solidFill>
+                  <a:srgbClr val="3F3F3F"/>
+                </a:solidFill>
+                <a:latin typeface="Encode Sans"/>
+              </a:rPr>
+              <a:t>El IPIB básicos registró un aumento de +0.85% mensual en julio 2026, acumulando 30.18% interanual. Suele anticipar el IPC minorista.</a:t>
+            </a:r>
+          </a:p>
+        </p:txBody>
+      </p:sp>
+      <p:sp>
+        <p:nvSpPr>
+          <p:cNvPr id="6" name="TextBox 5"/>
+          <p:cNvSpPr txBox="1"/>
+          <p:nvPr/>
+        </p:nvSpPr>
+        <p:spPr>
+          <a:xfrm>
+            <a:off x="411480" y="3520440"/>
+            <a:ext cx="5486400" cy="2743200"/>
+          </a:xfrm>
+          <a:prstGeom prst="rect">
+            <a:avLst/>
+          </a:prstGeom>
+          <a:noFill/>
+        </p:spPr>
+        <p:txBody>
+          <a:bodyPr wrap="square" lIns="0" rIns="0">
+            <a:spAutoFit/>
+          </a:bodyPr>
+          <a:lstStyle/>
+          <a:p>
+            <a:pPr algn="l">
+              <a:spcAft>
+                <a:spcPts val="800"/>
+              </a:spcAft>
+            </a:pPr>
+            <a:r>
+              <a:rPr sz="1300" b="1" i="0">
+                <a:solidFill>
+                  <a:srgbClr val="00B2C9"/>
+                </a:solidFill>
+                <a:latin typeface="Encode Sans"/>
+              </a:rPr>
+              <a:t>●  </a:t>
+            </a:r>
+            <a:r>
+              <a:rPr sz="1300" b="0" i="0">
+                <a:solidFill>
+                  <a:srgbClr val="3F3F3F"/>
+                </a:solidFill>
+                <a:latin typeface="Encode Sans"/>
+              </a:rPr>
+              <a:t>Nivel general: +0.85% mensual</a:t>
+            </a:r>
+          </a:p>
+          <a:p>
+            <a:pPr algn="l">
+              <a:spcAft>
+                <a:spcPts val="800"/>
+              </a:spcAft>
+            </a:pPr>
+            <a:r>
+              <a:rPr sz="1300" b="1" i="0">
+                <a:solidFill>
+                  <a:srgbClr val="00B2C9"/>
+                </a:solidFill>
+                <a:latin typeface="Encode Sans"/>
+              </a:rPr>
+              <a:t>●  </a:t>
+            </a:r>
+            <a:r>
+              <a:rPr sz="1300" b="0" i="0">
+                <a:solidFill>
+                  <a:srgbClr val="3F3F3F"/>
+                </a:solidFill>
+                <a:latin typeface="Encode Sans"/>
+              </a:rPr>
+              <a:t>Interanual: 30.18%</a:t>
+            </a:r>
+          </a:p>
+          <a:p>
+            <a:pPr algn="l">
+              <a:spcAft>
+                <a:spcPts val="800"/>
+              </a:spcAft>
+            </a:pPr>
+            <a:r>
+              <a:rPr sz="1300" b="1" i="0">
+                <a:solidFill>
+                  <a:srgbClr val="00B2C9"/>
+                </a:solidFill>
+                <a:latin typeface="Encode Sans"/>
+              </a:rPr>
+              <a:t>●  </a:t>
+            </a:r>
+            <a:r>
+              <a:rPr sz="1300" b="0" i="0">
+                <a:solidFill>
+                  <a:srgbClr val="3F3F3F"/>
+                </a:solidFill>
+                <a:latin typeface="Encode Sans"/>
+              </a:rPr>
+              <a:t>Brecha vs IPC minorista: -1.3% pp (IPC +2.1%)</a:t>
+            </a:r>
+          </a:p>
+        </p:txBody>
+      </p:sp>
+      <p:pic>
+        <p:nvPicPr>
+          <p:cNvPr id="7" name="Picture 6" descr="image.png"/>
+          <p:cNvPicPr>
+            <a:picLocks noChangeAspect="1"/>
+          </p:cNvPicPr>
+          <p:nvPr/>
+        </p:nvPicPr>
+        <p:blipFill>
+          <a:blip r:embed="rId2"/>
+          <a:stretch>
+            <a:fillRect/>
+          </a:stretch>
+        </p:blipFill>
+        <p:spPr>
+          <a:xfrm>
+            <a:off x="6080760" y="1691640"/>
+            <a:ext cx="5669280" cy="2560320"/>
+          </a:xfrm>
+          <a:prstGeom prst="rect">
+            <a:avLst/>
+          </a:prstGeom>
+        </p:spPr>
+      </p:pic>
+      <p:graphicFrame>
+        <p:nvGraphicFramePr>
+          <p:cNvPr id="8" name="Table 7"/>
+          <p:cNvGraphicFramePr>
+            <a:graphicFrameLocks noGrp="1"/>
+          </p:cNvGraphicFramePr>
+          <p:nvPr/>
+        </p:nvGraphicFramePr>
+        <p:xfrm>
+          <a:off x="6080760" y="4434840"/>
+          <a:ext cx="5669280" cy="2048256"/>
+        </p:xfrm>
+        <a:graphic>
+          <a:graphicData uri="http://schemas.openxmlformats.org/drawingml/2006/table">
+            <a:tbl>
+              <a:tblPr firstRow="1" bandRow="1">
+                <a:tableStyleId>{5C22544A-7EE6-4342-B048-85BDC9FD1C3A}</a:tableStyleId>
+              </a:tblPr>
+              <a:tblGrid>
+                <a:gridCol w="1889760"/>
+                <a:gridCol w="1889760"/>
+                <a:gridCol w="1889760"/>
+              </a:tblGrid>
+              <a:tr h="292608">
+                <a:tc>
+                  <a:txBody>
+                    <a:bodyPr/>
+                    <a:lstStyle/>
+                    <a:p>
+                      <a:pPr algn="l"/>
+                      <a:r>
+                        <a:rPr sz="1000" b="1">
+                          <a:solidFill>
+                            <a:srgbClr val="FFFFFF"/>
+                          </a:solidFill>
+                          <a:latin typeface="Encode Sans"/>
+                        </a:rPr>
+                        <a:t>Mes</a:t>
+                      </a:r>
+                    </a:p>
+                  </a:txBody>
+                  <a:tcPr marL="36576" marR="36576" marT="18288" marB="18288">
+                    <a:solidFill>
+                      <a:srgbClr val="00B2C9"/>
+                    </a:solidFill>
+                  </a:tcPr>
+                </a:tc>
+                <a:tc>
+                  <a:txBody>
+                    <a:bodyPr/>
+                    <a:lstStyle/>
+                    <a:p>
+                      <a:pPr algn="r"/>
+                      <a:r>
+                        <a:rPr sz="1000" b="1">
+                          <a:solidFill>
+                            <a:srgbClr val="FFFFFF"/>
+                          </a:solidFill>
+                          <a:latin typeface="Encode Sans"/>
+                        </a:rPr>
+                        <a:t>VM %</a:t>
+                      </a:r>
+                    </a:p>
+                  </a:txBody>
+                  <a:tcPr marL="36576" marR="36576" marT="18288" marB="18288">
+                    <a:solidFill>
+                      <a:srgbClr val="00B2C9"/>
+                    </a:solidFill>
+                  </a:tcPr>
+                </a:tc>
+                <a:tc>
+                  <a:txBody>
+                    <a:bodyPr/>
+                    <a:lstStyle/>
+                    <a:p>
+                      <a:pPr algn="r"/>
+                      <a:r>
+                        <a:rPr sz="1000" b="1">
+                          <a:solidFill>
+                            <a:srgbClr val="FFFFFF"/>
+                          </a:solidFill>
+                          <a:latin typeface="Encode Sans"/>
+                        </a:rPr>
+                        <a:t>VIA %</a:t>
+                      </a:r>
+                    </a:p>
+                  </a:txBody>
+                  <a:tcPr marL="36576" marR="36576" marT="18288" marB="18288">
+                    <a:solidFill>
+                      <a:srgbClr val="00B2C9"/>
+                    </a:solidFill>
+                  </a:tcPr>
+                </a:tc>
+              </a:tr>
+              <a:tr h="292608">
+                <a:tc>
+                  <a:txBody>
+                    <a:bodyPr/>
+                    <a:lstStyle/>
+                    <a:p>
+                      <a:pPr algn="l"/>
+                      <a:r>
+                        <a:rPr sz="1000">
+                          <a:solidFill>
+                            <a:srgbClr val="3F3F3F"/>
+                          </a:solidFill>
+                          <a:latin typeface="Encode Sans"/>
+                        </a:rPr>
+                        <a:t>Agosto 2026</a:t>
+                      </a:r>
+                    </a:p>
+                  </a:txBody>
+                  <a:tcPr marL="36576" marR="36576" marT="18288" marB="18288">
+                    <a:solidFill>
+                      <a:srgbClr val="FFFFFF"/>
+                    </a:solidFill>
+                  </a:tcPr>
+                </a:tc>
+                <a:tc>
+                  <a:txBody>
+                    <a:bodyPr/>
+                    <a:lstStyle/>
+                    <a:p>
+                      <a:pPr algn="r"/>
+                      <a:r>
+                        <a:rPr sz="1000">
+                          <a:solidFill>
+                            <a:srgbClr val="3F3F3F"/>
+                          </a:solidFill>
+                          <a:latin typeface="Encode Sans"/>
+                        </a:rPr>
+                        <a:t>+2.27%</a:t>
+                      </a:r>
+                    </a:p>
+                  </a:txBody>
+                  <a:tcPr marL="36576" marR="36576" marT="18288" marB="18288">
+                    <a:solidFill>
+                      <a:srgbClr val="FFFFFF"/>
+                    </a:solidFill>
+                  </a:tcPr>
+                </a:tc>
+                <a:tc>
+                  <a:txBody>
+                    <a:bodyPr/>
+                    <a:lstStyle/>
+                    <a:p>
+                      <a:pPr algn="r"/>
+                      <a:r>
+                        <a:rPr sz="1000">
+                          <a:solidFill>
+                            <a:srgbClr val="3F3F3F"/>
+                          </a:solidFill>
+                          <a:latin typeface="Encode Sans"/>
+                        </a:rPr>
+                        <a:t>+28.9%</a:t>
+                      </a:r>
+                    </a:p>
+                  </a:txBody>
+                  <a:tcPr marL="36576" marR="36576" marT="18288" marB="18288">
+                    <a:solidFill>
+                      <a:srgbClr val="FFFFFF"/>
+                    </a:solidFill>
+                  </a:tcPr>
+                </a:tc>
+              </a:tr>
+              <a:tr h="292608">
+                <a:tc>
+                  <a:txBody>
+                    <a:bodyPr/>
+                    <a:lstStyle/>
+                    <a:p>
+                      <a:pPr algn="l"/>
+                      <a:r>
+                        <a:rPr sz="1000">
+                          <a:solidFill>
+                            <a:srgbClr val="3F3F3F"/>
+                          </a:solidFill>
+                          <a:latin typeface="Encode Sans"/>
+                        </a:rPr>
+                        <a:t>Julio 2026</a:t>
+                      </a:r>
+                    </a:p>
+                  </a:txBody>
+                  <a:tcPr marL="36576" marR="36576" marT="18288" marB="18288">
+                    <a:solidFill>
+                      <a:srgbClr val="F8F8F6"/>
+                    </a:solidFill>
+                  </a:tcPr>
+                </a:tc>
+                <a:tc>
+                  <a:txBody>
+                    <a:bodyPr/>
+                    <a:lstStyle/>
+                    <a:p>
+                      <a:pPr algn="r"/>
+                      <a:r>
+                        <a:rPr sz="1000">
+                          <a:solidFill>
+                            <a:srgbClr val="3F3F3F"/>
+                          </a:solidFill>
+                          <a:latin typeface="Encode Sans"/>
+                        </a:rPr>
+                        <a:t>+0.85%</a:t>
+                      </a:r>
+                    </a:p>
+                  </a:txBody>
+                  <a:tcPr marL="36576" marR="36576" marT="18288" marB="18288">
+                    <a:solidFill>
+                      <a:srgbClr val="F8F8F6"/>
+                    </a:solidFill>
+                  </a:tcPr>
+                </a:tc>
+                <a:tc>
+                  <a:txBody>
+                    <a:bodyPr/>
+                    <a:lstStyle/>
+                    <a:p>
+                      <a:pPr algn="r"/>
+                      <a:r>
+                        <a:rPr sz="1000">
+                          <a:solidFill>
+                            <a:srgbClr val="3F3F3F"/>
+                          </a:solidFill>
+                          <a:latin typeface="Encode Sans"/>
+                        </a:rPr>
+                        <a:t>+30.2%</a:t>
+                      </a:r>
+                    </a:p>
+                  </a:txBody>
+                  <a:tcPr marL="36576" marR="36576" marT="18288" marB="18288">
+                    <a:solidFill>
+                      <a:srgbClr val="F8F8F6"/>
+                    </a:solidFill>
+                  </a:tcPr>
+                </a:tc>
+              </a:tr>
+              <a:tr h="292608">
+                <a:tc>
+                  <a:txBody>
+                    <a:bodyPr/>
+                    <a:lstStyle/>
+                    <a:p>
+                      <a:pPr algn="l"/>
+                      <a:r>
+                        <a:rPr sz="1000">
+                          <a:solidFill>
+                            <a:srgbClr val="3F3F3F"/>
+                          </a:solidFill>
+                          <a:latin typeface="Encode Sans"/>
+                        </a:rPr>
+                        <a:t>Junio 2026</a:t>
+                      </a:r>
+                    </a:p>
+                  </a:txBody>
+                  <a:tcPr marL="36576" marR="36576" marT="18288" marB="18288">
+                    <a:solidFill>
+                      <a:srgbClr val="FFFFFF"/>
+                    </a:solidFill>
+                  </a:tcPr>
+                </a:tc>
+                <a:tc>
+                  <a:txBody>
+                    <a:bodyPr/>
+                    <a:lstStyle/>
+                    <a:p>
+                      <a:pPr algn="r"/>
+                      <a:r>
+                        <a:rPr sz="1000">
+                          <a:solidFill>
+                            <a:srgbClr val="3F3F3F"/>
+                          </a:solidFill>
+                          <a:latin typeface="Encode Sans"/>
+                        </a:rPr>
+                        <a:t>+1.15%</a:t>
+                      </a:r>
+                    </a:p>
+                  </a:txBody>
+                  <a:tcPr marL="36576" marR="36576" marT="18288" marB="18288">
+                    <a:solidFill>
+                      <a:srgbClr val="FFFFFF"/>
+                    </a:solidFill>
+                  </a:tcPr>
+                </a:tc>
+                <a:tc>
+                  <a:txBody>
+                    <a:bodyPr/>
+                    <a:lstStyle/>
+                    <a:p>
+                      <a:pPr algn="r"/>
+                      <a:r>
+                        <a:rPr sz="1000">
+                          <a:solidFill>
+                            <a:srgbClr val="3F3F3F"/>
+                          </a:solidFill>
+                          <a:latin typeface="Encode Sans"/>
+                        </a:rPr>
+                        <a:t>+33.0%</a:t>
+                      </a:r>
+                    </a:p>
+                  </a:txBody>
+                  <a:tcPr marL="36576" marR="36576" marT="18288" marB="18288">
+                    <a:solidFill>
+                      <a:srgbClr val="FFFFFF"/>
+                    </a:solidFill>
+                  </a:tcPr>
+                </a:tc>
+              </a:tr>
+              <a:tr h="292608">
+                <a:tc>
+                  <a:txBody>
+                    <a:bodyPr/>
+                    <a:lstStyle/>
+                    <a:p>
+                      <a:pPr algn="l"/>
+                      <a:r>
+                        <a:rPr sz="1000">
+                          <a:solidFill>
+                            <a:srgbClr val="3F3F3F"/>
+                          </a:solidFill>
+                          <a:latin typeface="Encode Sans"/>
+                        </a:rPr>
+                        <a:t>Mayo 2026</a:t>
+                      </a:r>
+                    </a:p>
+                  </a:txBody>
+                  <a:tcPr marL="36576" marR="36576" marT="18288" marB="18288">
+                    <a:solidFill>
+                      <a:srgbClr val="F8F8F6"/>
+                    </a:solidFill>
+                  </a:tcPr>
+                </a:tc>
+                <a:tc>
+                  <a:txBody>
+                    <a:bodyPr/>
+                    <a:lstStyle/>
+                    <a:p>
+                      <a:pPr algn="r"/>
+                      <a:r>
+                        <a:rPr sz="1000">
+                          <a:solidFill>
+                            <a:srgbClr val="3F3F3F"/>
+                          </a:solidFill>
+                          <a:latin typeface="Encode Sans"/>
+                        </a:rPr>
+                        <a:t>+2.68%</a:t>
+                      </a:r>
+                    </a:p>
+                  </a:txBody>
+                  <a:tcPr marL="36576" marR="36576" marT="18288" marB="18288">
+                    <a:solidFill>
+                      <a:srgbClr val="F8F8F6"/>
+                    </a:solidFill>
+                  </a:tcPr>
+                </a:tc>
+                <a:tc>
+                  <a:txBody>
+                    <a:bodyPr/>
+                    <a:lstStyle/>
+                    <a:p>
+                      <a:pPr algn="r"/>
+                      <a:r>
+                        <a:rPr sz="1000">
+                          <a:solidFill>
+                            <a:srgbClr val="3F3F3F"/>
+                          </a:solidFill>
+                          <a:latin typeface="Encode Sans"/>
+                        </a:rPr>
+                        <a:t>+33.5%</a:t>
+                      </a:r>
+                    </a:p>
+                  </a:txBody>
+                  <a:tcPr marL="36576" marR="36576" marT="18288" marB="18288">
+                    <a:solidFill>
+                      <a:srgbClr val="F8F8F6"/>
+                    </a:solidFill>
+                  </a:tcPr>
+                </a:tc>
+              </a:tr>
+              <a:tr h="292608">
+                <a:tc>
+                  <a:txBody>
+                    <a:bodyPr/>
+                    <a:lstStyle/>
+                    <a:p>
+                      <a:pPr algn="l"/>
+                      <a:r>
+                        <a:rPr sz="1000">
+                          <a:solidFill>
+                            <a:srgbClr val="3F3F3F"/>
+                          </a:solidFill>
+                          <a:latin typeface="Encode Sans"/>
+                        </a:rPr>
+                        <a:t>Abril 2026</a:t>
+                      </a:r>
+                    </a:p>
+                  </a:txBody>
+                  <a:tcPr marL="36576" marR="36576" marT="18288" marB="18288">
+                    <a:solidFill>
+                      <a:srgbClr val="FFFFFF"/>
+                    </a:solidFill>
+                  </a:tcPr>
+                </a:tc>
+                <a:tc>
+                  <a:txBody>
+                    <a:bodyPr/>
+                    <a:lstStyle/>
+                    <a:p>
+                      <a:pPr algn="r"/>
+                      <a:r>
+                        <a:rPr sz="1000">
+                          <a:solidFill>
+                            <a:srgbClr val="3F3F3F"/>
+                          </a:solidFill>
+                          <a:latin typeface="Encode Sans"/>
+                        </a:rPr>
+                        <a:t>+4.76%</a:t>
+                      </a:r>
+                    </a:p>
+                  </a:txBody>
+                  <a:tcPr marL="36576" marR="36576" marT="18288" marB="18288">
+                    <a:solidFill>
+                      <a:srgbClr val="FFFFFF"/>
+                    </a:solidFill>
+                  </a:tcPr>
+                </a:tc>
+                <a:tc>
+                  <a:txBody>
+                    <a:bodyPr/>
+                    <a:lstStyle/>
+                    <a:p>
+                      <a:pPr algn="r"/>
+                      <a:r>
+                        <a:rPr sz="1000">
+                          <a:solidFill>
+                            <a:srgbClr val="3F3F3F"/>
+                          </a:solidFill>
+                          <a:latin typeface="Encode Sans"/>
+                        </a:rPr>
+                        <a:t>+29.6%</a:t>
+                      </a:r>
+                    </a:p>
+                  </a:txBody>
+                  <a:tcPr marL="36576" marR="36576" marT="18288" marB="18288">
+                    <a:solidFill>
+                      <a:srgbClr val="FFFFFF"/>
+                    </a:solidFill>
+                  </a:tcPr>
+                </a:tc>
+              </a:tr>
+              <a:tr h="292608">
+                <a:tc>
+                  <a:txBody>
+                    <a:bodyPr/>
+                    <a:lstStyle/>
+                    <a:p>
+                      <a:pPr algn="l"/>
+                      <a:r>
+                        <a:rPr sz="1000">
+                          <a:solidFill>
+                            <a:srgbClr val="3F3F3F"/>
+                          </a:solidFill>
+                          <a:latin typeface="Encode Sans"/>
+                        </a:rPr>
+                        <a:t>Marzo 2026</a:t>
+                      </a:r>
+                    </a:p>
+                  </a:txBody>
+                  <a:tcPr marL="36576" marR="36576" marT="18288" marB="18288">
+                    <a:solidFill>
+                      <a:srgbClr val="F8F8F6"/>
+                    </a:solidFill>
+                  </a:tcPr>
+                </a:tc>
+                <a:tc>
+                  <a:txBody>
+                    <a:bodyPr/>
+                    <a:lstStyle/>
+                    <a:p>
+                      <a:pPr algn="r"/>
+                      <a:r>
+                        <a:rPr sz="1000">
+                          <a:solidFill>
+                            <a:srgbClr val="3F3F3F"/>
+                          </a:solidFill>
+                          <a:latin typeface="Encode Sans"/>
+                        </a:rPr>
+                        <a:t>+3.00%</a:t>
+                      </a:r>
+                    </a:p>
+                  </a:txBody>
+                  <a:tcPr marL="36576" marR="36576" marT="18288" marB="18288">
+                    <a:solidFill>
+                      <a:srgbClr val="F8F8F6"/>
+                    </a:solidFill>
+                  </a:tcPr>
+                </a:tc>
+                <a:tc>
+                  <a:txBody>
+                    <a:bodyPr/>
+                    <a:lstStyle/>
+                    <a:p>
+                      <a:pPr algn="r"/>
+                      <a:r>
+                        <a:rPr sz="1000">
+                          <a:solidFill>
+                            <a:srgbClr val="3F3F3F"/>
+                          </a:solidFill>
+                          <a:latin typeface="Encode Sans"/>
+                        </a:rPr>
+                        <a:t>+27.1%</a:t>
+                      </a:r>
+                    </a:p>
+                  </a:txBody>
+                  <a:tcPr marL="36576" marR="36576" marT="18288" marB="18288">
+                    <a:solidFill>
+                      <a:srgbClr val="F8F8F6"/>
+                    </a:solidFill>
+                  </a:tcPr>
+                </a:tc>
+              </a:tr>
+            </a:tbl>
+          </a:graphicData>
+        </a:graphic>
+      </p:graphicFrame>
+      <p:sp>
+        <p:nvSpPr>
+          <p:cNvPr id="9" name="TextBox 8"/>
+          <p:cNvSpPr txBox="1"/>
+          <p:nvPr/>
+        </p:nvSpPr>
+        <p:spPr>
+          <a:xfrm>
+            <a:off x="411480" y="6492240"/>
+            <a:ext cx="11368735" cy="274320"/>
+          </a:xfrm>
+          <a:prstGeom prst="rect">
+            <a:avLst/>
+          </a:prstGeom>
+          <a:noFill/>
+        </p:spPr>
+        <p:txBody>
+          <a:bodyPr wrap="none">
+            <a:spAutoFit/>
+          </a:bodyPr>
+          <a:lstStyle/>
+          <a:p>
+            <a:r>
+              <a:rPr sz="1000" b="0" i="1">
+                <a:solidFill>
+                  <a:srgbClr val="6A6760"/>
+                </a:solidFill>
+                <a:latin typeface="Encode Sans"/>
+              </a:rPr>
+              <a:t>Fuente: elaboración propia en base a INDEC</a:t>
+            </a:r>
+          </a:p>
+        </p:txBody>
+      </p:sp>
+    </p:spTree>
+  </p:cSld>
+  <p:clrMapOvr>
+    <a:masterClrMapping/>
+  </p:clrMapOvr>
+</p:sld>
+</file>
+
+<file path=ppt/slides/slide5.xml><?xml version="1.0" encoding="utf-8"?>
+<p:sld xmlns:a="http://schemas.openxmlformats.org/drawingml/2006/main" xmlns:p="http://schemas.openxmlformats.org/presentationml/2006/main" xmlns:r="http://schemas.openxmlformats.org/officeDocument/2006/relationships">
+  <p:cSld>
+    <p:spTree>
+      <p:nvGrpSpPr>
+        <p:cNvPr id="1" name=""/>
+        <p:cNvGrpSpPr/>
+        <p:nvPr/>
+      </p:nvGrpSpPr>
+      <p:grpSpPr/>
+      <p:sp>
+        <p:nvSpPr>
+          <p:cNvPr id="2" name="Rectangle 1"/>
+          <p:cNvSpPr/>
+          <p:nvPr/>
+        </p:nvSpPr>
+        <p:spPr>
+          <a:xfrm>
+            <a:off x="0" y="0"/>
+            <a:ext cx="12191695" cy="274320"/>
+          </a:xfrm>
+          <a:prstGeom prst="rect">
+            <a:avLst/>
+          </a:prstGeom>
+          <a:solidFill>
+            <a:srgbClr val="00B2C9"/>
+          </a:solidFill>
+          <a:ln>
+            <a:noFill/>
+          </a:ln>
+        </p:spPr>
+        <p:style>
+          <a:lnRef idx="1">
+            <a:schemeClr val="accent1"/>
+          </a:lnRef>
+          <a:fillRef idx="3">
+            <a:schemeClr val="accent1"/>
+          </a:fillRef>
+          <a:effectRef idx="2">
+            <a:schemeClr val="accent1"/>
+          </a:effectRef>
+          <a:fontRef idx="minor">
+            <a:schemeClr val="lt1"/>
+          </a:fontRef>
+        </p:style>
+        <p:txBody>
+          <a:bodyPr rtlCol="0" anchor="ctr"/>
+          <a:lstStyle/>
+          <a:p>
+            <a:pPr algn="ctr"/>
+          </a:p>
+        </p:txBody>
+      </p:sp>
+      <p:sp>
+        <p:nvSpPr>
+          <p:cNvPr id="3" name="TextBox 2"/>
+          <p:cNvSpPr txBox="1"/>
+          <p:nvPr/>
+        </p:nvSpPr>
+        <p:spPr>
+          <a:xfrm>
+            <a:off x="411480" y="457200"/>
+            <a:ext cx="11368735" cy="914400"/>
+          </a:xfrm>
+          <a:prstGeom prst="rect">
+            <a:avLst/>
+          </a:prstGeom>
+          <a:noFill/>
+        </p:spPr>
+        <p:txBody>
+          <a:bodyPr wrap="square" lIns="0" rIns="0">
+            <a:spAutoFit/>
+          </a:bodyPr>
+          <a:lstStyle/>
+          <a:p>
+            <a:pPr algn="l"/>
+            <a:r>
+              <a:rPr sz="2600" b="1" i="0">
+                <a:solidFill>
+                  <a:srgbClr val="00B2C9"/>
+                </a:solidFill>
+                <a:latin typeface="Encode Sans"/>
+              </a:rPr>
+              <a:t>IPIB BÁSICOS AGOSTO 2026: +2.27%</a:t>
+            </a:r>
+          </a:p>
+        </p:txBody>
+      </p:sp>
+      <p:sp>
+        <p:nvSpPr>
+          <p:cNvPr id="4" name="TextBox 3"/>
+          <p:cNvSpPr txBox="1"/>
+          <p:nvPr/>
+        </p:nvSpPr>
+        <p:spPr>
+          <a:xfrm>
+            <a:off x="411480" y="1280160"/>
+            <a:ext cx="11368735" cy="274320"/>
+          </a:xfrm>
+          <a:prstGeom prst="rect">
+            <a:avLst/>
+          </a:prstGeom>
+          <a:noFill/>
+        </p:spPr>
+        <p:txBody>
+          <a:bodyPr wrap="none">
+            <a:spAutoFit/>
+          </a:bodyPr>
+          <a:lstStyle/>
+          <a:p>
+            <a:r>
+              <a:rPr sz="1100" b="0" i="1">
+                <a:solidFill>
+                  <a:srgbClr val="6A6760"/>
+                </a:solidFill>
+                <a:latin typeface="Encode Sans"/>
+              </a:rPr>
+              <a:t>INDEC · período 2026-08</a:t>
+            </a:r>
+          </a:p>
+        </p:txBody>
+      </p:sp>
+      <p:sp>
+        <p:nvSpPr>
+          <p:cNvPr id="5" name="TextBox 4"/>
+          <p:cNvSpPr txBox="1"/>
+          <p:nvPr/>
+        </p:nvSpPr>
+        <p:spPr>
+          <a:xfrm>
+            <a:off x="411480" y="1691640"/>
+            <a:ext cx="5486400" cy="1645920"/>
+          </a:xfrm>
+          <a:prstGeom prst="rect">
+            <a:avLst/>
+          </a:prstGeom>
+          <a:noFill/>
+        </p:spPr>
+        <p:txBody>
+          <a:bodyPr wrap="square" lIns="0" rIns="0">
+            <a:spAutoFit/>
+          </a:bodyPr>
+          <a:lstStyle/>
+          <a:p>
+            <a:pPr algn="just"/>
+            <a:r>
+              <a:rPr sz="1300" b="0" i="0">
+                <a:solidFill>
+                  <a:srgbClr val="3F3F3F"/>
+                </a:solidFill>
+                <a:latin typeface="Encode Sans"/>
+              </a:rPr>
+              <a:t>El IPIB básicos registró un aumento de +2.27% mensual en agosto 2026, acumulando 28.86% interanual. Suele anticipar el IPC minorista.</a:t>
+            </a:r>
+          </a:p>
+        </p:txBody>
+      </p:sp>
+      <p:sp>
+        <p:nvSpPr>
+          <p:cNvPr id="6" name="TextBox 5"/>
+          <p:cNvSpPr txBox="1"/>
+          <p:nvPr/>
+        </p:nvSpPr>
+        <p:spPr>
+          <a:xfrm>
+            <a:off x="411480" y="3520440"/>
+            <a:ext cx="5486400" cy="2743200"/>
+          </a:xfrm>
+          <a:prstGeom prst="rect">
+            <a:avLst/>
+          </a:prstGeom>
+          <a:noFill/>
+        </p:spPr>
+        <p:txBody>
+          <a:bodyPr wrap="square" lIns="0" rIns="0">
+            <a:spAutoFit/>
+          </a:bodyPr>
+          <a:lstStyle/>
+          <a:p>
+            <a:pPr algn="l">
+              <a:spcAft>
+                <a:spcPts val="800"/>
+              </a:spcAft>
+            </a:pPr>
+            <a:r>
+              <a:rPr sz="1300" b="1" i="0">
+                <a:solidFill>
+                  <a:srgbClr val="00B2C9"/>
+                </a:solidFill>
+                <a:latin typeface="Encode Sans"/>
+              </a:rPr>
+              <a:t>●  </a:t>
+            </a:r>
+            <a:r>
+              <a:rPr sz="1300" b="0" i="0">
+                <a:solidFill>
+                  <a:srgbClr val="3F3F3F"/>
+                </a:solidFill>
+                <a:latin typeface="Encode Sans"/>
+              </a:rPr>
+              <a:t>Nivel general: +2.27% mensual</a:t>
+            </a:r>
+          </a:p>
+          <a:p>
+            <a:pPr algn="l">
+              <a:spcAft>
+                <a:spcPts val="800"/>
+              </a:spcAft>
+            </a:pPr>
+            <a:r>
+              <a:rPr sz="1300" b="1" i="0">
+                <a:solidFill>
+                  <a:srgbClr val="00B2C9"/>
+                </a:solidFill>
+                <a:latin typeface="Encode Sans"/>
+              </a:rPr>
+              <a:t>●  </a:t>
+            </a:r>
+            <a:r>
+              <a:rPr sz="1300" b="0" i="0">
+                <a:solidFill>
+                  <a:srgbClr val="3F3F3F"/>
+                </a:solidFill>
+                <a:latin typeface="Encode Sans"/>
+              </a:rPr>
+              <a:t>Interanual: 28.86%</a:t>
+            </a:r>
+          </a:p>
+          <a:p>
+            <a:pPr algn="l">
+              <a:spcAft>
+                <a:spcPts val="800"/>
+              </a:spcAft>
+            </a:pPr>
+            <a:r>
+              <a:rPr sz="1300" b="1" i="0">
+                <a:solidFill>
+                  <a:srgbClr val="00B2C9"/>
+                </a:solidFill>
+                <a:latin typeface="Encode Sans"/>
+              </a:rPr>
+              <a:t>●  </a:t>
+            </a:r>
+            <a:r>
+              <a:rPr sz="1300" b="0" i="0">
+                <a:solidFill>
+                  <a:srgbClr val="3F3F3F"/>
+                </a:solidFill>
+                <a:latin typeface="Encode Sans"/>
+              </a:rPr>
+              <a:t>Brecha vs IPC minorista: +0.6% pp (IPC +1.7%)</a:t>
+            </a:r>
+          </a:p>
+        </p:txBody>
+      </p:sp>
+      <p:pic>
+        <p:nvPicPr>
+          <p:cNvPr id="7" name="Picture 6" descr="image.png"/>
+          <p:cNvPicPr>
+            <a:picLocks noChangeAspect="1"/>
+          </p:cNvPicPr>
+          <p:nvPr/>
+        </p:nvPicPr>
+        <p:blipFill>
+          <a:blip r:embed="rId2"/>
+          <a:stretch>
+            <a:fillRect/>
+          </a:stretch>
+        </p:blipFill>
+        <p:spPr>
+          <a:xfrm>
+            <a:off x="6080760" y="1691640"/>
+            <a:ext cx="5669280" cy="2560320"/>
+          </a:xfrm>
+          <a:prstGeom prst="rect">
+            <a:avLst/>
+          </a:prstGeom>
+        </p:spPr>
+      </p:pic>
+      <p:graphicFrame>
+        <p:nvGraphicFramePr>
+          <p:cNvPr id="8" name="Table 7"/>
+          <p:cNvGraphicFramePr>
+            <a:graphicFrameLocks noGrp="1"/>
+          </p:cNvGraphicFramePr>
+          <p:nvPr/>
+        </p:nvGraphicFramePr>
+        <p:xfrm>
+          <a:off x="6080760" y="4434840"/>
+          <a:ext cx="5669280" cy="2048256"/>
+        </p:xfrm>
+        <a:graphic>
+          <a:graphicData uri="http://schemas.openxmlformats.org/drawingml/2006/table">
+            <a:tbl>
+              <a:tblPr firstRow="1" bandRow="1">
+                <a:tableStyleId>{5C22544A-7EE6-4342-B048-85BDC9FD1C3A}</a:tableStyleId>
+              </a:tblPr>
+              <a:tblGrid>
+                <a:gridCol w="1889760"/>
+                <a:gridCol w="1889760"/>
+                <a:gridCol w="1889760"/>
+              </a:tblGrid>
+              <a:tr h="292608">
+                <a:tc>
+                  <a:txBody>
+                    <a:bodyPr/>
+                    <a:lstStyle/>
+                    <a:p>
+                      <a:pPr algn="l"/>
+                      <a:r>
+                        <a:rPr sz="1000" b="1">
+                          <a:solidFill>
+                            <a:srgbClr val="FFFFFF"/>
+                          </a:solidFill>
+                          <a:latin typeface="Encode Sans"/>
+                        </a:rPr>
+                        <a:t>Mes</a:t>
+                      </a:r>
+                    </a:p>
+                  </a:txBody>
+                  <a:tcPr marL="36576" marR="36576" marT="18288" marB="18288">
+                    <a:solidFill>
+                      <a:srgbClr val="00B2C9"/>
+                    </a:solidFill>
+                  </a:tcPr>
+                </a:tc>
+                <a:tc>
+                  <a:txBody>
+                    <a:bodyPr/>
+                    <a:lstStyle/>
+                    <a:p>
+                      <a:pPr algn="r"/>
+                      <a:r>
+                        <a:rPr sz="1000" b="1">
+                          <a:solidFill>
+                            <a:srgbClr val="FFFFFF"/>
+                          </a:solidFill>
+                          <a:latin typeface="Encode Sans"/>
+                        </a:rPr>
+                        <a:t>VM %</a:t>
+                      </a:r>
+                    </a:p>
+                  </a:txBody>
+                  <a:tcPr marL="36576" marR="36576" marT="18288" marB="18288">
+                    <a:solidFill>
+                      <a:srgbClr val="00B2C9"/>
+                    </a:solidFill>
+                  </a:tcPr>
+                </a:tc>
+                <a:tc>
+                  <a:txBody>
+                    <a:bodyPr/>
+                    <a:lstStyle/>
+                    <a:p>
+                      <a:pPr algn="r"/>
+                      <a:r>
+                        <a:rPr sz="1000" b="1">
+                          <a:solidFill>
+                            <a:srgbClr val="FFFFFF"/>
+                          </a:solidFill>
+                          <a:latin typeface="Encode Sans"/>
+                        </a:rPr>
+                        <a:t>VIA %</a:t>
+                      </a:r>
+                    </a:p>
+                  </a:txBody>
+                  <a:tcPr marL="36576" marR="36576" marT="18288" marB="18288">
+                    <a:solidFill>
+                      <a:srgbClr val="00B2C9"/>
+                    </a:solidFill>
+                  </a:tcPr>
+                </a:tc>
+              </a:tr>
+              <a:tr h="292608">
+                <a:tc>
+                  <a:txBody>
+                    <a:bodyPr/>
+                    <a:lstStyle/>
+                    <a:p>
+                      <a:pPr algn="l"/>
+                      <a:r>
+                        <a:rPr sz="1000">
+                          <a:solidFill>
+                            <a:srgbClr val="3F3F3F"/>
+                          </a:solidFill>
+                          <a:latin typeface="Encode Sans"/>
+                        </a:rPr>
+                        <a:t>Agosto 2026</a:t>
+                      </a:r>
+                    </a:p>
+                  </a:txBody>
+                  <a:tcPr marL="36576" marR="36576" marT="18288" marB="18288">
+                    <a:solidFill>
+                      <a:srgbClr val="FFFFFF"/>
+                    </a:solidFill>
+                  </a:tcPr>
+                </a:tc>
+                <a:tc>
+                  <a:txBody>
+                    <a:bodyPr/>
+                    <a:lstStyle/>
+                    <a:p>
+                      <a:pPr algn="r"/>
+                      <a:r>
+                        <a:rPr sz="1000">
+                          <a:solidFill>
+                            <a:srgbClr val="3F3F3F"/>
+                          </a:solidFill>
+                          <a:latin typeface="Encode Sans"/>
+                        </a:rPr>
+                        <a:t>+2.27%</a:t>
+                      </a:r>
+                    </a:p>
+                  </a:txBody>
+                  <a:tcPr marL="36576" marR="36576" marT="18288" marB="18288">
+                    <a:solidFill>
+                      <a:srgbClr val="FFFFFF"/>
+                    </a:solidFill>
+                  </a:tcPr>
+                </a:tc>
+                <a:tc>
+                  <a:txBody>
+                    <a:bodyPr/>
+                    <a:lstStyle/>
+                    <a:p>
+                      <a:pPr algn="r"/>
+                      <a:r>
+                        <a:rPr sz="1000">
+                          <a:solidFill>
+                            <a:srgbClr val="3F3F3F"/>
+                          </a:solidFill>
+                          <a:latin typeface="Encode Sans"/>
+                        </a:rPr>
+                        <a:t>+28.9%</a:t>
+                      </a:r>
+                    </a:p>
+                  </a:txBody>
+                  <a:tcPr marL="36576" marR="36576" marT="18288" marB="18288">
+                    <a:solidFill>
+                      <a:srgbClr val="FFFFFF"/>
+                    </a:solidFill>
+                  </a:tcPr>
+                </a:tc>
+              </a:tr>
+              <a:tr h="292608">
+                <a:tc>
+                  <a:txBody>
+                    <a:bodyPr/>
+                    <a:lstStyle/>
+                    <a:p>
+                      <a:pPr algn="l"/>
+                      <a:r>
+                        <a:rPr sz="1000">
+                          <a:solidFill>
+                            <a:srgbClr val="3F3F3F"/>
+                          </a:solidFill>
+                          <a:latin typeface="Encode Sans"/>
+                        </a:rPr>
+                        <a:t>Julio 2026</a:t>
+                      </a:r>
+                    </a:p>
+                  </a:txBody>
+                  <a:tcPr marL="36576" marR="36576" marT="18288" marB="18288">
+                    <a:solidFill>
+                      <a:srgbClr val="F8F8F6"/>
+                    </a:solidFill>
+                  </a:tcPr>
+                </a:tc>
+                <a:tc>
+                  <a:txBody>
+                    <a:bodyPr/>
+                    <a:lstStyle/>
+                    <a:p>
+                      <a:pPr algn="r"/>
+                      <a:r>
+                        <a:rPr sz="1000">
+                          <a:solidFill>
+                            <a:srgbClr val="3F3F3F"/>
+                          </a:solidFill>
+                          <a:latin typeface="Encode Sans"/>
+                        </a:rPr>
+                        <a:t>+0.85%</a:t>
+                      </a:r>
+                    </a:p>
+                  </a:txBody>
+                  <a:tcPr marL="36576" marR="36576" marT="18288" marB="18288">
+                    <a:solidFill>
+                      <a:srgbClr val="F8F8F6"/>
+                    </a:solidFill>
+                  </a:tcPr>
+                </a:tc>
+                <a:tc>
+                  <a:txBody>
+                    <a:bodyPr/>
+                    <a:lstStyle/>
+                    <a:p>
+                      <a:pPr algn="r"/>
+                      <a:r>
+                        <a:rPr sz="1000">
+                          <a:solidFill>
+                            <a:srgbClr val="3F3F3F"/>
+                          </a:solidFill>
+                          <a:latin typeface="Encode Sans"/>
+                        </a:rPr>
+                        <a:t>+30.2%</a:t>
+                      </a:r>
+                    </a:p>
+                  </a:txBody>
+                  <a:tcPr marL="36576" marR="36576" marT="18288" marB="18288">
+                    <a:solidFill>
+                      <a:srgbClr val="F8F8F6"/>
+                    </a:solidFill>
+                  </a:tcPr>
+                </a:tc>
+              </a:tr>
+              <a:tr h="292608">
+                <a:tc>
+                  <a:txBody>
+                    <a:bodyPr/>
+                    <a:lstStyle/>
+                    <a:p>
+                      <a:pPr algn="l"/>
+                      <a:r>
+                        <a:rPr sz="1000">
+                          <a:solidFill>
+                            <a:srgbClr val="3F3F3F"/>
+                          </a:solidFill>
+                          <a:latin typeface="Encode Sans"/>
+                        </a:rPr>
+                        <a:t>Junio 2026</a:t>
+                      </a:r>
+                    </a:p>
+                  </a:txBody>
+                  <a:tcPr marL="36576" marR="36576" marT="18288" marB="18288">
+                    <a:solidFill>
+                      <a:srgbClr val="FFFFFF"/>
+                    </a:solidFill>
+                  </a:tcPr>
+                </a:tc>
+                <a:tc>
+                  <a:txBody>
+                    <a:bodyPr/>
+                    <a:lstStyle/>
+                    <a:p>
+                      <a:pPr algn="r"/>
+                      <a:r>
+                        <a:rPr sz="1000">
+                          <a:solidFill>
+                            <a:srgbClr val="3F3F3F"/>
+                          </a:solidFill>
+                          <a:latin typeface="Encode Sans"/>
+                        </a:rPr>
+                        <a:t>+1.15%</a:t>
+                      </a:r>
+                    </a:p>
+                  </a:txBody>
+                  <a:tcPr marL="36576" marR="36576" marT="18288" marB="18288">
+                    <a:solidFill>
+                      <a:srgbClr val="FFFFFF"/>
+                    </a:solidFill>
+                  </a:tcPr>
+                </a:tc>
+                <a:tc>
+                  <a:txBody>
+                    <a:bodyPr/>
+                    <a:lstStyle/>
+                    <a:p>
+                      <a:pPr algn="r"/>
+                      <a:r>
+                        <a:rPr sz="1000">
+                          <a:solidFill>
+                            <a:srgbClr val="3F3F3F"/>
+                          </a:solidFill>
+                          <a:latin typeface="Encode Sans"/>
+                        </a:rPr>
+                        <a:t>+33.0%</a:t>
+                      </a:r>
+                    </a:p>
+                  </a:txBody>
+                  <a:tcPr marL="36576" marR="36576" marT="18288" marB="18288">
+                    <a:solidFill>
+                      <a:srgbClr val="FFFFFF"/>
+                    </a:solidFill>
+                  </a:tcPr>
+                </a:tc>
+              </a:tr>
+              <a:tr h="292608">
+                <a:tc>
+                  <a:txBody>
+                    <a:bodyPr/>
+                    <a:lstStyle/>
+                    <a:p>
+                      <a:pPr algn="l"/>
+                      <a:r>
+                        <a:rPr sz="1000">
+                          <a:solidFill>
+                            <a:srgbClr val="3F3F3F"/>
+                          </a:solidFill>
+                          <a:latin typeface="Encode Sans"/>
+                        </a:rPr>
+                        <a:t>Mayo 2026</a:t>
+                      </a:r>
+                    </a:p>
+                  </a:txBody>
+                  <a:tcPr marL="36576" marR="36576" marT="18288" marB="18288">
+                    <a:solidFill>
+                      <a:srgbClr val="F8F8F6"/>
+                    </a:solidFill>
+                  </a:tcPr>
+                </a:tc>
+                <a:tc>
+                  <a:txBody>
+                    <a:bodyPr/>
+                    <a:lstStyle/>
+                    <a:p>
+                      <a:pPr algn="r"/>
+                      <a:r>
+                        <a:rPr sz="1000">
+                          <a:solidFill>
+                            <a:srgbClr val="3F3F3F"/>
+                          </a:solidFill>
+                          <a:latin typeface="Encode Sans"/>
+                        </a:rPr>
+                        <a:t>+2.68%</a:t>
+                      </a:r>
+                    </a:p>
+                  </a:txBody>
+                  <a:tcPr marL="36576" marR="36576" marT="18288" marB="18288">
+                    <a:solidFill>
+                      <a:srgbClr val="F8F8F6"/>
+                    </a:solidFill>
+                  </a:tcPr>
+                </a:tc>
+                <a:tc>
+                  <a:txBody>
+                    <a:bodyPr/>
+                    <a:lstStyle/>
+                    <a:p>
+                      <a:pPr algn="r"/>
+                      <a:r>
+                        <a:rPr sz="1000">
+                          <a:solidFill>
+                            <a:srgbClr val="3F3F3F"/>
+                          </a:solidFill>
+                          <a:latin typeface="Encode Sans"/>
+                        </a:rPr>
+                        <a:t>+33.5%</a:t>
+                      </a:r>
+                    </a:p>
+                  </a:txBody>
+                  <a:tcPr marL="36576" marR="36576" marT="18288" marB="18288">
+                    <a:solidFill>
+                      <a:srgbClr val="F8F8F6"/>
+                    </a:solidFill>
+                  </a:tcPr>
+                </a:tc>
+              </a:tr>
+              <a:tr h="292608">
+                <a:tc>
+                  <a:txBody>
+                    <a:bodyPr/>
+                    <a:lstStyle/>
+                    <a:p>
+                      <a:pPr algn="l"/>
+                      <a:r>
+                        <a:rPr sz="1000">
+                          <a:solidFill>
+                            <a:srgbClr val="3F3F3F"/>
+                          </a:solidFill>
+                          <a:latin typeface="Encode Sans"/>
+                        </a:rPr>
+                        <a:t>Abril 2026</a:t>
+                      </a:r>
+                    </a:p>
+                  </a:txBody>
+                  <a:tcPr marL="36576" marR="36576" marT="18288" marB="18288">
+                    <a:solidFill>
+                      <a:srgbClr val="FFFFFF"/>
+                    </a:solidFill>
+                  </a:tcPr>
+                </a:tc>
+                <a:tc>
+                  <a:txBody>
+                    <a:bodyPr/>
+                    <a:lstStyle/>
+                    <a:p>
+                      <a:pPr algn="r"/>
+                      <a:r>
+                        <a:rPr sz="1000">
+                          <a:solidFill>
+                            <a:srgbClr val="3F3F3F"/>
+                          </a:solidFill>
+                          <a:latin typeface="Encode Sans"/>
+                        </a:rPr>
+                        <a:t>+4.76%</a:t>
+                      </a:r>
+                    </a:p>
+                  </a:txBody>
+                  <a:tcPr marL="36576" marR="36576" marT="18288" marB="18288">
+                    <a:solidFill>
+                      <a:srgbClr val="FFFFFF"/>
+                    </a:solidFill>
+                  </a:tcPr>
+                </a:tc>
+                <a:tc>
+                  <a:txBody>
+                    <a:bodyPr/>
+                    <a:lstStyle/>
+                    <a:p>
+                      <a:pPr algn="r"/>
+                      <a:r>
+                        <a:rPr sz="1000">
+                          <a:solidFill>
+                            <a:srgbClr val="3F3F3F"/>
+                          </a:solidFill>
+                          <a:latin typeface="Encode Sans"/>
+                        </a:rPr>
+                        <a:t>+29.6%</a:t>
+                      </a:r>
+                    </a:p>
+                  </a:txBody>
+                  <a:tcPr marL="36576" marR="36576" marT="18288" marB="18288">
+                    <a:solidFill>
+                      <a:srgbClr val="FFFFFF"/>
+                    </a:solidFill>
+                  </a:tcPr>
+                </a:tc>
+              </a:tr>
+              <a:tr h="292608">
+                <a:tc>
+                  <a:txBody>
+                    <a:bodyPr/>
+                    <a:lstStyle/>
+                    <a:p>
+                      <a:pPr algn="l"/>
+                      <a:r>
+                        <a:rPr sz="1000">
+                          <a:solidFill>
+                            <a:srgbClr val="3F3F3F"/>
+                          </a:solidFill>
+                          <a:latin typeface="Encode Sans"/>
+                        </a:rPr>
+                        <a:t>Marzo 2026</a:t>
+                      </a:r>
+                    </a:p>
+                  </a:txBody>
+                  <a:tcPr marL="36576" marR="36576" marT="18288" marB="18288">
+                    <a:solidFill>
+                      <a:srgbClr val="F8F8F6"/>
+                    </a:solidFill>
+                  </a:tcPr>
+                </a:tc>
+                <a:tc>
+                  <a:txBody>
+                    <a:bodyPr/>
+                    <a:lstStyle/>
+                    <a:p>
+                      <a:pPr algn="r"/>
+                      <a:r>
+                        <a:rPr sz="1000">
+                          <a:solidFill>
+                            <a:srgbClr val="3F3F3F"/>
+                          </a:solidFill>
+                          <a:latin typeface="Encode Sans"/>
+                        </a:rPr>
+                        <a:t>+3.00%</a:t>
+                      </a:r>
+                    </a:p>
+                  </a:txBody>
+                  <a:tcPr marL="36576" marR="36576" marT="18288" marB="18288">
+                    <a:solidFill>
+                      <a:srgbClr val="F8F8F6"/>
+                    </a:solidFill>
+                  </a:tcPr>
+                </a:tc>
+                <a:tc>
+                  <a:txBody>
+                    <a:bodyPr/>
+                    <a:lstStyle/>
+                    <a:p>
+                      <a:pPr algn="r"/>
+                      <a:r>
+                        <a:rPr sz="1000">
+                          <a:solidFill>
+                            <a:srgbClr val="3F3F3F"/>
+                          </a:solidFill>
+                          <a:latin typeface="Encode Sans"/>
+                        </a:rPr>
+                        <a:t>+27.1%</a:t>
+                      </a:r>
+                    </a:p>
+                  </a:txBody>
+                  <a:tcPr marL="36576" marR="36576" marT="18288" marB="18288">
+                    <a:solidFill>
+                      <a:srgbClr val="F8F8F6"/>
+                    </a:solidFill>
+                  </a:tcPr>
+                </a:tc>
+              </a:tr>
+            </a:tbl>
+          </a:graphicData>
+        </a:graphic>
+      </p:graphicFrame>
+      <p:sp>
+        <p:nvSpPr>
+          <p:cNvPr id="9" name="TextBox 8"/>
+          <p:cNvSpPr txBox="1"/>
+          <p:nvPr/>
+        </p:nvSpPr>
+        <p:spPr>
+          <a:xfrm>
+            <a:off x="411480" y="6492240"/>
+            <a:ext cx="11368735" cy="274320"/>
+          </a:xfrm>
+          <a:prstGeom prst="rect">
+            <a:avLst/>
+          </a:prstGeom>
+          <a:noFill/>
+        </p:spPr>
+        <p:txBody>
+          <a:bodyPr wrap="none">
+            <a:spAutoFit/>
+          </a:bodyPr>
+          <a:lstStyle/>
+          <a:p>
+            <a:r>
+              <a:rPr sz="1000" b="0" i="1">
+                <a:solidFill>
+                  <a:srgbClr val="6A6760"/>
+                </a:solidFill>
+                <a:latin typeface="Encode Sans"/>
+              </a:rPr>
+              <a:t>Fuente: elaboración propia en base a INDEC</a:t>
+            </a:r>
+          </a:p>
+        </p:txBody>
+      </p:sp>
+    </p:spTree>
+  </p:cSld>
+  <p:clrMapOvr>
+    <a:masterClrMapping/>
+  </p:clrMapOvr>
+</p:sld>
+</file>
+
+<file path=ppt/slides/slide6.xml><?xml version="1.0" encoding="utf-8"?>
+<p:sld xmlns:a="http://schemas.openxmlformats.org/drawingml/2006/main" xmlns:p="http://schemas.openxmlformats.org/presentationml/2006/main" xmlns:r="http://schemas.openxmlformats.org/officeDocument/2006/relationships">
+  <p:cSld>
+    <p:spTree>
+      <p:nvGrpSpPr>
+        <p:cNvPr id="1" name=""/>
+        <p:cNvGrpSpPr/>
+        <p:nvPr/>
+      </p:nvGrpSpPr>
+      <p:grpSpPr/>
+      <p:sp>
+        <p:nvSpPr>
+          <p:cNvPr id="2" name="Rectangle 1"/>
+          <p:cNvSpPr/>
+          <p:nvPr/>
+        </p:nvSpPr>
+        <p:spPr>
+          <a:xfrm>
+            <a:off x="0" y="0"/>
+            <a:ext cx="12191695" cy="274320"/>
+          </a:xfrm>
+          <a:prstGeom prst="rect">
+            <a:avLst/>
+          </a:prstGeom>
+          <a:solidFill>
+            <a:srgbClr val="00B2C9"/>
+          </a:solidFill>
+          <a:ln>
+            <a:noFill/>
+          </a:ln>
+        </p:spPr>
+        <p:style>
+          <a:lnRef idx="1">
+            <a:schemeClr val="accent1"/>
+          </a:lnRef>
+          <a:fillRef idx="3">
+            <a:schemeClr val="accent1"/>
+          </a:fillRef>
+          <a:effectRef idx="2">
+            <a:schemeClr val="accent1"/>
+          </a:effectRef>
+          <a:fontRef idx="minor">
+            <a:schemeClr val="lt1"/>
+          </a:fontRef>
+        </p:style>
+        <p:txBody>
+          <a:bodyPr rtlCol="0" anchor="ctr"/>
+          <a:lstStyle/>
+          <a:p>
+            <a:pPr algn="ctr"/>
+          </a:p>
+        </p:txBody>
+      </p:sp>
+      <p:sp>
+        <p:nvSpPr>
+          <p:cNvPr id="3" name="TextBox 2"/>
+          <p:cNvSpPr txBox="1"/>
+          <p:nvPr/>
+        </p:nvSpPr>
+        <p:spPr>
+          <a:xfrm>
+            <a:off x="411480" y="457200"/>
+            <a:ext cx="11368735" cy="914400"/>
+          </a:xfrm>
+          <a:prstGeom prst="rect">
+            <a:avLst/>
+          </a:prstGeom>
+          <a:noFill/>
+        </p:spPr>
+        <p:txBody>
+          <a:bodyPr wrap="square" lIns="0" rIns="0">
+            <a:spAutoFit/>
+          </a:bodyPr>
+          <a:lstStyle/>
+          <a:p>
+            <a:pPr algn="l"/>
+            <a:r>
+              <a:rPr sz="2600" b="1" i="0">
+                <a:solidFill>
+                  <a:srgbClr val="00B2C9"/>
+                </a:solidFill>
+                <a:latin typeface="Encode Sans"/>
+              </a:rPr>
+              <a:t>IPP PRODUCTOR JULIO 2026: +0.89%</a:t>
+            </a:r>
+          </a:p>
+        </p:txBody>
+      </p:sp>
+      <p:sp>
+        <p:nvSpPr>
+          <p:cNvPr id="4" name="TextBox 3"/>
+          <p:cNvSpPr txBox="1"/>
+          <p:nvPr/>
+        </p:nvSpPr>
+        <p:spPr>
+          <a:xfrm>
+            <a:off x="411480" y="1280160"/>
+            <a:ext cx="11368735" cy="274320"/>
+          </a:xfrm>
+          <a:prstGeom prst="rect">
+            <a:avLst/>
+          </a:prstGeom>
+          <a:noFill/>
+        </p:spPr>
+        <p:txBody>
+          <a:bodyPr wrap="none">
+            <a:spAutoFit/>
+          </a:bodyPr>
+          <a:lstStyle/>
+          <a:p>
+            <a:r>
+              <a:rPr sz="1100" b="0" i="1">
+                <a:solidFill>
+                  <a:srgbClr val="6A6760"/>
+                </a:solidFill>
+                <a:latin typeface="Encode Sans"/>
+              </a:rPr>
+              <a:t>INDEC · período 2026-07</a:t>
+            </a:r>
+          </a:p>
+        </p:txBody>
+      </p:sp>
+      <p:sp>
+        <p:nvSpPr>
+          <p:cNvPr id="5" name="TextBox 4"/>
+          <p:cNvSpPr txBox="1"/>
+          <p:nvPr/>
+        </p:nvSpPr>
+        <p:spPr>
+          <a:xfrm>
+            <a:off x="411480" y="1691640"/>
+            <a:ext cx="5486400" cy="1645920"/>
+          </a:xfrm>
+          <a:prstGeom prst="rect">
+            <a:avLst/>
+          </a:prstGeom>
+          <a:noFill/>
+        </p:spPr>
+        <p:txBody>
+          <a:bodyPr wrap="square" lIns="0" rIns="0">
+            <a:spAutoFit/>
+          </a:bodyPr>
+          <a:lstStyle/>
+          <a:p>
+            <a:pPr algn="just"/>
+            <a:r>
+              <a:rPr sz="1300" b="0" i="0">
+                <a:solidFill>
+                  <a:srgbClr val="3F3F3F"/>
+                </a:solidFill>
+                <a:latin typeface="Encode Sans"/>
+              </a:rPr>
+              <a:t>El IPP productor registró un aumento de +0.89% mensual en julio 2026, acumulando 31.31% interanual. Suele anticipar el IPC minorista.</a:t>
+            </a:r>
+          </a:p>
+        </p:txBody>
+      </p:sp>
+      <p:sp>
+        <p:nvSpPr>
+          <p:cNvPr id="6" name="TextBox 5"/>
+          <p:cNvSpPr txBox="1"/>
+          <p:nvPr/>
+        </p:nvSpPr>
+        <p:spPr>
+          <a:xfrm>
+            <a:off x="411480" y="3520440"/>
+            <a:ext cx="5486400" cy="2743200"/>
+          </a:xfrm>
+          <a:prstGeom prst="rect">
+            <a:avLst/>
+          </a:prstGeom>
+          <a:noFill/>
+        </p:spPr>
+        <p:txBody>
+          <a:bodyPr wrap="square" lIns="0" rIns="0">
+            <a:spAutoFit/>
+          </a:bodyPr>
+          <a:lstStyle/>
+          <a:p>
+            <a:pPr algn="l">
+              <a:spcAft>
+                <a:spcPts val="800"/>
+              </a:spcAft>
+            </a:pPr>
+            <a:r>
+              <a:rPr sz="1300" b="1" i="0">
+                <a:solidFill>
+                  <a:srgbClr val="00B2C9"/>
+                </a:solidFill>
+                <a:latin typeface="Encode Sans"/>
+              </a:rPr>
+              <a:t>●  </a:t>
+            </a:r>
+            <a:r>
+              <a:rPr sz="1300" b="0" i="0">
+                <a:solidFill>
+                  <a:srgbClr val="3F3F3F"/>
+                </a:solidFill>
+                <a:latin typeface="Encode Sans"/>
+              </a:rPr>
+              <a:t>Nivel general: +0.89% mensual</a:t>
+            </a:r>
+          </a:p>
+          <a:p>
+            <a:pPr algn="l">
+              <a:spcAft>
+                <a:spcPts val="800"/>
+              </a:spcAft>
+            </a:pPr>
+            <a:r>
+              <a:rPr sz="1300" b="1" i="0">
+                <a:solidFill>
+                  <a:srgbClr val="00B2C9"/>
+                </a:solidFill>
+                <a:latin typeface="Encode Sans"/>
+              </a:rPr>
+              <a:t>●  </a:t>
+            </a:r>
+            <a:r>
+              <a:rPr sz="1300" b="0" i="0">
+                <a:solidFill>
+                  <a:srgbClr val="3F3F3F"/>
+                </a:solidFill>
+                <a:latin typeface="Encode Sans"/>
+              </a:rPr>
+              <a:t>Interanual: 31.31%</a:t>
+            </a:r>
+          </a:p>
+          <a:p>
+            <a:pPr algn="l">
+              <a:spcAft>
+                <a:spcPts val="800"/>
+              </a:spcAft>
+            </a:pPr>
+            <a:r>
+              <a:rPr sz="1300" b="1" i="0">
+                <a:solidFill>
+                  <a:srgbClr val="00B2C9"/>
+                </a:solidFill>
+                <a:latin typeface="Encode Sans"/>
+              </a:rPr>
+              <a:t>●  </a:t>
+            </a:r>
+            <a:r>
+              <a:rPr sz="1300" b="0" i="0">
+                <a:solidFill>
+                  <a:srgbClr val="3F3F3F"/>
+                </a:solidFill>
+                <a:latin typeface="Encode Sans"/>
+              </a:rPr>
+              <a:t>Brecha vs IPC minorista: -1.2% pp (IPC +2.1%)</a:t>
+            </a:r>
+          </a:p>
+        </p:txBody>
+      </p:sp>
+      <p:pic>
+        <p:nvPicPr>
+          <p:cNvPr id="7" name="Picture 6" descr="image.png"/>
+          <p:cNvPicPr>
+            <a:picLocks noChangeAspect="1"/>
+          </p:cNvPicPr>
+          <p:nvPr/>
+        </p:nvPicPr>
+        <p:blipFill>
+          <a:blip r:embed="rId2"/>
+          <a:stretch>
+            <a:fillRect/>
+          </a:stretch>
+        </p:blipFill>
+        <p:spPr>
+          <a:xfrm>
+            <a:off x="6080760" y="1691640"/>
+            <a:ext cx="5669280" cy="2560320"/>
+          </a:xfrm>
+          <a:prstGeom prst="rect">
+            <a:avLst/>
+          </a:prstGeom>
+        </p:spPr>
+      </p:pic>
+      <p:graphicFrame>
+        <p:nvGraphicFramePr>
+          <p:cNvPr id="8" name="Table 7"/>
+          <p:cNvGraphicFramePr>
+            <a:graphicFrameLocks noGrp="1"/>
+          </p:cNvGraphicFramePr>
+          <p:nvPr/>
+        </p:nvGraphicFramePr>
+        <p:xfrm>
+          <a:off x="6080760" y="4434840"/>
+          <a:ext cx="5669280" cy="2048256"/>
+        </p:xfrm>
+        <a:graphic>
+          <a:graphicData uri="http://schemas.openxmlformats.org/drawingml/2006/table">
+            <a:tbl>
+              <a:tblPr firstRow="1" bandRow="1">
+                <a:tableStyleId>{5C22544A-7EE6-4342-B048-85BDC9FD1C3A}</a:tableStyleId>
+              </a:tblPr>
+              <a:tblGrid>
+                <a:gridCol w="1889760"/>
+                <a:gridCol w="1889760"/>
+                <a:gridCol w="1889760"/>
+              </a:tblGrid>
+              <a:tr h="292608">
+                <a:tc>
+                  <a:txBody>
+                    <a:bodyPr/>
+                    <a:lstStyle/>
+                    <a:p>
+                      <a:pPr algn="l"/>
+                      <a:r>
+                        <a:rPr sz="1000" b="1">
+                          <a:solidFill>
+                            <a:srgbClr val="FFFFFF"/>
+                          </a:solidFill>
+                          <a:latin typeface="Encode Sans"/>
+                        </a:rPr>
+                        <a:t>Mes</a:t>
+                      </a:r>
+                    </a:p>
+                  </a:txBody>
+                  <a:tcPr marL="36576" marR="36576" marT="18288" marB="18288">
+                    <a:solidFill>
+                      <a:srgbClr val="00B2C9"/>
+                    </a:solidFill>
+                  </a:tcPr>
+                </a:tc>
+                <a:tc>
+                  <a:txBody>
+                    <a:bodyPr/>
+                    <a:lstStyle/>
+                    <a:p>
+                      <a:pPr algn="r"/>
+                      <a:r>
+                        <a:rPr sz="1000" b="1">
+                          <a:solidFill>
+                            <a:srgbClr val="FFFFFF"/>
+                          </a:solidFill>
+                          <a:latin typeface="Encode Sans"/>
+                        </a:rPr>
+                        <a:t>VM %</a:t>
+                      </a:r>
+                    </a:p>
+                  </a:txBody>
+                  <a:tcPr marL="36576" marR="36576" marT="18288" marB="18288">
+                    <a:solidFill>
+                      <a:srgbClr val="00B2C9"/>
+                    </a:solidFill>
+                  </a:tcPr>
+                </a:tc>
+                <a:tc>
+                  <a:txBody>
+                    <a:bodyPr/>
+                    <a:lstStyle/>
+                    <a:p>
+                      <a:pPr algn="r"/>
+                      <a:r>
+                        <a:rPr sz="1000" b="1">
+                          <a:solidFill>
+                            <a:srgbClr val="FFFFFF"/>
+                          </a:solidFill>
+                          <a:latin typeface="Encode Sans"/>
+                        </a:rPr>
+                        <a:t>VIA %</a:t>
+                      </a:r>
+                    </a:p>
+                  </a:txBody>
+                  <a:tcPr marL="36576" marR="36576" marT="18288" marB="18288">
+                    <a:solidFill>
+                      <a:srgbClr val="00B2C9"/>
+                    </a:solidFill>
+                  </a:tcPr>
+                </a:tc>
+              </a:tr>
+              <a:tr h="292608">
+                <a:tc>
+                  <a:txBody>
+                    <a:bodyPr/>
+                    <a:lstStyle/>
+                    <a:p>
+                      <a:pPr algn="l"/>
+                      <a:r>
+                        <a:rPr sz="1000">
+                          <a:solidFill>
+                            <a:srgbClr val="3F3F3F"/>
+                          </a:solidFill>
+                          <a:latin typeface="Encode Sans"/>
+                        </a:rPr>
+                        <a:t>Agosto 2026</a:t>
+                      </a:r>
+                    </a:p>
+                  </a:txBody>
+                  <a:tcPr marL="36576" marR="36576" marT="18288" marB="18288">
+                    <a:solidFill>
+                      <a:srgbClr val="FFFFFF"/>
+                    </a:solidFill>
+                  </a:tcPr>
+                </a:tc>
+                <a:tc>
+                  <a:txBody>
+                    <a:bodyPr/>
+                    <a:lstStyle/>
+                    <a:p>
+                      <a:pPr algn="r"/>
+                      <a:r>
+                        <a:rPr sz="1000">
+                          <a:solidFill>
+                            <a:srgbClr val="3F3F3F"/>
+                          </a:solidFill>
+                          <a:latin typeface="Encode Sans"/>
+                        </a:rPr>
+                        <a:t>+2.26%</a:t>
+                      </a:r>
+                    </a:p>
+                  </a:txBody>
+                  <a:tcPr marL="36576" marR="36576" marT="18288" marB="18288">
+                    <a:solidFill>
+                      <a:srgbClr val="FFFFFF"/>
+                    </a:solidFill>
+                  </a:tcPr>
+                </a:tc>
+                <a:tc>
+                  <a:txBody>
+                    <a:bodyPr/>
+                    <a:lstStyle/>
+                    <a:p>
+                      <a:pPr algn="r"/>
+                      <a:r>
+                        <a:rPr sz="1000">
+                          <a:solidFill>
+                            <a:srgbClr val="3F3F3F"/>
+                          </a:solidFill>
+                          <a:latin typeface="Encode Sans"/>
+                        </a:rPr>
+                        <a:t>+29.7%</a:t>
+                      </a:r>
+                    </a:p>
+                  </a:txBody>
+                  <a:tcPr marL="36576" marR="36576" marT="18288" marB="18288">
+                    <a:solidFill>
+                      <a:srgbClr val="FFFFFF"/>
+                    </a:solidFill>
+                  </a:tcPr>
+                </a:tc>
+              </a:tr>
+              <a:tr h="292608">
+                <a:tc>
+                  <a:txBody>
+                    <a:bodyPr/>
+                    <a:lstStyle/>
+                    <a:p>
+                      <a:pPr algn="l"/>
+                      <a:r>
+                        <a:rPr sz="1000">
+                          <a:solidFill>
+                            <a:srgbClr val="3F3F3F"/>
+                          </a:solidFill>
+                          <a:latin typeface="Encode Sans"/>
+                        </a:rPr>
+                        <a:t>Julio 2026</a:t>
+                      </a:r>
+                    </a:p>
+                  </a:txBody>
+                  <a:tcPr marL="36576" marR="36576" marT="18288" marB="18288">
+                    <a:solidFill>
+                      <a:srgbClr val="F8F8F6"/>
+                    </a:solidFill>
+                  </a:tcPr>
+                </a:tc>
+                <a:tc>
+                  <a:txBody>
+                    <a:bodyPr/>
+                    <a:lstStyle/>
+                    <a:p>
+                      <a:pPr algn="r"/>
+                      <a:r>
+                        <a:rPr sz="1000">
+                          <a:solidFill>
+                            <a:srgbClr val="3F3F3F"/>
+                          </a:solidFill>
+                          <a:latin typeface="Encode Sans"/>
+                        </a:rPr>
+                        <a:t>+0.89%</a:t>
+                      </a:r>
+                    </a:p>
+                  </a:txBody>
+                  <a:tcPr marL="36576" marR="36576" marT="18288" marB="18288">
+                    <a:solidFill>
+                      <a:srgbClr val="F8F8F6"/>
+                    </a:solidFill>
+                  </a:tcPr>
+                </a:tc>
+                <a:tc>
+                  <a:txBody>
+                    <a:bodyPr/>
+                    <a:lstStyle/>
+                    <a:p>
+                      <a:pPr algn="r"/>
+                      <a:r>
+                        <a:rPr sz="1000">
+                          <a:solidFill>
+                            <a:srgbClr val="3F3F3F"/>
+                          </a:solidFill>
+                          <a:latin typeface="Encode Sans"/>
+                        </a:rPr>
+                        <a:t>+31.3%</a:t>
+                      </a:r>
+                    </a:p>
+                  </a:txBody>
+                  <a:tcPr marL="36576" marR="36576" marT="18288" marB="18288">
+                    <a:solidFill>
+                      <a:srgbClr val="F8F8F6"/>
+                    </a:solidFill>
+                  </a:tcPr>
+                </a:tc>
+              </a:tr>
+              <a:tr h="292608">
+                <a:tc>
+                  <a:txBody>
+                    <a:bodyPr/>
+                    <a:lstStyle/>
+                    <a:p>
+                      <a:pPr algn="l"/>
+                      <a:r>
+                        <a:rPr sz="1000">
+                          <a:solidFill>
+                            <a:srgbClr val="3F3F3F"/>
+                          </a:solidFill>
+                          <a:latin typeface="Encode Sans"/>
+                        </a:rPr>
+                        <a:t>Junio 2026</a:t>
+                      </a:r>
+                    </a:p>
+                  </a:txBody>
+                  <a:tcPr marL="36576" marR="36576" marT="18288" marB="18288">
+                    <a:solidFill>
+                      <a:srgbClr val="FFFFFF"/>
+                    </a:solidFill>
+                  </a:tcPr>
+                </a:tc>
+                <a:tc>
+                  <a:txBody>
+                    <a:bodyPr/>
+                    <a:lstStyle/>
+                    <a:p>
+                      <a:pPr algn="r"/>
+                      <a:r>
+                        <a:rPr sz="1000">
+                          <a:solidFill>
+                            <a:srgbClr val="3F3F3F"/>
+                          </a:solidFill>
+                          <a:latin typeface="Encode Sans"/>
+                        </a:rPr>
+                        <a:t>+1.06%</a:t>
+                      </a:r>
+                    </a:p>
+                  </a:txBody>
+                  <a:tcPr marL="36576" marR="36576" marT="18288" marB="18288">
+                    <a:solidFill>
+                      <a:srgbClr val="FFFFFF"/>
+                    </a:solidFill>
+                  </a:tcPr>
+                </a:tc>
+                <a:tc>
+                  <a:txBody>
+                    <a:bodyPr/>
+                    <a:lstStyle/>
+                    <a:p>
+                      <a:pPr algn="r"/>
+                      <a:r>
+                        <a:rPr sz="1000">
+                          <a:solidFill>
+                            <a:srgbClr val="3F3F3F"/>
+                          </a:solidFill>
+                          <a:latin typeface="Encode Sans"/>
+                        </a:rPr>
+                        <a:t>+34.0%</a:t>
+                      </a:r>
+                    </a:p>
+                  </a:txBody>
+                  <a:tcPr marL="36576" marR="36576" marT="18288" marB="18288">
+                    <a:solidFill>
+                      <a:srgbClr val="FFFFFF"/>
+                    </a:solidFill>
+                  </a:tcPr>
+                </a:tc>
+              </a:tr>
+              <a:tr h="292608">
+                <a:tc>
+                  <a:txBody>
+                    <a:bodyPr/>
+                    <a:lstStyle/>
+                    <a:p>
+                      <a:pPr algn="l"/>
+                      <a:r>
+                        <a:rPr sz="1000">
+                          <a:solidFill>
+                            <a:srgbClr val="3F3F3F"/>
+                          </a:solidFill>
+                          <a:latin typeface="Encode Sans"/>
+                        </a:rPr>
+                        <a:t>Mayo 2026</a:t>
+                      </a:r>
+                    </a:p>
+                  </a:txBody>
+                  <a:tcPr marL="36576" marR="36576" marT="18288" marB="18288">
+                    <a:solidFill>
+                      <a:srgbClr val="F8F8F6"/>
+                    </a:solidFill>
+                  </a:tcPr>
+                </a:tc>
+                <a:tc>
+                  <a:txBody>
+                    <a:bodyPr/>
+                    <a:lstStyle/>
+                    <a:p>
+                      <a:pPr algn="r"/>
+                      <a:r>
+                        <a:rPr sz="1000">
+                          <a:solidFill>
+                            <a:srgbClr val="3F3F3F"/>
+                          </a:solidFill>
+                          <a:latin typeface="Encode Sans"/>
+                        </a:rPr>
+                        <a:t>+2.67%</a:t>
+                      </a:r>
+                    </a:p>
+                  </a:txBody>
+                  <a:tcPr marL="36576" marR="36576" marT="18288" marB="18288">
+                    <a:solidFill>
+                      <a:srgbClr val="F8F8F6"/>
+                    </a:solidFill>
+                  </a:tcPr>
+                </a:tc>
+                <a:tc>
+                  <a:txBody>
+                    <a:bodyPr/>
+                    <a:lstStyle/>
+                    <a:p>
+                      <a:pPr algn="r"/>
+                      <a:r>
+                        <a:rPr sz="1000">
+                          <a:solidFill>
+                            <a:srgbClr val="3F3F3F"/>
+                          </a:solidFill>
+                          <a:latin typeface="Encode Sans"/>
+                        </a:rPr>
+                        <a:t>+34.6%</a:t>
+                      </a:r>
+                    </a:p>
+                  </a:txBody>
+                  <a:tcPr marL="36576" marR="36576" marT="18288" marB="18288">
+                    <a:solidFill>
+                      <a:srgbClr val="F8F8F6"/>
+                    </a:solidFill>
+                  </a:tcPr>
+                </a:tc>
+              </a:tr>
+              <a:tr h="292608">
+                <a:tc>
+                  <a:txBody>
+                    <a:bodyPr/>
+                    <a:lstStyle/>
+                    <a:p>
+                      <a:pPr algn="l"/>
+                      <a:r>
+                        <a:rPr sz="1000">
+                          <a:solidFill>
+                            <a:srgbClr val="3F3F3F"/>
+                          </a:solidFill>
+                          <a:latin typeface="Encode Sans"/>
+                        </a:rPr>
+                        <a:t>Abril 2026</a:t>
+                      </a:r>
+                    </a:p>
+                  </a:txBody>
+                  <a:tcPr marL="36576" marR="36576" marT="18288" marB="18288">
+                    <a:solidFill>
+                      <a:srgbClr val="FFFFFF"/>
+                    </a:solidFill>
+                  </a:tcPr>
+                </a:tc>
+                <a:tc>
+                  <a:txBody>
+                    <a:bodyPr/>
+                    <a:lstStyle/>
+                    <a:p>
+                      <a:pPr algn="r"/>
+                      <a:r>
+                        <a:rPr sz="1000">
+                          <a:solidFill>
+                            <a:srgbClr val="3F3F3F"/>
+                          </a:solidFill>
+                          <a:latin typeface="Encode Sans"/>
+                        </a:rPr>
+                        <a:t>+4.79%</a:t>
+                      </a:r>
+                    </a:p>
+                  </a:txBody>
+                  <a:tcPr marL="36576" marR="36576" marT="18288" marB="18288">
+                    <a:solidFill>
+                      <a:srgbClr val="FFFFFF"/>
+                    </a:solidFill>
+                  </a:tcPr>
+                </a:tc>
+                <a:tc>
+                  <a:txBody>
+                    <a:bodyPr/>
+                    <a:lstStyle/>
+                    <a:p>
+                      <a:pPr algn="r"/>
+                      <a:r>
+                        <a:rPr sz="1000">
+                          <a:solidFill>
+                            <a:srgbClr val="3F3F3F"/>
+                          </a:solidFill>
+                          <a:latin typeface="Encode Sans"/>
+                        </a:rPr>
+                        <a:t>+30.9%</a:t>
+                      </a:r>
+                    </a:p>
+                  </a:txBody>
+                  <a:tcPr marL="36576" marR="36576" marT="18288" marB="18288">
+                    <a:solidFill>
+                      <a:srgbClr val="FFFFFF"/>
+                    </a:solidFill>
+                  </a:tcPr>
+                </a:tc>
+              </a:tr>
+              <a:tr h="292608">
+                <a:tc>
+                  <a:txBody>
+                    <a:bodyPr/>
+                    <a:lstStyle/>
+                    <a:p>
+                      <a:pPr algn="l"/>
+                      <a:r>
+                        <a:rPr sz="1000">
+                          <a:solidFill>
+                            <a:srgbClr val="3F3F3F"/>
+                          </a:solidFill>
+                          <a:latin typeface="Encode Sans"/>
+                        </a:rPr>
+                        <a:t>Marzo 2026</a:t>
+                      </a:r>
+                    </a:p>
+                  </a:txBody>
+                  <a:tcPr marL="36576" marR="36576" marT="18288" marB="18288">
+                    <a:solidFill>
+                      <a:srgbClr val="F8F8F6"/>
+                    </a:solidFill>
+                  </a:tcPr>
+                </a:tc>
+                <a:tc>
+                  <a:txBody>
+                    <a:bodyPr/>
+                    <a:lstStyle/>
+                    <a:p>
+                      <a:pPr algn="r"/>
+                      <a:r>
+                        <a:rPr sz="1000">
+                          <a:solidFill>
+                            <a:srgbClr val="3F3F3F"/>
+                          </a:solidFill>
+                          <a:latin typeface="Encode Sans"/>
+                        </a:rPr>
+                        <a:t>+2.95%</a:t>
+                      </a:r>
+                    </a:p>
+                  </a:txBody>
+                  <a:tcPr marL="36576" marR="36576" marT="18288" marB="18288">
+                    <a:solidFill>
+                      <a:srgbClr val="F8F8F6"/>
+                    </a:solidFill>
+                  </a:tcPr>
+                </a:tc>
+                <a:tc>
+                  <a:txBody>
+                    <a:bodyPr/>
+                    <a:lstStyle/>
+                    <a:p>
+                      <a:pPr algn="r"/>
+                      <a:r>
+                        <a:rPr sz="1000">
+                          <a:solidFill>
+                            <a:srgbClr val="3F3F3F"/>
+                          </a:solidFill>
+                          <a:latin typeface="Encode Sans"/>
+                        </a:rPr>
+                        <a:t>+28.1%</a:t>
+                      </a:r>
+                    </a:p>
+                  </a:txBody>
+                  <a:tcPr marL="36576" marR="36576" marT="18288" marB="18288">
+                    <a:solidFill>
+                      <a:srgbClr val="F8F8F6"/>
+                    </a:solidFill>
+                  </a:tcPr>
+                </a:tc>
+              </a:tr>
+            </a:tbl>
+          </a:graphicData>
+        </a:graphic>
+      </p:graphicFrame>
+      <p:sp>
+        <p:nvSpPr>
+          <p:cNvPr id="9" name="TextBox 8"/>
+          <p:cNvSpPr txBox="1"/>
+          <p:nvPr/>
+        </p:nvSpPr>
+        <p:spPr>
+          <a:xfrm>
+            <a:off x="411480" y="6492240"/>
+            <a:ext cx="11368735" cy="274320"/>
+          </a:xfrm>
+          <a:prstGeom prst="rect">
+            <a:avLst/>
+          </a:prstGeom>
+          <a:noFill/>
+        </p:spPr>
+        <p:txBody>
+          <a:bodyPr wrap="none">
+            <a:spAutoFit/>
+          </a:bodyPr>
+          <a:lstStyle/>
+          <a:p>
+            <a:r>
+              <a:rPr sz="1000" b="0" i="1">
+                <a:solidFill>
+                  <a:srgbClr val="6A6760"/>
+                </a:solidFill>
+                <a:latin typeface="Encode Sans"/>
+              </a:rPr>
+              <a:t>Fuente: elaboración propia en base a INDEC</a:t>
+            </a:r>
+          </a:p>
+        </p:txBody>
+      </p:sp>
+    </p:spTree>
+  </p:cSld>
+  <p:clrMapOvr>
+    <a:masterClrMapping/>
+  </p:clrMapOvr>
+</p:sld>
+</file>
+
+<file path=ppt/slides/slide7.xml><?xml version="1.0" encoding="utf-8"?>
+<p:sld xmlns:a="http://schemas.openxmlformats.org/drawingml/2006/main" xmlns:p="http://schemas.openxmlformats.org/presentationml/2006/main" xmlns:r="http://schemas.openxmlformats.org/officeDocument/2006/relationships">
+  <p:cSld>
+    <p:spTree>
+      <p:nvGrpSpPr>
+        <p:cNvPr id="1" name=""/>
+        <p:cNvGrpSpPr/>
+        <p:nvPr/>
+      </p:nvGrpSpPr>
+      <p:grpSpPr/>
+      <p:sp>
+        <p:nvSpPr>
+          <p:cNvPr id="2" name="Rectangle 1"/>
+          <p:cNvSpPr/>
+          <p:nvPr/>
+        </p:nvSpPr>
+        <p:spPr>
+          <a:xfrm>
+            <a:off x="0" y="0"/>
+            <a:ext cx="12191695" cy="274320"/>
+          </a:xfrm>
+          <a:prstGeom prst="rect">
+            <a:avLst/>
+          </a:prstGeom>
+          <a:solidFill>
+            <a:srgbClr val="00B2C9"/>
+          </a:solidFill>
+          <a:ln>
+            <a:noFill/>
+          </a:ln>
+        </p:spPr>
+        <p:style>
+          <a:lnRef idx="1">
+            <a:schemeClr val="accent1"/>
+          </a:lnRef>
+          <a:fillRef idx="3">
+            <a:schemeClr val="accent1"/>
+          </a:fillRef>
+          <a:effectRef idx="2">
+            <a:schemeClr val="accent1"/>
+          </a:effectRef>
+          <a:fontRef idx="minor">
+            <a:schemeClr val="lt1"/>
+          </a:fontRef>
+        </p:style>
+        <p:txBody>
+          <a:bodyPr rtlCol="0" anchor="ctr"/>
+          <a:lstStyle/>
+          <a:p>
+            <a:pPr algn="ctr"/>
+          </a:p>
+        </p:txBody>
+      </p:sp>
+      <p:sp>
+        <p:nvSpPr>
+          <p:cNvPr id="3" name="TextBox 2"/>
+          <p:cNvSpPr txBox="1"/>
+          <p:nvPr/>
+        </p:nvSpPr>
+        <p:spPr>
+          <a:xfrm>
+            <a:off x="411480" y="457200"/>
+            <a:ext cx="11368735" cy="914400"/>
+          </a:xfrm>
+          <a:prstGeom prst="rect">
+            <a:avLst/>
+          </a:prstGeom>
+          <a:noFill/>
+        </p:spPr>
+        <p:txBody>
+          <a:bodyPr wrap="square" lIns="0" rIns="0">
+            <a:spAutoFit/>
+          </a:bodyPr>
+          <a:lstStyle/>
+          <a:p>
+            <a:pPr algn="l"/>
+            <a:r>
+              <a:rPr sz="2600" b="1" i="0">
+                <a:solidFill>
+                  <a:srgbClr val="00B2C9"/>
+                </a:solidFill>
+                <a:latin typeface="Encode Sans"/>
+              </a:rPr>
+              <a:t>IPP PRODUCTOR AGOSTO 2026: +2.26%</a:t>
+            </a:r>
+          </a:p>
+        </p:txBody>
+      </p:sp>
+      <p:sp>
+        <p:nvSpPr>
+          <p:cNvPr id="4" name="TextBox 3"/>
+          <p:cNvSpPr txBox="1"/>
+          <p:nvPr/>
+        </p:nvSpPr>
+        <p:spPr>
+          <a:xfrm>
+            <a:off x="411480" y="1280160"/>
+            <a:ext cx="11368735" cy="274320"/>
+          </a:xfrm>
+          <a:prstGeom prst="rect">
+            <a:avLst/>
+          </a:prstGeom>
+          <a:noFill/>
+        </p:spPr>
+        <p:txBody>
+          <a:bodyPr wrap="none">
+            <a:spAutoFit/>
+          </a:bodyPr>
+          <a:lstStyle/>
+          <a:p>
+            <a:r>
+              <a:rPr sz="1100" b="0" i="1">
+                <a:solidFill>
+                  <a:srgbClr val="6A6760"/>
+                </a:solidFill>
+                <a:latin typeface="Encode Sans"/>
+              </a:rPr>
+              <a:t>INDEC · período 2026-08</a:t>
+            </a:r>
+          </a:p>
+        </p:txBody>
+      </p:sp>
+      <p:sp>
+        <p:nvSpPr>
+          <p:cNvPr id="5" name="TextBox 4"/>
+          <p:cNvSpPr txBox="1"/>
+          <p:nvPr/>
+        </p:nvSpPr>
+        <p:spPr>
+          <a:xfrm>
+            <a:off x="411480" y="1691640"/>
+            <a:ext cx="5486400" cy="1645920"/>
+          </a:xfrm>
+          <a:prstGeom prst="rect">
+            <a:avLst/>
+          </a:prstGeom>
+          <a:noFill/>
+        </p:spPr>
+        <p:txBody>
+          <a:bodyPr wrap="square" lIns="0" rIns="0">
+            <a:spAutoFit/>
+          </a:bodyPr>
+          <a:lstStyle/>
+          <a:p>
+            <a:pPr algn="just"/>
+            <a:r>
+              <a:rPr sz="1300" b="0" i="0">
+                <a:solidFill>
+                  <a:srgbClr val="3F3F3F"/>
+                </a:solidFill>
+                <a:latin typeface="Encode Sans"/>
+              </a:rPr>
+              <a:t>El IPP productor registró un aumento de +2.26% mensual en agosto 2026, acumulando 29.71% interanual. Suele anticipar el IPC minorista.</a:t>
+            </a:r>
+          </a:p>
+        </p:txBody>
+      </p:sp>
+      <p:sp>
+        <p:nvSpPr>
+          <p:cNvPr id="6" name="TextBox 5"/>
+          <p:cNvSpPr txBox="1"/>
+          <p:nvPr/>
+        </p:nvSpPr>
+        <p:spPr>
+          <a:xfrm>
+            <a:off x="411480" y="3520440"/>
+            <a:ext cx="5486400" cy="2743200"/>
+          </a:xfrm>
+          <a:prstGeom prst="rect">
+            <a:avLst/>
+          </a:prstGeom>
+          <a:noFill/>
+        </p:spPr>
+        <p:txBody>
+          <a:bodyPr wrap="square" lIns="0" rIns="0">
+            <a:spAutoFit/>
+          </a:bodyPr>
+          <a:lstStyle/>
+          <a:p>
+            <a:pPr algn="l">
+              <a:spcAft>
+                <a:spcPts val="800"/>
+              </a:spcAft>
+            </a:pPr>
+            <a:r>
+              <a:rPr sz="1300" b="1" i="0">
+                <a:solidFill>
+                  <a:srgbClr val="00B2C9"/>
+                </a:solidFill>
+                <a:latin typeface="Encode Sans"/>
+              </a:rPr>
+              <a:t>●  </a:t>
+            </a:r>
+            <a:r>
+              <a:rPr sz="1300" b="0" i="0">
+                <a:solidFill>
+                  <a:srgbClr val="3F3F3F"/>
+                </a:solidFill>
+                <a:latin typeface="Encode Sans"/>
+              </a:rPr>
+              <a:t>Nivel general: +2.26% mensual</a:t>
+            </a:r>
+          </a:p>
+          <a:p>
+            <a:pPr algn="l">
+              <a:spcAft>
+                <a:spcPts val="800"/>
+              </a:spcAft>
+            </a:pPr>
+            <a:r>
+              <a:rPr sz="1300" b="1" i="0">
+                <a:solidFill>
+                  <a:srgbClr val="00B2C9"/>
+                </a:solidFill>
+                <a:latin typeface="Encode Sans"/>
+              </a:rPr>
+              <a:t>●  </a:t>
+            </a:r>
+            <a:r>
+              <a:rPr sz="1300" b="0" i="0">
+                <a:solidFill>
+                  <a:srgbClr val="3F3F3F"/>
+                </a:solidFill>
+                <a:latin typeface="Encode Sans"/>
+              </a:rPr>
+              <a:t>Interanual: 29.71%</a:t>
+            </a:r>
+          </a:p>
+          <a:p>
+            <a:pPr algn="l">
+              <a:spcAft>
+                <a:spcPts val="800"/>
+              </a:spcAft>
+            </a:pPr>
+            <a:r>
+              <a:rPr sz="1300" b="1" i="0">
+                <a:solidFill>
+                  <a:srgbClr val="00B2C9"/>
+                </a:solidFill>
+                <a:latin typeface="Encode Sans"/>
+              </a:rPr>
+              <a:t>●  </a:t>
+            </a:r>
+            <a:r>
+              <a:rPr sz="1300" b="0" i="0">
+                <a:solidFill>
+                  <a:srgbClr val="3F3F3F"/>
+                </a:solidFill>
+                <a:latin typeface="Encode Sans"/>
+              </a:rPr>
+              <a:t>Brecha vs IPC minorista: +0.6% pp (IPC +1.7%)</a:t>
+            </a:r>
+          </a:p>
+        </p:txBody>
+      </p:sp>
+      <p:pic>
+        <p:nvPicPr>
+          <p:cNvPr id="7" name="Picture 6" descr="image.png"/>
+          <p:cNvPicPr>
+            <a:picLocks noChangeAspect="1"/>
+          </p:cNvPicPr>
+          <p:nvPr/>
+        </p:nvPicPr>
+        <p:blipFill>
+          <a:blip r:embed="rId2"/>
+          <a:stretch>
+            <a:fillRect/>
+          </a:stretch>
+        </p:blipFill>
+        <p:spPr>
+          <a:xfrm>
+            <a:off x="6080760" y="1691640"/>
+            <a:ext cx="5669280" cy="2560320"/>
+          </a:xfrm>
+          <a:prstGeom prst="rect">
+            <a:avLst/>
+          </a:prstGeom>
+        </p:spPr>
+      </p:pic>
+      <p:graphicFrame>
+        <p:nvGraphicFramePr>
+          <p:cNvPr id="8" name="Table 7"/>
+          <p:cNvGraphicFramePr>
+            <a:graphicFrameLocks noGrp="1"/>
+          </p:cNvGraphicFramePr>
+          <p:nvPr/>
+        </p:nvGraphicFramePr>
+        <p:xfrm>
+          <a:off x="6080760" y="4434840"/>
+          <a:ext cx="5669280" cy="2048256"/>
+        </p:xfrm>
+        <a:graphic>
+          <a:graphicData uri="http://schemas.openxmlformats.org/drawingml/2006/table">
+            <a:tbl>
+              <a:tblPr firstRow="1" bandRow="1">
+                <a:tableStyleId>{5C22544A-7EE6-4342-B048-85BDC9FD1C3A}</a:tableStyleId>
+              </a:tblPr>
+              <a:tblGrid>
+                <a:gridCol w="1889760"/>
+                <a:gridCol w="1889760"/>
+                <a:gridCol w="1889760"/>
+              </a:tblGrid>
+              <a:tr h="292608">
+                <a:tc>
+                  <a:txBody>
+                    <a:bodyPr/>
+                    <a:lstStyle/>
+                    <a:p>
+                      <a:pPr algn="l"/>
+                      <a:r>
+                        <a:rPr sz="1000" b="1">
+                          <a:solidFill>
+                            <a:srgbClr val="FFFFFF"/>
+                          </a:solidFill>
+                          <a:latin typeface="Encode Sans"/>
+                        </a:rPr>
+                        <a:t>Mes</a:t>
+                      </a:r>
+                    </a:p>
+                  </a:txBody>
+                  <a:tcPr marL="36576" marR="36576" marT="18288" marB="18288">
+                    <a:solidFill>
+                      <a:srgbClr val="00B2C9"/>
+                    </a:solidFill>
+                  </a:tcPr>
+                </a:tc>
+                <a:tc>
+                  <a:txBody>
+                    <a:bodyPr/>
+                    <a:lstStyle/>
+                    <a:p>
+                      <a:pPr algn="r"/>
+                      <a:r>
+                        <a:rPr sz="1000" b="1">
+                          <a:solidFill>
+                            <a:srgbClr val="FFFFFF"/>
+                          </a:solidFill>
+                          <a:latin typeface="Encode Sans"/>
+                        </a:rPr>
+                        <a:t>VM %</a:t>
+                      </a:r>
+                    </a:p>
+                  </a:txBody>
+                  <a:tcPr marL="36576" marR="36576" marT="18288" marB="18288">
+                    <a:solidFill>
+                      <a:srgbClr val="00B2C9"/>
+                    </a:solidFill>
+                  </a:tcPr>
+                </a:tc>
+                <a:tc>
+                  <a:txBody>
+                    <a:bodyPr/>
+                    <a:lstStyle/>
+                    <a:p>
+                      <a:pPr algn="r"/>
+                      <a:r>
+                        <a:rPr sz="1000" b="1">
+                          <a:solidFill>
+                            <a:srgbClr val="FFFFFF"/>
+                          </a:solidFill>
+                          <a:latin typeface="Encode Sans"/>
+                        </a:rPr>
+                        <a:t>VIA %</a:t>
+                      </a:r>
+                    </a:p>
+                  </a:txBody>
+                  <a:tcPr marL="36576" marR="36576" marT="18288" marB="18288">
+                    <a:solidFill>
+                      <a:srgbClr val="00B2C9"/>
+                    </a:solidFill>
+                  </a:tcPr>
+                </a:tc>
+              </a:tr>
+              <a:tr h="292608">
+                <a:tc>
+                  <a:txBody>
+                    <a:bodyPr/>
+                    <a:lstStyle/>
+                    <a:p>
+                      <a:pPr algn="l"/>
+                      <a:r>
+                        <a:rPr sz="1000">
+                          <a:solidFill>
+                            <a:srgbClr val="3F3F3F"/>
+                          </a:solidFill>
+                          <a:latin typeface="Encode Sans"/>
+                        </a:rPr>
+                        <a:t>Agosto 2026</a:t>
+                      </a:r>
+                    </a:p>
+                  </a:txBody>
+                  <a:tcPr marL="36576" marR="36576" marT="18288" marB="18288">
+                    <a:solidFill>
+                      <a:srgbClr val="FFFFFF"/>
+                    </a:solidFill>
+                  </a:tcPr>
+                </a:tc>
+                <a:tc>
+                  <a:txBody>
+                    <a:bodyPr/>
+                    <a:lstStyle/>
+                    <a:p>
+                      <a:pPr algn="r"/>
+                      <a:r>
+                        <a:rPr sz="1000">
+                          <a:solidFill>
+                            <a:srgbClr val="3F3F3F"/>
+                          </a:solidFill>
+                          <a:latin typeface="Encode Sans"/>
+                        </a:rPr>
+                        <a:t>+2.26%</a:t>
+                      </a:r>
+                    </a:p>
+                  </a:txBody>
+                  <a:tcPr marL="36576" marR="36576" marT="18288" marB="18288">
+                    <a:solidFill>
+                      <a:srgbClr val="FFFFFF"/>
+                    </a:solidFill>
+                  </a:tcPr>
+                </a:tc>
+                <a:tc>
+                  <a:txBody>
+                    <a:bodyPr/>
+                    <a:lstStyle/>
+                    <a:p>
+                      <a:pPr algn="r"/>
+                      <a:r>
+                        <a:rPr sz="1000">
+                          <a:solidFill>
+                            <a:srgbClr val="3F3F3F"/>
+                          </a:solidFill>
+                          <a:latin typeface="Encode Sans"/>
+                        </a:rPr>
+                        <a:t>+29.7%</a:t>
+                      </a:r>
+                    </a:p>
+                  </a:txBody>
+                  <a:tcPr marL="36576" marR="36576" marT="18288" marB="18288">
+                    <a:solidFill>
+                      <a:srgbClr val="FFFFFF"/>
+                    </a:solidFill>
+                  </a:tcPr>
+                </a:tc>
+              </a:tr>
+              <a:tr h="292608">
+                <a:tc>
+                  <a:txBody>
+                    <a:bodyPr/>
+                    <a:lstStyle/>
+                    <a:p>
+                      <a:pPr algn="l"/>
+                      <a:r>
+                        <a:rPr sz="1000">
+                          <a:solidFill>
+                            <a:srgbClr val="3F3F3F"/>
+                          </a:solidFill>
+                          <a:latin typeface="Encode Sans"/>
+                        </a:rPr>
+                        <a:t>Julio 2026</a:t>
+                      </a:r>
+                    </a:p>
+                  </a:txBody>
+                  <a:tcPr marL="36576" marR="36576" marT="18288" marB="18288">
+                    <a:solidFill>
+                      <a:srgbClr val="F8F8F6"/>
+                    </a:solidFill>
+                  </a:tcPr>
+                </a:tc>
+                <a:tc>
+                  <a:txBody>
+                    <a:bodyPr/>
+                    <a:lstStyle/>
+                    <a:p>
+                      <a:pPr algn="r"/>
+                      <a:r>
+                        <a:rPr sz="1000">
+                          <a:solidFill>
+                            <a:srgbClr val="3F3F3F"/>
+                          </a:solidFill>
+                          <a:latin typeface="Encode Sans"/>
+                        </a:rPr>
+                        <a:t>+0.89%</a:t>
+                      </a:r>
+                    </a:p>
+                  </a:txBody>
+                  <a:tcPr marL="36576" marR="36576" marT="18288" marB="18288">
+                    <a:solidFill>
+                      <a:srgbClr val="F8F8F6"/>
+                    </a:solidFill>
+                  </a:tcPr>
+                </a:tc>
+                <a:tc>
+                  <a:txBody>
+                    <a:bodyPr/>
+                    <a:lstStyle/>
+                    <a:p>
+                      <a:pPr algn="r"/>
+                      <a:r>
+                        <a:rPr sz="1000">
+                          <a:solidFill>
+                            <a:srgbClr val="3F3F3F"/>
+                          </a:solidFill>
+                          <a:latin typeface="Encode Sans"/>
+                        </a:rPr>
+                        <a:t>+31.3%</a:t>
+                      </a:r>
+                    </a:p>
+                  </a:txBody>
+                  <a:tcPr marL="36576" marR="36576" marT="18288" marB="18288">
+                    <a:solidFill>
+                      <a:srgbClr val="F8F8F6"/>
+                    </a:solidFill>
+                  </a:tcPr>
+                </a:tc>
+              </a:tr>
+              <a:tr h="292608">
+                <a:tc>
+                  <a:txBody>
+                    <a:bodyPr/>
+                    <a:lstStyle/>
+                    <a:p>
+                      <a:pPr algn="l"/>
+                      <a:r>
+                        <a:rPr sz="1000">
+                          <a:solidFill>
+                            <a:srgbClr val="3F3F3F"/>
+                          </a:solidFill>
+                          <a:latin typeface="Encode Sans"/>
+                        </a:rPr>
+                        <a:t>Junio 2026</a:t>
+                      </a:r>
+                    </a:p>
+                  </a:txBody>
+                  <a:tcPr marL="36576" marR="36576" marT="18288" marB="18288">
+                    <a:solidFill>
+                      <a:srgbClr val="FFFFFF"/>
+                    </a:solidFill>
+                  </a:tcPr>
+                </a:tc>
+                <a:tc>
+                  <a:txBody>
+                    <a:bodyPr/>
+                    <a:lstStyle/>
+                    <a:p>
+                      <a:pPr algn="r"/>
+                      <a:r>
+                        <a:rPr sz="1000">
+                          <a:solidFill>
+                            <a:srgbClr val="3F3F3F"/>
+                          </a:solidFill>
+                          <a:latin typeface="Encode Sans"/>
+                        </a:rPr>
+                        <a:t>+1.06%</a:t>
+                      </a:r>
+                    </a:p>
+                  </a:txBody>
+                  <a:tcPr marL="36576" marR="36576" marT="18288" marB="18288">
+                    <a:solidFill>
+                      <a:srgbClr val="FFFFFF"/>
+                    </a:solidFill>
+                  </a:tcPr>
+                </a:tc>
+                <a:tc>
+                  <a:txBody>
+                    <a:bodyPr/>
+                    <a:lstStyle/>
+                    <a:p>
+                      <a:pPr algn="r"/>
+                      <a:r>
+                        <a:rPr sz="1000">
+                          <a:solidFill>
+                            <a:srgbClr val="3F3F3F"/>
+                          </a:solidFill>
+                          <a:latin typeface="Encode Sans"/>
+                        </a:rPr>
+                        <a:t>+34.0%</a:t>
+                      </a:r>
+                    </a:p>
+                  </a:txBody>
+                  <a:tcPr marL="36576" marR="36576" marT="18288" marB="18288">
+                    <a:solidFill>
+                      <a:srgbClr val="FFFFFF"/>
+                    </a:solidFill>
+                  </a:tcPr>
+                </a:tc>
+              </a:tr>
+              <a:tr h="292608">
+                <a:tc>
+                  <a:txBody>
+                    <a:bodyPr/>
+                    <a:lstStyle/>
+                    <a:p>
+                      <a:pPr algn="l"/>
+                      <a:r>
+                        <a:rPr sz="1000">
+                          <a:solidFill>
+                            <a:srgbClr val="3F3F3F"/>
+                          </a:solidFill>
+                          <a:latin typeface="Encode Sans"/>
+                        </a:rPr>
+                        <a:t>Mayo 2026</a:t>
+                      </a:r>
+                    </a:p>
+                  </a:txBody>
+                  <a:tcPr marL="36576" marR="36576" marT="18288" marB="18288">
+                    <a:solidFill>
+                      <a:srgbClr val="F8F8F6"/>
+                    </a:solidFill>
+                  </a:tcPr>
+                </a:tc>
+                <a:tc>
+                  <a:txBody>
+                    <a:bodyPr/>
+                    <a:lstStyle/>
+                    <a:p>
+                      <a:pPr algn="r"/>
+                      <a:r>
+                        <a:rPr sz="1000">
+                          <a:solidFill>
+                            <a:srgbClr val="3F3F3F"/>
+                          </a:solidFill>
+                          <a:latin typeface="Encode Sans"/>
+                        </a:rPr>
+                        <a:t>+2.67%</a:t>
+                      </a:r>
+                    </a:p>
+                  </a:txBody>
+                  <a:tcPr marL="36576" marR="36576" marT="18288" marB="18288">
+                    <a:solidFill>
+                      <a:srgbClr val="F8F8F6"/>
+                    </a:solidFill>
+                  </a:tcPr>
+                </a:tc>
+                <a:tc>
+                  <a:txBody>
+                    <a:bodyPr/>
+                    <a:lstStyle/>
+                    <a:p>
+                      <a:pPr algn="r"/>
+                      <a:r>
+                        <a:rPr sz="1000">
+                          <a:solidFill>
+                            <a:srgbClr val="3F3F3F"/>
+                          </a:solidFill>
+                          <a:latin typeface="Encode Sans"/>
+                        </a:rPr>
+                        <a:t>+34.6%</a:t>
+                      </a:r>
+                    </a:p>
+                  </a:txBody>
+                  <a:tcPr marL="36576" marR="36576" marT="18288" marB="18288">
+                    <a:solidFill>
+                      <a:srgbClr val="F8F8F6"/>
+                    </a:solidFill>
+                  </a:tcPr>
+                </a:tc>
+              </a:tr>
+              <a:tr h="292608">
+                <a:tc>
+                  <a:txBody>
+                    <a:bodyPr/>
+                    <a:lstStyle/>
+                    <a:p>
+                      <a:pPr algn="l"/>
+                      <a:r>
+                        <a:rPr sz="1000">
+                          <a:solidFill>
+                            <a:srgbClr val="3F3F3F"/>
+                          </a:solidFill>
+                          <a:latin typeface="Encode Sans"/>
+                        </a:rPr>
+                        <a:t>Abril 2026</a:t>
+                      </a:r>
+                    </a:p>
+                  </a:txBody>
+                  <a:tcPr marL="36576" marR="36576" marT="18288" marB="18288">
+                    <a:solidFill>
+                      <a:srgbClr val="FFFFFF"/>
+                    </a:solidFill>
+                  </a:tcPr>
+                </a:tc>
+                <a:tc>
+                  <a:txBody>
+                    <a:bodyPr/>
+                    <a:lstStyle/>
+                    <a:p>
+                      <a:pPr algn="r"/>
+                      <a:r>
+                        <a:rPr sz="1000">
+                          <a:solidFill>
+                            <a:srgbClr val="3F3F3F"/>
+                          </a:solidFill>
+                          <a:latin typeface="Encode Sans"/>
+                        </a:rPr>
+                        <a:t>+4.79%</a:t>
+                      </a:r>
+                    </a:p>
+                  </a:txBody>
+                  <a:tcPr marL="36576" marR="36576" marT="18288" marB="18288">
+                    <a:solidFill>
+                      <a:srgbClr val="FFFFFF"/>
+                    </a:solidFill>
+                  </a:tcPr>
+                </a:tc>
+                <a:tc>
+                  <a:txBody>
+                    <a:bodyPr/>
+                    <a:lstStyle/>
+                    <a:p>
+                      <a:pPr algn="r"/>
+                      <a:r>
+                        <a:rPr sz="1000">
+                          <a:solidFill>
+                            <a:srgbClr val="3F3F3F"/>
+                          </a:solidFill>
+                          <a:latin typeface="Encode Sans"/>
+                        </a:rPr>
+                        <a:t>+30.9%</a:t>
+                      </a:r>
+                    </a:p>
+                  </a:txBody>
+                  <a:tcPr marL="36576" marR="36576" marT="18288" marB="18288">
+                    <a:solidFill>
+                      <a:srgbClr val="FFFFFF"/>
+                    </a:solidFill>
+                  </a:tcPr>
+                </a:tc>
+              </a:tr>
+              <a:tr h="292608">
+                <a:tc>
+                  <a:txBody>
+                    <a:bodyPr/>
+                    <a:lstStyle/>
+                    <a:p>
+                      <a:pPr algn="l"/>
+                      <a:r>
+                        <a:rPr sz="1000">
+                          <a:solidFill>
+                            <a:srgbClr val="3F3F3F"/>
+                          </a:solidFill>
+                          <a:latin typeface="Encode Sans"/>
+                        </a:rPr>
+                        <a:t>Marzo 2026</a:t>
+                      </a:r>
+                    </a:p>
+                  </a:txBody>
+                  <a:tcPr marL="36576" marR="36576" marT="18288" marB="18288">
+                    <a:solidFill>
+                      <a:srgbClr val="F8F8F6"/>
+                    </a:solidFill>
+                  </a:tcPr>
+                </a:tc>
+                <a:tc>
+                  <a:txBody>
+                    <a:bodyPr/>
+                    <a:lstStyle/>
+                    <a:p>
+                      <a:pPr algn="r"/>
+                      <a:r>
+                        <a:rPr sz="1000">
+                          <a:solidFill>
+                            <a:srgbClr val="3F3F3F"/>
+                          </a:solidFill>
+                          <a:latin typeface="Encode Sans"/>
+                        </a:rPr>
+                        <a:t>+2.95%</a:t>
+                      </a:r>
+                    </a:p>
+                  </a:txBody>
+                  <a:tcPr marL="36576" marR="36576" marT="18288" marB="18288">
+                    <a:solidFill>
+                      <a:srgbClr val="F8F8F6"/>
+                    </a:solidFill>
+                  </a:tcPr>
+                </a:tc>
+                <a:tc>
+                  <a:txBody>
+                    <a:bodyPr/>
+                    <a:lstStyle/>
+                    <a:p>
+                      <a:pPr algn="r"/>
+                      <a:r>
+                        <a:rPr sz="1000">
+                          <a:solidFill>
+                            <a:srgbClr val="3F3F3F"/>
+                          </a:solidFill>
+                          <a:latin typeface="Encode Sans"/>
+                        </a:rPr>
+                        <a:t>+28.1%</a:t>
                       </a:r>
                     </a:p>
                   </a:txBody>

</xml_diff>

<commit_message>
data: update 2026-09-17 ( data.json despidos.json scraper/historical_despidos.json publicaciones_semana.pptx rrii_brutas.xlsx)
</commit_message>
<xml_diff>
--- a/publicaciones_semana.pptx
+++ b/publicaciones_semana.pptx
@@ -12,6 +12,7 @@
     <p:sldId id="260" r:id="rId11"/>
     <p:sldId id="261" r:id="rId12"/>
     <p:sldId id="262" r:id="rId13"/>
+    <p:sldId id="263" r:id="rId14"/>
   </p:sldIdLst>
   <p:sldSz cx="12191695" cy="6858000" type="screen4x3"/>
   <p:notesSz cx="6858000" cy="9144000"/>
@@ -3277,7 +3278,7 @@
                 </a:solidFill>
                 <a:latin typeface="Encode Sans"/>
               </a:rPr>
-              <a:t>6 publicaciones · datos oficiales INDEC / BCRA / Hacienda</a:t>
+              <a:t>7 publicaciones · datos oficiales INDEC / BCRA / Hacienda</a:t>
             </a:r>
           </a:p>
         </p:txBody>
@@ -8323,6 +8324,278 @@
                 <a:latin typeface="Encode Sans"/>
               </a:rPr>
               <a:t>Fuente: elaboración propia en base a INDEC</a:t>
+            </a:r>
+          </a:p>
+        </p:txBody>
+      </p:sp>
+    </p:spTree>
+  </p:cSld>
+  <p:clrMapOvr>
+    <a:masterClrMapping/>
+  </p:clrMapOvr>
+</p:sld>
+</file>
+
+<file path=ppt/slides/slide8.xml><?xml version="1.0" encoding="utf-8"?>
+<p:sld xmlns:a="http://schemas.openxmlformats.org/drawingml/2006/main" xmlns:p="http://schemas.openxmlformats.org/presentationml/2006/main" xmlns:r="http://schemas.openxmlformats.org/officeDocument/2006/relationships">
+  <p:cSld>
+    <p:spTree>
+      <p:nvGrpSpPr>
+        <p:cNvPr id="1" name=""/>
+        <p:cNvGrpSpPr/>
+        <p:nvPr/>
+      </p:nvGrpSpPr>
+      <p:grpSpPr/>
+      <p:sp>
+        <p:nvSpPr>
+          <p:cNvPr id="2" name="Rectangle 1"/>
+          <p:cNvSpPr/>
+          <p:nvPr/>
+        </p:nvSpPr>
+        <p:spPr>
+          <a:xfrm>
+            <a:off x="0" y="0"/>
+            <a:ext cx="12191695" cy="274320"/>
+          </a:xfrm>
+          <a:prstGeom prst="rect">
+            <a:avLst/>
+          </a:prstGeom>
+          <a:solidFill>
+            <a:srgbClr val="00B2C9"/>
+          </a:solidFill>
+          <a:ln>
+            <a:noFill/>
+          </a:ln>
+        </p:spPr>
+        <p:style>
+          <a:lnRef idx="1">
+            <a:schemeClr val="accent1"/>
+          </a:lnRef>
+          <a:fillRef idx="3">
+            <a:schemeClr val="accent1"/>
+          </a:fillRef>
+          <a:effectRef idx="2">
+            <a:schemeClr val="accent1"/>
+          </a:effectRef>
+          <a:fontRef idx="minor">
+            <a:schemeClr val="lt1"/>
+          </a:fontRef>
+        </p:style>
+        <p:txBody>
+          <a:bodyPr rtlCol="0" anchor="ctr"/>
+          <a:lstStyle/>
+          <a:p>
+            <a:pPr algn="ctr"/>
+          </a:p>
+        </p:txBody>
+      </p:sp>
+      <p:sp>
+        <p:nvSpPr>
+          <p:cNvPr id="3" name="TextBox 2"/>
+          <p:cNvSpPr txBox="1"/>
+          <p:nvPr/>
+        </p:nvSpPr>
+        <p:spPr>
+          <a:xfrm>
+            <a:off x="411480" y="457200"/>
+            <a:ext cx="11368735" cy="914400"/>
+          </a:xfrm>
+          <a:prstGeom prst="rect">
+            <a:avLst/>
+          </a:prstGeom>
+          <a:noFill/>
+        </p:spPr>
+        <p:txBody>
+          <a:bodyPr wrap="square" lIns="0" rIns="0">
+            <a:spAutoFit/>
+          </a:bodyPr>
+          <a:lstStyle/>
+          <a:p>
+            <a:pPr algn="l"/>
+            <a:r>
+              <a:rPr sz="2600" b="1" i="0">
+                <a:solidFill>
+                  <a:srgbClr val="00B2C9"/>
+                </a:solidFill>
+                <a:latin typeface="Encode Sans"/>
+              </a:rPr>
+              <a:t>PBI TRIMESTRAL 2DO TRIMESTRE 2026</a:t>
+            </a:r>
+          </a:p>
+        </p:txBody>
+      </p:sp>
+      <p:sp>
+        <p:nvSpPr>
+          <p:cNvPr id="4" name="TextBox 3"/>
+          <p:cNvSpPr txBox="1"/>
+          <p:nvPr/>
+        </p:nvSpPr>
+        <p:spPr>
+          <a:xfrm>
+            <a:off x="411480" y="1280160"/>
+            <a:ext cx="11368735" cy="274320"/>
+          </a:xfrm>
+          <a:prstGeom prst="rect">
+            <a:avLst/>
+          </a:prstGeom>
+          <a:noFill/>
+        </p:spPr>
+        <p:txBody>
+          <a:bodyPr wrap="none">
+            <a:spAutoFit/>
+          </a:bodyPr>
+          <a:lstStyle/>
+          <a:p>
+            <a:r>
+              <a:rPr sz="1100" b="0" i="1">
+                <a:solidFill>
+                  <a:srgbClr val="6A6760"/>
+                </a:solidFill>
+                <a:latin typeface="Encode Sans"/>
+              </a:rPr>
+              <a:t>INDEC CCNN · período 2do trimestre 2026</a:t>
+            </a:r>
+          </a:p>
+        </p:txBody>
+      </p:sp>
+      <p:sp>
+        <p:nvSpPr>
+          <p:cNvPr id="5" name="TextBox 4"/>
+          <p:cNvSpPr txBox="1"/>
+          <p:nvPr/>
+        </p:nvSpPr>
+        <p:spPr>
+          <a:xfrm>
+            <a:off x="411480" y="1691640"/>
+            <a:ext cx="5486400" cy="1645920"/>
+          </a:xfrm>
+          <a:prstGeom prst="rect">
+            <a:avLst/>
+          </a:prstGeom>
+          <a:noFill/>
+        </p:spPr>
+        <p:txBody>
+          <a:bodyPr wrap="square" lIns="0" rIns="0">
+            <a:spAutoFit/>
+          </a:bodyPr>
+          <a:lstStyle/>
+          <a:p>
+            <a:pPr algn="just"/>
+            <a:r>
+              <a:rPr sz="1300" b="0" i="0">
+                <a:solidFill>
+                  <a:srgbClr val="3F3F3F"/>
+                </a:solidFill>
+                <a:latin typeface="Encode Sans"/>
+              </a:rPr>
+              <a:t>Se publicó la actualización de PBI trimestral para 2do trimestre 2026. Fuente: INDEC CCNN.</a:t>
+            </a:r>
+          </a:p>
+        </p:txBody>
+      </p:sp>
+      <p:sp>
+        <p:nvSpPr>
+          <p:cNvPr id="6" name="TextBox 5"/>
+          <p:cNvSpPr txBox="1"/>
+          <p:nvPr/>
+        </p:nvSpPr>
+        <p:spPr>
+          <a:xfrm>
+            <a:off x="411480" y="3520440"/>
+            <a:ext cx="5486400" cy="2743200"/>
+          </a:xfrm>
+          <a:prstGeom prst="rect">
+            <a:avLst/>
+          </a:prstGeom>
+          <a:noFill/>
+        </p:spPr>
+        <p:txBody>
+          <a:bodyPr wrap="square" lIns="0" rIns="0">
+            <a:spAutoFit/>
+          </a:bodyPr>
+          <a:lstStyle/>
+          <a:p>
+            <a:pPr algn="l">
+              <a:spcAft>
+                <a:spcPts val="800"/>
+              </a:spcAft>
+            </a:pPr>
+            <a:r>
+              <a:rPr sz="1300" b="1" i="0">
+                <a:solidFill>
+                  <a:srgbClr val="00B2C9"/>
+                </a:solidFill>
+                <a:latin typeface="Encode Sans"/>
+              </a:rPr>
+              <a:t>●  </a:t>
+            </a:r>
+            <a:r>
+              <a:rPr sz="1300" b="0" i="0">
+                <a:solidFill>
+                  <a:srgbClr val="3F3F3F"/>
+                </a:solidFill>
+                <a:latin typeface="Encode Sans"/>
+              </a:rPr>
+              <a:t>pbi: 792.800,00</a:t>
+            </a:r>
+          </a:p>
+          <a:p>
+            <a:pPr algn="l">
+              <a:spcAft>
+                <a:spcPts val="800"/>
+              </a:spcAft>
+            </a:pPr>
+            <a:r>
+              <a:rPr sz="1300" b="1" i="0">
+                <a:solidFill>
+                  <a:srgbClr val="00B2C9"/>
+                </a:solidFill>
+                <a:latin typeface="Encode Sans"/>
+              </a:rPr>
+              <a:t>●  </a:t>
+            </a:r>
+            <a:r>
+              <a:rPr sz="1300" b="0" i="0">
+                <a:solidFill>
+                  <a:srgbClr val="3F3F3F"/>
+                </a:solidFill>
+                <a:latin typeface="Encode Sans"/>
+              </a:rPr>
+              <a:t>via: 2,00</a:t>
+            </a:r>
+          </a:p>
+        </p:txBody>
+      </p:sp>
+      <p:sp>
+        <p:nvSpPr>
+          <p:cNvPr id="7" name="TextBox 6"/>
+          <p:cNvSpPr txBox="1"/>
+          <p:nvPr/>
+        </p:nvSpPr>
+        <p:spPr>
+          <a:xfrm>
+            <a:off x="411480" y="6492240"/>
+            <a:ext cx="11368735" cy="274320"/>
+          </a:xfrm>
+          <a:prstGeom prst="rect">
+            <a:avLst/>
+          </a:prstGeom>
+          <a:noFill/>
+        </p:spPr>
+        <p:txBody>
+          <a:bodyPr wrap="none">
+            <a:spAutoFit/>
+          </a:bodyPr>
+          <a:lstStyle/>
+          <a:p>
+            <a:r>
+              <a:rPr sz="1000" b="0" i="1">
+                <a:solidFill>
+                  <a:srgbClr val="6A6760"/>
+                </a:solidFill>
+                <a:latin typeface="Encode Sans"/>
+              </a:rPr>
+              <a:t>Fuente: elaboración propia en base a INDEC CCNN</a:t>
             </a:r>
           </a:p>
         </p:txBody>

</xml_diff>

<commit_message>
data: update 2026-09-18 ( data.json despidos.json scraper/historical_despidos.json publicaciones_semana.pptx rrii_brutas.xlsx)
</commit_message>
<xml_diff>
--- a/publicaciones_semana.pptx
+++ b/publicaciones_semana.pptx
@@ -13,6 +13,7 @@
     <p:sldId id="261" r:id="rId12"/>
     <p:sldId id="262" r:id="rId13"/>
     <p:sldId id="263" r:id="rId14"/>
+    <p:sldId id="264" r:id="rId15"/>
   </p:sldIdLst>
   <p:sldSz cx="12191695" cy="6858000" type="screen4x3"/>
   <p:notesSz cx="6858000" cy="9144000"/>
@@ -3278,7 +3279,7 @@
                 </a:solidFill>
                 <a:latin typeface="Encode Sans"/>
               </a:rPr>
-              <a:t>7 publicaciones · datos oficiales INDEC / BCRA / Hacienda</a:t>
+              <a:t>8 publicaciones · datos oficiales INDEC / BCRA / Hacienda</a:t>
             </a:r>
           </a:p>
         </p:txBody>
@@ -8596,6 +8597,851 @@
                 <a:latin typeface="Encode Sans"/>
               </a:rPr>
               <a:t>Fuente: elaboración propia en base a INDEC CCNN</a:t>
+            </a:r>
+          </a:p>
+        </p:txBody>
+      </p:sp>
+    </p:spTree>
+  </p:cSld>
+  <p:clrMapOvr>
+    <a:masterClrMapping/>
+  </p:clrMapOvr>
+</p:sld>
+</file>
+
+<file path=ppt/slides/slide9.xml><?xml version="1.0" encoding="utf-8"?>
+<p:sld xmlns:a="http://schemas.openxmlformats.org/drawingml/2006/main" xmlns:p="http://schemas.openxmlformats.org/presentationml/2006/main" xmlns:r="http://schemas.openxmlformats.org/officeDocument/2006/relationships">
+  <p:cSld>
+    <p:spTree>
+      <p:nvGrpSpPr>
+        <p:cNvPr id="1" name=""/>
+        <p:cNvGrpSpPr/>
+        <p:nvPr/>
+      </p:nvGrpSpPr>
+      <p:grpSpPr/>
+      <p:sp>
+        <p:nvSpPr>
+          <p:cNvPr id="2" name="Rectangle 1"/>
+          <p:cNvSpPr/>
+          <p:nvPr/>
+        </p:nvSpPr>
+        <p:spPr>
+          <a:xfrm>
+            <a:off x="0" y="0"/>
+            <a:ext cx="12191695" cy="274320"/>
+          </a:xfrm>
+          <a:prstGeom prst="rect">
+            <a:avLst/>
+          </a:prstGeom>
+          <a:solidFill>
+            <a:srgbClr val="00B2C9"/>
+          </a:solidFill>
+          <a:ln>
+            <a:noFill/>
+          </a:ln>
+        </p:spPr>
+        <p:style>
+          <a:lnRef idx="1">
+            <a:schemeClr val="accent1"/>
+          </a:lnRef>
+          <a:fillRef idx="3">
+            <a:schemeClr val="accent1"/>
+          </a:fillRef>
+          <a:effectRef idx="2">
+            <a:schemeClr val="accent1"/>
+          </a:effectRef>
+          <a:fontRef idx="minor">
+            <a:schemeClr val="lt1"/>
+          </a:fontRef>
+        </p:style>
+        <p:txBody>
+          <a:bodyPr rtlCol="0" anchor="ctr"/>
+          <a:lstStyle/>
+          <a:p>
+            <a:pPr algn="ctr"/>
+          </a:p>
+        </p:txBody>
+      </p:sp>
+      <p:sp>
+        <p:nvSpPr>
+          <p:cNvPr id="3" name="TextBox 2"/>
+          <p:cNvSpPr txBox="1"/>
+          <p:nvPr/>
+        </p:nvSpPr>
+        <p:spPr>
+          <a:xfrm>
+            <a:off x="411480" y="457200"/>
+            <a:ext cx="11368735" cy="914400"/>
+          </a:xfrm>
+          <a:prstGeom prst="rect">
+            <a:avLst/>
+          </a:prstGeom>
+          <a:noFill/>
+        </p:spPr>
+        <p:txBody>
+          <a:bodyPr wrap="square" lIns="0" rIns="0">
+            <a:spAutoFit/>
+          </a:bodyPr>
+          <a:lstStyle/>
+          <a:p>
+            <a:pPr algn="l"/>
+            <a:r>
+              <a:rPr sz="2600" b="1" i="0">
+                <a:solidFill>
+                  <a:srgbClr val="00B2C9"/>
+                </a:solidFill>
+                <a:latin typeface="Encode Sans"/>
+              </a:rPr>
+              <a:t>FISCAL AGOSTO 2026: SUPERÁVIT PRIMARIO $1.990K M$</a:t>
+            </a:r>
+          </a:p>
+        </p:txBody>
+      </p:sp>
+      <p:sp>
+        <p:nvSpPr>
+          <p:cNvPr id="4" name="TextBox 3"/>
+          <p:cNvSpPr txBox="1"/>
+          <p:nvPr/>
+        </p:nvSpPr>
+        <p:spPr>
+          <a:xfrm>
+            <a:off x="411480" y="1280160"/>
+            <a:ext cx="11368735" cy="274320"/>
+          </a:xfrm>
+          <a:prstGeom prst="rect">
+            <a:avLst/>
+          </a:prstGeom>
+          <a:noFill/>
+        </p:spPr>
+        <p:txBody>
+          <a:bodyPr wrap="none">
+            <a:spAutoFit/>
+          </a:bodyPr>
+          <a:lstStyle/>
+          <a:p>
+            <a:r>
+              <a:rPr sz="1100" b="0" i="1">
+                <a:solidFill>
+                  <a:srgbClr val="6A6760"/>
+                </a:solidFill>
+                <a:latin typeface="Encode Sans"/>
+              </a:rPr>
+              <a:t>Hacienda (vía INDEC IMIG) · período 2026-08</a:t>
+            </a:r>
+          </a:p>
+        </p:txBody>
+      </p:sp>
+      <p:sp>
+        <p:nvSpPr>
+          <p:cNvPr id="5" name="TextBox 4"/>
+          <p:cNvSpPr txBox="1"/>
+          <p:nvPr/>
+        </p:nvSpPr>
+        <p:spPr>
+          <a:xfrm>
+            <a:off x="411480" y="1691640"/>
+            <a:ext cx="5486400" cy="1645920"/>
+          </a:xfrm>
+          <a:prstGeom prst="rect">
+            <a:avLst/>
+          </a:prstGeom>
+          <a:noFill/>
+        </p:spPr>
+        <p:txBody>
+          <a:bodyPr wrap="square" lIns="0" rIns="0">
+            <a:spAutoFit/>
+          </a:bodyPr>
+          <a:lstStyle/>
+          <a:p>
+            <a:pPr algn="just"/>
+            <a:r>
+              <a:rPr sz="1300" b="0" i="0">
+                <a:solidFill>
+                  <a:srgbClr val="3F3F3F"/>
+                </a:solidFill>
+                <a:latin typeface="Encode Sans"/>
+              </a:rPr>
+              <a:t>El Sector Público Nacional No Financiero registró un resultado primario de +1.990 mil millones de pesos en agosto 2026. El resultado financiero alcanzó +636K M$.</a:t>
+            </a:r>
+          </a:p>
+        </p:txBody>
+      </p:sp>
+      <p:sp>
+        <p:nvSpPr>
+          <p:cNvPr id="6" name="TextBox 5"/>
+          <p:cNvSpPr txBox="1"/>
+          <p:nvPr/>
+        </p:nvSpPr>
+        <p:spPr>
+          <a:xfrm>
+            <a:off x="411480" y="3520440"/>
+            <a:ext cx="5486400" cy="2743200"/>
+          </a:xfrm>
+          <a:prstGeom prst="rect">
+            <a:avLst/>
+          </a:prstGeom>
+          <a:noFill/>
+        </p:spPr>
+        <p:txBody>
+          <a:bodyPr wrap="square" lIns="0" rIns="0">
+            <a:spAutoFit/>
+          </a:bodyPr>
+          <a:lstStyle/>
+          <a:p>
+            <a:pPr algn="l">
+              <a:spcAft>
+                <a:spcPts val="800"/>
+              </a:spcAft>
+            </a:pPr>
+            <a:r>
+              <a:rPr sz="1300" b="1" i="0">
+                <a:solidFill>
+                  <a:srgbClr val="00B2C9"/>
+                </a:solidFill>
+                <a:latin typeface="Encode Sans"/>
+              </a:rPr>
+              <a:t>●  </a:t>
+            </a:r>
+            <a:r>
+              <a:rPr sz="1300" b="0" i="0">
+                <a:solidFill>
+                  <a:srgbClr val="3F3F3F"/>
+                </a:solidFill>
+                <a:latin typeface="Encode Sans"/>
+              </a:rPr>
+              <a:t>Resultado primario: +1.990 mil millones de pesos</a:t>
+            </a:r>
+          </a:p>
+          <a:p>
+            <a:pPr algn="l">
+              <a:spcAft>
+                <a:spcPts val="800"/>
+              </a:spcAft>
+            </a:pPr>
+            <a:r>
+              <a:rPr sz="1300" b="1" i="0">
+                <a:solidFill>
+                  <a:srgbClr val="00B2C9"/>
+                </a:solidFill>
+                <a:latin typeface="Encode Sans"/>
+              </a:rPr>
+              <a:t>●  </a:t>
+            </a:r>
+            <a:r>
+              <a:rPr sz="1300" b="0" i="0">
+                <a:solidFill>
+                  <a:srgbClr val="3F3F3F"/>
+                </a:solidFill>
+                <a:latin typeface="Encode Sans"/>
+              </a:rPr>
+              <a:t>Resultado financiero: +636 mil millones</a:t>
+            </a:r>
+          </a:p>
+          <a:p>
+            <a:pPr algn="l">
+              <a:spcAft>
+                <a:spcPts val="800"/>
+              </a:spcAft>
+            </a:pPr>
+            <a:r>
+              <a:rPr sz="1300" b="1" i="0">
+                <a:solidFill>
+                  <a:srgbClr val="00B2C9"/>
+                </a:solidFill>
+                <a:latin typeface="Encode Sans"/>
+              </a:rPr>
+              <a:t>●  </a:t>
+            </a:r>
+            <a:r>
+              <a:rPr sz="1300" b="0" i="0">
+                <a:solidFill>
+                  <a:srgbClr val="3F3F3F"/>
+                </a:solidFill>
+                <a:latin typeface="Encode Sans"/>
+              </a:rPr>
+              <a:t>Fuente: Secretaría de Hacienda, base caja (Metodología 2017)</a:t>
+            </a:r>
+          </a:p>
+        </p:txBody>
+      </p:sp>
+      <p:pic>
+        <p:nvPicPr>
+          <p:cNvPr id="7" name="Picture 6" descr="image.png"/>
+          <p:cNvPicPr>
+            <a:picLocks noChangeAspect="1"/>
+          </p:cNvPicPr>
+          <p:nvPr/>
+        </p:nvPicPr>
+        <p:blipFill>
+          <a:blip r:embed="rId2"/>
+          <a:stretch>
+            <a:fillRect/>
+          </a:stretch>
+        </p:blipFill>
+        <p:spPr>
+          <a:xfrm>
+            <a:off x="6080760" y="1691640"/>
+            <a:ext cx="5669280" cy="2560320"/>
+          </a:xfrm>
+          <a:prstGeom prst="rect">
+            <a:avLst/>
+          </a:prstGeom>
+        </p:spPr>
+      </p:pic>
+      <p:graphicFrame>
+        <p:nvGraphicFramePr>
+          <p:cNvPr id="8" name="Table 7"/>
+          <p:cNvGraphicFramePr>
+            <a:graphicFrameLocks noGrp="1"/>
+          </p:cNvGraphicFramePr>
+          <p:nvPr/>
+        </p:nvGraphicFramePr>
+        <p:xfrm>
+          <a:off x="6080760" y="4434840"/>
+          <a:ext cx="5669280" cy="2048256"/>
+        </p:xfrm>
+        <a:graphic>
+          <a:graphicData uri="http://schemas.openxmlformats.org/drawingml/2006/table">
+            <a:tbl>
+              <a:tblPr firstRow="1" bandRow="1">
+                <a:tableStyleId>{5C22544A-7EE6-4342-B048-85BDC9FD1C3A}</a:tableStyleId>
+              </a:tblPr>
+              <a:tblGrid>
+                <a:gridCol w="1889760"/>
+                <a:gridCol w="1889760"/>
+                <a:gridCol w="1889760"/>
+              </a:tblGrid>
+              <a:tr h="292608">
+                <a:tc>
+                  <a:txBody>
+                    <a:bodyPr/>
+                    <a:lstStyle/>
+                    <a:p>
+                      <a:pPr algn="l"/>
+                      <a:r>
+                        <a:rPr sz="1000" b="1">
+                          <a:solidFill>
+                            <a:srgbClr val="FFFFFF"/>
+                          </a:solidFill>
+                          <a:latin typeface="Encode Sans"/>
+                        </a:rPr>
+                        <a:t>Mes</a:t>
+                      </a:r>
+                    </a:p>
+                  </a:txBody>
+                  <a:tcPr marL="36576" marR="36576" marT="18288" marB="18288">
+                    <a:solidFill>
+                      <a:srgbClr val="00B2C9"/>
+                    </a:solidFill>
+                  </a:tcPr>
+                </a:tc>
+                <a:tc>
+                  <a:txBody>
+                    <a:bodyPr/>
+                    <a:lstStyle/>
+                    <a:p>
+                      <a:pPr algn="r"/>
+                      <a:r>
+                        <a:rPr sz="1000" b="1">
+                          <a:solidFill>
+                            <a:srgbClr val="FFFFFF"/>
+                          </a:solidFill>
+                          <a:latin typeface="Encode Sans"/>
+                        </a:rPr>
+                        <a:t>Primario M$</a:t>
+                      </a:r>
+                    </a:p>
+                  </a:txBody>
+                  <a:tcPr marL="36576" marR="36576" marT="18288" marB="18288">
+                    <a:solidFill>
+                      <a:srgbClr val="00B2C9"/>
+                    </a:solidFill>
+                  </a:tcPr>
+                </a:tc>
+                <a:tc>
+                  <a:txBody>
+                    <a:bodyPr/>
+                    <a:lstStyle/>
+                    <a:p>
+                      <a:pPr algn="r"/>
+                      <a:r>
+                        <a:rPr sz="1000" b="1">
+                          <a:solidFill>
+                            <a:srgbClr val="FFFFFF"/>
+                          </a:solidFill>
+                          <a:latin typeface="Encode Sans"/>
+                        </a:rPr>
+                        <a:t>Financiero M$</a:t>
+                      </a:r>
+                    </a:p>
+                  </a:txBody>
+                  <a:tcPr marL="36576" marR="36576" marT="18288" marB="18288">
+                    <a:solidFill>
+                      <a:srgbClr val="00B2C9"/>
+                    </a:solidFill>
+                  </a:tcPr>
+                </a:tc>
+              </a:tr>
+              <a:tr h="292608">
+                <a:tc>
+                  <a:txBody>
+                    <a:bodyPr/>
+                    <a:lstStyle/>
+                    <a:p>
+                      <a:pPr algn="l"/>
+                      <a:r>
+                        <a:rPr sz="1000">
+                          <a:solidFill>
+                            <a:srgbClr val="3F3F3F"/>
+                          </a:solidFill>
+                          <a:latin typeface="Encode Sans"/>
+                        </a:rPr>
+                        <a:t>Agosto 2026</a:t>
+                      </a:r>
+                    </a:p>
+                  </a:txBody>
+                  <a:tcPr marL="36576" marR="36576" marT="18288" marB="18288">
+                    <a:solidFill>
+                      <a:srgbClr val="FFFFFF"/>
+                    </a:solidFill>
+                  </a:tcPr>
+                </a:tc>
+                <a:tc>
+                  <a:txBody>
+                    <a:bodyPr/>
+                    <a:lstStyle/>
+                    <a:p>
+                      <a:pPr algn="r"/>
+                      <a:r>
+                        <a:rPr sz="1000">
+                          <a:solidFill>
+                            <a:srgbClr val="3F3F3F"/>
+                          </a:solidFill>
+                          <a:latin typeface="Encode Sans"/>
+                        </a:rPr>
+                        <a:t>1.990.322</a:t>
+                      </a:r>
+                    </a:p>
+                  </a:txBody>
+                  <a:tcPr marL="36576" marR="36576" marT="18288" marB="18288">
+                    <a:solidFill>
+                      <a:srgbClr val="FFFFFF"/>
+                    </a:solidFill>
+                  </a:tcPr>
+                </a:tc>
+                <a:tc>
+                  <a:txBody>
+                    <a:bodyPr/>
+                    <a:lstStyle/>
+                    <a:p>
+                      <a:pPr algn="r"/>
+                      <a:r>
+                        <a:rPr sz="1000">
+                          <a:solidFill>
+                            <a:srgbClr val="3F3F3F"/>
+                          </a:solidFill>
+                          <a:latin typeface="Encode Sans"/>
+                        </a:rPr>
+                        <a:t>635.529</a:t>
+                      </a:r>
+                    </a:p>
+                  </a:txBody>
+                  <a:tcPr marL="36576" marR="36576" marT="18288" marB="18288">
+                    <a:solidFill>
+                      <a:srgbClr val="FFFFFF"/>
+                    </a:solidFill>
+                  </a:tcPr>
+                </a:tc>
+              </a:tr>
+              <a:tr h="292608">
+                <a:tc>
+                  <a:txBody>
+                    <a:bodyPr/>
+                    <a:lstStyle/>
+                    <a:p>
+                      <a:pPr algn="l"/>
+                      <a:r>
+                        <a:rPr sz="1000">
+                          <a:solidFill>
+                            <a:srgbClr val="3F3F3F"/>
+                          </a:solidFill>
+                          <a:latin typeface="Encode Sans"/>
+                        </a:rPr>
+                        <a:t>Julio 2026</a:t>
+                      </a:r>
+                    </a:p>
+                  </a:txBody>
+                  <a:tcPr marL="36576" marR="36576" marT="18288" marB="18288">
+                    <a:solidFill>
+                      <a:srgbClr val="F8F8F6"/>
+                    </a:solidFill>
+                  </a:tcPr>
+                </a:tc>
+                <a:tc>
+                  <a:txBody>
+                    <a:bodyPr/>
+                    <a:lstStyle/>
+                    <a:p>
+                      <a:pPr algn="r"/>
+                      <a:r>
+                        <a:rPr sz="1000">
+                          <a:solidFill>
+                            <a:srgbClr val="3F3F3F"/>
+                          </a:solidFill>
+                          <a:latin typeface="Encode Sans"/>
+                        </a:rPr>
+                        <a:t>2.960.333</a:t>
+                      </a:r>
+                    </a:p>
+                  </a:txBody>
+                  <a:tcPr marL="36576" marR="36576" marT="18288" marB="18288">
+                    <a:solidFill>
+                      <a:srgbClr val="F8F8F6"/>
+                    </a:solidFill>
+                  </a:tcPr>
+                </a:tc>
+                <a:tc>
+                  <a:txBody>
+                    <a:bodyPr/>
+                    <a:lstStyle/>
+                    <a:p>
+                      <a:pPr algn="r"/>
+                      <a:r>
+                        <a:rPr sz="1000">
+                          <a:solidFill>
+                            <a:srgbClr val="3F3F3F"/>
+                          </a:solidFill>
+                          <a:latin typeface="Encode Sans"/>
+                        </a:rPr>
+                        <a:t>244.897</a:t>
+                      </a:r>
+                    </a:p>
+                  </a:txBody>
+                  <a:tcPr marL="36576" marR="36576" marT="18288" marB="18288">
+                    <a:solidFill>
+                      <a:srgbClr val="F8F8F6"/>
+                    </a:solidFill>
+                  </a:tcPr>
+                </a:tc>
+              </a:tr>
+              <a:tr h="292608">
+                <a:tc>
+                  <a:txBody>
+                    <a:bodyPr/>
+                    <a:lstStyle/>
+                    <a:p>
+                      <a:pPr algn="l"/>
+                      <a:r>
+                        <a:rPr sz="1000">
+                          <a:solidFill>
+                            <a:srgbClr val="3F3F3F"/>
+                          </a:solidFill>
+                          <a:latin typeface="Encode Sans"/>
+                        </a:rPr>
+                        <a:t>Junio 2026</a:t>
+                      </a:r>
+                    </a:p>
+                  </a:txBody>
+                  <a:tcPr marL="36576" marR="36576" marT="18288" marB="18288">
+                    <a:solidFill>
+                      <a:srgbClr val="FFFFFF"/>
+                    </a:solidFill>
+                  </a:tcPr>
+                </a:tc>
+                <a:tc>
+                  <a:txBody>
+                    <a:bodyPr/>
+                    <a:lstStyle/>
+                    <a:p>
+                      <a:pPr algn="r"/>
+                      <a:r>
+                        <a:rPr sz="1000">
+                          <a:solidFill>
+                            <a:srgbClr val="3F3F3F"/>
+                          </a:solidFill>
+                          <a:latin typeface="Encode Sans"/>
+                        </a:rPr>
+                        <a:t>-696.843</a:t>
+                      </a:r>
+                    </a:p>
+                  </a:txBody>
+                  <a:tcPr marL="36576" marR="36576" marT="18288" marB="18288">
+                    <a:solidFill>
+                      <a:srgbClr val="FFFFFF"/>
+                    </a:solidFill>
+                  </a:tcPr>
+                </a:tc>
+                <a:tc>
+                  <a:txBody>
+                    <a:bodyPr/>
+                    <a:lstStyle/>
+                    <a:p>
+                      <a:pPr algn="r"/>
+                      <a:r>
+                        <a:rPr sz="1000">
+                          <a:solidFill>
+                            <a:srgbClr val="3F3F3F"/>
+                          </a:solidFill>
+                          <a:latin typeface="Encode Sans"/>
+                        </a:rPr>
+                        <a:t>-1.024.891</a:t>
+                      </a:r>
+                    </a:p>
+                  </a:txBody>
+                  <a:tcPr marL="36576" marR="36576" marT="18288" marB="18288">
+                    <a:solidFill>
+                      <a:srgbClr val="FFFFFF"/>
+                    </a:solidFill>
+                  </a:tcPr>
+                </a:tc>
+              </a:tr>
+              <a:tr h="292608">
+                <a:tc>
+                  <a:txBody>
+                    <a:bodyPr/>
+                    <a:lstStyle/>
+                    <a:p>
+                      <a:pPr algn="l"/>
+                      <a:r>
+                        <a:rPr sz="1000">
+                          <a:solidFill>
+                            <a:srgbClr val="3F3F3F"/>
+                          </a:solidFill>
+                          <a:latin typeface="Encode Sans"/>
+                        </a:rPr>
+                        <a:t>Mayo 2026</a:t>
+                      </a:r>
+                    </a:p>
+                  </a:txBody>
+                  <a:tcPr marL="36576" marR="36576" marT="18288" marB="18288">
+                    <a:solidFill>
+                      <a:srgbClr val="F8F8F6"/>
+                    </a:solidFill>
+                  </a:tcPr>
+                </a:tc>
+                <a:tc>
+                  <a:txBody>
+                    <a:bodyPr/>
+                    <a:lstStyle/>
+                    <a:p>
+                      <a:pPr algn="r"/>
+                      <a:r>
+                        <a:rPr sz="1000">
+                          <a:solidFill>
+                            <a:srgbClr val="3F3F3F"/>
+                          </a:solidFill>
+                          <a:latin typeface="Encode Sans"/>
+                        </a:rPr>
+                        <a:t>1.924.367</a:t>
+                      </a:r>
+                    </a:p>
+                  </a:txBody>
+                  <a:tcPr marL="36576" marR="36576" marT="18288" marB="18288">
+                    <a:solidFill>
+                      <a:srgbClr val="F8F8F6"/>
+                    </a:solidFill>
+                  </a:tcPr>
+                </a:tc>
+                <a:tc>
+                  <a:txBody>
+                    <a:bodyPr/>
+                    <a:lstStyle/>
+                    <a:p>
+                      <a:pPr algn="r"/>
+                      <a:r>
+                        <a:rPr sz="1000">
+                          <a:solidFill>
+                            <a:srgbClr val="3F3F3F"/>
+                          </a:solidFill>
+                          <a:latin typeface="Encode Sans"/>
+                        </a:rPr>
+                        <a:t>506.761</a:t>
+                      </a:r>
+                    </a:p>
+                  </a:txBody>
+                  <a:tcPr marL="36576" marR="36576" marT="18288" marB="18288">
+                    <a:solidFill>
+                      <a:srgbClr val="F8F8F6"/>
+                    </a:solidFill>
+                  </a:tcPr>
+                </a:tc>
+              </a:tr>
+              <a:tr h="292608">
+                <a:tc>
+                  <a:txBody>
+                    <a:bodyPr/>
+                    <a:lstStyle/>
+                    <a:p>
+                      <a:pPr algn="l"/>
+                      <a:r>
+                        <a:rPr sz="1000">
+                          <a:solidFill>
+                            <a:srgbClr val="3F3F3F"/>
+                          </a:solidFill>
+                          <a:latin typeface="Encode Sans"/>
+                        </a:rPr>
+                        <a:t>Abril 2026</a:t>
+                      </a:r>
+                    </a:p>
+                  </a:txBody>
+                  <a:tcPr marL="36576" marR="36576" marT="18288" marB="18288">
+                    <a:solidFill>
+                      <a:srgbClr val="FFFFFF"/>
+                    </a:solidFill>
+                  </a:tcPr>
+                </a:tc>
+                <a:tc>
+                  <a:txBody>
+                    <a:bodyPr/>
+                    <a:lstStyle/>
+                    <a:p>
+                      <a:pPr algn="r"/>
+                      <a:r>
+                        <a:rPr sz="1000">
+                          <a:solidFill>
+                            <a:srgbClr val="3F3F3F"/>
+                          </a:solidFill>
+                          <a:latin typeface="Encode Sans"/>
+                        </a:rPr>
+                        <a:t>632.844</a:t>
+                      </a:r>
+                    </a:p>
+                  </a:txBody>
+                  <a:tcPr marL="36576" marR="36576" marT="18288" marB="18288">
+                    <a:solidFill>
+                      <a:srgbClr val="FFFFFF"/>
+                    </a:solidFill>
+                  </a:tcPr>
+                </a:tc>
+                <a:tc>
+                  <a:txBody>
+                    <a:bodyPr/>
+                    <a:lstStyle/>
+                    <a:p>
+                      <a:pPr algn="r"/>
+                      <a:r>
+                        <a:rPr sz="1000">
+                          <a:solidFill>
+                            <a:srgbClr val="3F3F3F"/>
+                          </a:solidFill>
+                          <a:latin typeface="Encode Sans"/>
+                        </a:rPr>
+                        <a:t>356.292</a:t>
+                      </a:r>
+                    </a:p>
+                  </a:txBody>
+                  <a:tcPr marL="36576" marR="36576" marT="18288" marB="18288">
+                    <a:solidFill>
+                      <a:srgbClr val="FFFFFF"/>
+                    </a:solidFill>
+                  </a:tcPr>
+                </a:tc>
+              </a:tr>
+              <a:tr h="292608">
+                <a:tc>
+                  <a:txBody>
+                    <a:bodyPr/>
+                    <a:lstStyle/>
+                    <a:p>
+                      <a:pPr algn="l"/>
+                      <a:r>
+                        <a:rPr sz="1000">
+                          <a:solidFill>
+                            <a:srgbClr val="3F3F3F"/>
+                          </a:solidFill>
+                          <a:latin typeface="Encode Sans"/>
+                        </a:rPr>
+                        <a:t>Marzo 2026</a:t>
+                      </a:r>
+                    </a:p>
+                  </a:txBody>
+                  <a:tcPr marL="36576" marR="36576" marT="18288" marB="18288">
+                    <a:solidFill>
+                      <a:srgbClr val="F8F8F6"/>
+                    </a:solidFill>
+                  </a:tcPr>
+                </a:tc>
+                <a:tc>
+                  <a:txBody>
+                    <a:bodyPr/>
+                    <a:lstStyle/>
+                    <a:p>
+                      <a:pPr algn="r"/>
+                      <a:r>
+                        <a:rPr sz="1000">
+                          <a:solidFill>
+                            <a:srgbClr val="3F3F3F"/>
+                          </a:solidFill>
+                          <a:latin typeface="Encode Sans"/>
+                        </a:rPr>
+                        <a:t>930.284</a:t>
+                      </a:r>
+                    </a:p>
+                  </a:txBody>
+                  <a:tcPr marL="36576" marR="36576" marT="18288" marB="18288">
+                    <a:solidFill>
+                      <a:srgbClr val="F8F8F6"/>
+                    </a:solidFill>
+                  </a:tcPr>
+                </a:tc>
+                <a:tc>
+                  <a:txBody>
+                    <a:bodyPr/>
+                    <a:lstStyle/>
+                    <a:p>
+                      <a:pPr algn="r"/>
+                      <a:r>
+                        <a:rPr sz="1000">
+                          <a:solidFill>
+                            <a:srgbClr val="3F3F3F"/>
+                          </a:solidFill>
+                          <a:latin typeface="Encode Sans"/>
+                        </a:rPr>
+                        <a:t>246.434</a:t>
+                      </a:r>
+                    </a:p>
+                  </a:txBody>
+                  <a:tcPr marL="36576" marR="36576" marT="18288" marB="18288">
+                    <a:solidFill>
+                      <a:srgbClr val="F8F8F6"/>
+                    </a:solidFill>
+                  </a:tcPr>
+                </a:tc>
+              </a:tr>
+            </a:tbl>
+          </a:graphicData>
+        </a:graphic>
+      </p:graphicFrame>
+      <p:sp>
+        <p:nvSpPr>
+          <p:cNvPr id="9" name="TextBox 8"/>
+          <p:cNvSpPr txBox="1"/>
+          <p:nvPr/>
+        </p:nvSpPr>
+        <p:spPr>
+          <a:xfrm>
+            <a:off x="411480" y="6492240"/>
+            <a:ext cx="11368735" cy="274320"/>
+          </a:xfrm>
+          <a:prstGeom prst="rect">
+            <a:avLst/>
+          </a:prstGeom>
+          <a:noFill/>
+        </p:spPr>
+        <p:txBody>
+          <a:bodyPr wrap="none">
+            <a:spAutoFit/>
+          </a:bodyPr>
+          <a:lstStyle/>
+          <a:p>
+            <a:r>
+              <a:rPr sz="1000" b="0" i="1">
+                <a:solidFill>
+                  <a:srgbClr val="6A6760"/>
+                </a:solidFill>
+                <a:latin typeface="Encode Sans"/>
+              </a:rPr>
+              <a:t>Fuente: elaboración propia en base a Hacienda (vía INDEC IMIG)</a:t>
             </a:r>
           </a:p>
         </p:txBody>

</xml_diff>

<commit_message>
data: update 2026-09-19 ( data.json despidos.json scraper/historical_despidos.json publicaciones_semana.pptx rrii_brutas.xlsx)
</commit_message>
<xml_diff>
--- a/publicaciones_semana.pptx
+++ b/publicaciones_semana.pptx
@@ -14,6 +14,7 @@
     <p:sldId id="262" r:id="rId13"/>
     <p:sldId id="263" r:id="rId14"/>
     <p:sldId id="264" r:id="rId15"/>
+    <p:sldId id="265" r:id="rId16"/>
   </p:sldIdLst>
   <p:sldSz cx="12191695" cy="6858000" type="screen4x3"/>
   <p:notesSz cx="6858000" cy="9144000"/>
@@ -3279,7 +3280,7 @@
                 </a:solidFill>
                 <a:latin typeface="Encode Sans"/>
               </a:rPr>
-              <a:t>8 publicaciones · datos oficiales INDEC / BCRA / Hacienda</a:t>
+              <a:t>9 publicaciones · datos oficiales INDEC / BCRA / Hacienda</a:t>
             </a:r>
           </a:p>
         </p:txBody>
@@ -3292,7 +3293,7 @@
 </p:sld>
 </file>
 
-<file path=ppt/slides/slide2.xml><?xml version="1.0" encoding="utf-8"?>
+<file path=ppt/slides/slide10.xml><?xml version="1.0" encoding="utf-8"?>
 <p:sld xmlns:a="http://schemas.openxmlformats.org/drawingml/2006/main" xmlns:p="http://schemas.openxmlformats.org/presentationml/2006/main" xmlns:r="http://schemas.openxmlformats.org/officeDocument/2006/relationships">
   <p:cSld>
     <p:spTree>
@@ -3375,7 +3376,7 @@
                 </a:solidFill>
                 <a:latin typeface="Encode Sans"/>
               </a:rPr>
-              <a:t>INDUSTRIA JULIO 2026: IPI CRECIÓ +0.0% I.A.</a:t>
+              <a:t>FISCAL AGOSTO 2026: SUPERÁVIT PRIMARIO $1.990K M$</a:t>
             </a:r>
           </a:p>
         </p:txBody>
@@ -3409,7 +3410,7 @@
                 </a:solidFill>
                 <a:latin typeface="Encode Sans"/>
               </a:rPr>
-              <a:t>INDEC · período 2026-07</a:t>
+              <a:t>Hacienda (vía INDEC IMIG) · período 2026-08</a:t>
             </a:r>
           </a:p>
         </p:txBody>
@@ -3444,7 +3445,7 @@
                 </a:solidFill>
                 <a:latin typeface="Encode Sans"/>
               </a:rPr>
-              <a:t>El Índice de Producción Industrial Manufacturero (IPI) registró una variación interanual de +0.0% en julio 2026.</a:t>
+              <a:t>El Sector Público Nacional No Financiero registró un resultado primario de +1.990 mil millones de pesos en agosto 2026. El resultado financiero alcanzó +636K M$.</a:t>
             </a:r>
           </a:p>
         </p:txBody>
@@ -3492,7 +3493,7 @@
                 </a:solidFill>
                 <a:latin typeface="Encode Sans"/>
               </a:rPr>
-              <a:t>Variación interanual: +0.0%</a:t>
+              <a:t>Resultado primario: +1.990 mil millones de pesos</a:t>
             </a:r>
           </a:p>
           <a:p>
@@ -3517,7 +3518,32 @@
                 </a:solidFill>
                 <a:latin typeface="Encode Sans"/>
               </a:rPr>
-              <a:t>Serie INDEC, base 2004=100. Mide la producción manufacturera (16 ramas).</a:t>
+              <a:t>Resultado financiero: +636 mil millones</a:t>
+            </a:r>
+          </a:p>
+          <a:p>
+            <a:pPr algn="l">
+              <a:spcAft>
+                <a:spcPts val="800"/>
+              </a:spcAft>
+            </a:pPr>
+            <a:r>
+              <a:rPr sz="1300" b="1" i="0">
+                <a:solidFill>
+                  <a:srgbClr val="00B2C9"/>
+                </a:solidFill>
+                <a:latin typeface="Encode Sans"/>
+              </a:rPr>
+              <a:t>●  </a:t>
+            </a:r>
+            <a:r>
+              <a:rPr sz="1300" b="0" i="0">
+                <a:solidFill>
+                  <a:srgbClr val="3F3F3F"/>
+                </a:solidFill>
+                <a:latin typeface="Encode Sans"/>
+              </a:rPr>
+              <a:t>Fuente: Secretaría de Hacienda, base caja (Metodología 2017)</a:t>
             </a:r>
           </a:p>
         </p:txBody>
@@ -3606,7 +3632,7 @@
                           </a:solidFill>
                           <a:latin typeface="Encode Sans"/>
                         </a:rPr>
-                        <a:t>Original</a:t>
+                        <a:t>Primario M$</a:t>
                       </a:r>
                     </a:p>
                   </a:txBody>
@@ -3629,7 +3655,7 @@
                           </a:solidFill>
                           <a:latin typeface="Encode Sans"/>
                         </a:rPr>
-                        <a:t>VIA %</a:t>
+                        <a:t>Financiero M$</a:t>
                       </a:r>
                     </a:p>
                   </a:txBody>
@@ -3654,7 +3680,7 @@
                           </a:solidFill>
                           <a:latin typeface="Encode Sans"/>
                         </a:rPr>
-                        <a:t>Julio 2026</a:t>
+                        <a:t>Agosto 2026</a:t>
                       </a:r>
                     </a:p>
                   </a:txBody>
@@ -3677,7 +3703,7 @@
                           </a:solidFill>
                           <a:latin typeface="Encode Sans"/>
                         </a:rPr>
-                        <a:t>118,2</a:t>
+                        <a:t>1.990.322</a:t>
                       </a:r>
                     </a:p>
                   </a:txBody>
@@ -3700,7 +3726,7 @@
                           </a:solidFill>
                           <a:latin typeface="Encode Sans"/>
                         </a:rPr>
-                        <a:t>-4.9%</a:t>
+                        <a:t>635.529</a:t>
                       </a:r>
                     </a:p>
                   </a:txBody>
@@ -3725,7 +3751,7 @@
                           </a:solidFill>
                           <a:latin typeface="Encode Sans"/>
                         </a:rPr>
-                        <a:t>Junio 2026</a:t>
+                        <a:t>Julio 2026</a:t>
                       </a:r>
                     </a:p>
                   </a:txBody>
@@ -3748,7 +3774,7 @@
                           </a:solidFill>
                           <a:latin typeface="Encode Sans"/>
                         </a:rPr>
-                        <a:t>120,0</a:t>
+                        <a:t>2.960.333</a:t>
                       </a:r>
                     </a:p>
                   </a:txBody>
@@ -3771,7 +3797,7 @@
                           </a:solidFill>
                           <a:latin typeface="Encode Sans"/>
                         </a:rPr>
-                        <a:t>+2.1%</a:t>
+                        <a:t>244.897</a:t>
                       </a:r>
                     </a:p>
                   </a:txBody>
@@ -3796,7 +3822,7 @@
                           </a:solidFill>
                           <a:latin typeface="Encode Sans"/>
                         </a:rPr>
-                        <a:t>Mayo 2026</a:t>
+                        <a:t>Junio 2026</a:t>
                       </a:r>
                     </a:p>
                   </a:txBody>
@@ -3819,7 +3845,7 @@
                           </a:solidFill>
                           <a:latin typeface="Encode Sans"/>
                         </a:rPr>
-                        <a:t>117,0</a:t>
+                        <a:t>-696.843</a:t>
                       </a:r>
                     </a:p>
                   </a:txBody>
@@ -3842,7 +3868,7 @@
                           </a:solidFill>
                           <a:latin typeface="Encode Sans"/>
                         </a:rPr>
-                        <a:t>-5.7%</a:t>
+                        <a:t>-1.024.891</a:t>
                       </a:r>
                     </a:p>
                   </a:txBody>
@@ -3867,7 +3893,7 @@
                           </a:solidFill>
                           <a:latin typeface="Encode Sans"/>
                         </a:rPr>
-                        <a:t>Abril 2026</a:t>
+                        <a:t>Mayo 2026</a:t>
                       </a:r>
                     </a:p>
                   </a:txBody>
@@ -3890,7 +3916,7 @@
                           </a:solidFill>
                           <a:latin typeface="Encode Sans"/>
                         </a:rPr>
-                        <a:t>118,6</a:t>
+                        <a:t>1.924.367</a:t>
                       </a:r>
                     </a:p>
                   </a:txBody>
@@ -3913,7 +3939,7 @@
                           </a:solidFill>
                           <a:latin typeface="Encode Sans"/>
                         </a:rPr>
-                        <a:t>-2.4%</a:t>
+                        <a:t>506.761</a:t>
                       </a:r>
                     </a:p>
                   </a:txBody>
@@ -3938,7 +3964,7 @@
                           </a:solidFill>
                           <a:latin typeface="Encode Sans"/>
                         </a:rPr>
-                        <a:t>Marzo 2026</a:t>
+                        <a:t>Abril 2026</a:t>
                       </a:r>
                     </a:p>
                   </a:txBody>
@@ -3961,7 +3987,7 @@
                           </a:solidFill>
                           <a:latin typeface="Encode Sans"/>
                         </a:rPr>
-                        <a:t>122,2</a:t>
+                        <a:t>632.844</a:t>
                       </a:r>
                     </a:p>
                   </a:txBody>
@@ -3984,7 +4010,7 @@
                           </a:solidFill>
                           <a:latin typeface="Encode Sans"/>
                         </a:rPr>
-                        <a:t>+5.1%</a:t>
+                        <a:t>356.292</a:t>
                       </a:r>
                     </a:p>
                   </a:txBody>
@@ -4009,7 +4035,7 @@
                           </a:solidFill>
                           <a:latin typeface="Encode Sans"/>
                         </a:rPr>
-                        <a:t>Febrero 2026</a:t>
+                        <a:t>Marzo 2026</a:t>
                       </a:r>
                     </a:p>
                   </a:txBody>
@@ -4032,7 +4058,7 @@
                           </a:solidFill>
                           <a:latin typeface="Encode Sans"/>
                         </a:rPr>
-                        <a:t>100,3</a:t>
+                        <a:t>930.284</a:t>
                       </a:r>
                     </a:p>
                   </a:txBody>
@@ -4055,7 +4081,7 @@
                           </a:solidFill>
                           <a:latin typeface="Encode Sans"/>
                         </a:rPr>
-                        <a:t>-8.8%</a:t>
+                        <a:t>246.434</a:t>
                       </a:r>
                     </a:p>
                   </a:txBody>
@@ -4099,7 +4125,7 @@
                 </a:solidFill>
                 <a:latin typeface="Encode Sans"/>
               </a:rPr>
-              <a:t>Fuente: elaboración propia en base a INDEC</a:t>
+              <a:t>Fuente: elaboración propia en base a Hacienda (vía INDEC IMIG)</a:t>
             </a:r>
           </a:p>
         </p:txBody>
@@ -4112,7 +4138,7 @@
 </p:sld>
 </file>
 
-<file path=ppt/slides/slide3.xml><?xml version="1.0" encoding="utf-8"?>
+<file path=ppt/slides/slide2.xml><?xml version="1.0" encoding="utf-8"?>
 <p:sld xmlns:a="http://schemas.openxmlformats.org/drawingml/2006/main" xmlns:p="http://schemas.openxmlformats.org/presentationml/2006/main" xmlns:r="http://schemas.openxmlformats.org/officeDocument/2006/relationships">
   <p:cSld>
     <p:spTree>
@@ -4195,7 +4221,7 @@
                 </a:solidFill>
                 <a:latin typeface="Encode Sans"/>
               </a:rPr>
-              <a:t>IPIM MAYORISTA AGOSTO 2026: +2.14%</a:t>
+              <a:t>INDUSTRIA JULIO 2026: IPI CRECIÓ +0.0% I.A.</a:t>
             </a:r>
           </a:p>
         </p:txBody>
@@ -4229,7 +4255,7 @@
                 </a:solidFill>
                 <a:latin typeface="Encode Sans"/>
               </a:rPr>
-              <a:t>INDEC · período 2026-08</a:t>
+              <a:t>INDEC · período 2026-07</a:t>
             </a:r>
           </a:p>
         </p:txBody>
@@ -4264,7 +4290,7 @@
                 </a:solidFill>
                 <a:latin typeface="Encode Sans"/>
               </a:rPr>
-              <a:t>El IPIM mayorista registró un aumento de +2.14% mensual en agosto 2026, acumulando 29.82% interanual. Suele anticipar el IPC minorista.</a:t>
+              <a:t>El Índice de Producción Industrial Manufacturero (IPI) registró una variación interanual de +0.0% en julio 2026.</a:t>
             </a:r>
           </a:p>
         </p:txBody>
@@ -4312,7 +4338,7 @@
                 </a:solidFill>
                 <a:latin typeface="Encode Sans"/>
               </a:rPr>
-              <a:t>Nivel general: +2.14% mensual</a:t>
+              <a:t>Variación interanual: +0.0%</a:t>
             </a:r>
           </a:p>
           <a:p>
@@ -4337,32 +4363,7 @@
                 </a:solidFill>
                 <a:latin typeface="Encode Sans"/>
               </a:rPr>
-              <a:t>Interanual: 29.82%</a:t>
-            </a:r>
-          </a:p>
-          <a:p>
-            <a:pPr algn="l">
-              <a:spcAft>
-                <a:spcPts val="800"/>
-              </a:spcAft>
-            </a:pPr>
-            <a:r>
-              <a:rPr sz="1300" b="1" i="0">
-                <a:solidFill>
-                  <a:srgbClr val="00B2C9"/>
-                </a:solidFill>
-                <a:latin typeface="Encode Sans"/>
-              </a:rPr>
-              <a:t>●  </a:t>
-            </a:r>
-            <a:r>
-              <a:rPr sz="1300" b="0" i="0">
-                <a:solidFill>
-                  <a:srgbClr val="3F3F3F"/>
-                </a:solidFill>
-                <a:latin typeface="Encode Sans"/>
-              </a:rPr>
-              <a:t>Brecha vs IPC minorista: +0.5% pp (IPC +1.7%)</a:t>
+              <a:t>Serie INDEC, base 2004=100. Mide la producción manufacturera (16 ramas).</a:t>
             </a:r>
           </a:p>
         </p:txBody>
@@ -4451,7 +4452,7 @@
                           </a:solidFill>
                           <a:latin typeface="Encode Sans"/>
                         </a:rPr>
-                        <a:t>VM %</a:t>
+                        <a:t>Original</a:t>
                       </a:r>
                     </a:p>
                   </a:txBody>
@@ -4499,7 +4500,7 @@
                           </a:solidFill>
                           <a:latin typeface="Encode Sans"/>
                         </a:rPr>
-                        <a:t>Agosto 2026</a:t>
+                        <a:t>Julio 2026</a:t>
                       </a:r>
                     </a:p>
                   </a:txBody>
@@ -4522,7 +4523,7 @@
                           </a:solidFill>
                           <a:latin typeface="Encode Sans"/>
                         </a:rPr>
-                        <a:t>+2.14%</a:t>
+                        <a:t>118,2</a:t>
                       </a:r>
                     </a:p>
                   </a:txBody>
@@ -4545,7 +4546,7 @@
                           </a:solidFill>
                           <a:latin typeface="Encode Sans"/>
                         </a:rPr>
-                        <a:t>+29.8%</a:t>
+                        <a:t>-4.9%</a:t>
                       </a:r>
                     </a:p>
                   </a:txBody>
@@ -4570,7 +4571,7 @@
                           </a:solidFill>
                           <a:latin typeface="Encode Sans"/>
                         </a:rPr>
-                        <a:t>Julio 2026</a:t>
+                        <a:t>Junio 2026</a:t>
                       </a:r>
                     </a:p>
                   </a:txBody>
@@ -4593,7 +4594,7 @@
                           </a:solidFill>
                           <a:latin typeface="Encode Sans"/>
                         </a:rPr>
-                        <a:t>+0.80%</a:t>
+                        <a:t>120,0</a:t>
                       </a:r>
                     </a:p>
                   </a:txBody>
@@ -4616,7 +4617,7 @@
                           </a:solidFill>
                           <a:latin typeface="Encode Sans"/>
                         </a:rPr>
-                        <a:t>+31.1%</a:t>
+                        <a:t>+2.1%</a:t>
                       </a:r>
                     </a:p>
                   </a:txBody>
@@ -4641,7 +4642,7 @@
                           </a:solidFill>
                           <a:latin typeface="Encode Sans"/>
                         </a:rPr>
-                        <a:t>Junio 2026</a:t>
+                        <a:t>Mayo 2026</a:t>
                       </a:r>
                     </a:p>
                   </a:txBody>
@@ -4664,7 +4665,7 @@
                           </a:solidFill>
                           <a:latin typeface="Encode Sans"/>
                         </a:rPr>
-                        <a:t>+1.08%</a:t>
+                        <a:t>117,0</a:t>
                       </a:r>
                     </a:p>
                   </a:txBody>
@@ -4687,7 +4688,7 @@
                           </a:solidFill>
                           <a:latin typeface="Encode Sans"/>
                         </a:rPr>
-                        <a:t>+33.7%</a:t>
+                        <a:t>-5.7%</a:t>
                       </a:r>
                     </a:p>
                   </a:txBody>
@@ -4712,7 +4713,7 @@
                           </a:solidFill>
                           <a:latin typeface="Encode Sans"/>
                         </a:rPr>
-                        <a:t>Mayo 2026</a:t>
+                        <a:t>Abril 2026</a:t>
                       </a:r>
                     </a:p>
                   </a:txBody>
@@ -4735,7 +4736,7 @@
                           </a:solidFill>
                           <a:latin typeface="Encode Sans"/>
                         </a:rPr>
-                        <a:t>+2.51%</a:t>
+                        <a:t>118,6</a:t>
                       </a:r>
                     </a:p>
                   </a:txBody>
@@ -4758,7 +4759,7 @@
                           </a:solidFill>
                           <a:latin typeface="Encode Sans"/>
                         </a:rPr>
-                        <a:t>+34.5%</a:t>
+                        <a:t>-2.4%</a:t>
                       </a:r>
                     </a:p>
                   </a:txBody>
@@ -4783,7 +4784,7 @@
                           </a:solidFill>
                           <a:latin typeface="Encode Sans"/>
                         </a:rPr>
-                        <a:t>Abril 2026</a:t>
+                        <a:t>Marzo 2026</a:t>
                       </a:r>
                     </a:p>
                   </a:txBody>
@@ -4806,7 +4807,7 @@
                           </a:solidFill>
                           <a:latin typeface="Encode Sans"/>
                         </a:rPr>
-                        <a:t>+5.16%</a:t>
+                        <a:t>122,2</a:t>
                       </a:r>
                     </a:p>
                   </a:txBody>
@@ -4829,7 +4830,7 @@
                           </a:solidFill>
                           <a:latin typeface="Encode Sans"/>
                         </a:rPr>
-                        <a:t>+30.8%</a:t>
+                        <a:t>+5.1%</a:t>
                       </a:r>
                     </a:p>
                   </a:txBody>
@@ -4854,7 +4855,7 @@
                           </a:solidFill>
                           <a:latin typeface="Encode Sans"/>
                         </a:rPr>
-                        <a:t>Marzo 2026</a:t>
+                        <a:t>Febrero 2026</a:t>
                       </a:r>
                     </a:p>
                   </a:txBody>
@@ -4877,7 +4878,7 @@
                           </a:solidFill>
                           <a:latin typeface="Encode Sans"/>
                         </a:rPr>
-                        <a:t>+3.38%</a:t>
+                        <a:t>100,3</a:t>
                       </a:r>
                     </a:p>
                   </a:txBody>
@@ -4900,7 +4901,7 @@
                           </a:solidFill>
                           <a:latin typeface="Encode Sans"/>
                         </a:rPr>
-                        <a:t>+27.9%</a:t>
+                        <a:t>-8.8%</a:t>
                       </a:r>
                     </a:p>
                   </a:txBody>
@@ -4957,7 +4958,7 @@
 </p:sld>
 </file>
 
-<file path=ppt/slides/slide4.xml><?xml version="1.0" encoding="utf-8"?>
+<file path=ppt/slides/slide3.xml><?xml version="1.0" encoding="utf-8"?>
 <p:sld xmlns:a="http://schemas.openxmlformats.org/drawingml/2006/main" xmlns:p="http://schemas.openxmlformats.org/presentationml/2006/main" xmlns:r="http://schemas.openxmlformats.org/officeDocument/2006/relationships">
   <p:cSld>
     <p:spTree>
@@ -5040,7 +5041,7 @@
                 </a:solidFill>
                 <a:latin typeface="Encode Sans"/>
               </a:rPr>
-              <a:t>IPIB BÁSICOS JULIO 2026: +0.85%</a:t>
+              <a:t>IPIM MAYORISTA AGOSTO 2026: +2.14%</a:t>
             </a:r>
           </a:p>
         </p:txBody>
@@ -5074,7 +5075,7 @@
                 </a:solidFill>
                 <a:latin typeface="Encode Sans"/>
               </a:rPr>
-              <a:t>INDEC · período 2026-07</a:t>
+              <a:t>INDEC · período 2026-08</a:t>
             </a:r>
           </a:p>
         </p:txBody>
@@ -5109,7 +5110,7 @@
                 </a:solidFill>
                 <a:latin typeface="Encode Sans"/>
               </a:rPr>
-              <a:t>El IPIB básicos registró un aumento de +0.85% mensual en julio 2026, acumulando 30.18% interanual. Suele anticipar el IPC minorista.</a:t>
+              <a:t>El IPIM mayorista registró un aumento de +2.14% mensual en agosto 2026, acumulando 29.82% interanual. Suele anticipar el IPC minorista.</a:t>
             </a:r>
           </a:p>
         </p:txBody>
@@ -5157,7 +5158,7 @@
                 </a:solidFill>
                 <a:latin typeface="Encode Sans"/>
               </a:rPr>
-              <a:t>Nivel general: +0.85% mensual</a:t>
+              <a:t>Nivel general: +2.14% mensual</a:t>
             </a:r>
           </a:p>
           <a:p>
@@ -5182,7 +5183,7 @@
                 </a:solidFill>
                 <a:latin typeface="Encode Sans"/>
               </a:rPr>
-              <a:t>Interanual: 30.18%</a:t>
+              <a:t>Interanual: 29.82%</a:t>
             </a:r>
           </a:p>
           <a:p>
@@ -5207,7 +5208,7 @@
                 </a:solidFill>
                 <a:latin typeface="Encode Sans"/>
               </a:rPr>
-              <a:t>Brecha vs IPC minorista: -1.3% pp (IPC +2.1%)</a:t>
+              <a:t>Brecha vs IPC minorista: +0.5% pp (IPC +1.7%)</a:t>
             </a:r>
           </a:p>
         </p:txBody>
@@ -5367,7 +5368,7 @@
                           </a:solidFill>
                           <a:latin typeface="Encode Sans"/>
                         </a:rPr>
-                        <a:t>+2.27%</a:t>
+                        <a:t>+2.14%</a:t>
                       </a:r>
                     </a:p>
                   </a:txBody>
@@ -5390,7 +5391,7 @@
                           </a:solidFill>
                           <a:latin typeface="Encode Sans"/>
                         </a:rPr>
-                        <a:t>+28.9%</a:t>
+                        <a:t>+29.8%</a:t>
                       </a:r>
                     </a:p>
                   </a:txBody>
@@ -5438,7 +5439,7 @@
                           </a:solidFill>
                           <a:latin typeface="Encode Sans"/>
                         </a:rPr>
-                        <a:t>+0.85%</a:t>
+                        <a:t>+0.80%</a:t>
                       </a:r>
                     </a:p>
                   </a:txBody>
@@ -5461,7 +5462,7 @@
                           </a:solidFill>
                           <a:latin typeface="Encode Sans"/>
                         </a:rPr>
-                        <a:t>+30.2%</a:t>
+                        <a:t>+31.1%</a:t>
                       </a:r>
                     </a:p>
                   </a:txBody>
@@ -5509,7 +5510,7 @@
                           </a:solidFill>
                           <a:latin typeface="Encode Sans"/>
                         </a:rPr>
-                        <a:t>+1.15%</a:t>
+                        <a:t>+1.08%</a:t>
                       </a:r>
                     </a:p>
                   </a:txBody>
@@ -5532,7 +5533,7 @@
                           </a:solidFill>
                           <a:latin typeface="Encode Sans"/>
                         </a:rPr>
-                        <a:t>+33.0%</a:t>
+                        <a:t>+33.7%</a:t>
                       </a:r>
                     </a:p>
                   </a:txBody>
@@ -5580,7 +5581,7 @@
                           </a:solidFill>
                           <a:latin typeface="Encode Sans"/>
                         </a:rPr>
-                        <a:t>+2.68%</a:t>
+                        <a:t>+2.51%</a:t>
                       </a:r>
                     </a:p>
                   </a:txBody>
@@ -5603,7 +5604,7 @@
                           </a:solidFill>
                           <a:latin typeface="Encode Sans"/>
                         </a:rPr>
-                        <a:t>+33.5%</a:t>
+                        <a:t>+34.5%</a:t>
                       </a:r>
                     </a:p>
                   </a:txBody>
@@ -5651,7 +5652,7 @@
                           </a:solidFill>
                           <a:latin typeface="Encode Sans"/>
                         </a:rPr>
-                        <a:t>+4.76%</a:t>
+                        <a:t>+5.16%</a:t>
                       </a:r>
                     </a:p>
                   </a:txBody>
@@ -5674,7 +5675,7 @@
                           </a:solidFill>
                           <a:latin typeface="Encode Sans"/>
                         </a:rPr>
-                        <a:t>+29.6%</a:t>
+                        <a:t>+30.8%</a:t>
                       </a:r>
                     </a:p>
                   </a:txBody>
@@ -5722,7 +5723,7 @@
                           </a:solidFill>
                           <a:latin typeface="Encode Sans"/>
                         </a:rPr>
-                        <a:t>+3.00%</a:t>
+                        <a:t>+3.38%</a:t>
                       </a:r>
                     </a:p>
                   </a:txBody>
@@ -5745,7 +5746,7 @@
                           </a:solidFill>
                           <a:latin typeface="Encode Sans"/>
                         </a:rPr>
-                        <a:t>+27.1%</a:t>
+                        <a:t>+27.9%</a:t>
                       </a:r>
                     </a:p>
                   </a:txBody>
@@ -5802,7 +5803,7 @@
 </p:sld>
 </file>
 
-<file path=ppt/slides/slide5.xml><?xml version="1.0" encoding="utf-8"?>
+<file path=ppt/slides/slide4.xml><?xml version="1.0" encoding="utf-8"?>
 <p:sld xmlns:a="http://schemas.openxmlformats.org/drawingml/2006/main" xmlns:p="http://schemas.openxmlformats.org/presentationml/2006/main" xmlns:r="http://schemas.openxmlformats.org/officeDocument/2006/relationships">
   <p:cSld>
     <p:spTree>
@@ -5885,7 +5886,7 @@
                 </a:solidFill>
                 <a:latin typeface="Encode Sans"/>
               </a:rPr>
-              <a:t>IPIB BÁSICOS AGOSTO 2026: +2.27%</a:t>
+              <a:t>IPIB BÁSICOS JULIO 2026: +0.85%</a:t>
             </a:r>
           </a:p>
         </p:txBody>
@@ -5919,7 +5920,7 @@
                 </a:solidFill>
                 <a:latin typeface="Encode Sans"/>
               </a:rPr>
-              <a:t>INDEC · período 2026-08</a:t>
+              <a:t>INDEC · período 2026-07</a:t>
             </a:r>
           </a:p>
         </p:txBody>
@@ -5954,7 +5955,7 @@
                 </a:solidFill>
                 <a:latin typeface="Encode Sans"/>
               </a:rPr>
-              <a:t>El IPIB básicos registró un aumento de +2.27% mensual en agosto 2026, acumulando 28.86% interanual. Suele anticipar el IPC minorista.</a:t>
+              <a:t>El IPIB básicos registró un aumento de +0.85% mensual en julio 2026, acumulando 30.18% interanual. Suele anticipar el IPC minorista.</a:t>
             </a:r>
           </a:p>
         </p:txBody>
@@ -6002,7 +6003,7 @@
                 </a:solidFill>
                 <a:latin typeface="Encode Sans"/>
               </a:rPr>
-              <a:t>Nivel general: +2.27% mensual</a:t>
+              <a:t>Nivel general: +0.85% mensual</a:t>
             </a:r>
           </a:p>
           <a:p>
@@ -6027,7 +6028,7 @@
                 </a:solidFill>
                 <a:latin typeface="Encode Sans"/>
               </a:rPr>
-              <a:t>Interanual: 28.86%</a:t>
+              <a:t>Interanual: 30.18%</a:t>
             </a:r>
           </a:p>
           <a:p>
@@ -6052,7 +6053,7 @@
                 </a:solidFill>
                 <a:latin typeface="Encode Sans"/>
               </a:rPr>
-              <a:t>Brecha vs IPC minorista: +0.6% pp (IPC +1.7%)</a:t>
+              <a:t>Brecha vs IPC minorista: -1.3% pp (IPC +2.1%)</a:t>
             </a:r>
           </a:p>
         </p:txBody>
@@ -6647,7 +6648,7 @@
 </p:sld>
 </file>
 
-<file path=ppt/slides/slide6.xml><?xml version="1.0" encoding="utf-8"?>
+<file path=ppt/slides/slide5.xml><?xml version="1.0" encoding="utf-8"?>
 <p:sld xmlns:a="http://schemas.openxmlformats.org/drawingml/2006/main" xmlns:p="http://schemas.openxmlformats.org/presentationml/2006/main" xmlns:r="http://schemas.openxmlformats.org/officeDocument/2006/relationships">
   <p:cSld>
     <p:spTree>
@@ -6730,7 +6731,7 @@
                 </a:solidFill>
                 <a:latin typeface="Encode Sans"/>
               </a:rPr>
-              <a:t>IPP PRODUCTOR JULIO 2026: +0.89%</a:t>
+              <a:t>IPIB BÁSICOS AGOSTO 2026: +2.27%</a:t>
             </a:r>
           </a:p>
         </p:txBody>
@@ -6764,7 +6765,7 @@
                 </a:solidFill>
                 <a:latin typeface="Encode Sans"/>
               </a:rPr>
-              <a:t>INDEC · período 2026-07</a:t>
+              <a:t>INDEC · período 2026-08</a:t>
             </a:r>
           </a:p>
         </p:txBody>
@@ -6799,7 +6800,7 @@
                 </a:solidFill>
                 <a:latin typeface="Encode Sans"/>
               </a:rPr>
-              <a:t>El IPP productor registró un aumento de +0.89% mensual en julio 2026, acumulando 31.31% interanual. Suele anticipar el IPC minorista.</a:t>
+              <a:t>El IPIB básicos registró un aumento de +2.27% mensual en agosto 2026, acumulando 28.86% interanual. Suele anticipar el IPC minorista.</a:t>
             </a:r>
           </a:p>
         </p:txBody>
@@ -6847,7 +6848,7 @@
                 </a:solidFill>
                 <a:latin typeface="Encode Sans"/>
               </a:rPr>
-              <a:t>Nivel general: +0.89% mensual</a:t>
+              <a:t>Nivel general: +2.27% mensual</a:t>
             </a:r>
           </a:p>
           <a:p>
@@ -6872,7 +6873,7 @@
                 </a:solidFill>
                 <a:latin typeface="Encode Sans"/>
               </a:rPr>
-              <a:t>Interanual: 31.31%</a:t>
+              <a:t>Interanual: 28.86%</a:t>
             </a:r>
           </a:p>
           <a:p>
@@ -6897,7 +6898,7 @@
                 </a:solidFill>
                 <a:latin typeface="Encode Sans"/>
               </a:rPr>
-              <a:t>Brecha vs IPC minorista: -1.2% pp (IPC +2.1%)</a:t>
+              <a:t>Brecha vs IPC minorista: +0.6% pp (IPC +1.7%)</a:t>
             </a:r>
           </a:p>
         </p:txBody>
@@ -7057,7 +7058,7 @@
                           </a:solidFill>
                           <a:latin typeface="Encode Sans"/>
                         </a:rPr>
-                        <a:t>+2.26%</a:t>
+                        <a:t>+2.27%</a:t>
                       </a:r>
                     </a:p>
                   </a:txBody>
@@ -7080,7 +7081,7 @@
                           </a:solidFill>
                           <a:latin typeface="Encode Sans"/>
                         </a:rPr>
-                        <a:t>+29.7%</a:t>
+                        <a:t>+28.9%</a:t>
                       </a:r>
                     </a:p>
                   </a:txBody>
@@ -7128,7 +7129,7 @@
                           </a:solidFill>
                           <a:latin typeface="Encode Sans"/>
                         </a:rPr>
-                        <a:t>+0.89%</a:t>
+                        <a:t>+0.85%</a:t>
                       </a:r>
                     </a:p>
                   </a:txBody>
@@ -7151,7 +7152,7 @@
                           </a:solidFill>
                           <a:latin typeface="Encode Sans"/>
                         </a:rPr>
-                        <a:t>+31.3%</a:t>
+                        <a:t>+30.2%</a:t>
                       </a:r>
                     </a:p>
                   </a:txBody>
@@ -7199,7 +7200,7 @@
                           </a:solidFill>
                           <a:latin typeface="Encode Sans"/>
                         </a:rPr>
-                        <a:t>+1.06%</a:t>
+                        <a:t>+1.15%</a:t>
                       </a:r>
                     </a:p>
                   </a:txBody>
@@ -7222,7 +7223,7 @@
                           </a:solidFill>
                           <a:latin typeface="Encode Sans"/>
                         </a:rPr>
-                        <a:t>+34.0%</a:t>
+                        <a:t>+33.0%</a:t>
                       </a:r>
                     </a:p>
                   </a:txBody>
@@ -7270,7 +7271,7 @@
                           </a:solidFill>
                           <a:latin typeface="Encode Sans"/>
                         </a:rPr>
-                        <a:t>+2.67%</a:t>
+                        <a:t>+2.68%</a:t>
                       </a:r>
                     </a:p>
                   </a:txBody>
@@ -7293,7 +7294,7 @@
                           </a:solidFill>
                           <a:latin typeface="Encode Sans"/>
                         </a:rPr>
-                        <a:t>+34.6%</a:t>
+                        <a:t>+33.5%</a:t>
                       </a:r>
                     </a:p>
                   </a:txBody>
@@ -7341,7 +7342,7 @@
                           </a:solidFill>
                           <a:latin typeface="Encode Sans"/>
                         </a:rPr>
-                        <a:t>+4.79%</a:t>
+                        <a:t>+4.76%</a:t>
                       </a:r>
                     </a:p>
                   </a:txBody>
@@ -7364,7 +7365,7 @@
                           </a:solidFill>
                           <a:latin typeface="Encode Sans"/>
                         </a:rPr>
-                        <a:t>+30.9%</a:t>
+                        <a:t>+29.6%</a:t>
                       </a:r>
                     </a:p>
                   </a:txBody>
@@ -7412,7 +7413,7 @@
                           </a:solidFill>
                           <a:latin typeface="Encode Sans"/>
                         </a:rPr>
-                        <a:t>+2.95%</a:t>
+                        <a:t>+3.00%</a:t>
                       </a:r>
                     </a:p>
                   </a:txBody>
@@ -7435,7 +7436,7 @@
                           </a:solidFill>
                           <a:latin typeface="Encode Sans"/>
                         </a:rPr>
-                        <a:t>+28.1%</a:t>
+                        <a:t>+27.1%</a:t>
                       </a:r>
                     </a:p>
                   </a:txBody>
@@ -7492,7 +7493,7 @@
 </p:sld>
 </file>
 
-<file path=ppt/slides/slide7.xml><?xml version="1.0" encoding="utf-8"?>
+<file path=ppt/slides/slide6.xml><?xml version="1.0" encoding="utf-8"?>
 <p:sld xmlns:a="http://schemas.openxmlformats.org/drawingml/2006/main" xmlns:p="http://schemas.openxmlformats.org/presentationml/2006/main" xmlns:r="http://schemas.openxmlformats.org/officeDocument/2006/relationships">
   <p:cSld>
     <p:spTree>
@@ -7575,7 +7576,7 @@
                 </a:solidFill>
                 <a:latin typeface="Encode Sans"/>
               </a:rPr>
-              <a:t>IPP PRODUCTOR AGOSTO 2026: +2.26%</a:t>
+              <a:t>IPP PRODUCTOR JULIO 2026: +0.89%</a:t>
             </a:r>
           </a:p>
         </p:txBody>
@@ -7609,7 +7610,7 @@
                 </a:solidFill>
                 <a:latin typeface="Encode Sans"/>
               </a:rPr>
-              <a:t>INDEC · período 2026-08</a:t>
+              <a:t>INDEC · período 2026-07</a:t>
             </a:r>
           </a:p>
         </p:txBody>
@@ -7644,7 +7645,7 @@
                 </a:solidFill>
                 <a:latin typeface="Encode Sans"/>
               </a:rPr>
-              <a:t>El IPP productor registró un aumento de +2.26% mensual en agosto 2026, acumulando 29.71% interanual. Suele anticipar el IPC minorista.</a:t>
+              <a:t>El IPP productor registró un aumento de +0.89% mensual en julio 2026, acumulando 31.31% interanual. Suele anticipar el IPC minorista.</a:t>
             </a:r>
           </a:p>
         </p:txBody>
@@ -7692,7 +7693,7 @@
                 </a:solidFill>
                 <a:latin typeface="Encode Sans"/>
               </a:rPr>
-              <a:t>Nivel general: +2.26% mensual</a:t>
+              <a:t>Nivel general: +0.89% mensual</a:t>
             </a:r>
           </a:p>
           <a:p>
@@ -7717,7 +7718,7 @@
                 </a:solidFill>
                 <a:latin typeface="Encode Sans"/>
               </a:rPr>
-              <a:t>Interanual: 29.71%</a:t>
+              <a:t>Interanual: 31.31%</a:t>
             </a:r>
           </a:p>
           <a:p>
@@ -7742,7 +7743,7 @@
                 </a:solidFill>
                 <a:latin typeface="Encode Sans"/>
               </a:rPr>
-              <a:t>Brecha vs IPC minorista: +0.6% pp (IPC +1.7%)</a:t>
+              <a:t>Brecha vs IPC minorista: -1.2% pp (IPC +2.1%)</a:t>
             </a:r>
           </a:p>
         </p:txBody>
@@ -8337,7 +8338,7 @@
 </p:sld>
 </file>
 
-<file path=ppt/slides/slide8.xml><?xml version="1.0" encoding="utf-8"?>
+<file path=ppt/slides/slide7.xml><?xml version="1.0" encoding="utf-8"?>
 <p:sld xmlns:a="http://schemas.openxmlformats.org/drawingml/2006/main" xmlns:p="http://schemas.openxmlformats.org/presentationml/2006/main" xmlns:r="http://schemas.openxmlformats.org/officeDocument/2006/relationships">
   <p:cSld>
     <p:spTree>
@@ -8420,7 +8421,7 @@
                 </a:solidFill>
                 <a:latin typeface="Encode Sans"/>
               </a:rPr>
-              <a:t>PBI TRIMESTRAL 2DO TRIMESTRE 2026</a:t>
+              <a:t>IPP PRODUCTOR AGOSTO 2026: +2.26%</a:t>
             </a:r>
           </a:p>
         </p:txBody>
@@ -8454,7 +8455,7 @@
                 </a:solidFill>
                 <a:latin typeface="Encode Sans"/>
               </a:rPr>
-              <a:t>INDEC CCNN · período 2do trimestre 2026</a:t>
+              <a:t>INDEC · período 2026-08</a:t>
             </a:r>
           </a:p>
         </p:txBody>
@@ -8489,7 +8490,7 @@
                 </a:solidFill>
                 <a:latin typeface="Encode Sans"/>
               </a:rPr>
-              <a:t>Se publicó la actualización de PBI trimestral para 2do trimestre 2026. Fuente: INDEC CCNN.</a:t>
+              <a:t>El IPP productor registró un aumento de +2.26% mensual en agosto 2026, acumulando 29.71% interanual. Suele anticipar el IPC minorista.</a:t>
             </a:r>
           </a:p>
         </p:txBody>
@@ -8537,7 +8538,7 @@
                 </a:solidFill>
                 <a:latin typeface="Encode Sans"/>
               </a:rPr>
-              <a:t>pbi: 792.800,00</a:t>
+              <a:t>Nivel general: +2.26% mensual</a:t>
             </a:r>
           </a:p>
           <a:p>
@@ -8562,231 +8563,9 @@
                 </a:solidFill>
                 <a:latin typeface="Encode Sans"/>
               </a:rPr>
-              <a:t>via: 2,00</a:t>
-            </a:r>
-          </a:p>
-        </p:txBody>
-      </p:sp>
-      <p:sp>
-        <p:nvSpPr>
-          <p:cNvPr id="7" name="TextBox 6"/>
-          <p:cNvSpPr txBox="1"/>
-          <p:nvPr/>
-        </p:nvSpPr>
-        <p:spPr>
-          <a:xfrm>
-            <a:off x="411480" y="6492240"/>
-            <a:ext cx="11368735" cy="274320"/>
-          </a:xfrm>
-          <a:prstGeom prst="rect">
-            <a:avLst/>
-          </a:prstGeom>
-          <a:noFill/>
-        </p:spPr>
-        <p:txBody>
-          <a:bodyPr wrap="none">
-            <a:spAutoFit/>
-          </a:bodyPr>
-          <a:lstStyle/>
-          <a:p>
-            <a:r>
-              <a:rPr sz="1000" b="0" i="1">
-                <a:solidFill>
-                  <a:srgbClr val="6A6760"/>
-                </a:solidFill>
-                <a:latin typeface="Encode Sans"/>
-              </a:rPr>
-              <a:t>Fuente: elaboración propia en base a INDEC CCNN</a:t>
-            </a:r>
-          </a:p>
-        </p:txBody>
-      </p:sp>
-    </p:spTree>
-  </p:cSld>
-  <p:clrMapOvr>
-    <a:masterClrMapping/>
-  </p:clrMapOvr>
-</p:sld>
-</file>
-
-<file path=ppt/slides/slide9.xml><?xml version="1.0" encoding="utf-8"?>
-<p:sld xmlns:a="http://schemas.openxmlformats.org/drawingml/2006/main" xmlns:p="http://schemas.openxmlformats.org/presentationml/2006/main" xmlns:r="http://schemas.openxmlformats.org/officeDocument/2006/relationships">
-  <p:cSld>
-    <p:spTree>
-      <p:nvGrpSpPr>
-        <p:cNvPr id="1" name=""/>
-        <p:cNvGrpSpPr/>
-        <p:nvPr/>
-      </p:nvGrpSpPr>
-      <p:grpSpPr/>
-      <p:sp>
-        <p:nvSpPr>
-          <p:cNvPr id="2" name="Rectangle 1"/>
-          <p:cNvSpPr/>
-          <p:nvPr/>
-        </p:nvSpPr>
-        <p:spPr>
-          <a:xfrm>
-            <a:off x="0" y="0"/>
-            <a:ext cx="12191695" cy="274320"/>
-          </a:xfrm>
-          <a:prstGeom prst="rect">
-            <a:avLst/>
-          </a:prstGeom>
-          <a:solidFill>
-            <a:srgbClr val="00B2C9"/>
-          </a:solidFill>
-          <a:ln>
-            <a:noFill/>
-          </a:ln>
-        </p:spPr>
-        <p:style>
-          <a:lnRef idx="1">
-            <a:schemeClr val="accent1"/>
-          </a:lnRef>
-          <a:fillRef idx="3">
-            <a:schemeClr val="accent1"/>
-          </a:fillRef>
-          <a:effectRef idx="2">
-            <a:schemeClr val="accent1"/>
-          </a:effectRef>
-          <a:fontRef idx="minor">
-            <a:schemeClr val="lt1"/>
-          </a:fontRef>
-        </p:style>
-        <p:txBody>
-          <a:bodyPr rtlCol="0" anchor="ctr"/>
-          <a:lstStyle/>
-          <a:p>
-            <a:pPr algn="ctr"/>
-          </a:p>
-        </p:txBody>
-      </p:sp>
-      <p:sp>
-        <p:nvSpPr>
-          <p:cNvPr id="3" name="TextBox 2"/>
-          <p:cNvSpPr txBox="1"/>
-          <p:nvPr/>
-        </p:nvSpPr>
-        <p:spPr>
-          <a:xfrm>
-            <a:off x="411480" y="457200"/>
-            <a:ext cx="11368735" cy="914400"/>
-          </a:xfrm>
-          <a:prstGeom prst="rect">
-            <a:avLst/>
-          </a:prstGeom>
-          <a:noFill/>
-        </p:spPr>
-        <p:txBody>
-          <a:bodyPr wrap="square" lIns="0" rIns="0">
-            <a:spAutoFit/>
-          </a:bodyPr>
-          <a:lstStyle/>
-          <a:p>
-            <a:pPr algn="l"/>
-            <a:r>
-              <a:rPr sz="2600" b="1" i="0">
-                <a:solidFill>
-                  <a:srgbClr val="00B2C9"/>
-                </a:solidFill>
-                <a:latin typeface="Encode Sans"/>
-              </a:rPr>
-              <a:t>FISCAL AGOSTO 2026: SUPERÁVIT PRIMARIO $1.990K M$</a:t>
-            </a:r>
-          </a:p>
-        </p:txBody>
-      </p:sp>
-      <p:sp>
-        <p:nvSpPr>
-          <p:cNvPr id="4" name="TextBox 3"/>
-          <p:cNvSpPr txBox="1"/>
-          <p:nvPr/>
-        </p:nvSpPr>
-        <p:spPr>
-          <a:xfrm>
-            <a:off x="411480" y="1280160"/>
-            <a:ext cx="11368735" cy="274320"/>
-          </a:xfrm>
-          <a:prstGeom prst="rect">
-            <a:avLst/>
-          </a:prstGeom>
-          <a:noFill/>
-        </p:spPr>
-        <p:txBody>
-          <a:bodyPr wrap="none">
-            <a:spAutoFit/>
-          </a:bodyPr>
-          <a:lstStyle/>
-          <a:p>
-            <a:r>
-              <a:rPr sz="1100" b="0" i="1">
-                <a:solidFill>
-                  <a:srgbClr val="6A6760"/>
-                </a:solidFill>
-                <a:latin typeface="Encode Sans"/>
-              </a:rPr>
-              <a:t>Hacienda (vía INDEC IMIG) · período 2026-08</a:t>
-            </a:r>
-          </a:p>
-        </p:txBody>
-      </p:sp>
-      <p:sp>
-        <p:nvSpPr>
-          <p:cNvPr id="5" name="TextBox 4"/>
-          <p:cNvSpPr txBox="1"/>
-          <p:nvPr/>
-        </p:nvSpPr>
-        <p:spPr>
-          <a:xfrm>
-            <a:off x="411480" y="1691640"/>
-            <a:ext cx="5486400" cy="1645920"/>
-          </a:xfrm>
-          <a:prstGeom prst="rect">
-            <a:avLst/>
-          </a:prstGeom>
-          <a:noFill/>
-        </p:spPr>
-        <p:txBody>
-          <a:bodyPr wrap="square" lIns="0" rIns="0">
-            <a:spAutoFit/>
-          </a:bodyPr>
-          <a:lstStyle/>
-          <a:p>
-            <a:pPr algn="just"/>
-            <a:r>
-              <a:rPr sz="1300" b="0" i="0">
-                <a:solidFill>
-                  <a:srgbClr val="3F3F3F"/>
-                </a:solidFill>
-                <a:latin typeface="Encode Sans"/>
-              </a:rPr>
-              <a:t>El Sector Público Nacional No Financiero registró un resultado primario de +1.990 mil millones de pesos en agosto 2026. El resultado financiero alcanzó +636K M$.</a:t>
-            </a:r>
-          </a:p>
-        </p:txBody>
-      </p:sp>
-      <p:sp>
-        <p:nvSpPr>
-          <p:cNvPr id="6" name="TextBox 5"/>
-          <p:cNvSpPr txBox="1"/>
-          <p:nvPr/>
-        </p:nvSpPr>
-        <p:spPr>
-          <a:xfrm>
-            <a:off x="411480" y="3520440"/>
-            <a:ext cx="5486400" cy="2743200"/>
-          </a:xfrm>
-          <a:prstGeom prst="rect">
-            <a:avLst/>
-          </a:prstGeom>
-          <a:noFill/>
-        </p:spPr>
-        <p:txBody>
-          <a:bodyPr wrap="square" lIns="0" rIns="0">
-            <a:spAutoFit/>
-          </a:bodyPr>
-          <a:lstStyle/>
+              <a:t>Interanual: 29.71%</a:t>
+            </a:r>
+          </a:p>
           <a:p>
             <a:pPr algn="l">
               <a:spcAft>
@@ -8809,57 +8588,7 @@
                 </a:solidFill>
                 <a:latin typeface="Encode Sans"/>
               </a:rPr>
-              <a:t>Resultado primario: +1.990 mil millones de pesos</a:t>
-            </a:r>
-          </a:p>
-          <a:p>
-            <a:pPr algn="l">
-              <a:spcAft>
-                <a:spcPts val="800"/>
-              </a:spcAft>
-            </a:pPr>
-            <a:r>
-              <a:rPr sz="1300" b="1" i="0">
-                <a:solidFill>
-                  <a:srgbClr val="00B2C9"/>
-                </a:solidFill>
-                <a:latin typeface="Encode Sans"/>
-              </a:rPr>
-              <a:t>●  </a:t>
-            </a:r>
-            <a:r>
-              <a:rPr sz="1300" b="0" i="0">
-                <a:solidFill>
-                  <a:srgbClr val="3F3F3F"/>
-                </a:solidFill>
-                <a:latin typeface="Encode Sans"/>
-              </a:rPr>
-              <a:t>Resultado financiero: +636 mil millones</a:t>
-            </a:r>
-          </a:p>
-          <a:p>
-            <a:pPr algn="l">
-              <a:spcAft>
-                <a:spcPts val="800"/>
-              </a:spcAft>
-            </a:pPr>
-            <a:r>
-              <a:rPr sz="1300" b="1" i="0">
-                <a:solidFill>
-                  <a:srgbClr val="00B2C9"/>
-                </a:solidFill>
-                <a:latin typeface="Encode Sans"/>
-              </a:rPr>
-              <a:t>●  </a:t>
-            </a:r>
-            <a:r>
-              <a:rPr sz="1300" b="0" i="0">
-                <a:solidFill>
-                  <a:srgbClr val="3F3F3F"/>
-                </a:solidFill>
-                <a:latin typeface="Encode Sans"/>
-              </a:rPr>
-              <a:t>Fuente: Secretaría de Hacienda, base caja (Metodología 2017)</a:t>
+              <a:t>Brecha vs IPC minorista: +0.6% pp (IPC +1.7%)</a:t>
             </a:r>
           </a:p>
         </p:txBody>
@@ -8948,7 +8677,7 @@
                           </a:solidFill>
                           <a:latin typeface="Encode Sans"/>
                         </a:rPr>
-                        <a:t>Primario M$</a:t>
+                        <a:t>VM %</a:t>
                       </a:r>
                     </a:p>
                   </a:txBody>
@@ -8971,7 +8700,7 @@
                           </a:solidFill>
                           <a:latin typeface="Encode Sans"/>
                         </a:rPr>
-                        <a:t>Financiero M$</a:t>
+                        <a:t>VIA %</a:t>
                       </a:r>
                     </a:p>
                   </a:txBody>
@@ -9019,7 +8748,7 @@
                           </a:solidFill>
                           <a:latin typeface="Encode Sans"/>
                         </a:rPr>
-                        <a:t>1.990.322</a:t>
+                        <a:t>+2.26%</a:t>
                       </a:r>
                     </a:p>
                   </a:txBody>
@@ -9042,7 +8771,7 @@
                           </a:solidFill>
                           <a:latin typeface="Encode Sans"/>
                         </a:rPr>
-                        <a:t>635.529</a:t>
+                        <a:t>+29.7%</a:t>
                       </a:r>
                     </a:p>
                   </a:txBody>
@@ -9090,7 +8819,7 @@
                           </a:solidFill>
                           <a:latin typeface="Encode Sans"/>
                         </a:rPr>
-                        <a:t>2.960.333</a:t>
+                        <a:t>+0.89%</a:t>
                       </a:r>
                     </a:p>
                   </a:txBody>
@@ -9113,7 +8842,7 @@
                           </a:solidFill>
                           <a:latin typeface="Encode Sans"/>
                         </a:rPr>
-                        <a:t>244.897</a:t>
+                        <a:t>+31.3%</a:t>
                       </a:r>
                     </a:p>
                   </a:txBody>
@@ -9161,7 +8890,7 @@
                           </a:solidFill>
                           <a:latin typeface="Encode Sans"/>
                         </a:rPr>
-                        <a:t>-696.843</a:t>
+                        <a:t>+1.06%</a:t>
                       </a:r>
                     </a:p>
                   </a:txBody>
@@ -9184,7 +8913,7 @@
                           </a:solidFill>
                           <a:latin typeface="Encode Sans"/>
                         </a:rPr>
-                        <a:t>-1.024.891</a:t>
+                        <a:t>+34.0%</a:t>
                       </a:r>
                     </a:p>
                   </a:txBody>
@@ -9232,7 +8961,7 @@
                           </a:solidFill>
                           <a:latin typeface="Encode Sans"/>
                         </a:rPr>
-                        <a:t>1.924.367</a:t>
+                        <a:t>+2.67%</a:t>
                       </a:r>
                     </a:p>
                   </a:txBody>
@@ -9255,7 +8984,7 @@
                           </a:solidFill>
                           <a:latin typeface="Encode Sans"/>
                         </a:rPr>
-                        <a:t>506.761</a:t>
+                        <a:t>+34.6%</a:t>
                       </a:r>
                     </a:p>
                   </a:txBody>
@@ -9303,7 +9032,7 @@
                           </a:solidFill>
                           <a:latin typeface="Encode Sans"/>
                         </a:rPr>
-                        <a:t>632.844</a:t>
+                        <a:t>+4.79%</a:t>
                       </a:r>
                     </a:p>
                   </a:txBody>
@@ -9326,7 +9055,7 @@
                           </a:solidFill>
                           <a:latin typeface="Encode Sans"/>
                         </a:rPr>
-                        <a:t>356.292</a:t>
+                        <a:t>+30.9%</a:t>
                       </a:r>
                     </a:p>
                   </a:txBody>
@@ -9374,7 +9103,7 @@
                           </a:solidFill>
                           <a:latin typeface="Encode Sans"/>
                         </a:rPr>
-                        <a:t>930.284</a:t>
+                        <a:t>+2.95%</a:t>
                       </a:r>
                     </a:p>
                   </a:txBody>
@@ -9397,7 +9126,7 @@
                           </a:solidFill>
                           <a:latin typeface="Encode Sans"/>
                         </a:rPr>
-                        <a:t>246.434</a:t>
+                        <a:t>+28.1%</a:t>
                       </a:r>
                     </a:p>
                   </a:txBody>
@@ -9441,7 +9170,1311 @@
                 </a:solidFill>
                 <a:latin typeface="Encode Sans"/>
               </a:rPr>
-              <a:t>Fuente: elaboración propia en base a Hacienda (vía INDEC IMIG)</a:t>
+              <a:t>Fuente: elaboración propia en base a INDEC</a:t>
+            </a:r>
+          </a:p>
+        </p:txBody>
+      </p:sp>
+    </p:spTree>
+  </p:cSld>
+  <p:clrMapOvr>
+    <a:masterClrMapping/>
+  </p:clrMapOvr>
+</p:sld>
+</file>
+
+<file path=ppt/slides/slide8.xml><?xml version="1.0" encoding="utf-8"?>
+<p:sld xmlns:a="http://schemas.openxmlformats.org/drawingml/2006/main" xmlns:p="http://schemas.openxmlformats.org/presentationml/2006/main" xmlns:r="http://schemas.openxmlformats.org/officeDocument/2006/relationships">
+  <p:cSld>
+    <p:spTree>
+      <p:nvGrpSpPr>
+        <p:cNvPr id="1" name=""/>
+        <p:cNvGrpSpPr/>
+        <p:nvPr/>
+      </p:nvGrpSpPr>
+      <p:grpSpPr/>
+      <p:sp>
+        <p:nvSpPr>
+          <p:cNvPr id="2" name="Rectangle 1"/>
+          <p:cNvSpPr/>
+          <p:nvPr/>
+        </p:nvSpPr>
+        <p:spPr>
+          <a:xfrm>
+            <a:off x="0" y="0"/>
+            <a:ext cx="12191695" cy="274320"/>
+          </a:xfrm>
+          <a:prstGeom prst="rect">
+            <a:avLst/>
+          </a:prstGeom>
+          <a:solidFill>
+            <a:srgbClr val="00B2C9"/>
+          </a:solidFill>
+          <a:ln>
+            <a:noFill/>
+          </a:ln>
+        </p:spPr>
+        <p:style>
+          <a:lnRef idx="1">
+            <a:schemeClr val="accent1"/>
+          </a:lnRef>
+          <a:fillRef idx="3">
+            <a:schemeClr val="accent1"/>
+          </a:fillRef>
+          <a:effectRef idx="2">
+            <a:schemeClr val="accent1"/>
+          </a:effectRef>
+          <a:fontRef idx="minor">
+            <a:schemeClr val="lt1"/>
+          </a:fontRef>
+        </p:style>
+        <p:txBody>
+          <a:bodyPr rtlCol="0" anchor="ctr"/>
+          <a:lstStyle/>
+          <a:p>
+            <a:pPr algn="ctr"/>
+          </a:p>
+        </p:txBody>
+      </p:sp>
+      <p:sp>
+        <p:nvSpPr>
+          <p:cNvPr id="3" name="TextBox 2"/>
+          <p:cNvSpPr txBox="1"/>
+          <p:nvPr/>
+        </p:nvSpPr>
+        <p:spPr>
+          <a:xfrm>
+            <a:off x="411480" y="457200"/>
+            <a:ext cx="11368735" cy="914400"/>
+          </a:xfrm>
+          <a:prstGeom prst="rect">
+            <a:avLst/>
+          </a:prstGeom>
+          <a:noFill/>
+        </p:spPr>
+        <p:txBody>
+          <a:bodyPr wrap="square" lIns="0" rIns="0">
+            <a:spAutoFit/>
+          </a:bodyPr>
+          <a:lstStyle/>
+          <a:p>
+            <a:pPr algn="l"/>
+            <a:r>
+              <a:rPr sz="2600" b="1" i="0">
+                <a:solidFill>
+                  <a:srgbClr val="00B2C9"/>
+                </a:solidFill>
+                <a:latin typeface="Encode Sans"/>
+              </a:rPr>
+              <a:t>PBI TRIMESTRAL 2DO TRIMESTRE 2026</a:t>
+            </a:r>
+          </a:p>
+        </p:txBody>
+      </p:sp>
+      <p:sp>
+        <p:nvSpPr>
+          <p:cNvPr id="4" name="TextBox 3"/>
+          <p:cNvSpPr txBox="1"/>
+          <p:nvPr/>
+        </p:nvSpPr>
+        <p:spPr>
+          <a:xfrm>
+            <a:off x="411480" y="1280160"/>
+            <a:ext cx="11368735" cy="274320"/>
+          </a:xfrm>
+          <a:prstGeom prst="rect">
+            <a:avLst/>
+          </a:prstGeom>
+          <a:noFill/>
+        </p:spPr>
+        <p:txBody>
+          <a:bodyPr wrap="none">
+            <a:spAutoFit/>
+          </a:bodyPr>
+          <a:lstStyle/>
+          <a:p>
+            <a:r>
+              <a:rPr sz="1100" b="0" i="1">
+                <a:solidFill>
+                  <a:srgbClr val="6A6760"/>
+                </a:solidFill>
+                <a:latin typeface="Encode Sans"/>
+              </a:rPr>
+              <a:t>INDEC CCNN · período 2do trimestre 2026</a:t>
+            </a:r>
+          </a:p>
+        </p:txBody>
+      </p:sp>
+      <p:sp>
+        <p:nvSpPr>
+          <p:cNvPr id="5" name="TextBox 4"/>
+          <p:cNvSpPr txBox="1"/>
+          <p:nvPr/>
+        </p:nvSpPr>
+        <p:spPr>
+          <a:xfrm>
+            <a:off x="411480" y="1691640"/>
+            <a:ext cx="5486400" cy="1645920"/>
+          </a:xfrm>
+          <a:prstGeom prst="rect">
+            <a:avLst/>
+          </a:prstGeom>
+          <a:noFill/>
+        </p:spPr>
+        <p:txBody>
+          <a:bodyPr wrap="square" lIns="0" rIns="0">
+            <a:spAutoFit/>
+          </a:bodyPr>
+          <a:lstStyle/>
+          <a:p>
+            <a:pPr algn="just"/>
+            <a:r>
+              <a:rPr sz="1300" b="0" i="0">
+                <a:solidFill>
+                  <a:srgbClr val="3F3F3F"/>
+                </a:solidFill>
+                <a:latin typeface="Encode Sans"/>
+              </a:rPr>
+              <a:t>Se publicó la actualización de PBI trimestral para 2do trimestre 2026. Fuente: INDEC CCNN.</a:t>
+            </a:r>
+          </a:p>
+        </p:txBody>
+      </p:sp>
+      <p:sp>
+        <p:nvSpPr>
+          <p:cNvPr id="6" name="TextBox 5"/>
+          <p:cNvSpPr txBox="1"/>
+          <p:nvPr/>
+        </p:nvSpPr>
+        <p:spPr>
+          <a:xfrm>
+            <a:off x="411480" y="3520440"/>
+            <a:ext cx="5486400" cy="2743200"/>
+          </a:xfrm>
+          <a:prstGeom prst="rect">
+            <a:avLst/>
+          </a:prstGeom>
+          <a:noFill/>
+        </p:spPr>
+        <p:txBody>
+          <a:bodyPr wrap="square" lIns="0" rIns="0">
+            <a:spAutoFit/>
+          </a:bodyPr>
+          <a:lstStyle/>
+          <a:p>
+            <a:pPr algn="l">
+              <a:spcAft>
+                <a:spcPts val="800"/>
+              </a:spcAft>
+            </a:pPr>
+            <a:r>
+              <a:rPr sz="1300" b="1" i="0">
+                <a:solidFill>
+                  <a:srgbClr val="00B2C9"/>
+                </a:solidFill>
+                <a:latin typeface="Encode Sans"/>
+              </a:rPr>
+              <a:t>●  </a:t>
+            </a:r>
+            <a:r>
+              <a:rPr sz="1300" b="0" i="0">
+                <a:solidFill>
+                  <a:srgbClr val="3F3F3F"/>
+                </a:solidFill>
+                <a:latin typeface="Encode Sans"/>
+              </a:rPr>
+              <a:t>pbi: 792.800,00</a:t>
+            </a:r>
+          </a:p>
+          <a:p>
+            <a:pPr algn="l">
+              <a:spcAft>
+                <a:spcPts val="800"/>
+              </a:spcAft>
+            </a:pPr>
+            <a:r>
+              <a:rPr sz="1300" b="1" i="0">
+                <a:solidFill>
+                  <a:srgbClr val="00B2C9"/>
+                </a:solidFill>
+                <a:latin typeface="Encode Sans"/>
+              </a:rPr>
+              <a:t>●  </a:t>
+            </a:r>
+            <a:r>
+              <a:rPr sz="1300" b="0" i="0">
+                <a:solidFill>
+                  <a:srgbClr val="3F3F3F"/>
+                </a:solidFill>
+                <a:latin typeface="Encode Sans"/>
+              </a:rPr>
+              <a:t>via: 2,00</a:t>
+            </a:r>
+          </a:p>
+        </p:txBody>
+      </p:sp>
+      <p:sp>
+        <p:nvSpPr>
+          <p:cNvPr id="7" name="TextBox 6"/>
+          <p:cNvSpPr txBox="1"/>
+          <p:nvPr/>
+        </p:nvSpPr>
+        <p:spPr>
+          <a:xfrm>
+            <a:off x="411480" y="6492240"/>
+            <a:ext cx="11368735" cy="274320"/>
+          </a:xfrm>
+          <a:prstGeom prst="rect">
+            <a:avLst/>
+          </a:prstGeom>
+          <a:noFill/>
+        </p:spPr>
+        <p:txBody>
+          <a:bodyPr wrap="none">
+            <a:spAutoFit/>
+          </a:bodyPr>
+          <a:lstStyle/>
+          <a:p>
+            <a:r>
+              <a:rPr sz="1000" b="0" i="1">
+                <a:solidFill>
+                  <a:srgbClr val="6A6760"/>
+                </a:solidFill>
+                <a:latin typeface="Encode Sans"/>
+              </a:rPr>
+              <a:t>Fuente: elaboración propia en base a INDEC CCNN</a:t>
+            </a:r>
+          </a:p>
+        </p:txBody>
+      </p:sp>
+    </p:spTree>
+  </p:cSld>
+  <p:clrMapOvr>
+    <a:masterClrMapping/>
+  </p:clrMapOvr>
+</p:sld>
+</file>
+
+<file path=ppt/slides/slide9.xml><?xml version="1.0" encoding="utf-8"?>
+<p:sld xmlns:a="http://schemas.openxmlformats.org/drawingml/2006/main" xmlns:p="http://schemas.openxmlformats.org/presentationml/2006/main" xmlns:r="http://schemas.openxmlformats.org/officeDocument/2006/relationships">
+  <p:cSld>
+    <p:spTree>
+      <p:nvGrpSpPr>
+        <p:cNvPr id="1" name=""/>
+        <p:cNvGrpSpPr/>
+        <p:nvPr/>
+      </p:nvGrpSpPr>
+      <p:grpSpPr/>
+      <p:sp>
+        <p:nvSpPr>
+          <p:cNvPr id="2" name="Rectangle 1"/>
+          <p:cNvSpPr/>
+          <p:nvPr/>
+        </p:nvSpPr>
+        <p:spPr>
+          <a:xfrm>
+            <a:off x="0" y="0"/>
+            <a:ext cx="12191695" cy="274320"/>
+          </a:xfrm>
+          <a:prstGeom prst="rect">
+            <a:avLst/>
+          </a:prstGeom>
+          <a:solidFill>
+            <a:srgbClr val="00B2C9"/>
+          </a:solidFill>
+          <a:ln>
+            <a:noFill/>
+          </a:ln>
+        </p:spPr>
+        <p:style>
+          <a:lnRef idx="1">
+            <a:schemeClr val="accent1"/>
+          </a:lnRef>
+          <a:fillRef idx="3">
+            <a:schemeClr val="accent1"/>
+          </a:fillRef>
+          <a:effectRef idx="2">
+            <a:schemeClr val="accent1"/>
+          </a:effectRef>
+          <a:fontRef idx="minor">
+            <a:schemeClr val="lt1"/>
+          </a:fontRef>
+        </p:style>
+        <p:txBody>
+          <a:bodyPr rtlCol="0" anchor="ctr"/>
+          <a:lstStyle/>
+          <a:p>
+            <a:pPr algn="ctr"/>
+          </a:p>
+        </p:txBody>
+      </p:sp>
+      <p:sp>
+        <p:nvSpPr>
+          <p:cNvPr id="3" name="TextBox 2"/>
+          <p:cNvSpPr txBox="1"/>
+          <p:nvPr/>
+        </p:nvSpPr>
+        <p:spPr>
+          <a:xfrm>
+            <a:off x="411480" y="457200"/>
+            <a:ext cx="11368735" cy="914400"/>
+          </a:xfrm>
+          <a:prstGeom prst="rect">
+            <a:avLst/>
+          </a:prstGeom>
+          <a:noFill/>
+        </p:spPr>
+        <p:txBody>
+          <a:bodyPr wrap="square" lIns="0" rIns="0">
+            <a:spAutoFit/>
+          </a:bodyPr>
+          <a:lstStyle/>
+          <a:p>
+            <a:pPr algn="l"/>
+            <a:r>
+              <a:rPr sz="2600" b="1" i="0">
+                <a:solidFill>
+                  <a:srgbClr val="00B2C9"/>
+                </a:solidFill>
+                <a:latin typeface="Encode Sans"/>
+              </a:rPr>
+              <a:t>MERCADO DE TRABAJO 2DO T. 2026: DESOCUPACIÓN 7.9%</a:t>
+            </a:r>
+          </a:p>
+        </p:txBody>
+      </p:sp>
+      <p:sp>
+        <p:nvSpPr>
+          <p:cNvPr id="4" name="TextBox 3"/>
+          <p:cNvSpPr txBox="1"/>
+          <p:nvPr/>
+        </p:nvSpPr>
+        <p:spPr>
+          <a:xfrm>
+            <a:off x="411480" y="1280160"/>
+            <a:ext cx="11368735" cy="274320"/>
+          </a:xfrm>
+          <a:prstGeom prst="rect">
+            <a:avLst/>
+          </a:prstGeom>
+          <a:noFill/>
+        </p:spPr>
+        <p:txBody>
+          <a:bodyPr wrap="none">
+            <a:spAutoFit/>
+          </a:bodyPr>
+          <a:lstStyle/>
+          <a:p>
+            <a:r>
+              <a:rPr sz="1100" b="0" i="1">
+                <a:solidFill>
+                  <a:srgbClr val="6A6760"/>
+                </a:solidFill>
+                <a:latin typeface="Encode Sans"/>
+              </a:rPr>
+              <a:t>INDEC EPH · período 2do t. 2026</a:t>
+            </a:r>
+          </a:p>
+        </p:txBody>
+      </p:sp>
+      <p:sp>
+        <p:nvSpPr>
+          <p:cNvPr id="5" name="TextBox 4"/>
+          <p:cNvSpPr txBox="1"/>
+          <p:nvPr/>
+        </p:nvSpPr>
+        <p:spPr>
+          <a:xfrm>
+            <a:off x="411480" y="1691640"/>
+            <a:ext cx="5486400" cy="1645920"/>
+          </a:xfrm>
+          <a:prstGeom prst="rect">
+            <a:avLst/>
+          </a:prstGeom>
+          <a:noFill/>
+        </p:spPr>
+        <p:txBody>
+          <a:bodyPr wrap="square" lIns="0" rIns="0">
+            <a:spAutoFit/>
+          </a:bodyPr>
+          <a:lstStyle/>
+          <a:p>
+            <a:pPr algn="just"/>
+            <a:r>
+              <a:rPr sz="1300" b="0" i="0">
+                <a:solidFill>
+                  <a:srgbClr val="3F3F3F"/>
+                </a:solidFill>
+                <a:latin typeface="Encode Sans"/>
+              </a:rPr>
+              <a:t>La tasa de desocupación se ubicó en 7.9% de la PEA en el 2do t. 2026. Tasa de actividad: 48.9%; tasa de empleo: 45.0%. Vs 2do t. 2025: +0.3 pp (7.6%). Cobertura: 31 aglomerados urbanos (EPH-INDEC).</a:t>
+            </a:r>
+          </a:p>
+        </p:txBody>
+      </p:sp>
+      <p:sp>
+        <p:nvSpPr>
+          <p:cNvPr id="6" name="TextBox 5"/>
+          <p:cNvSpPr txBox="1"/>
+          <p:nvPr/>
+        </p:nvSpPr>
+        <p:spPr>
+          <a:xfrm>
+            <a:off x="411480" y="3520440"/>
+            <a:ext cx="5486400" cy="2743200"/>
+          </a:xfrm>
+          <a:prstGeom prst="rect">
+            <a:avLst/>
+          </a:prstGeom>
+          <a:noFill/>
+        </p:spPr>
+        <p:txBody>
+          <a:bodyPr wrap="square" lIns="0" rIns="0">
+            <a:spAutoFit/>
+          </a:bodyPr>
+          <a:lstStyle/>
+          <a:p>
+            <a:pPr algn="l">
+              <a:spcAft>
+                <a:spcPts val="800"/>
+              </a:spcAft>
+            </a:pPr>
+            <a:r>
+              <a:rPr sz="1300" b="1" i="0">
+                <a:solidFill>
+                  <a:srgbClr val="00B2C9"/>
+                </a:solidFill>
+                <a:latin typeface="Encode Sans"/>
+              </a:rPr>
+              <a:t>●  </a:t>
+            </a:r>
+            <a:r>
+              <a:rPr sz="1300" b="0" i="0">
+                <a:solidFill>
+                  <a:srgbClr val="3F3F3F"/>
+                </a:solidFill>
+                <a:latin typeface="Encode Sans"/>
+              </a:rPr>
+              <a:t>Desocupación: 7.9% de la población económicamente activa</a:t>
+            </a:r>
+          </a:p>
+          <a:p>
+            <a:pPr algn="l">
+              <a:spcAft>
+                <a:spcPts val="800"/>
+              </a:spcAft>
+            </a:pPr>
+            <a:r>
+              <a:rPr sz="1300" b="1" i="0">
+                <a:solidFill>
+                  <a:srgbClr val="00B2C9"/>
+                </a:solidFill>
+                <a:latin typeface="Encode Sans"/>
+              </a:rPr>
+              <a:t>●  </a:t>
+            </a:r>
+            <a:r>
+              <a:rPr sz="1300" b="0" i="0">
+                <a:solidFill>
+                  <a:srgbClr val="3F3F3F"/>
+                </a:solidFill>
+                <a:latin typeface="Encode Sans"/>
+              </a:rPr>
+              <a:t>Actividad: 48.9% de la población total</a:t>
+            </a:r>
+          </a:p>
+          <a:p>
+            <a:pPr algn="l">
+              <a:spcAft>
+                <a:spcPts val="800"/>
+              </a:spcAft>
+            </a:pPr>
+            <a:r>
+              <a:rPr sz="1300" b="1" i="0">
+                <a:solidFill>
+                  <a:srgbClr val="00B2C9"/>
+                </a:solidFill>
+                <a:latin typeface="Encode Sans"/>
+              </a:rPr>
+              <a:t>●  </a:t>
+            </a:r>
+            <a:r>
+              <a:rPr sz="1300" b="0" i="0">
+                <a:solidFill>
+                  <a:srgbClr val="3F3F3F"/>
+                </a:solidFill>
+                <a:latin typeface="Encode Sans"/>
+              </a:rPr>
+              <a:t>Empleo: 45.0% de la población total</a:t>
+            </a:r>
+          </a:p>
+          <a:p>
+            <a:pPr algn="l">
+              <a:spcAft>
+                <a:spcPts val="800"/>
+              </a:spcAft>
+            </a:pPr>
+            <a:r>
+              <a:rPr sz="1300" b="1" i="0">
+                <a:solidFill>
+                  <a:srgbClr val="00B2C9"/>
+                </a:solidFill>
+                <a:latin typeface="Encode Sans"/>
+              </a:rPr>
+              <a:t>●  </a:t>
+            </a:r>
+            <a:r>
+              <a:rPr sz="1300" b="0" i="0">
+                <a:solidFill>
+                  <a:srgbClr val="3F3F3F"/>
+                </a:solidFill>
+                <a:latin typeface="Encode Sans"/>
+              </a:rPr>
+              <a:t>Fuente: INDEC, Encuesta Permanente de Hogares (EPH)</a:t>
+            </a:r>
+          </a:p>
+        </p:txBody>
+      </p:sp>
+      <p:pic>
+        <p:nvPicPr>
+          <p:cNvPr id="7" name="Picture 6" descr="image.png"/>
+          <p:cNvPicPr>
+            <a:picLocks noChangeAspect="1"/>
+          </p:cNvPicPr>
+          <p:nvPr/>
+        </p:nvPicPr>
+        <p:blipFill>
+          <a:blip r:embed="rId2"/>
+          <a:stretch>
+            <a:fillRect/>
+          </a:stretch>
+        </p:blipFill>
+        <p:spPr>
+          <a:xfrm>
+            <a:off x="6080760" y="1691640"/>
+            <a:ext cx="5669280" cy="2560320"/>
+          </a:xfrm>
+          <a:prstGeom prst="rect">
+            <a:avLst/>
+          </a:prstGeom>
+        </p:spPr>
+      </p:pic>
+      <p:graphicFrame>
+        <p:nvGraphicFramePr>
+          <p:cNvPr id="8" name="Table 7"/>
+          <p:cNvGraphicFramePr>
+            <a:graphicFrameLocks noGrp="1"/>
+          </p:cNvGraphicFramePr>
+          <p:nvPr/>
+        </p:nvGraphicFramePr>
+        <p:xfrm>
+          <a:off x="6080760" y="4434840"/>
+          <a:ext cx="5669280" cy="2048256"/>
+        </p:xfrm>
+        <a:graphic>
+          <a:graphicData uri="http://schemas.openxmlformats.org/drawingml/2006/table">
+            <a:tbl>
+              <a:tblPr firstRow="1" bandRow="1">
+                <a:tableStyleId>{5C22544A-7EE6-4342-B048-85BDC9FD1C3A}</a:tableStyleId>
+              </a:tblPr>
+              <a:tblGrid>
+                <a:gridCol w="1417320"/>
+                <a:gridCol w="1417320"/>
+                <a:gridCol w="1417320"/>
+                <a:gridCol w="1417320"/>
+              </a:tblGrid>
+              <a:tr h="292608">
+                <a:tc>
+                  <a:txBody>
+                    <a:bodyPr/>
+                    <a:lstStyle/>
+                    <a:p>
+                      <a:pPr algn="l"/>
+                      <a:r>
+                        <a:rPr sz="1000" b="1">
+                          <a:solidFill>
+                            <a:srgbClr val="FFFFFF"/>
+                          </a:solidFill>
+                          <a:latin typeface="Encode Sans"/>
+                        </a:rPr>
+                        <a:t>Trimestre</a:t>
+                      </a:r>
+                    </a:p>
+                  </a:txBody>
+                  <a:tcPr marL="36576" marR="36576" marT="18288" marB="18288">
+                    <a:solidFill>
+                      <a:srgbClr val="00B2C9"/>
+                    </a:solidFill>
+                  </a:tcPr>
+                </a:tc>
+                <a:tc>
+                  <a:txBody>
+                    <a:bodyPr/>
+                    <a:lstStyle/>
+                    <a:p>
+                      <a:pPr algn="r"/>
+                      <a:r>
+                        <a:rPr sz="1000" b="1">
+                          <a:solidFill>
+                            <a:srgbClr val="FFFFFF"/>
+                          </a:solidFill>
+                          <a:latin typeface="Encode Sans"/>
+                        </a:rPr>
+                        <a:t>Desoc. %</a:t>
+                      </a:r>
+                    </a:p>
+                  </a:txBody>
+                  <a:tcPr marL="36576" marR="36576" marT="18288" marB="18288">
+                    <a:solidFill>
+                      <a:srgbClr val="00B2C9"/>
+                    </a:solidFill>
+                  </a:tcPr>
+                </a:tc>
+                <a:tc>
+                  <a:txBody>
+                    <a:bodyPr/>
+                    <a:lstStyle/>
+                    <a:p>
+                      <a:pPr algn="r"/>
+                      <a:r>
+                        <a:rPr sz="1000" b="1">
+                          <a:solidFill>
+                            <a:srgbClr val="FFFFFF"/>
+                          </a:solidFill>
+                          <a:latin typeface="Encode Sans"/>
+                        </a:rPr>
+                        <a:t>Activ. %</a:t>
+                      </a:r>
+                    </a:p>
+                  </a:txBody>
+                  <a:tcPr marL="36576" marR="36576" marT="18288" marB="18288">
+                    <a:solidFill>
+                      <a:srgbClr val="00B2C9"/>
+                    </a:solidFill>
+                  </a:tcPr>
+                </a:tc>
+                <a:tc>
+                  <a:txBody>
+                    <a:bodyPr/>
+                    <a:lstStyle/>
+                    <a:p>
+                      <a:pPr algn="r"/>
+                      <a:r>
+                        <a:rPr sz="1000" b="1">
+                          <a:solidFill>
+                            <a:srgbClr val="FFFFFF"/>
+                          </a:solidFill>
+                          <a:latin typeface="Encode Sans"/>
+                        </a:rPr>
+                        <a:t>Empleo %</a:t>
+                      </a:r>
+                    </a:p>
+                  </a:txBody>
+                  <a:tcPr marL="36576" marR="36576" marT="18288" marB="18288">
+                    <a:solidFill>
+                      <a:srgbClr val="00B2C9"/>
+                    </a:solidFill>
+                  </a:tcPr>
+                </a:tc>
+              </a:tr>
+              <a:tr h="292608">
+                <a:tc>
+                  <a:txBody>
+                    <a:bodyPr/>
+                    <a:lstStyle/>
+                    <a:p>
+                      <a:pPr algn="l"/>
+                      <a:r>
+                        <a:rPr sz="1000">
+                          <a:solidFill>
+                            <a:srgbClr val="3F3F3F"/>
+                          </a:solidFill>
+                          <a:latin typeface="Encode Sans"/>
+                        </a:rPr>
+                        <a:t>2do t. 2026</a:t>
+                      </a:r>
+                    </a:p>
+                  </a:txBody>
+                  <a:tcPr marL="36576" marR="36576" marT="18288" marB="18288">
+                    <a:solidFill>
+                      <a:srgbClr val="FFFFFF"/>
+                    </a:solidFill>
+                  </a:tcPr>
+                </a:tc>
+                <a:tc>
+                  <a:txBody>
+                    <a:bodyPr/>
+                    <a:lstStyle/>
+                    <a:p>
+                      <a:pPr algn="r"/>
+                      <a:r>
+                        <a:rPr sz="1000">
+                          <a:solidFill>
+                            <a:srgbClr val="3F3F3F"/>
+                          </a:solidFill>
+                          <a:latin typeface="Encode Sans"/>
+                        </a:rPr>
+                        <a:t>7.9%</a:t>
+                      </a:r>
+                    </a:p>
+                  </a:txBody>
+                  <a:tcPr marL="36576" marR="36576" marT="18288" marB="18288">
+                    <a:solidFill>
+                      <a:srgbClr val="FFFFFF"/>
+                    </a:solidFill>
+                  </a:tcPr>
+                </a:tc>
+                <a:tc>
+                  <a:txBody>
+                    <a:bodyPr/>
+                    <a:lstStyle/>
+                    <a:p>
+                      <a:pPr algn="r"/>
+                      <a:r>
+                        <a:rPr sz="1000">
+                          <a:solidFill>
+                            <a:srgbClr val="3F3F3F"/>
+                          </a:solidFill>
+                          <a:latin typeface="Encode Sans"/>
+                        </a:rPr>
+                        <a:t>48.9%</a:t>
+                      </a:r>
+                    </a:p>
+                  </a:txBody>
+                  <a:tcPr marL="36576" marR="36576" marT="18288" marB="18288">
+                    <a:solidFill>
+                      <a:srgbClr val="FFFFFF"/>
+                    </a:solidFill>
+                  </a:tcPr>
+                </a:tc>
+                <a:tc>
+                  <a:txBody>
+                    <a:bodyPr/>
+                    <a:lstStyle/>
+                    <a:p>
+                      <a:pPr algn="r"/>
+                      <a:r>
+                        <a:rPr sz="1000">
+                          <a:solidFill>
+                            <a:srgbClr val="3F3F3F"/>
+                          </a:solidFill>
+                          <a:latin typeface="Encode Sans"/>
+                        </a:rPr>
+                        <a:t>45.0%</a:t>
+                      </a:r>
+                    </a:p>
+                  </a:txBody>
+                  <a:tcPr marL="36576" marR="36576" marT="18288" marB="18288">
+                    <a:solidFill>
+                      <a:srgbClr val="FFFFFF"/>
+                    </a:solidFill>
+                  </a:tcPr>
+                </a:tc>
+              </a:tr>
+              <a:tr h="292608">
+                <a:tc>
+                  <a:txBody>
+                    <a:bodyPr/>
+                    <a:lstStyle/>
+                    <a:p>
+                      <a:pPr algn="l"/>
+                      <a:r>
+                        <a:rPr sz="1000">
+                          <a:solidFill>
+                            <a:srgbClr val="3F3F3F"/>
+                          </a:solidFill>
+                          <a:latin typeface="Encode Sans"/>
+                        </a:rPr>
+                        <a:t>1er t. 2026</a:t>
+                      </a:r>
+                    </a:p>
+                  </a:txBody>
+                  <a:tcPr marL="36576" marR="36576" marT="18288" marB="18288">
+                    <a:solidFill>
+                      <a:srgbClr val="F8F8F6"/>
+                    </a:solidFill>
+                  </a:tcPr>
+                </a:tc>
+                <a:tc>
+                  <a:txBody>
+                    <a:bodyPr/>
+                    <a:lstStyle/>
+                    <a:p>
+                      <a:pPr algn="r"/>
+                      <a:r>
+                        <a:rPr sz="1000">
+                          <a:solidFill>
+                            <a:srgbClr val="3F3F3F"/>
+                          </a:solidFill>
+                          <a:latin typeface="Encode Sans"/>
+                        </a:rPr>
+                        <a:t>7.8%</a:t>
+                      </a:r>
+                    </a:p>
+                  </a:txBody>
+                  <a:tcPr marL="36576" marR="36576" marT="18288" marB="18288">
+                    <a:solidFill>
+                      <a:srgbClr val="F8F8F6"/>
+                    </a:solidFill>
+                  </a:tcPr>
+                </a:tc>
+                <a:tc>
+                  <a:txBody>
+                    <a:bodyPr/>
+                    <a:lstStyle/>
+                    <a:p>
+                      <a:pPr algn="r"/>
+                      <a:r>
+                        <a:rPr sz="1000">
+                          <a:solidFill>
+                            <a:srgbClr val="3F3F3F"/>
+                          </a:solidFill>
+                          <a:latin typeface="Encode Sans"/>
+                        </a:rPr>
+                        <a:t>48.6%</a:t>
+                      </a:r>
+                    </a:p>
+                  </a:txBody>
+                  <a:tcPr marL="36576" marR="36576" marT="18288" marB="18288">
+                    <a:solidFill>
+                      <a:srgbClr val="F8F8F6"/>
+                    </a:solidFill>
+                  </a:tcPr>
+                </a:tc>
+                <a:tc>
+                  <a:txBody>
+                    <a:bodyPr/>
+                    <a:lstStyle/>
+                    <a:p>
+                      <a:pPr algn="r"/>
+                      <a:r>
+                        <a:rPr sz="1000">
+                          <a:solidFill>
+                            <a:srgbClr val="3F3F3F"/>
+                          </a:solidFill>
+                          <a:latin typeface="Encode Sans"/>
+                        </a:rPr>
+                        <a:t>44.8%</a:t>
+                      </a:r>
+                    </a:p>
+                  </a:txBody>
+                  <a:tcPr marL="36576" marR="36576" marT="18288" marB="18288">
+                    <a:solidFill>
+                      <a:srgbClr val="F8F8F6"/>
+                    </a:solidFill>
+                  </a:tcPr>
+                </a:tc>
+              </a:tr>
+              <a:tr h="292608">
+                <a:tc>
+                  <a:txBody>
+                    <a:bodyPr/>
+                    <a:lstStyle/>
+                    <a:p>
+                      <a:pPr algn="l"/>
+                      <a:r>
+                        <a:rPr sz="1000">
+                          <a:solidFill>
+                            <a:srgbClr val="3F3F3F"/>
+                          </a:solidFill>
+                          <a:latin typeface="Encode Sans"/>
+                        </a:rPr>
+                        <a:t>4to t. 2025</a:t>
+                      </a:r>
+                    </a:p>
+                  </a:txBody>
+                  <a:tcPr marL="36576" marR="36576" marT="18288" marB="18288">
+                    <a:solidFill>
+                      <a:srgbClr val="FFFFFF"/>
+                    </a:solidFill>
+                  </a:tcPr>
+                </a:tc>
+                <a:tc>
+                  <a:txBody>
+                    <a:bodyPr/>
+                    <a:lstStyle/>
+                    <a:p>
+                      <a:pPr algn="r"/>
+                      <a:r>
+                        <a:rPr sz="1000">
+                          <a:solidFill>
+                            <a:srgbClr val="3F3F3F"/>
+                          </a:solidFill>
+                          <a:latin typeface="Encode Sans"/>
+                        </a:rPr>
+                        <a:t>7.5%</a:t>
+                      </a:r>
+                    </a:p>
+                  </a:txBody>
+                  <a:tcPr marL="36576" marR="36576" marT="18288" marB="18288">
+                    <a:solidFill>
+                      <a:srgbClr val="FFFFFF"/>
+                    </a:solidFill>
+                  </a:tcPr>
+                </a:tc>
+                <a:tc>
+                  <a:txBody>
+                    <a:bodyPr/>
+                    <a:lstStyle/>
+                    <a:p>
+                      <a:pPr algn="r"/>
+                      <a:r>
+                        <a:rPr sz="1000">
+                          <a:solidFill>
+                            <a:srgbClr val="3F3F3F"/>
+                          </a:solidFill>
+                          <a:latin typeface="Encode Sans"/>
+                        </a:rPr>
+                        <a:t>48.6%</a:t>
+                      </a:r>
+                    </a:p>
+                  </a:txBody>
+                  <a:tcPr marL="36576" marR="36576" marT="18288" marB="18288">
+                    <a:solidFill>
+                      <a:srgbClr val="FFFFFF"/>
+                    </a:solidFill>
+                  </a:tcPr>
+                </a:tc>
+                <a:tc>
+                  <a:txBody>
+                    <a:bodyPr/>
+                    <a:lstStyle/>
+                    <a:p>
+                      <a:pPr algn="r"/>
+                      <a:r>
+                        <a:rPr sz="1000">
+                          <a:solidFill>
+                            <a:srgbClr val="3F3F3F"/>
+                          </a:solidFill>
+                          <a:latin typeface="Encode Sans"/>
+                        </a:rPr>
+                        <a:t>45.0%</a:t>
+                      </a:r>
+                    </a:p>
+                  </a:txBody>
+                  <a:tcPr marL="36576" marR="36576" marT="18288" marB="18288">
+                    <a:solidFill>
+                      <a:srgbClr val="FFFFFF"/>
+                    </a:solidFill>
+                  </a:tcPr>
+                </a:tc>
+              </a:tr>
+              <a:tr h="292608">
+                <a:tc>
+                  <a:txBody>
+                    <a:bodyPr/>
+                    <a:lstStyle/>
+                    <a:p>
+                      <a:pPr algn="l"/>
+                      <a:r>
+                        <a:rPr sz="1000">
+                          <a:solidFill>
+                            <a:srgbClr val="3F3F3F"/>
+                          </a:solidFill>
+                          <a:latin typeface="Encode Sans"/>
+                        </a:rPr>
+                        <a:t>3er t. 2025</a:t>
+                      </a:r>
+                    </a:p>
+                  </a:txBody>
+                  <a:tcPr marL="36576" marR="36576" marT="18288" marB="18288">
+                    <a:solidFill>
+                      <a:srgbClr val="F8F8F6"/>
+                    </a:solidFill>
+                  </a:tcPr>
+                </a:tc>
+                <a:tc>
+                  <a:txBody>
+                    <a:bodyPr/>
+                    <a:lstStyle/>
+                    <a:p>
+                      <a:pPr algn="r"/>
+                      <a:r>
+                        <a:rPr sz="1000">
+                          <a:solidFill>
+                            <a:srgbClr val="3F3F3F"/>
+                          </a:solidFill>
+                          <a:latin typeface="Encode Sans"/>
+                        </a:rPr>
+                        <a:t>6.6%</a:t>
+                      </a:r>
+                    </a:p>
+                  </a:txBody>
+                  <a:tcPr marL="36576" marR="36576" marT="18288" marB="18288">
+                    <a:solidFill>
+                      <a:srgbClr val="F8F8F6"/>
+                    </a:solidFill>
+                  </a:tcPr>
+                </a:tc>
+                <a:tc>
+                  <a:txBody>
+                    <a:bodyPr/>
+                    <a:lstStyle/>
+                    <a:p>
+                      <a:pPr algn="r"/>
+                      <a:r>
+                        <a:rPr sz="1000">
+                          <a:solidFill>
+                            <a:srgbClr val="3F3F3F"/>
+                          </a:solidFill>
+                          <a:latin typeface="Encode Sans"/>
+                        </a:rPr>
+                        <a:t>48.6%</a:t>
+                      </a:r>
+                    </a:p>
+                  </a:txBody>
+                  <a:tcPr marL="36576" marR="36576" marT="18288" marB="18288">
+                    <a:solidFill>
+                      <a:srgbClr val="F8F8F6"/>
+                    </a:solidFill>
+                  </a:tcPr>
+                </a:tc>
+                <a:tc>
+                  <a:txBody>
+                    <a:bodyPr/>
+                    <a:lstStyle/>
+                    <a:p>
+                      <a:pPr algn="r"/>
+                      <a:r>
+                        <a:rPr sz="1000">
+                          <a:solidFill>
+                            <a:srgbClr val="3F3F3F"/>
+                          </a:solidFill>
+                          <a:latin typeface="Encode Sans"/>
+                        </a:rPr>
+                        <a:t>45.4%</a:t>
+                      </a:r>
+                    </a:p>
+                  </a:txBody>
+                  <a:tcPr marL="36576" marR="36576" marT="18288" marB="18288">
+                    <a:solidFill>
+                      <a:srgbClr val="F8F8F6"/>
+                    </a:solidFill>
+                  </a:tcPr>
+                </a:tc>
+              </a:tr>
+              <a:tr h="292608">
+                <a:tc>
+                  <a:txBody>
+                    <a:bodyPr/>
+                    <a:lstStyle/>
+                    <a:p>
+                      <a:pPr algn="l"/>
+                      <a:r>
+                        <a:rPr sz="1000">
+                          <a:solidFill>
+                            <a:srgbClr val="3F3F3F"/>
+                          </a:solidFill>
+                          <a:latin typeface="Encode Sans"/>
+                        </a:rPr>
+                        <a:t>2do t. 2025</a:t>
+                      </a:r>
+                    </a:p>
+                  </a:txBody>
+                  <a:tcPr marL="36576" marR="36576" marT="18288" marB="18288">
+                    <a:solidFill>
+                      <a:srgbClr val="FFFFFF"/>
+                    </a:solidFill>
+                  </a:tcPr>
+                </a:tc>
+                <a:tc>
+                  <a:txBody>
+                    <a:bodyPr/>
+                    <a:lstStyle/>
+                    <a:p>
+                      <a:pPr algn="r"/>
+                      <a:r>
+                        <a:rPr sz="1000">
+                          <a:solidFill>
+                            <a:srgbClr val="3F3F3F"/>
+                          </a:solidFill>
+                          <a:latin typeface="Encode Sans"/>
+                        </a:rPr>
+                        <a:t>7.6%</a:t>
+                      </a:r>
+                    </a:p>
+                  </a:txBody>
+                  <a:tcPr marL="36576" marR="36576" marT="18288" marB="18288">
+                    <a:solidFill>
+                      <a:srgbClr val="FFFFFF"/>
+                    </a:solidFill>
+                  </a:tcPr>
+                </a:tc>
+                <a:tc>
+                  <a:txBody>
+                    <a:bodyPr/>
+                    <a:lstStyle/>
+                    <a:p>
+                      <a:pPr algn="r"/>
+                      <a:r>
+                        <a:rPr sz="1000">
+                          <a:solidFill>
+                            <a:srgbClr val="3F3F3F"/>
+                          </a:solidFill>
+                          <a:latin typeface="Encode Sans"/>
+                        </a:rPr>
+                        <a:t>48.1%</a:t>
+                      </a:r>
+                    </a:p>
+                  </a:txBody>
+                  <a:tcPr marL="36576" marR="36576" marT="18288" marB="18288">
+                    <a:solidFill>
+                      <a:srgbClr val="FFFFFF"/>
+                    </a:solidFill>
+                  </a:tcPr>
+                </a:tc>
+                <a:tc>
+                  <a:txBody>
+                    <a:bodyPr/>
+                    <a:lstStyle/>
+                    <a:p>
+                      <a:pPr algn="r"/>
+                      <a:r>
+                        <a:rPr sz="1000">
+                          <a:solidFill>
+                            <a:srgbClr val="3F3F3F"/>
+                          </a:solidFill>
+                          <a:latin typeface="Encode Sans"/>
+                        </a:rPr>
+                        <a:t>44.5%</a:t>
+                      </a:r>
+                    </a:p>
+                  </a:txBody>
+                  <a:tcPr marL="36576" marR="36576" marT="18288" marB="18288">
+                    <a:solidFill>
+                      <a:srgbClr val="FFFFFF"/>
+                    </a:solidFill>
+                  </a:tcPr>
+                </a:tc>
+              </a:tr>
+              <a:tr h="292608">
+                <a:tc>
+                  <a:txBody>
+                    <a:bodyPr/>
+                    <a:lstStyle/>
+                    <a:p>
+                      <a:pPr algn="l"/>
+                      <a:r>
+                        <a:rPr sz="1000">
+                          <a:solidFill>
+                            <a:srgbClr val="3F3F3F"/>
+                          </a:solidFill>
+                          <a:latin typeface="Encode Sans"/>
+                        </a:rPr>
+                        <a:t>1er t. 2025</a:t>
+                      </a:r>
+                    </a:p>
+                  </a:txBody>
+                  <a:tcPr marL="36576" marR="36576" marT="18288" marB="18288">
+                    <a:solidFill>
+                      <a:srgbClr val="F8F8F6"/>
+                    </a:solidFill>
+                  </a:tcPr>
+                </a:tc>
+                <a:tc>
+                  <a:txBody>
+                    <a:bodyPr/>
+                    <a:lstStyle/>
+                    <a:p>
+                      <a:pPr algn="r"/>
+                      <a:r>
+                        <a:rPr sz="1000">
+                          <a:solidFill>
+                            <a:srgbClr val="3F3F3F"/>
+                          </a:solidFill>
+                          <a:latin typeface="Encode Sans"/>
+                        </a:rPr>
+                        <a:t>7.9%</a:t>
+                      </a:r>
+                    </a:p>
+                  </a:txBody>
+                  <a:tcPr marL="36576" marR="36576" marT="18288" marB="18288">
+                    <a:solidFill>
+                      <a:srgbClr val="F8F8F6"/>
+                    </a:solidFill>
+                  </a:tcPr>
+                </a:tc>
+                <a:tc>
+                  <a:txBody>
+                    <a:bodyPr/>
+                    <a:lstStyle/>
+                    <a:p>
+                      <a:pPr algn="r"/>
+                      <a:r>
+                        <a:rPr sz="1000">
+                          <a:solidFill>
+                            <a:srgbClr val="3F3F3F"/>
+                          </a:solidFill>
+                          <a:latin typeface="Encode Sans"/>
+                        </a:rPr>
+                        <a:t>48.2%</a:t>
+                      </a:r>
+                    </a:p>
+                  </a:txBody>
+                  <a:tcPr marL="36576" marR="36576" marT="18288" marB="18288">
+                    <a:solidFill>
+                      <a:srgbClr val="F8F8F6"/>
+                    </a:solidFill>
+                  </a:tcPr>
+                </a:tc>
+                <a:tc>
+                  <a:txBody>
+                    <a:bodyPr/>
+                    <a:lstStyle/>
+                    <a:p>
+                      <a:pPr algn="r"/>
+                      <a:r>
+                        <a:rPr sz="1000">
+                          <a:solidFill>
+                            <a:srgbClr val="3F3F3F"/>
+                          </a:solidFill>
+                          <a:latin typeface="Encode Sans"/>
+                        </a:rPr>
+                        <a:t>44.4%</a:t>
+                      </a:r>
+                    </a:p>
+                  </a:txBody>
+                  <a:tcPr marL="36576" marR="36576" marT="18288" marB="18288">
+                    <a:solidFill>
+                      <a:srgbClr val="F8F8F6"/>
+                    </a:solidFill>
+                  </a:tcPr>
+                </a:tc>
+              </a:tr>
+            </a:tbl>
+          </a:graphicData>
+        </a:graphic>
+      </p:graphicFrame>
+      <p:sp>
+        <p:nvSpPr>
+          <p:cNvPr id="9" name="TextBox 8"/>
+          <p:cNvSpPr txBox="1"/>
+          <p:nvPr/>
+        </p:nvSpPr>
+        <p:spPr>
+          <a:xfrm>
+            <a:off x="411480" y="6492240"/>
+            <a:ext cx="11368735" cy="274320"/>
+          </a:xfrm>
+          <a:prstGeom prst="rect">
+            <a:avLst/>
+          </a:prstGeom>
+          <a:noFill/>
+        </p:spPr>
+        <p:txBody>
+          <a:bodyPr wrap="none">
+            <a:spAutoFit/>
+          </a:bodyPr>
+          <a:lstStyle/>
+          <a:p>
+            <a:r>
+              <a:rPr sz="1000" b="0" i="1">
+                <a:solidFill>
+                  <a:srgbClr val="6A6760"/>
+                </a:solidFill>
+                <a:latin typeface="Encode Sans"/>
+              </a:rPr>
+              <a:t>Fuente: elaboración propia en base a INDEC EPH</a:t>
             </a:r>
           </a:p>
         </p:txBody>

</xml_diff>

<commit_message>
data: update 2026-09-23 ( data.json despidos.json scraper/historical_despidos.json publicaciones_semana.pptx rrii_brutas.xlsx)
</commit_message>
<xml_diff>
--- a/publicaciones_semana.pptx
+++ b/publicaciones_semana.pptx
@@ -7,6 +7,7 @@
   <p:sldIdLst>
     <p:sldId id="256" r:id="rId7"/>
     <p:sldId id="257" r:id="rId8"/>
+    <p:sldId id="258" r:id="rId9"/>
   </p:sldIdLst>
   <p:sldSz cx="12191695" cy="6858000" type="screen4x3"/>
   <p:notesSz cx="6858000" cy="9144000"/>
@@ -3272,7 +3273,7 @@
                 </a:solidFill>
                 <a:latin typeface="Encode Sans"/>
               </a:rPr>
-              <a:t>1 publicaciones · datos oficiales INDEC / BCRA / Hacienda</a:t>
+              <a:t>2 publicaciones · datos oficiales INDEC / BCRA / Hacienda</a:t>
             </a:r>
           </a:p>
         </p:txBody>
@@ -4317,6 +4318,1013 @@
 </p:sld>
 </file>
 
+<file path=ppt/slides/slide3.xml><?xml version="1.0" encoding="utf-8"?>
+<p:sld xmlns:a="http://schemas.openxmlformats.org/drawingml/2006/main" xmlns:p="http://schemas.openxmlformats.org/presentationml/2006/main" xmlns:r="http://schemas.openxmlformats.org/officeDocument/2006/relationships">
+  <p:cSld>
+    <p:spTree>
+      <p:nvGrpSpPr>
+        <p:cNvPr id="1" name=""/>
+        <p:cNvGrpSpPr/>
+        <p:nvPr/>
+      </p:nvGrpSpPr>
+      <p:grpSpPr/>
+      <p:sp>
+        <p:nvSpPr>
+          <p:cNvPr id="2" name="Rectangle 1"/>
+          <p:cNvSpPr/>
+          <p:nvPr/>
+        </p:nvSpPr>
+        <p:spPr>
+          <a:xfrm>
+            <a:off x="0" y="0"/>
+            <a:ext cx="12191695" cy="274320"/>
+          </a:xfrm>
+          <a:prstGeom prst="rect">
+            <a:avLst/>
+          </a:prstGeom>
+          <a:solidFill>
+            <a:srgbClr val="00B2C9"/>
+          </a:solidFill>
+          <a:ln>
+            <a:noFill/>
+          </a:ln>
+        </p:spPr>
+        <p:style>
+          <a:lnRef idx="1">
+            <a:schemeClr val="accent1"/>
+          </a:lnRef>
+          <a:fillRef idx="3">
+            <a:schemeClr val="accent1"/>
+          </a:fillRef>
+          <a:effectRef idx="2">
+            <a:schemeClr val="accent1"/>
+          </a:effectRef>
+          <a:fontRef idx="minor">
+            <a:schemeClr val="lt1"/>
+          </a:fontRef>
+        </p:style>
+        <p:txBody>
+          <a:bodyPr rtlCol="0" anchor="ctr"/>
+          <a:lstStyle/>
+          <a:p>
+            <a:pPr algn="ctr"/>
+          </a:p>
+        </p:txBody>
+      </p:sp>
+      <p:sp>
+        <p:nvSpPr>
+          <p:cNvPr id="3" name="TextBox 2"/>
+          <p:cNvSpPr txBox="1"/>
+          <p:nvPr/>
+        </p:nvSpPr>
+        <p:spPr>
+          <a:xfrm>
+            <a:off x="411480" y="457200"/>
+            <a:ext cx="11368735" cy="914400"/>
+          </a:xfrm>
+          <a:prstGeom prst="rect">
+            <a:avLst/>
+          </a:prstGeom>
+          <a:noFill/>
+        </p:spPr>
+        <p:txBody>
+          <a:bodyPr wrap="square" lIns="0" rIns="0">
+            <a:spAutoFit/>
+          </a:bodyPr>
+          <a:lstStyle/>
+          <a:p>
+            <a:pPr algn="l"/>
+            <a:r>
+              <a:rPr sz="2600" b="1" i="0">
+                <a:solidFill>
+                  <a:srgbClr val="00B2C9"/>
+                </a:solidFill>
+                <a:latin typeface="Encode Sans"/>
+              </a:rPr>
+              <a:t>SUPERMERCADOS JULIO 2026: VENTAS REALES CAYERON -2.1%</a:t>
+            </a:r>
+          </a:p>
+        </p:txBody>
+      </p:sp>
+      <p:sp>
+        <p:nvSpPr>
+          <p:cNvPr id="4" name="TextBox 3"/>
+          <p:cNvSpPr txBox="1"/>
+          <p:nvPr/>
+        </p:nvSpPr>
+        <p:spPr>
+          <a:xfrm>
+            <a:off x="411480" y="1280160"/>
+            <a:ext cx="11368735" cy="274320"/>
+          </a:xfrm>
+          <a:prstGeom prst="rect">
+            <a:avLst/>
+          </a:prstGeom>
+          <a:noFill/>
+        </p:spPr>
+        <p:txBody>
+          <a:bodyPr wrap="none">
+            <a:spAutoFit/>
+          </a:bodyPr>
+          <a:lstStyle/>
+          <a:p>
+            <a:r>
+              <a:rPr sz="1100" b="0" i="1">
+                <a:solidFill>
+                  <a:srgbClr val="6A6760"/>
+                </a:solidFill>
+                <a:latin typeface="Encode Sans"/>
+              </a:rPr>
+              <a:t>INDEC · período 2026-07</a:t>
+            </a:r>
+          </a:p>
+        </p:txBody>
+      </p:sp>
+      <p:sp>
+        <p:nvSpPr>
+          <p:cNvPr id="5" name="TextBox 4"/>
+          <p:cNvSpPr txBox="1"/>
+          <p:nvPr/>
+        </p:nvSpPr>
+        <p:spPr>
+          <a:xfrm>
+            <a:off x="411480" y="1691640"/>
+            <a:ext cx="5486400" cy="1645920"/>
+          </a:xfrm>
+          <a:prstGeom prst="rect">
+            <a:avLst/>
+          </a:prstGeom>
+          <a:noFill/>
+        </p:spPr>
+        <p:txBody>
+          <a:bodyPr wrap="square" lIns="0" rIns="0">
+            <a:spAutoFit/>
+          </a:bodyPr>
+          <a:lstStyle/>
+          <a:p>
+            <a:pPr algn="just"/>
+            <a:r>
+              <a:rPr sz="1300" b="0" i="0">
+                <a:solidFill>
+                  <a:srgbClr val="3F3F3F"/>
+                </a:solidFill>
+                <a:latin typeface="Encode Sans"/>
+              </a:rPr>
+              <a:t>Las ventas de supermercados a precios constantes registraron una variación interanual real de -2.1% en julio 2026. Desestacionalizada: -0.7% m/m.</a:t>
+            </a:r>
+          </a:p>
+        </p:txBody>
+      </p:sp>
+      <p:sp>
+        <p:nvSpPr>
+          <p:cNvPr id="6" name="TextBox 5"/>
+          <p:cNvSpPr txBox="1"/>
+          <p:nvPr/>
+        </p:nvSpPr>
+        <p:spPr>
+          <a:xfrm>
+            <a:off x="411480" y="3520440"/>
+            <a:ext cx="5486400" cy="2743200"/>
+          </a:xfrm>
+          <a:prstGeom prst="rect">
+            <a:avLst/>
+          </a:prstGeom>
+          <a:noFill/>
+        </p:spPr>
+        <p:txBody>
+          <a:bodyPr wrap="square" lIns="0" rIns="0">
+            <a:spAutoFit/>
+          </a:bodyPr>
+          <a:lstStyle/>
+          <a:p>
+            <a:pPr algn="l">
+              <a:spcAft>
+                <a:spcPts val="800"/>
+              </a:spcAft>
+            </a:pPr>
+            <a:r>
+              <a:rPr sz="1300" b="1" i="0">
+                <a:solidFill>
+                  <a:srgbClr val="00B2C9"/>
+                </a:solidFill>
+                <a:latin typeface="Encode Sans"/>
+              </a:rPr>
+              <a:t>●  </a:t>
+            </a:r>
+            <a:r>
+              <a:rPr sz="1300" b="0" i="0">
+                <a:solidFill>
+                  <a:srgbClr val="3F3F3F"/>
+                </a:solidFill>
+                <a:latin typeface="Encode Sans"/>
+              </a:rPr>
+              <a:t>Variación interanual real: -2.1%</a:t>
+            </a:r>
+          </a:p>
+          <a:p>
+            <a:pPr algn="l">
+              <a:spcAft>
+                <a:spcPts val="800"/>
+              </a:spcAft>
+            </a:pPr>
+            <a:r>
+              <a:rPr sz="1300" b="1" i="0">
+                <a:solidFill>
+                  <a:srgbClr val="00B2C9"/>
+                </a:solidFill>
+                <a:latin typeface="Encode Sans"/>
+              </a:rPr>
+              <a:t>●  </a:t>
+            </a:r>
+            <a:r>
+              <a:rPr sz="1300" b="0" i="0">
+                <a:solidFill>
+                  <a:srgbClr val="3F3F3F"/>
+                </a:solidFill>
+                <a:latin typeface="Encode Sans"/>
+              </a:rPr>
+              <a:t>Variación mensual desestacionalizada: -0.7%</a:t>
+            </a:r>
+          </a:p>
+          <a:p>
+            <a:pPr algn="l">
+              <a:spcAft>
+                <a:spcPts val="800"/>
+              </a:spcAft>
+            </a:pPr>
+            <a:r>
+              <a:rPr sz="1300" b="1" i="0">
+                <a:solidFill>
+                  <a:srgbClr val="00B2C9"/>
+                </a:solidFill>
+                <a:latin typeface="Encode Sans"/>
+              </a:rPr>
+              <a:t>●  </a:t>
+            </a:r>
+            <a:r>
+              <a:rPr sz="1300" b="0" i="0">
+                <a:solidFill>
+                  <a:srgbClr val="3F3F3F"/>
+                </a:solidFill>
+                <a:latin typeface="Encode Sans"/>
+              </a:rPr>
+              <a:t>Acumulado del año: -2.7%</a:t>
+            </a:r>
+          </a:p>
+        </p:txBody>
+      </p:sp>
+      <p:pic>
+        <p:nvPicPr>
+          <p:cNvPr id="7" name="Picture 6" descr="image.png"/>
+          <p:cNvPicPr>
+            <a:picLocks noChangeAspect="1"/>
+          </p:cNvPicPr>
+          <p:nvPr/>
+        </p:nvPicPr>
+        <p:blipFill>
+          <a:blip r:embed="rId2"/>
+          <a:stretch>
+            <a:fillRect/>
+          </a:stretch>
+        </p:blipFill>
+        <p:spPr>
+          <a:xfrm>
+            <a:off x="6080760" y="1691640"/>
+            <a:ext cx="5669280" cy="2560320"/>
+          </a:xfrm>
+          <a:prstGeom prst="rect">
+            <a:avLst/>
+          </a:prstGeom>
+        </p:spPr>
+      </p:pic>
+      <p:graphicFrame>
+        <p:nvGraphicFramePr>
+          <p:cNvPr id="8" name="Table 7"/>
+          <p:cNvGraphicFramePr>
+            <a:graphicFrameLocks noGrp="1"/>
+          </p:cNvGraphicFramePr>
+          <p:nvPr/>
+        </p:nvGraphicFramePr>
+        <p:xfrm>
+          <a:off x="6080760" y="4434840"/>
+          <a:ext cx="5669280" cy="2048256"/>
+        </p:xfrm>
+        <a:graphic>
+          <a:graphicData uri="http://schemas.openxmlformats.org/drawingml/2006/table">
+            <a:tbl>
+              <a:tblPr firstRow="1" bandRow="1">
+                <a:tableStyleId>{5C22544A-7EE6-4342-B048-85BDC9FD1C3A}</a:tableStyleId>
+              </a:tblPr>
+              <a:tblGrid>
+                <a:gridCol w="1417320"/>
+                <a:gridCol w="1417320"/>
+                <a:gridCol w="1417320"/>
+                <a:gridCol w="1417320"/>
+              </a:tblGrid>
+              <a:tr h="292608">
+                <a:tc>
+                  <a:txBody>
+                    <a:bodyPr/>
+                    <a:lstStyle/>
+                    <a:p>
+                      <a:pPr algn="l"/>
+                      <a:r>
+                        <a:rPr sz="1000" b="1">
+                          <a:solidFill>
+                            <a:srgbClr val="FFFFFF"/>
+                          </a:solidFill>
+                          <a:latin typeface="Encode Sans"/>
+                        </a:rPr>
+                        <a:t>Mes</a:t>
+                      </a:r>
+                    </a:p>
+                  </a:txBody>
+                  <a:tcPr marL="36576" marR="36576" marT="18288" marB="18288">
+                    <a:solidFill>
+                      <a:srgbClr val="00B2C9"/>
+                    </a:solidFill>
+                  </a:tcPr>
+                </a:tc>
+                <a:tc>
+                  <a:txBody>
+                    <a:bodyPr/>
+                    <a:lstStyle/>
+                    <a:p>
+                      <a:pPr algn="r"/>
+                      <a:r>
+                        <a:rPr sz="1000" b="1">
+                          <a:solidFill>
+                            <a:srgbClr val="FFFFFF"/>
+                          </a:solidFill>
+                          <a:latin typeface="Encode Sans"/>
+                        </a:rPr>
+                        <a:t>Índice real</a:t>
+                      </a:r>
+                    </a:p>
+                  </a:txBody>
+                  <a:tcPr marL="36576" marR="36576" marT="18288" marB="18288">
+                    <a:solidFill>
+                      <a:srgbClr val="00B2C9"/>
+                    </a:solidFill>
+                  </a:tcPr>
+                </a:tc>
+                <a:tc>
+                  <a:txBody>
+                    <a:bodyPr/>
+                    <a:lstStyle/>
+                    <a:p>
+                      <a:pPr algn="r"/>
+                      <a:r>
+                        <a:rPr sz="1000" b="1">
+                          <a:solidFill>
+                            <a:srgbClr val="FFFFFF"/>
+                          </a:solidFill>
+                          <a:latin typeface="Encode Sans"/>
+                        </a:rPr>
+                        <a:t>VIA real %</a:t>
+                      </a:r>
+                    </a:p>
+                  </a:txBody>
+                  <a:tcPr marL="36576" marR="36576" marT="18288" marB="18288">
+                    <a:solidFill>
+                      <a:srgbClr val="00B2C9"/>
+                    </a:solidFill>
+                  </a:tcPr>
+                </a:tc>
+                <a:tc>
+                  <a:txBody>
+                    <a:bodyPr/>
+                    <a:lstStyle/>
+                    <a:p>
+                      <a:pPr algn="r"/>
+                      <a:r>
+                        <a:rPr sz="1000" b="1">
+                          <a:solidFill>
+                            <a:srgbClr val="FFFFFF"/>
+                          </a:solidFill>
+                          <a:latin typeface="Encode Sans"/>
+                        </a:rPr>
+                        <a:t>Acumulado %</a:t>
+                      </a:r>
+                    </a:p>
+                  </a:txBody>
+                  <a:tcPr marL="36576" marR="36576" marT="18288" marB="18288">
+                    <a:solidFill>
+                      <a:srgbClr val="00B2C9"/>
+                    </a:solidFill>
+                  </a:tcPr>
+                </a:tc>
+              </a:tr>
+              <a:tr h="292608">
+                <a:tc>
+                  <a:txBody>
+                    <a:bodyPr/>
+                    <a:lstStyle/>
+                    <a:p>
+                      <a:pPr algn="l"/>
+                      <a:r>
+                        <a:rPr sz="1000">
+                          <a:solidFill>
+                            <a:srgbClr val="3F3F3F"/>
+                          </a:solidFill>
+                          <a:latin typeface="Encode Sans"/>
+                        </a:rPr>
+                        <a:t>Julio 2026</a:t>
+                      </a:r>
+                    </a:p>
+                  </a:txBody>
+                  <a:tcPr marL="36576" marR="36576" marT="18288" marB="18288">
+                    <a:solidFill>
+                      <a:srgbClr val="FFFFFF"/>
+                    </a:solidFill>
+                  </a:tcPr>
+                </a:tc>
+                <a:tc>
+                  <a:txBody>
+                    <a:bodyPr/>
+                    <a:lstStyle/>
+                    <a:p>
+                      <a:pPr algn="r"/>
+                      <a:r>
+                        <a:rPr sz="1000">
+                          <a:solidFill>
+                            <a:srgbClr val="3F3F3F"/>
+                          </a:solidFill>
+                          <a:latin typeface="Encode Sans"/>
+                        </a:rPr>
+                        <a:t>80,3</a:t>
+                      </a:r>
+                    </a:p>
+                  </a:txBody>
+                  <a:tcPr marL="36576" marR="36576" marT="18288" marB="18288">
+                    <a:solidFill>
+                      <a:srgbClr val="FFFFFF"/>
+                    </a:solidFill>
+                  </a:tcPr>
+                </a:tc>
+                <a:tc>
+                  <a:txBody>
+                    <a:bodyPr/>
+                    <a:lstStyle/>
+                    <a:p>
+                      <a:pPr algn="r"/>
+                      <a:r>
+                        <a:rPr sz="1000">
+                          <a:solidFill>
+                            <a:srgbClr val="3F3F3F"/>
+                          </a:solidFill>
+                          <a:latin typeface="Encode Sans"/>
+                        </a:rPr>
+                        <a:t>-2.1%</a:t>
+                      </a:r>
+                    </a:p>
+                  </a:txBody>
+                  <a:tcPr marL="36576" marR="36576" marT="18288" marB="18288">
+                    <a:solidFill>
+                      <a:srgbClr val="FFFFFF"/>
+                    </a:solidFill>
+                  </a:tcPr>
+                </a:tc>
+                <a:tc>
+                  <a:txBody>
+                    <a:bodyPr/>
+                    <a:lstStyle/>
+                    <a:p>
+                      <a:pPr algn="r"/>
+                      <a:r>
+                        <a:rPr sz="1000">
+                          <a:solidFill>
+                            <a:srgbClr val="3F3F3F"/>
+                          </a:solidFill>
+                          <a:latin typeface="Encode Sans"/>
+                        </a:rPr>
+                        <a:t>-2.7%</a:t>
+                      </a:r>
+                    </a:p>
+                  </a:txBody>
+                  <a:tcPr marL="36576" marR="36576" marT="18288" marB="18288">
+                    <a:solidFill>
+                      <a:srgbClr val="FFFFFF"/>
+                    </a:solidFill>
+                  </a:tcPr>
+                </a:tc>
+              </a:tr>
+              <a:tr h="292608">
+                <a:tc>
+                  <a:txBody>
+                    <a:bodyPr/>
+                    <a:lstStyle/>
+                    <a:p>
+                      <a:pPr algn="l"/>
+                      <a:r>
+                        <a:rPr sz="1000">
+                          <a:solidFill>
+                            <a:srgbClr val="3F3F3F"/>
+                          </a:solidFill>
+                          <a:latin typeface="Encode Sans"/>
+                        </a:rPr>
+                        <a:t>Junio 2026</a:t>
+                      </a:r>
+                    </a:p>
+                  </a:txBody>
+                  <a:tcPr marL="36576" marR="36576" marT="18288" marB="18288">
+                    <a:solidFill>
+                      <a:srgbClr val="F8F8F6"/>
+                    </a:solidFill>
+                  </a:tcPr>
+                </a:tc>
+                <a:tc>
+                  <a:txBody>
+                    <a:bodyPr/>
+                    <a:lstStyle/>
+                    <a:p>
+                      <a:pPr algn="r"/>
+                      <a:r>
+                        <a:rPr sz="1000">
+                          <a:solidFill>
+                            <a:srgbClr val="3F3F3F"/>
+                          </a:solidFill>
+                          <a:latin typeface="Encode Sans"/>
+                        </a:rPr>
+                        <a:t>78,7</a:t>
+                      </a:r>
+                    </a:p>
+                  </a:txBody>
+                  <a:tcPr marL="36576" marR="36576" marT="18288" marB="18288">
+                    <a:solidFill>
+                      <a:srgbClr val="F8F8F6"/>
+                    </a:solidFill>
+                  </a:tcPr>
+                </a:tc>
+                <a:tc>
+                  <a:txBody>
+                    <a:bodyPr/>
+                    <a:lstStyle/>
+                    <a:p>
+                      <a:pPr algn="r"/>
+                      <a:r>
+                        <a:rPr sz="1000">
+                          <a:solidFill>
+                            <a:srgbClr val="3F3F3F"/>
+                          </a:solidFill>
+                          <a:latin typeface="Encode Sans"/>
+                        </a:rPr>
+                        <a:t>-3.1%</a:t>
+                      </a:r>
+                    </a:p>
+                  </a:txBody>
+                  <a:tcPr marL="36576" marR="36576" marT="18288" marB="18288">
+                    <a:solidFill>
+                      <a:srgbClr val="F8F8F6"/>
+                    </a:solidFill>
+                  </a:tcPr>
+                </a:tc>
+                <a:tc>
+                  <a:txBody>
+                    <a:bodyPr/>
+                    <a:lstStyle/>
+                    <a:p>
+                      <a:pPr algn="r"/>
+                      <a:r>
+                        <a:rPr sz="1000">
+                          <a:solidFill>
+                            <a:srgbClr val="3F3F3F"/>
+                          </a:solidFill>
+                          <a:latin typeface="Encode Sans"/>
+                        </a:rPr>
+                        <a:t>-2.8%</a:t>
+                      </a:r>
+                    </a:p>
+                  </a:txBody>
+                  <a:tcPr marL="36576" marR="36576" marT="18288" marB="18288">
+                    <a:solidFill>
+                      <a:srgbClr val="F8F8F6"/>
+                    </a:solidFill>
+                  </a:tcPr>
+                </a:tc>
+              </a:tr>
+              <a:tr h="292608">
+                <a:tc>
+                  <a:txBody>
+                    <a:bodyPr/>
+                    <a:lstStyle/>
+                    <a:p>
+                      <a:pPr algn="l"/>
+                      <a:r>
+                        <a:rPr sz="1000">
+                          <a:solidFill>
+                            <a:srgbClr val="3F3F3F"/>
+                          </a:solidFill>
+                          <a:latin typeface="Encode Sans"/>
+                        </a:rPr>
+                        <a:t>Mayo 2026</a:t>
+                      </a:r>
+                    </a:p>
+                  </a:txBody>
+                  <a:tcPr marL="36576" marR="36576" marT="18288" marB="18288">
+                    <a:solidFill>
+                      <a:srgbClr val="FFFFFF"/>
+                    </a:solidFill>
+                  </a:tcPr>
+                </a:tc>
+                <a:tc>
+                  <a:txBody>
+                    <a:bodyPr/>
+                    <a:lstStyle/>
+                    <a:p>
+                      <a:pPr algn="r"/>
+                      <a:r>
+                        <a:rPr sz="1000">
+                          <a:solidFill>
+                            <a:srgbClr val="3F3F3F"/>
+                          </a:solidFill>
+                          <a:latin typeface="Encode Sans"/>
+                        </a:rPr>
+                        <a:t>80,5</a:t>
+                      </a:r>
+                    </a:p>
+                  </a:txBody>
+                  <a:tcPr marL="36576" marR="36576" marT="18288" marB="18288">
+                    <a:solidFill>
+                      <a:srgbClr val="FFFFFF"/>
+                    </a:solidFill>
+                  </a:tcPr>
+                </a:tc>
+                <a:tc>
+                  <a:txBody>
+                    <a:bodyPr/>
+                    <a:lstStyle/>
+                    <a:p>
+                      <a:pPr algn="r"/>
+                      <a:r>
+                        <a:rPr sz="1000">
+                          <a:solidFill>
+                            <a:srgbClr val="3F3F3F"/>
+                          </a:solidFill>
+                          <a:latin typeface="Encode Sans"/>
+                        </a:rPr>
+                        <a:t>-0.7%</a:t>
+                      </a:r>
+                    </a:p>
+                  </a:txBody>
+                  <a:tcPr marL="36576" marR="36576" marT="18288" marB="18288">
+                    <a:solidFill>
+                      <a:srgbClr val="FFFFFF"/>
+                    </a:solidFill>
+                  </a:tcPr>
+                </a:tc>
+                <a:tc>
+                  <a:txBody>
+                    <a:bodyPr/>
+                    <a:lstStyle/>
+                    <a:p>
+                      <a:pPr algn="r"/>
+                      <a:r>
+                        <a:rPr sz="1000">
+                          <a:solidFill>
+                            <a:srgbClr val="3F3F3F"/>
+                          </a:solidFill>
+                          <a:latin typeface="Encode Sans"/>
+                        </a:rPr>
+                        <a:t>-2.8%</a:t>
+                      </a:r>
+                    </a:p>
+                  </a:txBody>
+                  <a:tcPr marL="36576" marR="36576" marT="18288" marB="18288">
+                    <a:solidFill>
+                      <a:srgbClr val="FFFFFF"/>
+                    </a:solidFill>
+                  </a:tcPr>
+                </a:tc>
+              </a:tr>
+              <a:tr h="292608">
+                <a:tc>
+                  <a:txBody>
+                    <a:bodyPr/>
+                    <a:lstStyle/>
+                    <a:p>
+                      <a:pPr algn="l"/>
+                      <a:r>
+                        <a:rPr sz="1000">
+                          <a:solidFill>
+                            <a:srgbClr val="3F3F3F"/>
+                          </a:solidFill>
+                          <a:latin typeface="Encode Sans"/>
+                        </a:rPr>
+                        <a:t>Abril 2026</a:t>
+                      </a:r>
+                    </a:p>
+                  </a:txBody>
+                  <a:tcPr marL="36576" marR="36576" marT="18288" marB="18288">
+                    <a:solidFill>
+                      <a:srgbClr val="F8F8F6"/>
+                    </a:solidFill>
+                  </a:tcPr>
+                </a:tc>
+                <a:tc>
+                  <a:txBody>
+                    <a:bodyPr/>
+                    <a:lstStyle/>
+                    <a:p>
+                      <a:pPr algn="r"/>
+                      <a:r>
+                        <a:rPr sz="1000">
+                          <a:solidFill>
+                            <a:srgbClr val="3F3F3F"/>
+                          </a:solidFill>
+                          <a:latin typeface="Encode Sans"/>
+                        </a:rPr>
+                        <a:t>78,5</a:t>
+                      </a:r>
+                    </a:p>
+                  </a:txBody>
+                  <a:tcPr marL="36576" marR="36576" marT="18288" marB="18288">
+                    <a:solidFill>
+                      <a:srgbClr val="F8F8F6"/>
+                    </a:solidFill>
+                  </a:tcPr>
+                </a:tc>
+                <a:tc>
+                  <a:txBody>
+                    <a:bodyPr/>
+                    <a:lstStyle/>
+                    <a:p>
+                      <a:pPr algn="r"/>
+                      <a:r>
+                        <a:rPr sz="1000">
+                          <a:solidFill>
+                            <a:srgbClr val="3F3F3F"/>
+                          </a:solidFill>
+                          <a:latin typeface="Encode Sans"/>
+                        </a:rPr>
+                        <a:t>-3.7%</a:t>
+                      </a:r>
+                    </a:p>
+                  </a:txBody>
+                  <a:tcPr marL="36576" marR="36576" marT="18288" marB="18288">
+                    <a:solidFill>
+                      <a:srgbClr val="F8F8F6"/>
+                    </a:solidFill>
+                  </a:tcPr>
+                </a:tc>
+                <a:tc>
+                  <a:txBody>
+                    <a:bodyPr/>
+                    <a:lstStyle/>
+                    <a:p>
+                      <a:pPr algn="r"/>
+                      <a:r>
+                        <a:rPr sz="1000">
+                          <a:solidFill>
+                            <a:srgbClr val="3F3F3F"/>
+                          </a:solidFill>
+                          <a:latin typeface="Encode Sans"/>
+                        </a:rPr>
+                        <a:t>-3.3%</a:t>
+                      </a:r>
+                    </a:p>
+                  </a:txBody>
+                  <a:tcPr marL="36576" marR="36576" marT="18288" marB="18288">
+                    <a:solidFill>
+                      <a:srgbClr val="F8F8F6"/>
+                    </a:solidFill>
+                  </a:tcPr>
+                </a:tc>
+              </a:tr>
+              <a:tr h="292608">
+                <a:tc>
+                  <a:txBody>
+                    <a:bodyPr/>
+                    <a:lstStyle/>
+                    <a:p>
+                      <a:pPr algn="l"/>
+                      <a:r>
+                        <a:rPr sz="1000">
+                          <a:solidFill>
+                            <a:srgbClr val="3F3F3F"/>
+                          </a:solidFill>
+                          <a:latin typeface="Encode Sans"/>
+                        </a:rPr>
+                        <a:t>Marzo 2026</a:t>
+                      </a:r>
+                    </a:p>
+                  </a:txBody>
+                  <a:tcPr marL="36576" marR="36576" marT="18288" marB="18288">
+                    <a:solidFill>
+                      <a:srgbClr val="FFFFFF"/>
+                    </a:solidFill>
+                  </a:tcPr>
+                </a:tc>
+                <a:tc>
+                  <a:txBody>
+                    <a:bodyPr/>
+                    <a:lstStyle/>
+                    <a:p>
+                      <a:pPr algn="r"/>
+                      <a:r>
+                        <a:rPr sz="1000">
+                          <a:solidFill>
+                            <a:srgbClr val="3F3F3F"/>
+                          </a:solidFill>
+                          <a:latin typeface="Encode Sans"/>
+                        </a:rPr>
+                        <a:t>82,4</a:t>
+                      </a:r>
+                    </a:p>
+                  </a:txBody>
+                  <a:tcPr marL="36576" marR="36576" marT="18288" marB="18288">
+                    <a:solidFill>
+                      <a:srgbClr val="FFFFFF"/>
+                    </a:solidFill>
+                  </a:tcPr>
+                </a:tc>
+                <a:tc>
+                  <a:txBody>
+                    <a:bodyPr/>
+                    <a:lstStyle/>
+                    <a:p>
+                      <a:pPr algn="r"/>
+                      <a:r>
+                        <a:rPr sz="1000">
+                          <a:solidFill>
+                            <a:srgbClr val="3F3F3F"/>
+                          </a:solidFill>
+                          <a:latin typeface="Encode Sans"/>
+                        </a:rPr>
+                        <a:t>-5.1%</a:t>
+                      </a:r>
+                    </a:p>
+                  </a:txBody>
+                  <a:tcPr marL="36576" marR="36576" marT="18288" marB="18288">
+                    <a:solidFill>
+                      <a:srgbClr val="FFFFFF"/>
+                    </a:solidFill>
+                  </a:tcPr>
+                </a:tc>
+                <a:tc>
+                  <a:txBody>
+                    <a:bodyPr/>
+                    <a:lstStyle/>
+                    <a:p>
+                      <a:pPr algn="r"/>
+                      <a:r>
+                        <a:rPr sz="1000">
+                          <a:solidFill>
+                            <a:srgbClr val="3F3F3F"/>
+                          </a:solidFill>
+                          <a:latin typeface="Encode Sans"/>
+                        </a:rPr>
+                        <a:t>-3.1%</a:t>
+                      </a:r>
+                    </a:p>
+                  </a:txBody>
+                  <a:tcPr marL="36576" marR="36576" marT="18288" marB="18288">
+                    <a:solidFill>
+                      <a:srgbClr val="FFFFFF"/>
+                    </a:solidFill>
+                  </a:tcPr>
+                </a:tc>
+              </a:tr>
+              <a:tr h="292608">
+                <a:tc>
+                  <a:txBody>
+                    <a:bodyPr/>
+                    <a:lstStyle/>
+                    <a:p>
+                      <a:pPr algn="l"/>
+                      <a:r>
+                        <a:rPr sz="1000">
+                          <a:solidFill>
+                            <a:srgbClr val="3F3F3F"/>
+                          </a:solidFill>
+                          <a:latin typeface="Encode Sans"/>
+                        </a:rPr>
+                        <a:t>Febrero 2026</a:t>
+                      </a:r>
+                    </a:p>
+                  </a:txBody>
+                  <a:tcPr marL="36576" marR="36576" marT="18288" marB="18288">
+                    <a:solidFill>
+                      <a:srgbClr val="F8F8F6"/>
+                    </a:solidFill>
+                  </a:tcPr>
+                </a:tc>
+                <a:tc>
+                  <a:txBody>
+                    <a:bodyPr/>
+                    <a:lstStyle/>
+                    <a:p>
+                      <a:pPr algn="r"/>
+                      <a:r>
+                        <a:rPr sz="1000">
+                          <a:solidFill>
+                            <a:srgbClr val="3F3F3F"/>
+                          </a:solidFill>
+                          <a:latin typeface="Encode Sans"/>
+                        </a:rPr>
+                        <a:t>76,0</a:t>
+                      </a:r>
+                    </a:p>
+                  </a:txBody>
+                  <a:tcPr marL="36576" marR="36576" marT="18288" marB="18288">
+                    <a:solidFill>
+                      <a:srgbClr val="F8F8F6"/>
+                    </a:solidFill>
+                  </a:tcPr>
+                </a:tc>
+                <a:tc>
+                  <a:txBody>
+                    <a:bodyPr/>
+                    <a:lstStyle/>
+                    <a:p>
+                      <a:pPr algn="r"/>
+                      <a:r>
+                        <a:rPr sz="1000">
+                          <a:solidFill>
+                            <a:srgbClr val="3F3F3F"/>
+                          </a:solidFill>
+                          <a:latin typeface="Encode Sans"/>
+                        </a:rPr>
+                        <a:t>-3.1%</a:t>
+                      </a:r>
+                    </a:p>
+                  </a:txBody>
+                  <a:tcPr marL="36576" marR="36576" marT="18288" marB="18288">
+                    <a:solidFill>
+                      <a:srgbClr val="F8F8F6"/>
+                    </a:solidFill>
+                  </a:tcPr>
+                </a:tc>
+                <a:tc>
+                  <a:txBody>
+                    <a:bodyPr/>
+                    <a:lstStyle/>
+                    <a:p>
+                      <a:pPr algn="r"/>
+                      <a:r>
+                        <a:rPr sz="1000">
+                          <a:solidFill>
+                            <a:srgbClr val="3F3F3F"/>
+                          </a:solidFill>
+                          <a:latin typeface="Encode Sans"/>
+                        </a:rPr>
+                        <a:t>-2.1%</a:t>
+                      </a:r>
+                    </a:p>
+                  </a:txBody>
+                  <a:tcPr marL="36576" marR="36576" marT="18288" marB="18288">
+                    <a:solidFill>
+                      <a:srgbClr val="F8F8F6"/>
+                    </a:solidFill>
+                  </a:tcPr>
+                </a:tc>
+              </a:tr>
+            </a:tbl>
+          </a:graphicData>
+        </a:graphic>
+      </p:graphicFrame>
+      <p:sp>
+        <p:nvSpPr>
+          <p:cNvPr id="9" name="TextBox 8"/>
+          <p:cNvSpPr txBox="1"/>
+          <p:nvPr/>
+        </p:nvSpPr>
+        <p:spPr>
+          <a:xfrm>
+            <a:off x="411480" y="6492240"/>
+            <a:ext cx="11368735" cy="274320"/>
+          </a:xfrm>
+          <a:prstGeom prst="rect">
+            <a:avLst/>
+          </a:prstGeom>
+          <a:noFill/>
+        </p:spPr>
+        <p:txBody>
+          <a:bodyPr wrap="none">
+            <a:spAutoFit/>
+          </a:bodyPr>
+          <a:lstStyle/>
+          <a:p>
+            <a:r>
+              <a:rPr sz="1000" b="0" i="1">
+                <a:solidFill>
+                  <a:srgbClr val="6A6760"/>
+                </a:solidFill>
+                <a:latin typeface="Encode Sans"/>
+              </a:rPr>
+              <a:t>Fuente: elaboración propia en base a INDEC</a:t>
+            </a:r>
+          </a:p>
+        </p:txBody>
+      </p:sp>
+    </p:spTree>
+  </p:cSld>
+  <p:clrMapOvr>
+    <a:masterClrMapping/>
+  </p:clrMapOvr>
+</p:sld>
+</file>
+
 <file path=ppt/theme/theme1.xml><?xml version="1.0" encoding="utf-8"?>
 <a:theme xmlns:a="http://schemas.openxmlformats.org/drawingml/2006/main" name="Office Theme">
   <a:themeElements>

</xml_diff>

<commit_message>
data: update 2026-09-24 ( data.json despidos.json scraper/historical_despidos.json publicaciones_semana.pptx rrii_brutas.xlsx)
</commit_message>
<xml_diff>
--- a/publicaciones_semana.pptx
+++ b/publicaciones_semana.pptx
@@ -8,6 +8,7 @@
     <p:sldId id="256" r:id="rId7"/>
     <p:sldId id="257" r:id="rId8"/>
     <p:sldId id="258" r:id="rId9"/>
+    <p:sldId id="259" r:id="rId10"/>
   </p:sldIdLst>
   <p:sldSz cx="12191695" cy="6858000" type="screen4x3"/>
   <p:notesSz cx="6858000" cy="9144000"/>
@@ -3273,7 +3274,7 @@
                 </a:solidFill>
                 <a:latin typeface="Encode Sans"/>
               </a:rPr>
-              <a:t>2 publicaciones · datos oficiales INDEC / BCRA / Hacienda</a:t>
+              <a:t>3 publicaciones · datos oficiales INDEC / BCRA / Hacienda</a:t>
             </a:r>
           </a:p>
         </p:txBody>
@@ -5269,6 +5270,1013 @@
                           <a:latin typeface="Encode Sans"/>
                         </a:rPr>
                         <a:t>-2.1%</a:t>
+                      </a:r>
+                    </a:p>
+                  </a:txBody>
+                  <a:tcPr marL="36576" marR="36576" marT="18288" marB="18288">
+                    <a:solidFill>
+                      <a:srgbClr val="F8F8F6"/>
+                    </a:solidFill>
+                  </a:tcPr>
+                </a:tc>
+              </a:tr>
+            </a:tbl>
+          </a:graphicData>
+        </a:graphic>
+      </p:graphicFrame>
+      <p:sp>
+        <p:nvSpPr>
+          <p:cNvPr id="9" name="TextBox 8"/>
+          <p:cNvSpPr txBox="1"/>
+          <p:nvPr/>
+        </p:nvSpPr>
+        <p:spPr>
+          <a:xfrm>
+            <a:off x="411480" y="6492240"/>
+            <a:ext cx="11368735" cy="274320"/>
+          </a:xfrm>
+          <a:prstGeom prst="rect">
+            <a:avLst/>
+          </a:prstGeom>
+          <a:noFill/>
+        </p:spPr>
+        <p:txBody>
+          <a:bodyPr wrap="none">
+            <a:spAutoFit/>
+          </a:bodyPr>
+          <a:lstStyle/>
+          <a:p>
+            <a:r>
+              <a:rPr sz="1000" b="0" i="1">
+                <a:solidFill>
+                  <a:srgbClr val="6A6760"/>
+                </a:solidFill>
+                <a:latin typeface="Encode Sans"/>
+              </a:rPr>
+              <a:t>Fuente: elaboración propia en base a INDEC</a:t>
+            </a:r>
+          </a:p>
+        </p:txBody>
+      </p:sp>
+    </p:spTree>
+  </p:cSld>
+  <p:clrMapOvr>
+    <a:masterClrMapping/>
+  </p:clrMapOvr>
+</p:sld>
+</file>
+
+<file path=ppt/slides/slide4.xml><?xml version="1.0" encoding="utf-8"?>
+<p:sld xmlns:a="http://schemas.openxmlformats.org/drawingml/2006/main" xmlns:p="http://schemas.openxmlformats.org/presentationml/2006/main" xmlns:r="http://schemas.openxmlformats.org/officeDocument/2006/relationships">
+  <p:cSld>
+    <p:spTree>
+      <p:nvGrpSpPr>
+        <p:cNvPr id="1" name=""/>
+        <p:cNvGrpSpPr/>
+        <p:nvPr/>
+      </p:nvGrpSpPr>
+      <p:grpSpPr/>
+      <p:sp>
+        <p:nvSpPr>
+          <p:cNvPr id="2" name="Rectangle 1"/>
+          <p:cNvSpPr/>
+          <p:nvPr/>
+        </p:nvSpPr>
+        <p:spPr>
+          <a:xfrm>
+            <a:off x="0" y="0"/>
+            <a:ext cx="12191695" cy="274320"/>
+          </a:xfrm>
+          <a:prstGeom prst="rect">
+            <a:avLst/>
+          </a:prstGeom>
+          <a:solidFill>
+            <a:srgbClr val="00B2C9"/>
+          </a:solidFill>
+          <a:ln>
+            <a:noFill/>
+          </a:ln>
+        </p:spPr>
+        <p:style>
+          <a:lnRef idx="1">
+            <a:schemeClr val="accent1"/>
+          </a:lnRef>
+          <a:fillRef idx="3">
+            <a:schemeClr val="accent1"/>
+          </a:fillRef>
+          <a:effectRef idx="2">
+            <a:schemeClr val="accent1"/>
+          </a:effectRef>
+          <a:fontRef idx="minor">
+            <a:schemeClr val="lt1"/>
+          </a:fontRef>
+        </p:style>
+        <p:txBody>
+          <a:bodyPr rtlCol="0" anchor="ctr"/>
+          <a:lstStyle/>
+          <a:p>
+            <a:pPr algn="ctr"/>
+          </a:p>
+        </p:txBody>
+      </p:sp>
+      <p:sp>
+        <p:nvSpPr>
+          <p:cNvPr id="3" name="TextBox 2"/>
+          <p:cNvSpPr txBox="1"/>
+          <p:nvPr/>
+        </p:nvSpPr>
+        <p:spPr>
+          <a:xfrm>
+            <a:off x="411480" y="457200"/>
+            <a:ext cx="11368735" cy="914400"/>
+          </a:xfrm>
+          <a:prstGeom prst="rect">
+            <a:avLst/>
+          </a:prstGeom>
+          <a:noFill/>
+        </p:spPr>
+        <p:txBody>
+          <a:bodyPr wrap="square" lIns="0" rIns="0">
+            <a:spAutoFit/>
+          </a:bodyPr>
+          <a:lstStyle/>
+          <a:p>
+            <a:pPr algn="l"/>
+            <a:r>
+              <a:rPr sz="2600" b="1" i="0">
+                <a:solidFill>
+                  <a:srgbClr val="00B2C9"/>
+                </a:solidFill>
+                <a:latin typeface="Encode Sans"/>
+              </a:rPr>
+              <a:t>EMAE JULIO 2026: ACTIVIDAD CAYÓ -1.4% I.A.</a:t>
+            </a:r>
+          </a:p>
+        </p:txBody>
+      </p:sp>
+      <p:sp>
+        <p:nvSpPr>
+          <p:cNvPr id="4" name="TextBox 3"/>
+          <p:cNvSpPr txBox="1"/>
+          <p:nvPr/>
+        </p:nvSpPr>
+        <p:spPr>
+          <a:xfrm>
+            <a:off x="411480" y="1280160"/>
+            <a:ext cx="11368735" cy="274320"/>
+          </a:xfrm>
+          <a:prstGeom prst="rect">
+            <a:avLst/>
+          </a:prstGeom>
+          <a:noFill/>
+        </p:spPr>
+        <p:txBody>
+          <a:bodyPr wrap="none">
+            <a:spAutoFit/>
+          </a:bodyPr>
+          <a:lstStyle/>
+          <a:p>
+            <a:r>
+              <a:rPr sz="1100" b="0" i="1">
+                <a:solidFill>
+                  <a:srgbClr val="6A6760"/>
+                </a:solidFill>
+                <a:latin typeface="Encode Sans"/>
+              </a:rPr>
+              <a:t>INDEC · período 2026-07</a:t>
+            </a:r>
+          </a:p>
+        </p:txBody>
+      </p:sp>
+      <p:sp>
+        <p:nvSpPr>
+          <p:cNvPr id="5" name="TextBox 4"/>
+          <p:cNvSpPr txBox="1"/>
+          <p:nvPr/>
+        </p:nvSpPr>
+        <p:spPr>
+          <a:xfrm>
+            <a:off x="411480" y="1691640"/>
+            <a:ext cx="5486400" cy="1645920"/>
+          </a:xfrm>
+          <a:prstGeom prst="rect">
+            <a:avLst/>
+          </a:prstGeom>
+          <a:noFill/>
+        </p:spPr>
+        <p:txBody>
+          <a:bodyPr wrap="square" lIns="0" rIns="0">
+            <a:spAutoFit/>
+          </a:bodyPr>
+          <a:lstStyle/>
+          <a:p>
+            <a:pPr algn="just"/>
+            <a:r>
+              <a:rPr sz="1300" b="0" i="0">
+                <a:solidFill>
+                  <a:srgbClr val="3F3F3F"/>
+                </a:solidFill>
+                <a:latin typeface="Encode Sans"/>
+              </a:rPr>
+              <a:t>El Estimador Mensual de Actividad Económica (EMAE) registró una variación interanual de -1.4% en julio 2026. En la medición desestacionalizada, el indicador se movió -2.9% respecto al mes anterior.</a:t>
+            </a:r>
+          </a:p>
+        </p:txBody>
+      </p:sp>
+      <p:sp>
+        <p:nvSpPr>
+          <p:cNvPr id="6" name="TextBox 5"/>
+          <p:cNvSpPr txBox="1"/>
+          <p:nvPr/>
+        </p:nvSpPr>
+        <p:spPr>
+          <a:xfrm>
+            <a:off x="411480" y="3520440"/>
+            <a:ext cx="5486400" cy="2743200"/>
+          </a:xfrm>
+          <a:prstGeom prst="rect">
+            <a:avLst/>
+          </a:prstGeom>
+          <a:noFill/>
+        </p:spPr>
+        <p:txBody>
+          <a:bodyPr wrap="square" lIns="0" rIns="0">
+            <a:spAutoFit/>
+          </a:bodyPr>
+          <a:lstStyle/>
+          <a:p>
+            <a:pPr algn="l">
+              <a:spcAft>
+                <a:spcPts val="800"/>
+              </a:spcAft>
+            </a:pPr>
+            <a:r>
+              <a:rPr sz="1300" b="1" i="0">
+                <a:solidFill>
+                  <a:srgbClr val="00B2C9"/>
+                </a:solidFill>
+                <a:latin typeface="Encode Sans"/>
+              </a:rPr>
+              <a:t>●  </a:t>
+            </a:r>
+            <a:r>
+              <a:rPr sz="1300" b="0" i="0">
+                <a:solidFill>
+                  <a:srgbClr val="3F3F3F"/>
+                </a:solidFill>
+                <a:latin typeface="Encode Sans"/>
+              </a:rPr>
+              <a:t>Variación interanual: -1.4%</a:t>
+            </a:r>
+          </a:p>
+          <a:p>
+            <a:pPr algn="l">
+              <a:spcAft>
+                <a:spcPts val="800"/>
+              </a:spcAft>
+            </a:pPr>
+            <a:r>
+              <a:rPr sz="1300" b="1" i="0">
+                <a:solidFill>
+                  <a:srgbClr val="00B2C9"/>
+                </a:solidFill>
+                <a:latin typeface="Encode Sans"/>
+              </a:rPr>
+              <a:t>●  </a:t>
+            </a:r>
+            <a:r>
+              <a:rPr sz="1300" b="0" i="0">
+                <a:solidFill>
+                  <a:srgbClr val="3F3F3F"/>
+                </a:solidFill>
+                <a:latin typeface="Encode Sans"/>
+              </a:rPr>
+              <a:t>Variación mensual desestacionalizada: -2.9%</a:t>
+            </a:r>
+          </a:p>
+          <a:p>
+            <a:pPr algn="l">
+              <a:spcAft>
+                <a:spcPts val="800"/>
+              </a:spcAft>
+            </a:pPr>
+            <a:r>
+              <a:rPr sz="1300" b="1" i="0">
+                <a:solidFill>
+                  <a:srgbClr val="00B2C9"/>
+                </a:solidFill>
+                <a:latin typeface="Encode Sans"/>
+              </a:rPr>
+              <a:t>●  </a:t>
+            </a:r>
+            <a:r>
+              <a:rPr sz="1300" b="0" i="0">
+                <a:solidFill>
+                  <a:srgbClr val="3F3F3F"/>
+                </a:solidFill>
+                <a:latin typeface="Encode Sans"/>
+              </a:rPr>
+              <a:t>Serie INDEC, base 2004=100. Mide el nivel general de actividad.</a:t>
+            </a:r>
+          </a:p>
+        </p:txBody>
+      </p:sp>
+      <p:pic>
+        <p:nvPicPr>
+          <p:cNvPr id="7" name="Picture 6" descr="image.png"/>
+          <p:cNvPicPr>
+            <a:picLocks noChangeAspect="1"/>
+          </p:cNvPicPr>
+          <p:nvPr/>
+        </p:nvPicPr>
+        <p:blipFill>
+          <a:blip r:embed="rId2"/>
+          <a:stretch>
+            <a:fillRect/>
+          </a:stretch>
+        </p:blipFill>
+        <p:spPr>
+          <a:xfrm>
+            <a:off x="6080760" y="1691640"/>
+            <a:ext cx="5669280" cy="2560320"/>
+          </a:xfrm>
+          <a:prstGeom prst="rect">
+            <a:avLst/>
+          </a:prstGeom>
+        </p:spPr>
+      </p:pic>
+      <p:graphicFrame>
+        <p:nvGraphicFramePr>
+          <p:cNvPr id="8" name="Table 7"/>
+          <p:cNvGraphicFramePr>
+            <a:graphicFrameLocks noGrp="1"/>
+          </p:cNvGraphicFramePr>
+          <p:nvPr/>
+        </p:nvGraphicFramePr>
+        <p:xfrm>
+          <a:off x="6080760" y="4434840"/>
+          <a:ext cx="5669280" cy="2048256"/>
+        </p:xfrm>
+        <a:graphic>
+          <a:graphicData uri="http://schemas.openxmlformats.org/drawingml/2006/table">
+            <a:tbl>
+              <a:tblPr firstRow="1" bandRow="1">
+                <a:tableStyleId>{5C22544A-7EE6-4342-B048-85BDC9FD1C3A}</a:tableStyleId>
+              </a:tblPr>
+              <a:tblGrid>
+                <a:gridCol w="1417320"/>
+                <a:gridCol w="1417320"/>
+                <a:gridCol w="1417320"/>
+                <a:gridCol w="1417320"/>
+              </a:tblGrid>
+              <a:tr h="292608">
+                <a:tc>
+                  <a:txBody>
+                    <a:bodyPr/>
+                    <a:lstStyle/>
+                    <a:p>
+                      <a:pPr algn="l"/>
+                      <a:r>
+                        <a:rPr sz="1000" b="1">
+                          <a:solidFill>
+                            <a:srgbClr val="FFFFFF"/>
+                          </a:solidFill>
+                          <a:latin typeface="Encode Sans"/>
+                        </a:rPr>
+                        <a:t>Mes</a:t>
+                      </a:r>
+                    </a:p>
+                  </a:txBody>
+                  <a:tcPr marL="36576" marR="36576" marT="18288" marB="18288">
+                    <a:solidFill>
+                      <a:srgbClr val="00B2C9"/>
+                    </a:solidFill>
+                  </a:tcPr>
+                </a:tc>
+                <a:tc>
+                  <a:txBody>
+                    <a:bodyPr/>
+                    <a:lstStyle/>
+                    <a:p>
+                      <a:pPr algn="r"/>
+                      <a:r>
+                        <a:rPr sz="1000" b="1">
+                          <a:solidFill>
+                            <a:srgbClr val="FFFFFF"/>
+                          </a:solidFill>
+                          <a:latin typeface="Encode Sans"/>
+                        </a:rPr>
+                        <a:t>Original</a:t>
+                      </a:r>
+                    </a:p>
+                  </a:txBody>
+                  <a:tcPr marL="36576" marR="36576" marT="18288" marB="18288">
+                    <a:solidFill>
+                      <a:srgbClr val="00B2C9"/>
+                    </a:solidFill>
+                  </a:tcPr>
+                </a:tc>
+                <a:tc>
+                  <a:txBody>
+                    <a:bodyPr/>
+                    <a:lstStyle/>
+                    <a:p>
+                      <a:pPr algn="r"/>
+                      <a:r>
+                        <a:rPr sz="1000" b="1">
+                          <a:solidFill>
+                            <a:srgbClr val="FFFFFF"/>
+                          </a:solidFill>
+                          <a:latin typeface="Encode Sans"/>
+                        </a:rPr>
+                        <a:t>VIA %</a:t>
+                      </a:r>
+                    </a:p>
+                  </a:txBody>
+                  <a:tcPr marL="36576" marR="36576" marT="18288" marB="18288">
+                    <a:solidFill>
+                      <a:srgbClr val="00B2C9"/>
+                    </a:solidFill>
+                  </a:tcPr>
+                </a:tc>
+                <a:tc>
+                  <a:txBody>
+                    <a:bodyPr/>
+                    <a:lstStyle/>
+                    <a:p>
+                      <a:pPr algn="r"/>
+                      <a:r>
+                        <a:rPr sz="1000" b="1">
+                          <a:solidFill>
+                            <a:srgbClr val="FFFFFF"/>
+                          </a:solidFill>
+                          <a:latin typeface="Encode Sans"/>
+                        </a:rPr>
+                        <a:t>Desest.</a:t>
+                      </a:r>
+                    </a:p>
+                  </a:txBody>
+                  <a:tcPr marL="36576" marR="36576" marT="18288" marB="18288">
+                    <a:solidFill>
+                      <a:srgbClr val="00B2C9"/>
+                    </a:solidFill>
+                  </a:tcPr>
+                </a:tc>
+              </a:tr>
+              <a:tr h="292608">
+                <a:tc>
+                  <a:txBody>
+                    <a:bodyPr/>
+                    <a:lstStyle/>
+                    <a:p>
+                      <a:pPr algn="l"/>
+                      <a:r>
+                        <a:rPr sz="1000">
+                          <a:solidFill>
+                            <a:srgbClr val="3F3F3F"/>
+                          </a:solidFill>
+                          <a:latin typeface="Encode Sans"/>
+                        </a:rPr>
+                        <a:t>Julio 2026</a:t>
+                      </a:r>
+                    </a:p>
+                  </a:txBody>
+                  <a:tcPr marL="36576" marR="36576" marT="18288" marB="18288">
+                    <a:solidFill>
+                      <a:srgbClr val="FFFFFF"/>
+                    </a:solidFill>
+                  </a:tcPr>
+                </a:tc>
+                <a:tc>
+                  <a:txBody>
+                    <a:bodyPr/>
+                    <a:lstStyle/>
+                    <a:p>
+                      <a:pPr algn="r"/>
+                      <a:r>
+                        <a:rPr sz="1000">
+                          <a:solidFill>
+                            <a:srgbClr val="3F3F3F"/>
+                          </a:solidFill>
+                          <a:latin typeface="Encode Sans"/>
+                        </a:rPr>
+                        <a:t>151,6</a:t>
+                      </a:r>
+                    </a:p>
+                  </a:txBody>
+                  <a:tcPr marL="36576" marR="36576" marT="18288" marB="18288">
+                    <a:solidFill>
+                      <a:srgbClr val="FFFFFF"/>
+                    </a:solidFill>
+                  </a:tcPr>
+                </a:tc>
+                <a:tc>
+                  <a:txBody>
+                    <a:bodyPr/>
+                    <a:lstStyle/>
+                    <a:p>
+                      <a:pPr algn="r"/>
+                      <a:r>
+                        <a:rPr sz="1000">
+                          <a:solidFill>
+                            <a:srgbClr val="3F3F3F"/>
+                          </a:solidFill>
+                          <a:latin typeface="Encode Sans"/>
+                        </a:rPr>
+                        <a:t>-1.4%</a:t>
+                      </a:r>
+                    </a:p>
+                  </a:txBody>
+                  <a:tcPr marL="36576" marR="36576" marT="18288" marB="18288">
+                    <a:solidFill>
+                      <a:srgbClr val="FFFFFF"/>
+                    </a:solidFill>
+                  </a:tcPr>
+                </a:tc>
+                <a:tc>
+                  <a:txBody>
+                    <a:bodyPr/>
+                    <a:lstStyle/>
+                    <a:p>
+                      <a:pPr algn="r"/>
+                      <a:r>
+                        <a:rPr sz="1000">
+                          <a:solidFill>
+                            <a:srgbClr val="3F3F3F"/>
+                          </a:solidFill>
+                          <a:latin typeface="Encode Sans"/>
+                        </a:rPr>
+                        <a:t>149,7</a:t>
+                      </a:r>
+                    </a:p>
+                  </a:txBody>
+                  <a:tcPr marL="36576" marR="36576" marT="18288" marB="18288">
+                    <a:solidFill>
+                      <a:srgbClr val="FFFFFF"/>
+                    </a:solidFill>
+                  </a:tcPr>
+                </a:tc>
+              </a:tr>
+              <a:tr h="292608">
+                <a:tc>
+                  <a:txBody>
+                    <a:bodyPr/>
+                    <a:lstStyle/>
+                    <a:p>
+                      <a:pPr algn="l"/>
+                      <a:r>
+                        <a:rPr sz="1000">
+                          <a:solidFill>
+                            <a:srgbClr val="3F3F3F"/>
+                          </a:solidFill>
+                          <a:latin typeface="Encode Sans"/>
+                        </a:rPr>
+                        <a:t>Junio 2026</a:t>
+                      </a:r>
+                    </a:p>
+                  </a:txBody>
+                  <a:tcPr marL="36576" marR="36576" marT="18288" marB="18288">
+                    <a:solidFill>
+                      <a:srgbClr val="F8F8F6"/>
+                    </a:solidFill>
+                  </a:tcPr>
+                </a:tc>
+                <a:tc>
+                  <a:txBody>
+                    <a:bodyPr/>
+                    <a:lstStyle/>
+                    <a:p>
+                      <a:pPr algn="r"/>
+                      <a:r>
+                        <a:rPr sz="1000">
+                          <a:solidFill>
+                            <a:srgbClr val="3F3F3F"/>
+                          </a:solidFill>
+                          <a:latin typeface="Encode Sans"/>
+                        </a:rPr>
+                        <a:t>161,7</a:t>
+                      </a:r>
+                    </a:p>
+                  </a:txBody>
+                  <a:tcPr marL="36576" marR="36576" marT="18288" marB="18288">
+                    <a:solidFill>
+                      <a:srgbClr val="F8F8F6"/>
+                    </a:solidFill>
+                  </a:tcPr>
+                </a:tc>
+                <a:tc>
+                  <a:txBody>
+                    <a:bodyPr/>
+                    <a:lstStyle/>
+                    <a:p>
+                      <a:pPr algn="r"/>
+                      <a:r>
+                        <a:rPr sz="1000">
+                          <a:solidFill>
+                            <a:srgbClr val="3F3F3F"/>
+                          </a:solidFill>
+                          <a:latin typeface="Encode Sans"/>
+                        </a:rPr>
+                        <a:t>+3.1%</a:t>
+                      </a:r>
+                    </a:p>
+                  </a:txBody>
+                  <a:tcPr marL="36576" marR="36576" marT="18288" marB="18288">
+                    <a:solidFill>
+                      <a:srgbClr val="F8F8F6"/>
+                    </a:solidFill>
+                  </a:tcPr>
+                </a:tc>
+                <a:tc>
+                  <a:txBody>
+                    <a:bodyPr/>
+                    <a:lstStyle/>
+                    <a:p>
+                      <a:pPr algn="r"/>
+                      <a:r>
+                        <a:rPr sz="1000">
+                          <a:solidFill>
+                            <a:srgbClr val="3F3F3F"/>
+                          </a:solidFill>
+                          <a:latin typeface="Encode Sans"/>
+                        </a:rPr>
+                        <a:t>154,1</a:t>
+                      </a:r>
+                    </a:p>
+                  </a:txBody>
+                  <a:tcPr marL="36576" marR="36576" marT="18288" marB="18288">
+                    <a:solidFill>
+                      <a:srgbClr val="F8F8F6"/>
+                    </a:solidFill>
+                  </a:tcPr>
+                </a:tc>
+              </a:tr>
+              <a:tr h="292608">
+                <a:tc>
+                  <a:txBody>
+                    <a:bodyPr/>
+                    <a:lstStyle/>
+                    <a:p>
+                      <a:pPr algn="l"/>
+                      <a:r>
+                        <a:rPr sz="1000">
+                          <a:solidFill>
+                            <a:srgbClr val="3F3F3F"/>
+                          </a:solidFill>
+                          <a:latin typeface="Encode Sans"/>
+                        </a:rPr>
+                        <a:t>Mayo 2026</a:t>
+                      </a:r>
+                    </a:p>
+                  </a:txBody>
+                  <a:tcPr marL="36576" marR="36576" marT="18288" marB="18288">
+                    <a:solidFill>
+                      <a:srgbClr val="FFFFFF"/>
+                    </a:solidFill>
+                  </a:tcPr>
+                </a:tc>
+                <a:tc>
+                  <a:txBody>
+                    <a:bodyPr/>
+                    <a:lstStyle/>
+                    <a:p>
+                      <a:pPr algn="r"/>
+                      <a:r>
+                        <a:rPr sz="1000">
+                          <a:solidFill>
+                            <a:srgbClr val="3F3F3F"/>
+                          </a:solidFill>
+                          <a:latin typeface="Encode Sans"/>
+                        </a:rPr>
+                        <a:t>166,3</a:t>
+                      </a:r>
+                    </a:p>
+                  </a:txBody>
+                  <a:tcPr marL="36576" marR="36576" marT="18288" marB="18288">
+                    <a:solidFill>
+                      <a:srgbClr val="FFFFFF"/>
+                    </a:solidFill>
+                  </a:tcPr>
+                </a:tc>
+                <a:tc>
+                  <a:txBody>
+                    <a:bodyPr/>
+                    <a:lstStyle/>
+                    <a:p>
+                      <a:pPr algn="r"/>
+                      <a:r>
+                        <a:rPr sz="1000">
+                          <a:solidFill>
+                            <a:srgbClr val="3F3F3F"/>
+                          </a:solidFill>
+                          <a:latin typeface="Encode Sans"/>
+                        </a:rPr>
+                        <a:t>+0.7%</a:t>
+                      </a:r>
+                    </a:p>
+                  </a:txBody>
+                  <a:tcPr marL="36576" marR="36576" marT="18288" marB="18288">
+                    <a:solidFill>
+                      <a:srgbClr val="FFFFFF"/>
+                    </a:solidFill>
+                  </a:tcPr>
+                </a:tc>
+                <a:tc>
+                  <a:txBody>
+                    <a:bodyPr/>
+                    <a:lstStyle/>
+                    <a:p>
+                      <a:pPr algn="r"/>
+                      <a:r>
+                        <a:rPr sz="1000">
+                          <a:solidFill>
+                            <a:srgbClr val="3F3F3F"/>
+                          </a:solidFill>
+                          <a:latin typeface="Encode Sans"/>
+                        </a:rPr>
+                        <a:t>153,7</a:t>
+                      </a:r>
+                    </a:p>
+                  </a:txBody>
+                  <a:tcPr marL="36576" marR="36576" marT="18288" marB="18288">
+                    <a:solidFill>
+                      <a:srgbClr val="FFFFFF"/>
+                    </a:solidFill>
+                  </a:tcPr>
+                </a:tc>
+              </a:tr>
+              <a:tr h="292608">
+                <a:tc>
+                  <a:txBody>
+                    <a:bodyPr/>
+                    <a:lstStyle/>
+                    <a:p>
+                      <a:pPr algn="l"/>
+                      <a:r>
+                        <a:rPr sz="1000">
+                          <a:solidFill>
+                            <a:srgbClr val="3F3F3F"/>
+                          </a:solidFill>
+                          <a:latin typeface="Encode Sans"/>
+                        </a:rPr>
+                        <a:t>Abril 2026</a:t>
+                      </a:r>
+                    </a:p>
+                  </a:txBody>
+                  <a:tcPr marL="36576" marR="36576" marT="18288" marB="18288">
+                    <a:solidFill>
+                      <a:srgbClr val="F8F8F6"/>
+                    </a:solidFill>
+                  </a:tcPr>
+                </a:tc>
+                <a:tc>
+                  <a:txBody>
+                    <a:bodyPr/>
+                    <a:lstStyle/>
+                    <a:p>
+                      <a:pPr algn="r"/>
+                      <a:r>
+                        <a:rPr sz="1000">
+                          <a:solidFill>
+                            <a:srgbClr val="3F3F3F"/>
+                          </a:solidFill>
+                          <a:latin typeface="Encode Sans"/>
+                        </a:rPr>
+                        <a:t>162,3</a:t>
+                      </a:r>
+                    </a:p>
+                  </a:txBody>
+                  <a:tcPr marL="36576" marR="36576" marT="18288" marB="18288">
+                    <a:solidFill>
+                      <a:srgbClr val="F8F8F6"/>
+                    </a:solidFill>
+                  </a:tcPr>
+                </a:tc>
+                <a:tc>
+                  <a:txBody>
+                    <a:bodyPr/>
+                    <a:lstStyle/>
+                    <a:p>
+                      <a:pPr algn="r"/>
+                      <a:r>
+                        <a:rPr sz="1000">
+                          <a:solidFill>
+                            <a:srgbClr val="3F3F3F"/>
+                          </a:solidFill>
+                          <a:latin typeface="Encode Sans"/>
+                        </a:rPr>
+                        <a:t>+2.1%</a:t>
+                      </a:r>
+                    </a:p>
+                  </a:txBody>
+                  <a:tcPr marL="36576" marR="36576" marT="18288" marB="18288">
+                    <a:solidFill>
+                      <a:srgbClr val="F8F8F6"/>
+                    </a:solidFill>
+                  </a:tcPr>
+                </a:tc>
+                <a:tc>
+                  <a:txBody>
+                    <a:bodyPr/>
+                    <a:lstStyle/>
+                    <a:p>
+                      <a:pPr algn="r"/>
+                      <a:r>
+                        <a:rPr sz="1000">
+                          <a:solidFill>
+                            <a:srgbClr val="3F3F3F"/>
+                          </a:solidFill>
+                          <a:latin typeface="Encode Sans"/>
+                        </a:rPr>
+                        <a:t>154,6</a:t>
+                      </a:r>
+                    </a:p>
+                  </a:txBody>
+                  <a:tcPr marL="36576" marR="36576" marT="18288" marB="18288">
+                    <a:solidFill>
+                      <a:srgbClr val="F8F8F6"/>
+                    </a:solidFill>
+                  </a:tcPr>
+                </a:tc>
+              </a:tr>
+              <a:tr h="292608">
+                <a:tc>
+                  <a:txBody>
+                    <a:bodyPr/>
+                    <a:lstStyle/>
+                    <a:p>
+                      <a:pPr algn="l"/>
+                      <a:r>
+                        <a:rPr sz="1000">
+                          <a:solidFill>
+                            <a:srgbClr val="3F3F3F"/>
+                          </a:solidFill>
+                          <a:latin typeface="Encode Sans"/>
+                        </a:rPr>
+                        <a:t>Marzo 2026</a:t>
+                      </a:r>
+                    </a:p>
+                  </a:txBody>
+                  <a:tcPr marL="36576" marR="36576" marT="18288" marB="18288">
+                    <a:solidFill>
+                      <a:srgbClr val="FFFFFF"/>
+                    </a:solidFill>
+                  </a:tcPr>
+                </a:tc>
+                <a:tc>
+                  <a:txBody>
+                    <a:bodyPr/>
+                    <a:lstStyle/>
+                    <a:p>
+                      <a:pPr algn="r"/>
+                      <a:r>
+                        <a:rPr sz="1000">
+                          <a:solidFill>
+                            <a:srgbClr val="3F3F3F"/>
+                          </a:solidFill>
+                          <a:latin typeface="Encode Sans"/>
+                        </a:rPr>
+                        <a:t>160,2</a:t>
+                      </a:r>
+                    </a:p>
+                  </a:txBody>
+                  <a:tcPr marL="36576" marR="36576" marT="18288" marB="18288">
+                    <a:solidFill>
+                      <a:srgbClr val="FFFFFF"/>
+                    </a:solidFill>
+                  </a:tcPr>
+                </a:tc>
+                <a:tc>
+                  <a:txBody>
+                    <a:bodyPr/>
+                    <a:lstStyle/>
+                    <a:p>
+                      <a:pPr algn="r"/>
+                      <a:r>
+                        <a:rPr sz="1000">
+                          <a:solidFill>
+                            <a:srgbClr val="3F3F3F"/>
+                          </a:solidFill>
+                          <a:latin typeface="Encode Sans"/>
+                        </a:rPr>
+                        <a:t>+6.4%</a:t>
+                      </a:r>
+                    </a:p>
+                  </a:txBody>
+                  <a:tcPr marL="36576" marR="36576" marT="18288" marB="18288">
+                    <a:solidFill>
+                      <a:srgbClr val="FFFFFF"/>
+                    </a:solidFill>
+                  </a:tcPr>
+                </a:tc>
+                <a:tc>
+                  <a:txBody>
+                    <a:bodyPr/>
+                    <a:lstStyle/>
+                    <a:p>
+                      <a:pPr algn="r"/>
+                      <a:r>
+                        <a:rPr sz="1000">
+                          <a:solidFill>
+                            <a:srgbClr val="3F3F3F"/>
+                          </a:solidFill>
+                          <a:latin typeface="Encode Sans"/>
+                        </a:rPr>
+                        <a:t>156,7</a:t>
+                      </a:r>
+                    </a:p>
+                  </a:txBody>
+                  <a:tcPr marL="36576" marR="36576" marT="18288" marB="18288">
+                    <a:solidFill>
+                      <a:srgbClr val="FFFFFF"/>
+                    </a:solidFill>
+                  </a:tcPr>
+                </a:tc>
+              </a:tr>
+              <a:tr h="292608">
+                <a:tc>
+                  <a:txBody>
+                    <a:bodyPr/>
+                    <a:lstStyle/>
+                    <a:p>
+                      <a:pPr algn="l"/>
+                      <a:r>
+                        <a:rPr sz="1000">
+                          <a:solidFill>
+                            <a:srgbClr val="3F3F3F"/>
+                          </a:solidFill>
+                          <a:latin typeface="Encode Sans"/>
+                        </a:rPr>
+                        <a:t>Febrero 2026</a:t>
+                      </a:r>
+                    </a:p>
+                  </a:txBody>
+                  <a:tcPr marL="36576" marR="36576" marT="18288" marB="18288">
+                    <a:solidFill>
+                      <a:srgbClr val="F8F8F6"/>
+                    </a:solidFill>
+                  </a:tcPr>
+                </a:tc>
+                <a:tc>
+                  <a:txBody>
+                    <a:bodyPr/>
+                    <a:lstStyle/>
+                    <a:p>
+                      <a:pPr algn="r"/>
+                      <a:r>
+                        <a:rPr sz="1000">
+                          <a:solidFill>
+                            <a:srgbClr val="3F3F3F"/>
+                          </a:solidFill>
+                          <a:latin typeface="Encode Sans"/>
+                        </a:rPr>
+                        <a:t>139,3</a:t>
+                      </a:r>
+                    </a:p>
+                  </a:txBody>
+                  <a:tcPr marL="36576" marR="36576" marT="18288" marB="18288">
+                    <a:solidFill>
+                      <a:srgbClr val="F8F8F6"/>
+                    </a:solidFill>
+                  </a:tcPr>
+                </a:tc>
+                <a:tc>
+                  <a:txBody>
+                    <a:bodyPr/>
+                    <a:lstStyle/>
+                    <a:p>
+                      <a:pPr algn="r"/>
+                      <a:r>
+                        <a:rPr sz="1000">
+                          <a:solidFill>
+                            <a:srgbClr val="3F3F3F"/>
+                          </a:solidFill>
+                          <a:latin typeface="Encode Sans"/>
+                        </a:rPr>
+                        <a:t>-1.5%</a:t>
+                      </a:r>
+                    </a:p>
+                  </a:txBody>
+                  <a:tcPr marL="36576" marR="36576" marT="18288" marB="18288">
+                    <a:solidFill>
+                      <a:srgbClr val="F8F8F6"/>
+                    </a:solidFill>
+                  </a:tcPr>
+                </a:tc>
+                <a:tc>
+                  <a:txBody>
+                    <a:bodyPr/>
+                    <a:lstStyle/>
+                    <a:p>
+                      <a:pPr algn="r"/>
+                      <a:r>
+                        <a:rPr sz="1000">
+                          <a:solidFill>
+                            <a:srgbClr val="3F3F3F"/>
+                          </a:solidFill>
+                          <a:latin typeface="Encode Sans"/>
+                        </a:rPr>
+                        <a:t>152,6</a:t>
                       </a:r>
                     </a:p>
                   </a:txBody>

</xml_diff>

<commit_message>
data: update 2026-09-25 ( data.json despidos.json scraper/historical_despidos.json publicaciones_semana.pptx rrii_brutas.xlsx)
</commit_message>
<xml_diff>
--- a/publicaciones_semana.pptx
+++ b/publicaciones_semana.pptx
@@ -9,6 +9,7 @@
     <p:sldId id="257" r:id="rId8"/>
     <p:sldId id="258" r:id="rId9"/>
     <p:sldId id="259" r:id="rId10"/>
+    <p:sldId id="260" r:id="rId11"/>
   </p:sldIdLst>
   <p:sldSz cx="12191695" cy="6858000" type="screen4x3"/>
   <p:notesSz cx="6858000" cy="9144000"/>
@@ -3274,7 +3275,7 @@
                 </a:solidFill>
                 <a:latin typeface="Encode Sans"/>
               </a:rPr>
-              <a:t>3 publicaciones · datos oficiales INDEC / BCRA / Hacienda</a:t>
+              <a:t>4 publicaciones · datos oficiales INDEC / BCRA / Hacienda</a:t>
             </a:r>
           </a:p>
         </p:txBody>
@@ -6277,6 +6278,1038 @@
                           <a:latin typeface="Encode Sans"/>
                         </a:rPr>
                         <a:t>152,6</a:t>
+                      </a:r>
+                    </a:p>
+                  </a:txBody>
+                  <a:tcPr marL="36576" marR="36576" marT="18288" marB="18288">
+                    <a:solidFill>
+                      <a:srgbClr val="F8F8F6"/>
+                    </a:solidFill>
+                  </a:tcPr>
+                </a:tc>
+              </a:tr>
+            </a:tbl>
+          </a:graphicData>
+        </a:graphic>
+      </p:graphicFrame>
+      <p:sp>
+        <p:nvSpPr>
+          <p:cNvPr id="9" name="TextBox 8"/>
+          <p:cNvSpPr txBox="1"/>
+          <p:nvPr/>
+        </p:nvSpPr>
+        <p:spPr>
+          <a:xfrm>
+            <a:off x="411480" y="6492240"/>
+            <a:ext cx="11368735" cy="274320"/>
+          </a:xfrm>
+          <a:prstGeom prst="rect">
+            <a:avLst/>
+          </a:prstGeom>
+          <a:noFill/>
+        </p:spPr>
+        <p:txBody>
+          <a:bodyPr wrap="none">
+            <a:spAutoFit/>
+          </a:bodyPr>
+          <a:lstStyle/>
+          <a:p>
+            <a:r>
+              <a:rPr sz="1000" b="0" i="1">
+                <a:solidFill>
+                  <a:srgbClr val="6A6760"/>
+                </a:solidFill>
+                <a:latin typeface="Encode Sans"/>
+              </a:rPr>
+              <a:t>Fuente: elaboración propia en base a INDEC</a:t>
+            </a:r>
+          </a:p>
+        </p:txBody>
+      </p:sp>
+    </p:spTree>
+  </p:cSld>
+  <p:clrMapOvr>
+    <a:masterClrMapping/>
+  </p:clrMapOvr>
+</p:sld>
+</file>
+
+<file path=ppt/slides/slide5.xml><?xml version="1.0" encoding="utf-8"?>
+<p:sld xmlns:a="http://schemas.openxmlformats.org/drawingml/2006/main" xmlns:p="http://schemas.openxmlformats.org/presentationml/2006/main" xmlns:r="http://schemas.openxmlformats.org/officeDocument/2006/relationships">
+  <p:cSld>
+    <p:spTree>
+      <p:nvGrpSpPr>
+        <p:cNvPr id="1" name=""/>
+        <p:cNvGrpSpPr/>
+        <p:nvPr/>
+      </p:nvGrpSpPr>
+      <p:grpSpPr/>
+      <p:sp>
+        <p:nvSpPr>
+          <p:cNvPr id="2" name="Rectangle 1"/>
+          <p:cNvSpPr/>
+          <p:nvPr/>
+        </p:nvSpPr>
+        <p:spPr>
+          <a:xfrm>
+            <a:off x="0" y="0"/>
+            <a:ext cx="12191695" cy="274320"/>
+          </a:xfrm>
+          <a:prstGeom prst="rect">
+            <a:avLst/>
+          </a:prstGeom>
+          <a:solidFill>
+            <a:srgbClr val="00B2C9"/>
+          </a:solidFill>
+          <a:ln>
+            <a:noFill/>
+          </a:ln>
+        </p:spPr>
+        <p:style>
+          <a:lnRef idx="1">
+            <a:schemeClr val="accent1"/>
+          </a:lnRef>
+          <a:fillRef idx="3">
+            <a:schemeClr val="accent1"/>
+          </a:fillRef>
+          <a:effectRef idx="2">
+            <a:schemeClr val="accent1"/>
+          </a:effectRef>
+          <a:fontRef idx="minor">
+            <a:schemeClr val="lt1"/>
+          </a:fontRef>
+        </p:style>
+        <p:txBody>
+          <a:bodyPr rtlCol="0" anchor="ctr"/>
+          <a:lstStyle/>
+          <a:p>
+            <a:pPr algn="ctr"/>
+          </a:p>
+        </p:txBody>
+      </p:sp>
+      <p:sp>
+        <p:nvSpPr>
+          <p:cNvPr id="3" name="TextBox 2"/>
+          <p:cNvSpPr txBox="1"/>
+          <p:nvPr/>
+        </p:nvSpPr>
+        <p:spPr>
+          <a:xfrm>
+            <a:off x="411480" y="457200"/>
+            <a:ext cx="11368735" cy="914400"/>
+          </a:xfrm>
+          <a:prstGeom prst="rect">
+            <a:avLst/>
+          </a:prstGeom>
+          <a:noFill/>
+        </p:spPr>
+        <p:txBody>
+          <a:bodyPr wrap="square" lIns="0" rIns="0">
+            <a:spAutoFit/>
+          </a:bodyPr>
+          <a:lstStyle/>
+          <a:p>
+            <a:pPr algn="l"/>
+            <a:r>
+              <a:rPr sz="2600" b="1" i="0">
+                <a:solidFill>
+                  <a:srgbClr val="00B2C9"/>
+                </a:solidFill>
+                <a:latin typeface="Encode Sans"/>
+              </a:rPr>
+              <a:t>TURISMO INTERNACIONAL AGOSTO 2026: SALDO -219.172 PERSONAS</a:t>
+            </a:r>
+          </a:p>
+        </p:txBody>
+      </p:sp>
+      <p:sp>
+        <p:nvSpPr>
+          <p:cNvPr id="4" name="TextBox 3"/>
+          <p:cNvSpPr txBox="1"/>
+          <p:nvPr/>
+        </p:nvSpPr>
+        <p:spPr>
+          <a:xfrm>
+            <a:off x="411480" y="1280160"/>
+            <a:ext cx="11368735" cy="274320"/>
+          </a:xfrm>
+          <a:prstGeom prst="rect">
+            <a:avLst/>
+          </a:prstGeom>
+          <a:noFill/>
+        </p:spPr>
+        <p:txBody>
+          <a:bodyPr wrap="none">
+            <a:spAutoFit/>
+          </a:bodyPr>
+          <a:lstStyle/>
+          <a:p>
+            <a:r>
+              <a:rPr sz="1100" b="0" i="1">
+                <a:solidFill>
+                  <a:srgbClr val="6A6760"/>
+                </a:solidFill>
+                <a:latin typeface="Encode Sans"/>
+              </a:rPr>
+              <a:t>INDEC · período 2026-08</a:t>
+            </a:r>
+          </a:p>
+        </p:txBody>
+      </p:sp>
+      <p:sp>
+        <p:nvSpPr>
+          <p:cNvPr id="5" name="TextBox 4"/>
+          <p:cNvSpPr txBox="1"/>
+          <p:nvPr/>
+        </p:nvSpPr>
+        <p:spPr>
+          <a:xfrm>
+            <a:off x="411480" y="1691640"/>
+            <a:ext cx="5486400" cy="1645920"/>
+          </a:xfrm>
+          <a:prstGeom prst="rect">
+            <a:avLst/>
+          </a:prstGeom>
+          <a:noFill/>
+        </p:spPr>
+        <p:txBody>
+          <a:bodyPr wrap="square" lIns="0" rIns="0">
+            <a:spAutoFit/>
+          </a:bodyPr>
+          <a:lstStyle/>
+          <a:p>
+            <a:pPr algn="just"/>
+            <a:r>
+              <a:rPr sz="1300" b="0" i="0">
+                <a:solidFill>
+                  <a:srgbClr val="3F3F3F"/>
+                </a:solidFill>
+                <a:latin typeface="Encode Sans"/>
+              </a:rPr>
+              <a:t>En agosto 2026 ingresaron 432.883 turistas no residentes y salieron 652.055 argentinos al exterior, con saldo de -219.172 personas. Receptivo +8.9% i.a., emisivo -18.3% i.a.</a:t>
+            </a:r>
+          </a:p>
+        </p:txBody>
+      </p:sp>
+      <p:sp>
+        <p:nvSpPr>
+          <p:cNvPr id="6" name="TextBox 5"/>
+          <p:cNvSpPr txBox="1"/>
+          <p:nvPr/>
+        </p:nvSpPr>
+        <p:spPr>
+          <a:xfrm>
+            <a:off x="411480" y="3520440"/>
+            <a:ext cx="5486400" cy="2743200"/>
+          </a:xfrm>
+          <a:prstGeom prst="rect">
+            <a:avLst/>
+          </a:prstGeom>
+          <a:noFill/>
+        </p:spPr>
+        <p:txBody>
+          <a:bodyPr wrap="square" lIns="0" rIns="0">
+            <a:spAutoFit/>
+          </a:bodyPr>
+          <a:lstStyle/>
+          <a:p>
+            <a:pPr algn="l">
+              <a:spcAft>
+                <a:spcPts val="800"/>
+              </a:spcAft>
+            </a:pPr>
+            <a:r>
+              <a:rPr sz="1300" b="1" i="0">
+                <a:solidFill>
+                  <a:srgbClr val="00B2C9"/>
+                </a:solidFill>
+                <a:latin typeface="Encode Sans"/>
+              </a:rPr>
+              <a:t>●  </a:t>
+            </a:r>
+            <a:r>
+              <a:rPr sz="1300" b="0" i="0">
+                <a:solidFill>
+                  <a:srgbClr val="3F3F3F"/>
+                </a:solidFill>
+                <a:latin typeface="Encode Sans"/>
+              </a:rPr>
+              <a:t>Receptivo: 432.883 personas</a:t>
+            </a:r>
+          </a:p>
+          <a:p>
+            <a:pPr algn="l">
+              <a:spcAft>
+                <a:spcPts val="800"/>
+              </a:spcAft>
+            </a:pPr>
+            <a:r>
+              <a:rPr sz="1300" b="1" i="0">
+                <a:solidFill>
+                  <a:srgbClr val="00B2C9"/>
+                </a:solidFill>
+                <a:latin typeface="Encode Sans"/>
+              </a:rPr>
+              <a:t>●  </a:t>
+            </a:r>
+            <a:r>
+              <a:rPr sz="1300" b="0" i="0">
+                <a:solidFill>
+                  <a:srgbClr val="3F3F3F"/>
+                </a:solidFill>
+                <a:latin typeface="Encode Sans"/>
+              </a:rPr>
+              <a:t>Emisivo: 652.055 personas</a:t>
+            </a:r>
+          </a:p>
+          <a:p>
+            <a:pPr algn="l">
+              <a:spcAft>
+                <a:spcPts val="800"/>
+              </a:spcAft>
+            </a:pPr>
+            <a:r>
+              <a:rPr sz="1300" b="1" i="0">
+                <a:solidFill>
+                  <a:srgbClr val="00B2C9"/>
+                </a:solidFill>
+                <a:latin typeface="Encode Sans"/>
+              </a:rPr>
+              <a:t>●  </a:t>
+            </a:r>
+            <a:r>
+              <a:rPr sz="1300" b="0" i="0">
+                <a:solidFill>
+                  <a:srgbClr val="3F3F3F"/>
+                </a:solidFill>
+                <a:latin typeface="Encode Sans"/>
+              </a:rPr>
+              <a:t>Saldo (receptivo − emisivo): -219.172 personas</a:t>
+            </a:r>
+          </a:p>
+          <a:p>
+            <a:pPr algn="l">
+              <a:spcAft>
+                <a:spcPts val="800"/>
+              </a:spcAft>
+            </a:pPr>
+            <a:r>
+              <a:rPr sz="1300" b="1" i="0">
+                <a:solidFill>
+                  <a:srgbClr val="00B2C9"/>
+                </a:solidFill>
+                <a:latin typeface="Encode Sans"/>
+              </a:rPr>
+              <a:t>●  </a:t>
+            </a:r>
+            <a:r>
+              <a:rPr sz="1300" b="0" i="0">
+                <a:solidFill>
+                  <a:srgbClr val="3F3F3F"/>
+                </a:solidFill>
+                <a:latin typeface="Encode Sans"/>
+              </a:rPr>
+              <a:t>Fuente: INDEC, Estadísticas de Turismo Internacional (todas las vías)</a:t>
+            </a:r>
+          </a:p>
+        </p:txBody>
+      </p:sp>
+      <p:pic>
+        <p:nvPicPr>
+          <p:cNvPr id="7" name="Picture 6" descr="image.png"/>
+          <p:cNvPicPr>
+            <a:picLocks noChangeAspect="1"/>
+          </p:cNvPicPr>
+          <p:nvPr/>
+        </p:nvPicPr>
+        <p:blipFill>
+          <a:blip r:embed="rId2"/>
+          <a:stretch>
+            <a:fillRect/>
+          </a:stretch>
+        </p:blipFill>
+        <p:spPr>
+          <a:xfrm>
+            <a:off x="6080760" y="1691640"/>
+            <a:ext cx="5669280" cy="2560320"/>
+          </a:xfrm>
+          <a:prstGeom prst="rect">
+            <a:avLst/>
+          </a:prstGeom>
+        </p:spPr>
+      </p:pic>
+      <p:graphicFrame>
+        <p:nvGraphicFramePr>
+          <p:cNvPr id="8" name="Table 7"/>
+          <p:cNvGraphicFramePr>
+            <a:graphicFrameLocks noGrp="1"/>
+          </p:cNvGraphicFramePr>
+          <p:nvPr/>
+        </p:nvGraphicFramePr>
+        <p:xfrm>
+          <a:off x="6080760" y="4434840"/>
+          <a:ext cx="5669280" cy="2048256"/>
+        </p:xfrm>
+        <a:graphic>
+          <a:graphicData uri="http://schemas.openxmlformats.org/drawingml/2006/table">
+            <a:tbl>
+              <a:tblPr firstRow="1" bandRow="1">
+                <a:tableStyleId>{5C22544A-7EE6-4342-B048-85BDC9FD1C3A}</a:tableStyleId>
+              </a:tblPr>
+              <a:tblGrid>
+                <a:gridCol w="1417320"/>
+                <a:gridCol w="1417320"/>
+                <a:gridCol w="1417320"/>
+                <a:gridCol w="1417320"/>
+              </a:tblGrid>
+              <a:tr h="292608">
+                <a:tc>
+                  <a:txBody>
+                    <a:bodyPr/>
+                    <a:lstStyle/>
+                    <a:p>
+                      <a:pPr algn="l"/>
+                      <a:r>
+                        <a:rPr sz="1000" b="1">
+                          <a:solidFill>
+                            <a:srgbClr val="FFFFFF"/>
+                          </a:solidFill>
+                          <a:latin typeface="Encode Sans"/>
+                        </a:rPr>
+                        <a:t>Mes</a:t>
+                      </a:r>
+                    </a:p>
+                  </a:txBody>
+                  <a:tcPr marL="36576" marR="36576" marT="18288" marB="18288">
+                    <a:solidFill>
+                      <a:srgbClr val="00B2C9"/>
+                    </a:solidFill>
+                  </a:tcPr>
+                </a:tc>
+                <a:tc>
+                  <a:txBody>
+                    <a:bodyPr/>
+                    <a:lstStyle/>
+                    <a:p>
+                      <a:pPr algn="r"/>
+                      <a:r>
+                        <a:rPr sz="1000" b="1">
+                          <a:solidFill>
+                            <a:srgbClr val="FFFFFF"/>
+                          </a:solidFill>
+                          <a:latin typeface="Encode Sans"/>
+                        </a:rPr>
+                        <a:t>Receptivo</a:t>
+                      </a:r>
+                    </a:p>
+                  </a:txBody>
+                  <a:tcPr marL="36576" marR="36576" marT="18288" marB="18288">
+                    <a:solidFill>
+                      <a:srgbClr val="00B2C9"/>
+                    </a:solidFill>
+                  </a:tcPr>
+                </a:tc>
+                <a:tc>
+                  <a:txBody>
+                    <a:bodyPr/>
+                    <a:lstStyle/>
+                    <a:p>
+                      <a:pPr algn="r"/>
+                      <a:r>
+                        <a:rPr sz="1000" b="1">
+                          <a:solidFill>
+                            <a:srgbClr val="FFFFFF"/>
+                          </a:solidFill>
+                          <a:latin typeface="Encode Sans"/>
+                        </a:rPr>
+                        <a:t>Emisivo</a:t>
+                      </a:r>
+                    </a:p>
+                  </a:txBody>
+                  <a:tcPr marL="36576" marR="36576" marT="18288" marB="18288">
+                    <a:solidFill>
+                      <a:srgbClr val="00B2C9"/>
+                    </a:solidFill>
+                  </a:tcPr>
+                </a:tc>
+                <a:tc>
+                  <a:txBody>
+                    <a:bodyPr/>
+                    <a:lstStyle/>
+                    <a:p>
+                      <a:pPr algn="r"/>
+                      <a:r>
+                        <a:rPr sz="1000" b="1">
+                          <a:solidFill>
+                            <a:srgbClr val="FFFFFF"/>
+                          </a:solidFill>
+                          <a:latin typeface="Encode Sans"/>
+                        </a:rPr>
+                        <a:t>Saldo</a:t>
+                      </a:r>
+                    </a:p>
+                  </a:txBody>
+                  <a:tcPr marL="36576" marR="36576" marT="18288" marB="18288">
+                    <a:solidFill>
+                      <a:srgbClr val="00B2C9"/>
+                    </a:solidFill>
+                  </a:tcPr>
+                </a:tc>
+              </a:tr>
+              <a:tr h="292608">
+                <a:tc>
+                  <a:txBody>
+                    <a:bodyPr/>
+                    <a:lstStyle/>
+                    <a:p>
+                      <a:pPr algn="l"/>
+                      <a:r>
+                        <a:rPr sz="1000">
+                          <a:solidFill>
+                            <a:srgbClr val="3F3F3F"/>
+                          </a:solidFill>
+                          <a:latin typeface="Encode Sans"/>
+                        </a:rPr>
+                        <a:t>Agosto 2026</a:t>
+                      </a:r>
+                    </a:p>
+                  </a:txBody>
+                  <a:tcPr marL="36576" marR="36576" marT="18288" marB="18288">
+                    <a:solidFill>
+                      <a:srgbClr val="FFFFFF"/>
+                    </a:solidFill>
+                  </a:tcPr>
+                </a:tc>
+                <a:tc>
+                  <a:txBody>
+                    <a:bodyPr/>
+                    <a:lstStyle/>
+                    <a:p>
+                      <a:pPr algn="r"/>
+                      <a:r>
+                        <a:rPr sz="1000">
+                          <a:solidFill>
+                            <a:srgbClr val="3F3F3F"/>
+                          </a:solidFill>
+                          <a:latin typeface="Encode Sans"/>
+                        </a:rPr>
+                        <a:t>432.883</a:t>
+                      </a:r>
+                    </a:p>
+                  </a:txBody>
+                  <a:tcPr marL="36576" marR="36576" marT="18288" marB="18288">
+                    <a:solidFill>
+                      <a:srgbClr val="FFFFFF"/>
+                    </a:solidFill>
+                  </a:tcPr>
+                </a:tc>
+                <a:tc>
+                  <a:txBody>
+                    <a:bodyPr/>
+                    <a:lstStyle/>
+                    <a:p>
+                      <a:pPr algn="r"/>
+                      <a:r>
+                        <a:rPr sz="1000">
+                          <a:solidFill>
+                            <a:srgbClr val="3F3F3F"/>
+                          </a:solidFill>
+                          <a:latin typeface="Encode Sans"/>
+                        </a:rPr>
+                        <a:t>652.055</a:t>
+                      </a:r>
+                    </a:p>
+                  </a:txBody>
+                  <a:tcPr marL="36576" marR="36576" marT="18288" marB="18288">
+                    <a:solidFill>
+                      <a:srgbClr val="FFFFFF"/>
+                    </a:solidFill>
+                  </a:tcPr>
+                </a:tc>
+                <a:tc>
+                  <a:txBody>
+                    <a:bodyPr/>
+                    <a:lstStyle/>
+                    <a:p>
+                      <a:pPr algn="r"/>
+                      <a:r>
+                        <a:rPr sz="1000">
+                          <a:solidFill>
+                            <a:srgbClr val="3F3F3F"/>
+                          </a:solidFill>
+                          <a:latin typeface="Encode Sans"/>
+                        </a:rPr>
+                        <a:t>-219.172</a:t>
+                      </a:r>
+                    </a:p>
+                  </a:txBody>
+                  <a:tcPr marL="36576" marR="36576" marT="18288" marB="18288">
+                    <a:solidFill>
+                      <a:srgbClr val="FFFFFF"/>
+                    </a:solidFill>
+                  </a:tcPr>
+                </a:tc>
+              </a:tr>
+              <a:tr h="292608">
+                <a:tc>
+                  <a:txBody>
+                    <a:bodyPr/>
+                    <a:lstStyle/>
+                    <a:p>
+                      <a:pPr algn="l"/>
+                      <a:r>
+                        <a:rPr sz="1000">
+                          <a:solidFill>
+                            <a:srgbClr val="3F3F3F"/>
+                          </a:solidFill>
+                          <a:latin typeface="Encode Sans"/>
+                        </a:rPr>
+                        <a:t>Julio 2026</a:t>
+                      </a:r>
+                    </a:p>
+                  </a:txBody>
+                  <a:tcPr marL="36576" marR="36576" marT="18288" marB="18288">
+                    <a:solidFill>
+                      <a:srgbClr val="F8F8F6"/>
+                    </a:solidFill>
+                  </a:tcPr>
+                </a:tc>
+                <a:tc>
+                  <a:txBody>
+                    <a:bodyPr/>
+                    <a:lstStyle/>
+                    <a:p>
+                      <a:pPr algn="r"/>
+                      <a:r>
+                        <a:rPr sz="1000">
+                          <a:solidFill>
+                            <a:srgbClr val="3F3F3F"/>
+                          </a:solidFill>
+                          <a:latin typeface="Encode Sans"/>
+                        </a:rPr>
+                        <a:t>466.234</a:t>
+                      </a:r>
+                    </a:p>
+                  </a:txBody>
+                  <a:tcPr marL="36576" marR="36576" marT="18288" marB="18288">
+                    <a:solidFill>
+                      <a:srgbClr val="F8F8F6"/>
+                    </a:solidFill>
+                  </a:tcPr>
+                </a:tc>
+                <a:tc>
+                  <a:txBody>
+                    <a:bodyPr/>
+                    <a:lstStyle/>
+                    <a:p>
+                      <a:pPr algn="r"/>
+                      <a:r>
+                        <a:rPr sz="1000">
+                          <a:solidFill>
+                            <a:srgbClr val="3F3F3F"/>
+                          </a:solidFill>
+                          <a:latin typeface="Encode Sans"/>
+                        </a:rPr>
+                        <a:t>697.150</a:t>
+                      </a:r>
+                    </a:p>
+                  </a:txBody>
+                  <a:tcPr marL="36576" marR="36576" marT="18288" marB="18288">
+                    <a:solidFill>
+                      <a:srgbClr val="F8F8F6"/>
+                    </a:solidFill>
+                  </a:tcPr>
+                </a:tc>
+                <a:tc>
+                  <a:txBody>
+                    <a:bodyPr/>
+                    <a:lstStyle/>
+                    <a:p>
+                      <a:pPr algn="r"/>
+                      <a:r>
+                        <a:rPr sz="1000">
+                          <a:solidFill>
+                            <a:srgbClr val="3F3F3F"/>
+                          </a:solidFill>
+                          <a:latin typeface="Encode Sans"/>
+                        </a:rPr>
+                        <a:t>-230.916</a:t>
+                      </a:r>
+                    </a:p>
+                  </a:txBody>
+                  <a:tcPr marL="36576" marR="36576" marT="18288" marB="18288">
+                    <a:solidFill>
+                      <a:srgbClr val="F8F8F6"/>
+                    </a:solidFill>
+                  </a:tcPr>
+                </a:tc>
+              </a:tr>
+              <a:tr h="292608">
+                <a:tc>
+                  <a:txBody>
+                    <a:bodyPr/>
+                    <a:lstStyle/>
+                    <a:p>
+                      <a:pPr algn="l"/>
+                      <a:r>
+                        <a:rPr sz="1000">
+                          <a:solidFill>
+                            <a:srgbClr val="3F3F3F"/>
+                          </a:solidFill>
+                          <a:latin typeface="Encode Sans"/>
+                        </a:rPr>
+                        <a:t>Junio 2026</a:t>
+                      </a:r>
+                    </a:p>
+                  </a:txBody>
+                  <a:tcPr marL="36576" marR="36576" marT="18288" marB="18288">
+                    <a:solidFill>
+                      <a:srgbClr val="FFFFFF"/>
+                    </a:solidFill>
+                  </a:tcPr>
+                </a:tc>
+                <a:tc>
+                  <a:txBody>
+                    <a:bodyPr/>
+                    <a:lstStyle/>
+                    <a:p>
+                      <a:pPr algn="r"/>
+                      <a:r>
+                        <a:rPr sz="1000">
+                          <a:solidFill>
+                            <a:srgbClr val="3F3F3F"/>
+                          </a:solidFill>
+                          <a:latin typeface="Encode Sans"/>
+                        </a:rPr>
+                        <a:t>329.177</a:t>
+                      </a:r>
+                    </a:p>
+                  </a:txBody>
+                  <a:tcPr marL="36576" marR="36576" marT="18288" marB="18288">
+                    <a:solidFill>
+                      <a:srgbClr val="FFFFFF"/>
+                    </a:solidFill>
+                  </a:tcPr>
+                </a:tc>
+                <a:tc>
+                  <a:txBody>
+                    <a:bodyPr/>
+                    <a:lstStyle/>
+                    <a:p>
+                      <a:pPr algn="r"/>
+                      <a:r>
+                        <a:rPr sz="1000">
+                          <a:solidFill>
+                            <a:srgbClr val="3F3F3F"/>
+                          </a:solidFill>
+                          <a:latin typeface="Encode Sans"/>
+                        </a:rPr>
+                        <a:t>501.918</a:t>
+                      </a:r>
+                    </a:p>
+                  </a:txBody>
+                  <a:tcPr marL="36576" marR="36576" marT="18288" marB="18288">
+                    <a:solidFill>
+                      <a:srgbClr val="FFFFFF"/>
+                    </a:solidFill>
+                  </a:tcPr>
+                </a:tc>
+                <a:tc>
+                  <a:txBody>
+                    <a:bodyPr/>
+                    <a:lstStyle/>
+                    <a:p>
+                      <a:pPr algn="r"/>
+                      <a:r>
+                        <a:rPr sz="1000">
+                          <a:solidFill>
+                            <a:srgbClr val="3F3F3F"/>
+                          </a:solidFill>
+                          <a:latin typeface="Encode Sans"/>
+                        </a:rPr>
+                        <a:t>-172.741</a:t>
+                      </a:r>
+                    </a:p>
+                  </a:txBody>
+                  <a:tcPr marL="36576" marR="36576" marT="18288" marB="18288">
+                    <a:solidFill>
+                      <a:srgbClr val="FFFFFF"/>
+                    </a:solidFill>
+                  </a:tcPr>
+                </a:tc>
+              </a:tr>
+              <a:tr h="292608">
+                <a:tc>
+                  <a:txBody>
+                    <a:bodyPr/>
+                    <a:lstStyle/>
+                    <a:p>
+                      <a:pPr algn="l"/>
+                      <a:r>
+                        <a:rPr sz="1000">
+                          <a:solidFill>
+                            <a:srgbClr val="3F3F3F"/>
+                          </a:solidFill>
+                          <a:latin typeface="Encode Sans"/>
+                        </a:rPr>
+                        <a:t>Mayo 2026</a:t>
+                      </a:r>
+                    </a:p>
+                  </a:txBody>
+                  <a:tcPr marL="36576" marR="36576" marT="18288" marB="18288">
+                    <a:solidFill>
+                      <a:srgbClr val="F8F8F6"/>
+                    </a:solidFill>
+                  </a:tcPr>
+                </a:tc>
+                <a:tc>
+                  <a:txBody>
+                    <a:bodyPr/>
+                    <a:lstStyle/>
+                    <a:p>
+                      <a:pPr algn="r"/>
+                      <a:r>
+                        <a:rPr sz="1000">
+                          <a:solidFill>
+                            <a:srgbClr val="3F3F3F"/>
+                          </a:solidFill>
+                          <a:latin typeface="Encode Sans"/>
+                        </a:rPr>
+                        <a:t>379.860</a:t>
+                      </a:r>
+                    </a:p>
+                  </a:txBody>
+                  <a:tcPr marL="36576" marR="36576" marT="18288" marB="18288">
+                    <a:solidFill>
+                      <a:srgbClr val="F8F8F6"/>
+                    </a:solidFill>
+                  </a:tcPr>
+                </a:tc>
+                <a:tc>
+                  <a:txBody>
+                    <a:bodyPr/>
+                    <a:lstStyle/>
+                    <a:p>
+                      <a:pPr algn="r"/>
+                      <a:r>
+                        <a:rPr sz="1000">
+                          <a:solidFill>
+                            <a:srgbClr val="3F3F3F"/>
+                          </a:solidFill>
+                          <a:latin typeface="Encode Sans"/>
+                        </a:rPr>
+                        <a:t>661.853</a:t>
+                      </a:r>
+                    </a:p>
+                  </a:txBody>
+                  <a:tcPr marL="36576" marR="36576" marT="18288" marB="18288">
+                    <a:solidFill>
+                      <a:srgbClr val="F8F8F6"/>
+                    </a:solidFill>
+                  </a:tcPr>
+                </a:tc>
+                <a:tc>
+                  <a:txBody>
+                    <a:bodyPr/>
+                    <a:lstStyle/>
+                    <a:p>
+                      <a:pPr algn="r"/>
+                      <a:r>
+                        <a:rPr sz="1000">
+                          <a:solidFill>
+                            <a:srgbClr val="3F3F3F"/>
+                          </a:solidFill>
+                          <a:latin typeface="Encode Sans"/>
+                        </a:rPr>
+                        <a:t>-281.993</a:t>
+                      </a:r>
+                    </a:p>
+                  </a:txBody>
+                  <a:tcPr marL="36576" marR="36576" marT="18288" marB="18288">
+                    <a:solidFill>
+                      <a:srgbClr val="F8F8F6"/>
+                    </a:solidFill>
+                  </a:tcPr>
+                </a:tc>
+              </a:tr>
+              <a:tr h="292608">
+                <a:tc>
+                  <a:txBody>
+                    <a:bodyPr/>
+                    <a:lstStyle/>
+                    <a:p>
+                      <a:pPr algn="l"/>
+                      <a:r>
+                        <a:rPr sz="1000">
+                          <a:solidFill>
+                            <a:srgbClr val="3F3F3F"/>
+                          </a:solidFill>
+                          <a:latin typeface="Encode Sans"/>
+                        </a:rPr>
+                        <a:t>Abril 2026</a:t>
+                      </a:r>
+                    </a:p>
+                  </a:txBody>
+                  <a:tcPr marL="36576" marR="36576" marT="18288" marB="18288">
+                    <a:solidFill>
+                      <a:srgbClr val="FFFFFF"/>
+                    </a:solidFill>
+                  </a:tcPr>
+                </a:tc>
+                <a:tc>
+                  <a:txBody>
+                    <a:bodyPr/>
+                    <a:lstStyle/>
+                    <a:p>
+                      <a:pPr algn="r"/>
+                      <a:r>
+                        <a:rPr sz="1000">
+                          <a:solidFill>
+                            <a:srgbClr val="3F3F3F"/>
+                          </a:solidFill>
+                          <a:latin typeface="Encode Sans"/>
+                        </a:rPr>
+                        <a:t>463.072</a:t>
+                      </a:r>
+                    </a:p>
+                  </a:txBody>
+                  <a:tcPr marL="36576" marR="36576" marT="18288" marB="18288">
+                    <a:solidFill>
+                      <a:srgbClr val="FFFFFF"/>
+                    </a:solidFill>
+                  </a:tcPr>
+                </a:tc>
+                <a:tc>
+                  <a:txBody>
+                    <a:bodyPr/>
+                    <a:lstStyle/>
+                    <a:p>
+                      <a:pPr algn="r"/>
+                      <a:r>
+                        <a:rPr sz="1000">
+                          <a:solidFill>
+                            <a:srgbClr val="3F3F3F"/>
+                          </a:solidFill>
+                          <a:latin typeface="Encode Sans"/>
+                        </a:rPr>
+                        <a:t>764.757</a:t>
+                      </a:r>
+                    </a:p>
+                  </a:txBody>
+                  <a:tcPr marL="36576" marR="36576" marT="18288" marB="18288">
+                    <a:solidFill>
+                      <a:srgbClr val="FFFFFF"/>
+                    </a:solidFill>
+                  </a:tcPr>
+                </a:tc>
+                <a:tc>
+                  <a:txBody>
+                    <a:bodyPr/>
+                    <a:lstStyle/>
+                    <a:p>
+                      <a:pPr algn="r"/>
+                      <a:r>
+                        <a:rPr sz="1000">
+                          <a:solidFill>
+                            <a:srgbClr val="3F3F3F"/>
+                          </a:solidFill>
+                          <a:latin typeface="Encode Sans"/>
+                        </a:rPr>
+                        <a:t>-301.685</a:t>
+                      </a:r>
+                    </a:p>
+                  </a:txBody>
+                  <a:tcPr marL="36576" marR="36576" marT="18288" marB="18288">
+                    <a:solidFill>
+                      <a:srgbClr val="FFFFFF"/>
+                    </a:solidFill>
+                  </a:tcPr>
+                </a:tc>
+              </a:tr>
+              <a:tr h="292608">
+                <a:tc>
+                  <a:txBody>
+                    <a:bodyPr/>
+                    <a:lstStyle/>
+                    <a:p>
+                      <a:pPr algn="l"/>
+                      <a:r>
+                        <a:rPr sz="1000">
+                          <a:solidFill>
+                            <a:srgbClr val="3F3F3F"/>
+                          </a:solidFill>
+                          <a:latin typeface="Encode Sans"/>
+                        </a:rPr>
+                        <a:t>Marzo 2026</a:t>
+                      </a:r>
+                    </a:p>
+                  </a:txBody>
+                  <a:tcPr marL="36576" marR="36576" marT="18288" marB="18288">
+                    <a:solidFill>
+                      <a:srgbClr val="F8F8F6"/>
+                    </a:solidFill>
+                  </a:tcPr>
+                </a:tc>
+                <a:tc>
+                  <a:txBody>
+                    <a:bodyPr/>
+                    <a:lstStyle/>
+                    <a:p>
+                      <a:pPr algn="r"/>
+                      <a:r>
+                        <a:rPr sz="1000">
+                          <a:solidFill>
+                            <a:srgbClr val="3F3F3F"/>
+                          </a:solidFill>
+                          <a:latin typeface="Encode Sans"/>
+                        </a:rPr>
+                        <a:t>509.625</a:t>
+                      </a:r>
+                    </a:p>
+                  </a:txBody>
+                  <a:tcPr marL="36576" marR="36576" marT="18288" marB="18288">
+                    <a:solidFill>
+                      <a:srgbClr val="F8F8F6"/>
+                    </a:solidFill>
+                  </a:tcPr>
+                </a:tc>
+                <a:tc>
+                  <a:txBody>
+                    <a:bodyPr/>
+                    <a:lstStyle/>
+                    <a:p>
+                      <a:pPr algn="r"/>
+                      <a:r>
+                        <a:rPr sz="1000">
+                          <a:solidFill>
+                            <a:srgbClr val="3F3F3F"/>
+                          </a:solidFill>
+                          <a:latin typeface="Encode Sans"/>
+                        </a:rPr>
+                        <a:t>1.061.777</a:t>
+                      </a:r>
+                    </a:p>
+                  </a:txBody>
+                  <a:tcPr marL="36576" marR="36576" marT="18288" marB="18288">
+                    <a:solidFill>
+                      <a:srgbClr val="F8F8F6"/>
+                    </a:solidFill>
+                  </a:tcPr>
+                </a:tc>
+                <a:tc>
+                  <a:txBody>
+                    <a:bodyPr/>
+                    <a:lstStyle/>
+                    <a:p>
+                      <a:pPr algn="r"/>
+                      <a:r>
+                        <a:rPr sz="1000">
+                          <a:solidFill>
+                            <a:srgbClr val="3F3F3F"/>
+                          </a:solidFill>
+                          <a:latin typeface="Encode Sans"/>
+                        </a:rPr>
+                        <a:t>-552.152</a:t>
                       </a:r>
                     </a:p>
                   </a:txBody>

</xml_diff>

<commit_message>
data: update 2026-10-02 ( data.json despidos.json scraper/historical_despidos.json publicaciones_semana.pptx rrii_brutas.xlsx)
</commit_message>
<xml_diff>
--- a/publicaciones_semana.pptx
+++ b/publicaciones_semana.pptx
@@ -7,6 +7,7 @@
   <p:sldIdLst>
     <p:sldId id="256" r:id="rId7"/>
     <p:sldId id="257" r:id="rId8"/>
+    <p:sldId id="258" r:id="rId9"/>
   </p:sldIdLst>
   <p:sldSz cx="12191695" cy="6858000" type="screen4x3"/>
   <p:notesSz cx="6858000" cy="9144000"/>
@@ -3272,7 +3273,7 @@
                 </a:solidFill>
                 <a:latin typeface="Encode Sans"/>
               </a:rPr>
-              <a:t>1 publicaciones · datos oficiales INDEC / BCRA / Hacienda</a:t>
+              <a:t>2 publicaciones · datos oficiales INDEC / BCRA / Hacienda</a:t>
             </a:r>
           </a:p>
         </p:txBody>
@@ -3620,6 +3621,1038 @@
                 <a:latin typeface="Encode Sans"/>
               </a:rPr>
               <a:t>Fuente: elaboración propia en base a INDEC</a:t>
+            </a:r>
+          </a:p>
+        </p:txBody>
+      </p:sp>
+    </p:spTree>
+  </p:cSld>
+  <p:clrMapOvr>
+    <a:masterClrMapping/>
+  </p:clrMapOvr>
+</p:sld>
+</file>
+
+<file path=ppt/slides/slide3.xml><?xml version="1.0" encoding="utf-8"?>
+<p:sld xmlns:a="http://schemas.openxmlformats.org/drawingml/2006/main" xmlns:p="http://schemas.openxmlformats.org/presentationml/2006/main" xmlns:r="http://schemas.openxmlformats.org/officeDocument/2006/relationships">
+  <p:cSld>
+    <p:spTree>
+      <p:nvGrpSpPr>
+        <p:cNvPr id="1" name=""/>
+        <p:cNvGrpSpPr/>
+        <p:nvPr/>
+      </p:nvGrpSpPr>
+      <p:grpSpPr/>
+      <p:sp>
+        <p:nvSpPr>
+          <p:cNvPr id="2" name="Rectangle 1"/>
+          <p:cNvSpPr/>
+          <p:nvPr/>
+        </p:nvSpPr>
+        <p:spPr>
+          <a:xfrm>
+            <a:off x="0" y="0"/>
+            <a:ext cx="12191695" cy="274320"/>
+          </a:xfrm>
+          <a:prstGeom prst="rect">
+            <a:avLst/>
+          </a:prstGeom>
+          <a:solidFill>
+            <a:srgbClr val="00B2C9"/>
+          </a:solidFill>
+          <a:ln>
+            <a:noFill/>
+          </a:ln>
+        </p:spPr>
+        <p:style>
+          <a:lnRef idx="1">
+            <a:schemeClr val="accent1"/>
+          </a:lnRef>
+          <a:fillRef idx="3">
+            <a:schemeClr val="accent1"/>
+          </a:fillRef>
+          <a:effectRef idx="2">
+            <a:schemeClr val="accent1"/>
+          </a:effectRef>
+          <a:fontRef idx="minor">
+            <a:schemeClr val="lt1"/>
+          </a:fontRef>
+        </p:style>
+        <p:txBody>
+          <a:bodyPr rtlCol="0" anchor="ctr"/>
+          <a:lstStyle/>
+          <a:p>
+            <a:pPr algn="ctr"/>
+          </a:p>
+        </p:txBody>
+      </p:sp>
+      <p:sp>
+        <p:nvSpPr>
+          <p:cNvPr id="3" name="TextBox 2"/>
+          <p:cNvSpPr txBox="1"/>
+          <p:nvPr/>
+        </p:nvSpPr>
+        <p:spPr>
+          <a:xfrm>
+            <a:off x="411480" y="457200"/>
+            <a:ext cx="11368735" cy="914400"/>
+          </a:xfrm>
+          <a:prstGeom prst="rect">
+            <a:avLst/>
+          </a:prstGeom>
+          <a:noFill/>
+        </p:spPr>
+        <p:txBody>
+          <a:bodyPr wrap="square" lIns="0" rIns="0">
+            <a:spAutoFit/>
+          </a:bodyPr>
+          <a:lstStyle/>
+          <a:p>
+            <a:pPr algn="l"/>
+            <a:r>
+              <a:rPr sz="2600" b="1" i="0">
+                <a:solidFill>
+                  <a:srgbClr val="00B2C9"/>
+                </a:solidFill>
+                <a:latin typeface="Encode Sans"/>
+              </a:rPr>
+              <a:t>RECAUDACIÓN SEPTIEMBRE 2026: CRECIÓ +8.6% REAL I.A.</a:t>
+            </a:r>
+          </a:p>
+        </p:txBody>
+      </p:sp>
+      <p:sp>
+        <p:nvSpPr>
+          <p:cNvPr id="4" name="TextBox 3"/>
+          <p:cNvSpPr txBox="1"/>
+          <p:nvPr/>
+        </p:nvSpPr>
+        <p:spPr>
+          <a:xfrm>
+            <a:off x="411480" y="1280160"/>
+            <a:ext cx="11368735" cy="274320"/>
+          </a:xfrm>
+          <a:prstGeom prst="rect">
+            <a:avLst/>
+          </a:prstGeom>
+          <a:noFill/>
+        </p:spPr>
+        <p:txBody>
+          <a:bodyPr wrap="none">
+            <a:spAutoFit/>
+          </a:bodyPr>
+          <a:lstStyle/>
+          <a:p>
+            <a:r>
+              <a:rPr sz="1100" b="0" i="1">
+                <a:solidFill>
+                  <a:srgbClr val="6A6760"/>
+                </a:solidFill>
+                <a:latin typeface="Encode Sans"/>
+              </a:rPr>
+              <a:t>AFIP/ARCA · período 2026-09</a:t>
+            </a:r>
+          </a:p>
+        </p:txBody>
+      </p:sp>
+      <p:sp>
+        <p:nvSpPr>
+          <p:cNvPr id="5" name="TextBox 4"/>
+          <p:cNvSpPr txBox="1"/>
+          <p:nvPr/>
+        </p:nvSpPr>
+        <p:spPr>
+          <a:xfrm>
+            <a:off x="411480" y="1691640"/>
+            <a:ext cx="5486400" cy="1645920"/>
+          </a:xfrm>
+          <a:prstGeom prst="rect">
+            <a:avLst/>
+          </a:prstGeom>
+          <a:noFill/>
+        </p:spPr>
+        <p:txBody>
+          <a:bodyPr wrap="square" lIns="0" rIns="0">
+            <a:spAutoFit/>
+          </a:bodyPr>
+          <a:lstStyle/>
+          <a:p>
+            <a:pPr algn="just"/>
+            <a:r>
+              <a:rPr sz="1300" b="0" i="0">
+                <a:solidFill>
+                  <a:srgbClr val="3F3F3F"/>
+                </a:solidFill>
+                <a:latin typeface="Encode Sans"/>
+              </a:rPr>
+              <a:t>AFIP/ARCA recaudó $21.359K millones en septiembre 2026. Variación nominal interanual: +38.3%. En términos reales (deflactado por REM): +8.6% i.a. Quiebre de tendencia: venía con 6 meses de caída real interanual.</a:t>
+            </a:r>
+          </a:p>
+        </p:txBody>
+      </p:sp>
+      <p:sp>
+        <p:nvSpPr>
+          <p:cNvPr id="6" name="TextBox 5"/>
+          <p:cNvSpPr txBox="1"/>
+          <p:nvPr/>
+        </p:nvSpPr>
+        <p:spPr>
+          <a:xfrm>
+            <a:off x="411480" y="3520440"/>
+            <a:ext cx="5486400" cy="2743200"/>
+          </a:xfrm>
+          <a:prstGeom prst="rect">
+            <a:avLst/>
+          </a:prstGeom>
+          <a:noFill/>
+        </p:spPr>
+        <p:txBody>
+          <a:bodyPr wrap="square" lIns="0" rIns="0">
+            <a:spAutoFit/>
+          </a:bodyPr>
+          <a:lstStyle/>
+          <a:p>
+            <a:pPr algn="l">
+              <a:spcAft>
+                <a:spcPts val="800"/>
+              </a:spcAft>
+            </a:pPr>
+            <a:r>
+              <a:rPr sz="1300" b="1" i="0">
+                <a:solidFill>
+                  <a:srgbClr val="00B2C9"/>
+                </a:solidFill>
+                <a:latin typeface="Encode Sans"/>
+              </a:rPr>
+              <a:t>●  </a:t>
+            </a:r>
+            <a:r>
+              <a:rPr sz="1300" b="0" i="0">
+                <a:solidFill>
+                  <a:srgbClr val="3F3F3F"/>
+                </a:solidFill>
+                <a:latin typeface="Encode Sans"/>
+              </a:rPr>
+              <a:t>Total: $21.359K M$</a:t>
+            </a:r>
+          </a:p>
+          <a:p>
+            <a:pPr algn="l">
+              <a:spcAft>
+                <a:spcPts val="800"/>
+              </a:spcAft>
+            </a:pPr>
+            <a:r>
+              <a:rPr sz="1300" b="1" i="0">
+                <a:solidFill>
+                  <a:srgbClr val="00B2C9"/>
+                </a:solidFill>
+                <a:latin typeface="Encode Sans"/>
+              </a:rPr>
+              <a:t>●  </a:t>
+            </a:r>
+            <a:r>
+              <a:rPr sz="1300" b="0" i="0">
+                <a:solidFill>
+                  <a:srgbClr val="3F3F3F"/>
+                </a:solidFill>
+                <a:latin typeface="Encode Sans"/>
+              </a:rPr>
+              <a:t>Variación nominal i.a.: +38.3%</a:t>
+            </a:r>
+          </a:p>
+          <a:p>
+            <a:pPr algn="l">
+              <a:spcAft>
+                <a:spcPts val="800"/>
+              </a:spcAft>
+            </a:pPr>
+            <a:r>
+              <a:rPr sz="1300" b="1" i="0">
+                <a:solidFill>
+                  <a:srgbClr val="00B2C9"/>
+                </a:solidFill>
+                <a:latin typeface="Encode Sans"/>
+              </a:rPr>
+              <a:t>●  </a:t>
+            </a:r>
+            <a:r>
+              <a:rPr sz="1300" b="0" i="0">
+                <a:solidFill>
+                  <a:srgbClr val="3F3F3F"/>
+                </a:solidFill>
+                <a:latin typeface="Encode Sans"/>
+              </a:rPr>
+              <a:t>Variación real i.a.: +8.6% (deflactor: REM)</a:t>
+            </a:r>
+          </a:p>
+          <a:p>
+            <a:pPr algn="l">
+              <a:spcAft>
+                <a:spcPts val="800"/>
+              </a:spcAft>
+            </a:pPr>
+            <a:r>
+              <a:rPr sz="1300" b="1" i="0">
+                <a:solidFill>
+                  <a:srgbClr val="00B2C9"/>
+                </a:solidFill>
+                <a:latin typeface="Encode Sans"/>
+              </a:rPr>
+              <a:t>●  </a:t>
+            </a:r>
+            <a:r>
+              <a:rPr sz="1300" b="0" i="0">
+                <a:solidFill>
+                  <a:srgbClr val="3F3F3F"/>
+                </a:solidFill>
+                <a:latin typeface="Encode Sans"/>
+              </a:rPr>
+              <a:t>Fuente: ARCA (ex AFIP) · indec.gob.ar series</a:t>
+            </a:r>
+          </a:p>
+        </p:txBody>
+      </p:sp>
+      <p:pic>
+        <p:nvPicPr>
+          <p:cNvPr id="7" name="Picture 6" descr="image.png"/>
+          <p:cNvPicPr>
+            <a:picLocks noChangeAspect="1"/>
+          </p:cNvPicPr>
+          <p:nvPr/>
+        </p:nvPicPr>
+        <p:blipFill>
+          <a:blip r:embed="rId2"/>
+          <a:stretch>
+            <a:fillRect/>
+          </a:stretch>
+        </p:blipFill>
+        <p:spPr>
+          <a:xfrm>
+            <a:off x="6080760" y="1691640"/>
+            <a:ext cx="5669280" cy="2560320"/>
+          </a:xfrm>
+          <a:prstGeom prst="rect">
+            <a:avLst/>
+          </a:prstGeom>
+        </p:spPr>
+      </p:pic>
+      <p:graphicFrame>
+        <p:nvGraphicFramePr>
+          <p:cNvPr id="8" name="Table 7"/>
+          <p:cNvGraphicFramePr>
+            <a:graphicFrameLocks noGrp="1"/>
+          </p:cNvGraphicFramePr>
+          <p:nvPr/>
+        </p:nvGraphicFramePr>
+        <p:xfrm>
+          <a:off x="6080760" y="4434840"/>
+          <a:ext cx="5669280" cy="2048256"/>
+        </p:xfrm>
+        <a:graphic>
+          <a:graphicData uri="http://schemas.openxmlformats.org/drawingml/2006/table">
+            <a:tbl>
+              <a:tblPr firstRow="1" bandRow="1">
+                <a:tableStyleId>{5C22544A-7EE6-4342-B048-85BDC9FD1C3A}</a:tableStyleId>
+              </a:tblPr>
+              <a:tblGrid>
+                <a:gridCol w="1417320"/>
+                <a:gridCol w="1417320"/>
+                <a:gridCol w="1417320"/>
+                <a:gridCol w="1417320"/>
+              </a:tblGrid>
+              <a:tr h="292608">
+                <a:tc>
+                  <a:txBody>
+                    <a:bodyPr/>
+                    <a:lstStyle/>
+                    <a:p>
+                      <a:pPr algn="l"/>
+                      <a:r>
+                        <a:rPr sz="1000" b="1">
+                          <a:solidFill>
+                            <a:srgbClr val="FFFFFF"/>
+                          </a:solidFill>
+                          <a:latin typeface="Encode Sans"/>
+                        </a:rPr>
+                        <a:t>Mes</a:t>
+                      </a:r>
+                    </a:p>
+                  </a:txBody>
+                  <a:tcPr marL="36576" marR="36576" marT="18288" marB="18288">
+                    <a:solidFill>
+                      <a:srgbClr val="00B2C9"/>
+                    </a:solidFill>
+                  </a:tcPr>
+                </a:tc>
+                <a:tc>
+                  <a:txBody>
+                    <a:bodyPr/>
+                    <a:lstStyle/>
+                    <a:p>
+                      <a:pPr algn="r"/>
+                      <a:r>
+                        <a:rPr sz="1000" b="1">
+                          <a:solidFill>
+                            <a:srgbClr val="FFFFFF"/>
+                          </a:solidFill>
+                          <a:latin typeface="Encode Sans"/>
+                        </a:rPr>
+                        <a:t>Total M$</a:t>
+                      </a:r>
+                    </a:p>
+                  </a:txBody>
+                  <a:tcPr marL="36576" marR="36576" marT="18288" marB="18288">
+                    <a:solidFill>
+                      <a:srgbClr val="00B2C9"/>
+                    </a:solidFill>
+                  </a:tcPr>
+                </a:tc>
+                <a:tc>
+                  <a:txBody>
+                    <a:bodyPr/>
+                    <a:lstStyle/>
+                    <a:p>
+                      <a:pPr algn="r"/>
+                      <a:r>
+                        <a:rPr sz="1000" b="1">
+                          <a:solidFill>
+                            <a:srgbClr val="FFFFFF"/>
+                          </a:solidFill>
+                          <a:latin typeface="Encode Sans"/>
+                        </a:rPr>
+                        <a:t>Var. nom. i.a.</a:t>
+                      </a:r>
+                    </a:p>
+                  </a:txBody>
+                  <a:tcPr marL="36576" marR="36576" marT="18288" marB="18288">
+                    <a:solidFill>
+                      <a:srgbClr val="00B2C9"/>
+                    </a:solidFill>
+                  </a:tcPr>
+                </a:tc>
+                <a:tc>
+                  <a:txBody>
+                    <a:bodyPr/>
+                    <a:lstStyle/>
+                    <a:p>
+                      <a:pPr algn="r"/>
+                      <a:r>
+                        <a:rPr sz="1000" b="1">
+                          <a:solidFill>
+                            <a:srgbClr val="FFFFFF"/>
+                          </a:solidFill>
+                          <a:latin typeface="Encode Sans"/>
+                        </a:rPr>
+                        <a:t>Var. real i.a.</a:t>
+                      </a:r>
+                    </a:p>
+                  </a:txBody>
+                  <a:tcPr marL="36576" marR="36576" marT="18288" marB="18288">
+                    <a:solidFill>
+                      <a:srgbClr val="00B2C9"/>
+                    </a:solidFill>
+                  </a:tcPr>
+                </a:tc>
+              </a:tr>
+              <a:tr h="292608">
+                <a:tc>
+                  <a:txBody>
+                    <a:bodyPr/>
+                    <a:lstStyle/>
+                    <a:p>
+                      <a:pPr algn="l"/>
+                      <a:r>
+                        <a:rPr sz="1000">
+                          <a:solidFill>
+                            <a:srgbClr val="3F3F3F"/>
+                          </a:solidFill>
+                          <a:latin typeface="Encode Sans"/>
+                        </a:rPr>
+                        <a:t>Septiembre 2026</a:t>
+                      </a:r>
+                    </a:p>
+                  </a:txBody>
+                  <a:tcPr marL="36576" marR="36576" marT="18288" marB="18288">
+                    <a:solidFill>
+                      <a:srgbClr val="FFFFFF"/>
+                    </a:solidFill>
+                  </a:tcPr>
+                </a:tc>
+                <a:tc>
+                  <a:txBody>
+                    <a:bodyPr/>
+                    <a:lstStyle/>
+                    <a:p>
+                      <a:pPr algn="r"/>
+                      <a:r>
+                        <a:rPr sz="1000">
+                          <a:solidFill>
+                            <a:srgbClr val="3F3F3F"/>
+                          </a:solidFill>
+                          <a:latin typeface="Encode Sans"/>
+                        </a:rPr>
+                        <a:t>21.359K</a:t>
+                      </a:r>
+                    </a:p>
+                  </a:txBody>
+                  <a:tcPr marL="36576" marR="36576" marT="18288" marB="18288">
+                    <a:solidFill>
+                      <a:srgbClr val="FFFFFF"/>
+                    </a:solidFill>
+                  </a:tcPr>
+                </a:tc>
+                <a:tc>
+                  <a:txBody>
+                    <a:bodyPr/>
+                    <a:lstStyle/>
+                    <a:p>
+                      <a:pPr algn="r"/>
+                      <a:r>
+                        <a:rPr sz="1000">
+                          <a:solidFill>
+                            <a:srgbClr val="3F3F3F"/>
+                          </a:solidFill>
+                          <a:latin typeface="Encode Sans"/>
+                        </a:rPr>
+                        <a:t>—</a:t>
+                      </a:r>
+                    </a:p>
+                  </a:txBody>
+                  <a:tcPr marL="36576" marR="36576" marT="18288" marB="18288">
+                    <a:solidFill>
+                      <a:srgbClr val="FFFFFF"/>
+                    </a:solidFill>
+                  </a:tcPr>
+                </a:tc>
+                <a:tc>
+                  <a:txBody>
+                    <a:bodyPr/>
+                    <a:lstStyle/>
+                    <a:p>
+                      <a:pPr algn="r"/>
+                      <a:r>
+                        <a:rPr sz="1000">
+                          <a:solidFill>
+                            <a:srgbClr val="3F3F3F"/>
+                          </a:solidFill>
+                          <a:latin typeface="Encode Sans"/>
+                        </a:rPr>
+                        <a:t>—</a:t>
+                      </a:r>
+                    </a:p>
+                  </a:txBody>
+                  <a:tcPr marL="36576" marR="36576" marT="18288" marB="18288">
+                    <a:solidFill>
+                      <a:srgbClr val="FFFFFF"/>
+                    </a:solidFill>
+                  </a:tcPr>
+                </a:tc>
+              </a:tr>
+              <a:tr h="292608">
+                <a:tc>
+                  <a:txBody>
+                    <a:bodyPr/>
+                    <a:lstStyle/>
+                    <a:p>
+                      <a:pPr algn="l"/>
+                      <a:r>
+                        <a:rPr sz="1000">
+                          <a:solidFill>
+                            <a:srgbClr val="3F3F3F"/>
+                          </a:solidFill>
+                          <a:latin typeface="Encode Sans"/>
+                        </a:rPr>
+                        <a:t>Agosto 2026</a:t>
+                      </a:r>
+                    </a:p>
+                  </a:txBody>
+                  <a:tcPr marL="36576" marR="36576" marT="18288" marB="18288">
+                    <a:solidFill>
+                      <a:srgbClr val="F8F8F6"/>
+                    </a:solidFill>
+                  </a:tcPr>
+                </a:tc>
+                <a:tc>
+                  <a:txBody>
+                    <a:bodyPr/>
+                    <a:lstStyle/>
+                    <a:p>
+                      <a:pPr algn="r"/>
+                      <a:r>
+                        <a:rPr sz="1000">
+                          <a:solidFill>
+                            <a:srgbClr val="3F3F3F"/>
+                          </a:solidFill>
+                          <a:latin typeface="Encode Sans"/>
+                        </a:rPr>
+                        <a:t>20.509K</a:t>
+                      </a:r>
+                    </a:p>
+                  </a:txBody>
+                  <a:tcPr marL="36576" marR="36576" marT="18288" marB="18288">
+                    <a:solidFill>
+                      <a:srgbClr val="F8F8F6"/>
+                    </a:solidFill>
+                  </a:tcPr>
+                </a:tc>
+                <a:tc>
+                  <a:txBody>
+                    <a:bodyPr/>
+                    <a:lstStyle/>
+                    <a:p>
+                      <a:pPr algn="r"/>
+                      <a:r>
+                        <a:rPr sz="1000">
+                          <a:solidFill>
+                            <a:srgbClr val="3F3F3F"/>
+                          </a:solidFill>
+                          <a:latin typeface="Encode Sans"/>
+                        </a:rPr>
+                        <a:t>—</a:t>
+                      </a:r>
+                    </a:p>
+                  </a:txBody>
+                  <a:tcPr marL="36576" marR="36576" marT="18288" marB="18288">
+                    <a:solidFill>
+                      <a:srgbClr val="F8F8F6"/>
+                    </a:solidFill>
+                  </a:tcPr>
+                </a:tc>
+                <a:tc>
+                  <a:txBody>
+                    <a:bodyPr/>
+                    <a:lstStyle/>
+                    <a:p>
+                      <a:pPr algn="r"/>
+                      <a:r>
+                        <a:rPr sz="1000">
+                          <a:solidFill>
+                            <a:srgbClr val="3F3F3F"/>
+                          </a:solidFill>
+                          <a:latin typeface="Encode Sans"/>
+                        </a:rPr>
+                        <a:t>—</a:t>
+                      </a:r>
+                    </a:p>
+                  </a:txBody>
+                  <a:tcPr marL="36576" marR="36576" marT="18288" marB="18288">
+                    <a:solidFill>
+                      <a:srgbClr val="F8F8F6"/>
+                    </a:solidFill>
+                  </a:tcPr>
+                </a:tc>
+              </a:tr>
+              <a:tr h="292608">
+                <a:tc>
+                  <a:txBody>
+                    <a:bodyPr/>
+                    <a:lstStyle/>
+                    <a:p>
+                      <a:pPr algn="l"/>
+                      <a:r>
+                        <a:rPr sz="1000">
+                          <a:solidFill>
+                            <a:srgbClr val="3F3F3F"/>
+                          </a:solidFill>
+                          <a:latin typeface="Encode Sans"/>
+                        </a:rPr>
+                        <a:t>Julio 2026</a:t>
+                      </a:r>
+                    </a:p>
+                  </a:txBody>
+                  <a:tcPr marL="36576" marR="36576" marT="18288" marB="18288">
+                    <a:solidFill>
+                      <a:srgbClr val="FFFFFF"/>
+                    </a:solidFill>
+                  </a:tcPr>
+                </a:tc>
+                <a:tc>
+                  <a:txBody>
+                    <a:bodyPr/>
+                    <a:lstStyle/>
+                    <a:p>
+                      <a:pPr algn="r"/>
+                      <a:r>
+                        <a:rPr sz="1000">
+                          <a:solidFill>
+                            <a:srgbClr val="3F3F3F"/>
+                          </a:solidFill>
+                          <a:latin typeface="Encode Sans"/>
+                        </a:rPr>
+                        <a:t>22.965K</a:t>
+                      </a:r>
+                    </a:p>
+                  </a:txBody>
+                  <a:tcPr marL="36576" marR="36576" marT="18288" marB="18288">
+                    <a:solidFill>
+                      <a:srgbClr val="FFFFFF"/>
+                    </a:solidFill>
+                  </a:tcPr>
+                </a:tc>
+                <a:tc>
+                  <a:txBody>
+                    <a:bodyPr/>
+                    <a:lstStyle/>
+                    <a:p>
+                      <a:pPr algn="r"/>
+                      <a:r>
+                        <a:rPr sz="1000">
+                          <a:solidFill>
+                            <a:srgbClr val="3F3F3F"/>
+                          </a:solidFill>
+                          <a:latin typeface="Encode Sans"/>
+                        </a:rPr>
+                        <a:t>—</a:t>
+                      </a:r>
+                    </a:p>
+                  </a:txBody>
+                  <a:tcPr marL="36576" marR="36576" marT="18288" marB="18288">
+                    <a:solidFill>
+                      <a:srgbClr val="FFFFFF"/>
+                    </a:solidFill>
+                  </a:tcPr>
+                </a:tc>
+                <a:tc>
+                  <a:txBody>
+                    <a:bodyPr/>
+                    <a:lstStyle/>
+                    <a:p>
+                      <a:pPr algn="r"/>
+                      <a:r>
+                        <a:rPr sz="1000">
+                          <a:solidFill>
+                            <a:srgbClr val="3F3F3F"/>
+                          </a:solidFill>
+                          <a:latin typeface="Encode Sans"/>
+                        </a:rPr>
+                        <a:t>—</a:t>
+                      </a:r>
+                    </a:p>
+                  </a:txBody>
+                  <a:tcPr marL="36576" marR="36576" marT="18288" marB="18288">
+                    <a:solidFill>
+                      <a:srgbClr val="FFFFFF"/>
+                    </a:solidFill>
+                  </a:tcPr>
+                </a:tc>
+              </a:tr>
+              <a:tr h="292608">
+                <a:tc>
+                  <a:txBody>
+                    <a:bodyPr/>
+                    <a:lstStyle/>
+                    <a:p>
+                      <a:pPr algn="l"/>
+                      <a:r>
+                        <a:rPr sz="1000">
+                          <a:solidFill>
+                            <a:srgbClr val="3F3F3F"/>
+                          </a:solidFill>
+                          <a:latin typeface="Encode Sans"/>
+                        </a:rPr>
+                        <a:t>Junio 2026</a:t>
+                      </a:r>
+                    </a:p>
+                  </a:txBody>
+                  <a:tcPr marL="36576" marR="36576" marT="18288" marB="18288">
+                    <a:solidFill>
+                      <a:srgbClr val="F8F8F6"/>
+                    </a:solidFill>
+                  </a:tcPr>
+                </a:tc>
+                <a:tc>
+                  <a:txBody>
+                    <a:bodyPr/>
+                    <a:lstStyle/>
+                    <a:p>
+                      <a:pPr algn="r"/>
+                      <a:r>
+                        <a:rPr sz="1000">
+                          <a:solidFill>
+                            <a:srgbClr val="3F3F3F"/>
+                          </a:solidFill>
+                          <a:latin typeface="Encode Sans"/>
+                        </a:rPr>
+                        <a:t>20.017K</a:t>
+                      </a:r>
+                    </a:p>
+                  </a:txBody>
+                  <a:tcPr marL="36576" marR="36576" marT="18288" marB="18288">
+                    <a:solidFill>
+                      <a:srgbClr val="F8F8F6"/>
+                    </a:solidFill>
+                  </a:tcPr>
+                </a:tc>
+                <a:tc>
+                  <a:txBody>
+                    <a:bodyPr/>
+                    <a:lstStyle/>
+                    <a:p>
+                      <a:pPr algn="r"/>
+                      <a:r>
+                        <a:rPr sz="1000">
+                          <a:solidFill>
+                            <a:srgbClr val="3F3F3F"/>
+                          </a:solidFill>
+                          <a:latin typeface="Encode Sans"/>
+                        </a:rPr>
+                        <a:t>—</a:t>
+                      </a:r>
+                    </a:p>
+                  </a:txBody>
+                  <a:tcPr marL="36576" marR="36576" marT="18288" marB="18288">
+                    <a:solidFill>
+                      <a:srgbClr val="F8F8F6"/>
+                    </a:solidFill>
+                  </a:tcPr>
+                </a:tc>
+                <a:tc>
+                  <a:txBody>
+                    <a:bodyPr/>
+                    <a:lstStyle/>
+                    <a:p>
+                      <a:pPr algn="r"/>
+                      <a:r>
+                        <a:rPr sz="1000">
+                          <a:solidFill>
+                            <a:srgbClr val="3F3F3F"/>
+                          </a:solidFill>
+                          <a:latin typeface="Encode Sans"/>
+                        </a:rPr>
+                        <a:t>—</a:t>
+                      </a:r>
+                    </a:p>
+                  </a:txBody>
+                  <a:tcPr marL="36576" marR="36576" marT="18288" marB="18288">
+                    <a:solidFill>
+                      <a:srgbClr val="F8F8F6"/>
+                    </a:solidFill>
+                  </a:tcPr>
+                </a:tc>
+              </a:tr>
+              <a:tr h="292608">
+                <a:tc>
+                  <a:txBody>
+                    <a:bodyPr/>
+                    <a:lstStyle/>
+                    <a:p>
+                      <a:pPr algn="l"/>
+                      <a:r>
+                        <a:rPr sz="1000">
+                          <a:solidFill>
+                            <a:srgbClr val="3F3F3F"/>
+                          </a:solidFill>
+                          <a:latin typeface="Encode Sans"/>
+                        </a:rPr>
+                        <a:t>Mayo 2026</a:t>
+                      </a:r>
+                    </a:p>
+                  </a:txBody>
+                  <a:tcPr marL="36576" marR="36576" marT="18288" marB="18288">
+                    <a:solidFill>
+                      <a:srgbClr val="FFFFFF"/>
+                    </a:solidFill>
+                  </a:tcPr>
+                </a:tc>
+                <a:tc>
+                  <a:txBody>
+                    <a:bodyPr/>
+                    <a:lstStyle/>
+                    <a:p>
+                      <a:pPr algn="r"/>
+                      <a:r>
+                        <a:rPr sz="1000">
+                          <a:solidFill>
+                            <a:srgbClr val="3F3F3F"/>
+                          </a:solidFill>
+                          <a:latin typeface="Encode Sans"/>
+                        </a:rPr>
+                        <a:t>21.514K</a:t>
+                      </a:r>
+                    </a:p>
+                  </a:txBody>
+                  <a:tcPr marL="36576" marR="36576" marT="18288" marB="18288">
+                    <a:solidFill>
+                      <a:srgbClr val="FFFFFF"/>
+                    </a:solidFill>
+                  </a:tcPr>
+                </a:tc>
+                <a:tc>
+                  <a:txBody>
+                    <a:bodyPr/>
+                    <a:lstStyle/>
+                    <a:p>
+                      <a:pPr algn="r"/>
+                      <a:r>
+                        <a:rPr sz="1000">
+                          <a:solidFill>
+                            <a:srgbClr val="3F3F3F"/>
+                          </a:solidFill>
+                          <a:latin typeface="Encode Sans"/>
+                        </a:rPr>
+                        <a:t>—</a:t>
+                      </a:r>
+                    </a:p>
+                  </a:txBody>
+                  <a:tcPr marL="36576" marR="36576" marT="18288" marB="18288">
+                    <a:solidFill>
+                      <a:srgbClr val="FFFFFF"/>
+                    </a:solidFill>
+                  </a:tcPr>
+                </a:tc>
+                <a:tc>
+                  <a:txBody>
+                    <a:bodyPr/>
+                    <a:lstStyle/>
+                    <a:p>
+                      <a:pPr algn="r"/>
+                      <a:r>
+                        <a:rPr sz="1000">
+                          <a:solidFill>
+                            <a:srgbClr val="3F3F3F"/>
+                          </a:solidFill>
+                          <a:latin typeface="Encode Sans"/>
+                        </a:rPr>
+                        <a:t>—</a:t>
+                      </a:r>
+                    </a:p>
+                  </a:txBody>
+                  <a:tcPr marL="36576" marR="36576" marT="18288" marB="18288">
+                    <a:solidFill>
+                      <a:srgbClr val="FFFFFF"/>
+                    </a:solidFill>
+                  </a:tcPr>
+                </a:tc>
+              </a:tr>
+              <a:tr h="292608">
+                <a:tc>
+                  <a:txBody>
+                    <a:bodyPr/>
+                    <a:lstStyle/>
+                    <a:p>
+                      <a:pPr algn="l"/>
+                      <a:r>
+                        <a:rPr sz="1000">
+                          <a:solidFill>
+                            <a:srgbClr val="3F3F3F"/>
+                          </a:solidFill>
+                          <a:latin typeface="Encode Sans"/>
+                        </a:rPr>
+                        <a:t>Abril 2026</a:t>
+                      </a:r>
+                    </a:p>
+                  </a:txBody>
+                  <a:tcPr marL="36576" marR="36576" marT="18288" marB="18288">
+                    <a:solidFill>
+                      <a:srgbClr val="F8F8F6"/>
+                    </a:solidFill>
+                  </a:tcPr>
+                </a:tc>
+                <a:tc>
+                  <a:txBody>
+                    <a:bodyPr/>
+                    <a:lstStyle/>
+                    <a:p>
+                      <a:pPr algn="r"/>
+                      <a:r>
+                        <a:rPr sz="1000">
+                          <a:solidFill>
+                            <a:srgbClr val="3F3F3F"/>
+                          </a:solidFill>
+                          <a:latin typeface="Encode Sans"/>
+                        </a:rPr>
+                        <a:t>17.401K</a:t>
+                      </a:r>
+                    </a:p>
+                  </a:txBody>
+                  <a:tcPr marL="36576" marR="36576" marT="18288" marB="18288">
+                    <a:solidFill>
+                      <a:srgbClr val="F8F8F6"/>
+                    </a:solidFill>
+                  </a:tcPr>
+                </a:tc>
+                <a:tc>
+                  <a:txBody>
+                    <a:bodyPr/>
+                    <a:lstStyle/>
+                    <a:p>
+                      <a:pPr algn="r"/>
+                      <a:r>
+                        <a:rPr sz="1000">
+                          <a:solidFill>
+                            <a:srgbClr val="3F3F3F"/>
+                          </a:solidFill>
+                          <a:latin typeface="Encode Sans"/>
+                        </a:rPr>
+                        <a:t>—</a:t>
+                      </a:r>
+                    </a:p>
+                  </a:txBody>
+                  <a:tcPr marL="36576" marR="36576" marT="18288" marB="18288">
+                    <a:solidFill>
+                      <a:srgbClr val="F8F8F6"/>
+                    </a:solidFill>
+                  </a:tcPr>
+                </a:tc>
+                <a:tc>
+                  <a:txBody>
+                    <a:bodyPr/>
+                    <a:lstStyle/>
+                    <a:p>
+                      <a:pPr algn="r"/>
+                      <a:r>
+                        <a:rPr sz="1000">
+                          <a:solidFill>
+                            <a:srgbClr val="3F3F3F"/>
+                          </a:solidFill>
+                          <a:latin typeface="Encode Sans"/>
+                        </a:rPr>
+                        <a:t>—</a:t>
+                      </a:r>
+                    </a:p>
+                  </a:txBody>
+                  <a:tcPr marL="36576" marR="36576" marT="18288" marB="18288">
+                    <a:solidFill>
+                      <a:srgbClr val="F8F8F6"/>
+                    </a:solidFill>
+                  </a:tcPr>
+                </a:tc>
+              </a:tr>
+            </a:tbl>
+          </a:graphicData>
+        </a:graphic>
+      </p:graphicFrame>
+      <p:sp>
+        <p:nvSpPr>
+          <p:cNvPr id="9" name="TextBox 8"/>
+          <p:cNvSpPr txBox="1"/>
+          <p:nvPr/>
+        </p:nvSpPr>
+        <p:spPr>
+          <a:xfrm>
+            <a:off x="411480" y="6492240"/>
+            <a:ext cx="11368735" cy="274320"/>
+          </a:xfrm>
+          <a:prstGeom prst="rect">
+            <a:avLst/>
+          </a:prstGeom>
+          <a:noFill/>
+        </p:spPr>
+        <p:txBody>
+          <a:bodyPr wrap="none">
+            <a:spAutoFit/>
+          </a:bodyPr>
+          <a:lstStyle/>
+          <a:p>
+            <a:r>
+              <a:rPr sz="1000" b="0" i="1">
+                <a:solidFill>
+                  <a:srgbClr val="6A6760"/>
+                </a:solidFill>
+                <a:latin typeface="Encode Sans"/>
+              </a:rPr>
+              <a:t>Fuente: elaboración propia en base a AFIP/ARCA</a:t>
             </a:r>
           </a:p>
         </p:txBody>

</xml_diff>

<commit_message>
data: update 2026-10-07 ( data.json despidos.json scraper/historical_despidos.json publicaciones_semana.pptx rrii_brutas.xlsx)
</commit_message>
<xml_diff>
--- a/publicaciones_semana.pptx
+++ b/publicaciones_semana.pptx
@@ -3239,7 +3239,7 @@
                 </a:solidFill>
                 <a:latin typeface="Encode Sans"/>
               </a:rPr>
-              <a:t>Publicaciones de la semana del 28 de septiembre de 2026</a:t>
+              <a:t>Publicaciones de la semana del 05 de octubre de 2026</a:t>
             </a:r>
           </a:p>
         </p:txBody>
@@ -3369,7 +3369,7 @@
                 </a:solidFill>
                 <a:latin typeface="Encode Sans"/>
               </a:rPr>
-              <a:t>BALANZA DE PAGOS 2DO TRIMESTRE 2026</a:t>
+              <a:t>INDUSTRIA AGOSTO 2026: IPI CAYÓ -3.2% I.A.</a:t>
             </a:r>
           </a:p>
         </p:txBody>
@@ -3403,7 +3403,7 @@
                 </a:solidFill>
                 <a:latin typeface="Encode Sans"/>
               </a:rPr>
-              <a:t>INDEC · período 2do trimestre 2026</a:t>
+              <a:t>INDEC · período 2026-08</a:t>
             </a:r>
           </a:p>
         </p:txBody>
@@ -3438,7 +3438,7 @@
                 </a:solidFill>
                 <a:latin typeface="Encode Sans"/>
               </a:rPr>
-              <a:t>Se publicó la actualización de Balanza de pagos para 2do trimestre 2026. Fuente: INDEC.</a:t>
+              <a:t>El Índice de Producción Industrial Manufacturero (IPI) registró una variación interanual de -3.2% en agosto 2026.</a:t>
             </a:r>
           </a:p>
         </p:txBody>
@@ -3486,7 +3486,7 @@
                 </a:solidFill>
                 <a:latin typeface="Encode Sans"/>
               </a:rPr>
-              <a:t>cta_cte: 2.214,00</a:t>
+              <a:t>Variación interanual: -3.2%</a:t>
             </a:r>
           </a:p>
           <a:p>
@@ -3511,404 +3511,7 @@
                 </a:solidFill>
                 <a:latin typeface="Encode Sans"/>
               </a:rPr>
-              <a:t>bienes: 9.293,00</a:t>
-            </a:r>
-          </a:p>
-          <a:p>
-            <a:pPr algn="l">
-              <a:spcAft>
-                <a:spcPts val="800"/>
-              </a:spcAft>
-            </a:pPr>
-            <a:r>
-              <a:rPr sz="1300" b="1" i="0">
-                <a:solidFill>
-                  <a:srgbClr val="00B2C9"/>
-                </a:solidFill>
-                <a:latin typeface="Encode Sans"/>
-              </a:rPr>
-              <a:t>●  </a:t>
-            </a:r>
-            <a:r>
-              <a:rPr sz="1300" b="0" i="0">
-                <a:solidFill>
-                  <a:srgbClr val="3F3F3F"/>
-                </a:solidFill>
-                <a:latin typeface="Encode Sans"/>
-              </a:rPr>
-              <a:t>servicios: -2.102,00</a:t>
-            </a:r>
-          </a:p>
-          <a:p>
-            <a:pPr algn="l">
-              <a:spcAft>
-                <a:spcPts val="800"/>
-              </a:spcAft>
-            </a:pPr>
-            <a:r>
-              <a:rPr sz="1300" b="1" i="0">
-                <a:solidFill>
-                  <a:srgbClr val="00B2C9"/>
-                </a:solidFill>
-                <a:latin typeface="Encode Sans"/>
-              </a:rPr>
-              <a:t>●  </a:t>
-            </a:r>
-            <a:r>
-              <a:rPr sz="1300" b="0" i="0">
-                <a:solidFill>
-                  <a:srgbClr val="3F3F3F"/>
-                </a:solidFill>
-                <a:latin typeface="Encode Sans"/>
-              </a:rPr>
-              <a:t>ing_prim: -6.032,00</a:t>
-            </a:r>
-          </a:p>
-          <a:p>
-            <a:pPr algn="l">
-              <a:spcAft>
-                <a:spcPts val="800"/>
-              </a:spcAft>
-            </a:pPr>
-            <a:r>
-              <a:rPr sz="1300" b="1" i="0">
-                <a:solidFill>
-                  <a:srgbClr val="00B2C9"/>
-                </a:solidFill>
-                <a:latin typeface="Encode Sans"/>
-              </a:rPr>
-              <a:t>●  </a:t>
-            </a:r>
-            <a:r>
-              <a:rPr sz="1300" b="0" i="0">
-                <a:solidFill>
-                  <a:srgbClr val="3F3F3F"/>
-                </a:solidFill>
-                <a:latin typeface="Encode Sans"/>
-              </a:rPr>
-              <a:t>ing_sec: 1.055,00</a:t>
-            </a:r>
-          </a:p>
-        </p:txBody>
-      </p:sp>
-      <p:sp>
-        <p:nvSpPr>
-          <p:cNvPr id="7" name="TextBox 6"/>
-          <p:cNvSpPr txBox="1"/>
-          <p:nvPr/>
-        </p:nvSpPr>
-        <p:spPr>
-          <a:xfrm>
-            <a:off x="411480" y="6492240"/>
-            <a:ext cx="11368735" cy="274320"/>
-          </a:xfrm>
-          <a:prstGeom prst="rect">
-            <a:avLst/>
-          </a:prstGeom>
-          <a:noFill/>
-        </p:spPr>
-        <p:txBody>
-          <a:bodyPr wrap="none">
-            <a:spAutoFit/>
-          </a:bodyPr>
-          <a:lstStyle/>
-          <a:p>
-            <a:r>
-              <a:rPr sz="1000" b="0" i="1">
-                <a:solidFill>
-                  <a:srgbClr val="6A6760"/>
-                </a:solidFill>
-                <a:latin typeface="Encode Sans"/>
-              </a:rPr>
-              <a:t>Fuente: elaboración propia en base a INDEC</a:t>
-            </a:r>
-          </a:p>
-        </p:txBody>
-      </p:sp>
-    </p:spTree>
-  </p:cSld>
-  <p:clrMapOvr>
-    <a:masterClrMapping/>
-  </p:clrMapOvr>
-</p:sld>
-</file>
-
-<file path=ppt/slides/slide3.xml><?xml version="1.0" encoding="utf-8"?>
-<p:sld xmlns:a="http://schemas.openxmlformats.org/drawingml/2006/main" xmlns:p="http://schemas.openxmlformats.org/presentationml/2006/main" xmlns:r="http://schemas.openxmlformats.org/officeDocument/2006/relationships">
-  <p:cSld>
-    <p:spTree>
-      <p:nvGrpSpPr>
-        <p:cNvPr id="1" name=""/>
-        <p:cNvGrpSpPr/>
-        <p:nvPr/>
-      </p:nvGrpSpPr>
-      <p:grpSpPr/>
-      <p:sp>
-        <p:nvSpPr>
-          <p:cNvPr id="2" name="Rectangle 1"/>
-          <p:cNvSpPr/>
-          <p:nvPr/>
-        </p:nvSpPr>
-        <p:spPr>
-          <a:xfrm>
-            <a:off x="0" y="0"/>
-            <a:ext cx="12191695" cy="274320"/>
-          </a:xfrm>
-          <a:prstGeom prst="rect">
-            <a:avLst/>
-          </a:prstGeom>
-          <a:solidFill>
-            <a:srgbClr val="00B2C9"/>
-          </a:solidFill>
-          <a:ln>
-            <a:noFill/>
-          </a:ln>
-        </p:spPr>
-        <p:style>
-          <a:lnRef idx="1">
-            <a:schemeClr val="accent1"/>
-          </a:lnRef>
-          <a:fillRef idx="3">
-            <a:schemeClr val="accent1"/>
-          </a:fillRef>
-          <a:effectRef idx="2">
-            <a:schemeClr val="accent1"/>
-          </a:effectRef>
-          <a:fontRef idx="minor">
-            <a:schemeClr val="lt1"/>
-          </a:fontRef>
-        </p:style>
-        <p:txBody>
-          <a:bodyPr rtlCol="0" anchor="ctr"/>
-          <a:lstStyle/>
-          <a:p>
-            <a:pPr algn="ctr"/>
-          </a:p>
-        </p:txBody>
-      </p:sp>
-      <p:sp>
-        <p:nvSpPr>
-          <p:cNvPr id="3" name="TextBox 2"/>
-          <p:cNvSpPr txBox="1"/>
-          <p:nvPr/>
-        </p:nvSpPr>
-        <p:spPr>
-          <a:xfrm>
-            <a:off x="411480" y="457200"/>
-            <a:ext cx="11368735" cy="914400"/>
-          </a:xfrm>
-          <a:prstGeom prst="rect">
-            <a:avLst/>
-          </a:prstGeom>
-          <a:noFill/>
-        </p:spPr>
-        <p:txBody>
-          <a:bodyPr wrap="square" lIns="0" rIns="0">
-            <a:spAutoFit/>
-          </a:bodyPr>
-          <a:lstStyle/>
-          <a:p>
-            <a:pPr algn="l"/>
-            <a:r>
-              <a:rPr sz="2600" b="1" i="0">
-                <a:solidFill>
-                  <a:srgbClr val="00B2C9"/>
-                </a:solidFill>
-                <a:latin typeface="Encode Sans"/>
-              </a:rPr>
-              <a:t>RECAUDACIÓN SEPTIEMBRE 2026: CRECIÓ +8.6% REAL I.A.</a:t>
-            </a:r>
-          </a:p>
-        </p:txBody>
-      </p:sp>
-      <p:sp>
-        <p:nvSpPr>
-          <p:cNvPr id="4" name="TextBox 3"/>
-          <p:cNvSpPr txBox="1"/>
-          <p:nvPr/>
-        </p:nvSpPr>
-        <p:spPr>
-          <a:xfrm>
-            <a:off x="411480" y="1280160"/>
-            <a:ext cx="11368735" cy="274320"/>
-          </a:xfrm>
-          <a:prstGeom prst="rect">
-            <a:avLst/>
-          </a:prstGeom>
-          <a:noFill/>
-        </p:spPr>
-        <p:txBody>
-          <a:bodyPr wrap="none">
-            <a:spAutoFit/>
-          </a:bodyPr>
-          <a:lstStyle/>
-          <a:p>
-            <a:r>
-              <a:rPr sz="1100" b="0" i="1">
-                <a:solidFill>
-                  <a:srgbClr val="6A6760"/>
-                </a:solidFill>
-                <a:latin typeface="Encode Sans"/>
-              </a:rPr>
-              <a:t>AFIP/ARCA · período 2026-09</a:t>
-            </a:r>
-          </a:p>
-        </p:txBody>
-      </p:sp>
-      <p:sp>
-        <p:nvSpPr>
-          <p:cNvPr id="5" name="TextBox 4"/>
-          <p:cNvSpPr txBox="1"/>
-          <p:nvPr/>
-        </p:nvSpPr>
-        <p:spPr>
-          <a:xfrm>
-            <a:off x="411480" y="1691640"/>
-            <a:ext cx="5486400" cy="1645920"/>
-          </a:xfrm>
-          <a:prstGeom prst="rect">
-            <a:avLst/>
-          </a:prstGeom>
-          <a:noFill/>
-        </p:spPr>
-        <p:txBody>
-          <a:bodyPr wrap="square" lIns="0" rIns="0">
-            <a:spAutoFit/>
-          </a:bodyPr>
-          <a:lstStyle/>
-          <a:p>
-            <a:pPr algn="just"/>
-            <a:r>
-              <a:rPr sz="1300" b="0" i="0">
-                <a:solidFill>
-                  <a:srgbClr val="3F3F3F"/>
-                </a:solidFill>
-                <a:latin typeface="Encode Sans"/>
-              </a:rPr>
-              <a:t>AFIP/ARCA recaudó $21.359K millones en septiembre 2026. Variación nominal interanual: +38.3%. En términos reales (deflactado por REM): +8.6% i.a. Quiebre de tendencia: venía con 6 meses de caída real interanual.</a:t>
-            </a:r>
-          </a:p>
-        </p:txBody>
-      </p:sp>
-      <p:sp>
-        <p:nvSpPr>
-          <p:cNvPr id="6" name="TextBox 5"/>
-          <p:cNvSpPr txBox="1"/>
-          <p:nvPr/>
-        </p:nvSpPr>
-        <p:spPr>
-          <a:xfrm>
-            <a:off x="411480" y="3520440"/>
-            <a:ext cx="5486400" cy="2743200"/>
-          </a:xfrm>
-          <a:prstGeom prst="rect">
-            <a:avLst/>
-          </a:prstGeom>
-          <a:noFill/>
-        </p:spPr>
-        <p:txBody>
-          <a:bodyPr wrap="square" lIns="0" rIns="0">
-            <a:spAutoFit/>
-          </a:bodyPr>
-          <a:lstStyle/>
-          <a:p>
-            <a:pPr algn="l">
-              <a:spcAft>
-                <a:spcPts val="800"/>
-              </a:spcAft>
-            </a:pPr>
-            <a:r>
-              <a:rPr sz="1300" b="1" i="0">
-                <a:solidFill>
-                  <a:srgbClr val="00B2C9"/>
-                </a:solidFill>
-                <a:latin typeface="Encode Sans"/>
-              </a:rPr>
-              <a:t>●  </a:t>
-            </a:r>
-            <a:r>
-              <a:rPr sz="1300" b="0" i="0">
-                <a:solidFill>
-                  <a:srgbClr val="3F3F3F"/>
-                </a:solidFill>
-                <a:latin typeface="Encode Sans"/>
-              </a:rPr>
-              <a:t>Total: $21.359K M$</a:t>
-            </a:r>
-          </a:p>
-          <a:p>
-            <a:pPr algn="l">
-              <a:spcAft>
-                <a:spcPts val="800"/>
-              </a:spcAft>
-            </a:pPr>
-            <a:r>
-              <a:rPr sz="1300" b="1" i="0">
-                <a:solidFill>
-                  <a:srgbClr val="00B2C9"/>
-                </a:solidFill>
-                <a:latin typeface="Encode Sans"/>
-              </a:rPr>
-              <a:t>●  </a:t>
-            </a:r>
-            <a:r>
-              <a:rPr sz="1300" b="0" i="0">
-                <a:solidFill>
-                  <a:srgbClr val="3F3F3F"/>
-                </a:solidFill>
-                <a:latin typeface="Encode Sans"/>
-              </a:rPr>
-              <a:t>Variación nominal i.a.: +38.3%</a:t>
-            </a:r>
-          </a:p>
-          <a:p>
-            <a:pPr algn="l">
-              <a:spcAft>
-                <a:spcPts val="800"/>
-              </a:spcAft>
-            </a:pPr>
-            <a:r>
-              <a:rPr sz="1300" b="1" i="0">
-                <a:solidFill>
-                  <a:srgbClr val="00B2C9"/>
-                </a:solidFill>
-                <a:latin typeface="Encode Sans"/>
-              </a:rPr>
-              <a:t>●  </a:t>
-            </a:r>
-            <a:r>
-              <a:rPr sz="1300" b="0" i="0">
-                <a:solidFill>
-                  <a:srgbClr val="3F3F3F"/>
-                </a:solidFill>
-                <a:latin typeface="Encode Sans"/>
-              </a:rPr>
-              <a:t>Variación real i.a.: +8.6% (deflactor: REM)</a:t>
-            </a:r>
-          </a:p>
-          <a:p>
-            <a:pPr algn="l">
-              <a:spcAft>
-                <a:spcPts val="800"/>
-              </a:spcAft>
-            </a:pPr>
-            <a:r>
-              <a:rPr sz="1300" b="1" i="0">
-                <a:solidFill>
-                  <a:srgbClr val="00B2C9"/>
-                </a:solidFill>
-                <a:latin typeface="Encode Sans"/>
-              </a:rPr>
-              <a:t>●  </a:t>
-            </a:r>
-            <a:r>
-              <a:rPr sz="1300" b="0" i="0">
-                <a:solidFill>
-                  <a:srgbClr val="3F3F3F"/>
-                </a:solidFill>
-                <a:latin typeface="Encode Sans"/>
-              </a:rPr>
-              <a:t>Fuente: ARCA (ex AFIP) · indec.gob.ar series</a:t>
+              <a:t>Serie INDEC, base 2004=100. Mide la producción manufacturera (16 ramas).</a:t>
             </a:r>
           </a:p>
         </p:txBody>
@@ -3956,10 +3559,9 @@
                 <a:tableStyleId>{5C22544A-7EE6-4342-B048-85BDC9FD1C3A}</a:tableStyleId>
               </a:tblPr>
               <a:tblGrid>
-                <a:gridCol w="1417320"/>
-                <a:gridCol w="1417320"/>
-                <a:gridCol w="1417320"/>
-                <a:gridCol w="1417320"/>
+                <a:gridCol w="1889760"/>
+                <a:gridCol w="1889760"/>
+                <a:gridCol w="1889760"/>
               </a:tblGrid>
               <a:tr h="292608">
                 <a:tc>
@@ -3998,7 +3600,7 @@
                           </a:solidFill>
                           <a:latin typeface="Encode Sans"/>
                         </a:rPr>
-                        <a:t>Total M$</a:t>
+                        <a:t>Original</a:t>
                       </a:r>
                     </a:p>
                   </a:txBody>
@@ -4021,30 +3623,7 @@
                           </a:solidFill>
                           <a:latin typeface="Encode Sans"/>
                         </a:rPr>
-                        <a:t>Var. nom. i.a.</a:t>
-                      </a:r>
-                    </a:p>
-                  </a:txBody>
-                  <a:tcPr marL="36576" marR="36576" marT="18288" marB="18288">
-                    <a:solidFill>
-                      <a:srgbClr val="00B2C9"/>
-                    </a:solidFill>
-                  </a:tcPr>
-                </a:tc>
-                <a:tc>
-                  <a:txBody>
-                    <a:bodyPr/>
-                    <a:lstStyle/>
-                    <a:p>
-                      <a:pPr algn="r"/>
-                      <a:r>
-                        <a:rPr sz="1000" b="1">
-                          <a:solidFill>
-                            <a:srgbClr val="FFFFFF"/>
-                          </a:solidFill>
-                          <a:latin typeface="Encode Sans"/>
-                        </a:rPr>
-                        <a:t>Var. real i.a.</a:t>
+                        <a:t>VIA %</a:t>
                       </a:r>
                     </a:p>
                   </a:txBody>
@@ -4069,7 +3648,7 @@
                           </a:solidFill>
                           <a:latin typeface="Encode Sans"/>
                         </a:rPr>
-                        <a:t>Septiembre 2026</a:t>
+                        <a:t>Agosto 2026</a:t>
                       </a:r>
                     </a:p>
                   </a:txBody>
@@ -4092,7 +3671,7 @@
                           </a:solidFill>
                           <a:latin typeface="Encode Sans"/>
                         </a:rPr>
-                        <a:t>21.359K</a:t>
+                        <a:t>119,3</a:t>
                       </a:r>
                     </a:p>
                   </a:txBody>
@@ -4115,30 +3694,7 @@
                           </a:solidFill>
                           <a:latin typeface="Encode Sans"/>
                         </a:rPr>
-                        <a:t>—</a:t>
-                      </a:r>
-                    </a:p>
-                  </a:txBody>
-                  <a:tcPr marL="36576" marR="36576" marT="18288" marB="18288">
-                    <a:solidFill>
-                      <a:srgbClr val="FFFFFF"/>
-                    </a:solidFill>
-                  </a:tcPr>
-                </a:tc>
-                <a:tc>
-                  <a:txBody>
-                    <a:bodyPr/>
-                    <a:lstStyle/>
-                    <a:p>
-                      <a:pPr algn="r"/>
-                      <a:r>
-                        <a:rPr sz="1000">
-                          <a:solidFill>
-                            <a:srgbClr val="3F3F3F"/>
-                          </a:solidFill>
-                          <a:latin typeface="Encode Sans"/>
-                        </a:rPr>
-                        <a:t>—</a:t>
+                        <a:t>-3.2%</a:t>
                       </a:r>
                     </a:p>
                   </a:txBody>
@@ -4163,7 +3719,7 @@
                           </a:solidFill>
                           <a:latin typeface="Encode Sans"/>
                         </a:rPr>
-                        <a:t>Agosto 2026</a:t>
+                        <a:t>Julio 2026</a:t>
                       </a:r>
                     </a:p>
                   </a:txBody>
@@ -4186,7 +3742,7 @@
                           </a:solidFill>
                           <a:latin typeface="Encode Sans"/>
                         </a:rPr>
-                        <a:t>20.509K</a:t>
+                        <a:t>118,1</a:t>
                       </a:r>
                     </a:p>
                   </a:txBody>
@@ -4209,30 +3765,7 @@
                           </a:solidFill>
                           <a:latin typeface="Encode Sans"/>
                         </a:rPr>
-                        <a:t>—</a:t>
-                      </a:r>
-                    </a:p>
-                  </a:txBody>
-                  <a:tcPr marL="36576" marR="36576" marT="18288" marB="18288">
-                    <a:solidFill>
-                      <a:srgbClr val="F8F8F6"/>
-                    </a:solidFill>
-                  </a:tcPr>
-                </a:tc>
-                <a:tc>
-                  <a:txBody>
-                    <a:bodyPr/>
-                    <a:lstStyle/>
-                    <a:p>
-                      <a:pPr algn="r"/>
-                      <a:r>
-                        <a:rPr sz="1000">
-                          <a:solidFill>
-                            <a:srgbClr val="3F3F3F"/>
-                          </a:solidFill>
-                          <a:latin typeface="Encode Sans"/>
-                        </a:rPr>
-                        <a:t>—</a:t>
+                        <a:t>-4.9%</a:t>
                       </a:r>
                     </a:p>
                   </a:txBody>
@@ -4257,7 +3790,7 @@
                           </a:solidFill>
                           <a:latin typeface="Encode Sans"/>
                         </a:rPr>
-                        <a:t>Julio 2026</a:t>
+                        <a:t>Junio 2026</a:t>
                       </a:r>
                     </a:p>
                   </a:txBody>
@@ -4280,7 +3813,7 @@
                           </a:solidFill>
                           <a:latin typeface="Encode Sans"/>
                         </a:rPr>
-                        <a:t>22.965K</a:t>
+                        <a:t>119,8</a:t>
                       </a:r>
                     </a:p>
                   </a:txBody>
@@ -4303,30 +3836,7 @@
                           </a:solidFill>
                           <a:latin typeface="Encode Sans"/>
                         </a:rPr>
-                        <a:t>—</a:t>
-                      </a:r>
-                    </a:p>
-                  </a:txBody>
-                  <a:tcPr marL="36576" marR="36576" marT="18288" marB="18288">
-                    <a:solidFill>
-                      <a:srgbClr val="FFFFFF"/>
-                    </a:solidFill>
-                  </a:tcPr>
-                </a:tc>
-                <a:tc>
-                  <a:txBody>
-                    <a:bodyPr/>
-                    <a:lstStyle/>
-                    <a:p>
-                      <a:pPr algn="r"/>
-                      <a:r>
-                        <a:rPr sz="1000">
-                          <a:solidFill>
-                            <a:srgbClr val="3F3F3F"/>
-                          </a:solidFill>
-                          <a:latin typeface="Encode Sans"/>
-                        </a:rPr>
-                        <a:t>—</a:t>
+                        <a:t>+2.0%</a:t>
                       </a:r>
                     </a:p>
                   </a:txBody>
@@ -4351,7 +3861,7 @@
                           </a:solidFill>
                           <a:latin typeface="Encode Sans"/>
                         </a:rPr>
-                        <a:t>Junio 2026</a:t>
+                        <a:t>Mayo 2026</a:t>
                       </a:r>
                     </a:p>
                   </a:txBody>
@@ -4374,7 +3884,7 @@
                           </a:solidFill>
                           <a:latin typeface="Encode Sans"/>
                         </a:rPr>
-                        <a:t>20.017K</a:t>
+                        <a:t>116,9</a:t>
                       </a:r>
                     </a:p>
                   </a:txBody>
@@ -4397,30 +3907,7 @@
                           </a:solidFill>
                           <a:latin typeface="Encode Sans"/>
                         </a:rPr>
-                        <a:t>—</a:t>
-                      </a:r>
-                    </a:p>
-                  </a:txBody>
-                  <a:tcPr marL="36576" marR="36576" marT="18288" marB="18288">
-                    <a:solidFill>
-                      <a:srgbClr val="F8F8F6"/>
-                    </a:solidFill>
-                  </a:tcPr>
-                </a:tc>
-                <a:tc>
-                  <a:txBody>
-                    <a:bodyPr/>
-                    <a:lstStyle/>
-                    <a:p>
-                      <a:pPr algn="r"/>
-                      <a:r>
-                        <a:rPr sz="1000">
-                          <a:solidFill>
-                            <a:srgbClr val="3F3F3F"/>
-                          </a:solidFill>
-                          <a:latin typeface="Encode Sans"/>
-                        </a:rPr>
-                        <a:t>—</a:t>
+                        <a:t>-5.7%</a:t>
                       </a:r>
                     </a:p>
                   </a:txBody>
@@ -4445,7 +3932,7 @@
                           </a:solidFill>
                           <a:latin typeface="Encode Sans"/>
                         </a:rPr>
-                        <a:t>Mayo 2026</a:t>
+                        <a:t>Abril 2026</a:t>
                       </a:r>
                     </a:p>
                   </a:txBody>
@@ -4468,7 +3955,7 @@
                           </a:solidFill>
                           <a:latin typeface="Encode Sans"/>
                         </a:rPr>
-                        <a:t>21.514K</a:t>
+                        <a:t>118,5</a:t>
                       </a:r>
                     </a:p>
                   </a:txBody>
@@ -4491,30 +3978,7 @@
                           </a:solidFill>
                           <a:latin typeface="Encode Sans"/>
                         </a:rPr>
-                        <a:t>—</a:t>
-                      </a:r>
-                    </a:p>
-                  </a:txBody>
-                  <a:tcPr marL="36576" marR="36576" marT="18288" marB="18288">
-                    <a:solidFill>
-                      <a:srgbClr val="FFFFFF"/>
-                    </a:solidFill>
-                  </a:tcPr>
-                </a:tc>
-                <a:tc>
-                  <a:txBody>
-                    <a:bodyPr/>
-                    <a:lstStyle/>
-                    <a:p>
-                      <a:pPr algn="r"/>
-                      <a:r>
-                        <a:rPr sz="1000">
-                          <a:solidFill>
-                            <a:srgbClr val="3F3F3F"/>
-                          </a:solidFill>
-                          <a:latin typeface="Encode Sans"/>
-                        </a:rPr>
-                        <a:t>—</a:t>
+                        <a:t>-2.4%</a:t>
                       </a:r>
                     </a:p>
                   </a:txBody>
@@ -4539,7 +4003,7 @@
                           </a:solidFill>
                           <a:latin typeface="Encode Sans"/>
                         </a:rPr>
-                        <a:t>Abril 2026</a:t>
+                        <a:t>Marzo 2026</a:t>
                       </a:r>
                     </a:p>
                   </a:txBody>
@@ -4562,7 +4026,7 @@
                           </a:solidFill>
                           <a:latin typeface="Encode Sans"/>
                         </a:rPr>
-                        <a:t>17.401K</a:t>
+                        <a:t>122,1</a:t>
                       </a:r>
                     </a:p>
                   </a:txBody>
@@ -4585,7 +4049,497 @@
                           </a:solidFill>
                           <a:latin typeface="Encode Sans"/>
                         </a:rPr>
-                        <a:t>—</a:t>
+                        <a:t>+5.0%</a:t>
+                      </a:r>
+                    </a:p>
+                  </a:txBody>
+                  <a:tcPr marL="36576" marR="36576" marT="18288" marB="18288">
+                    <a:solidFill>
+                      <a:srgbClr val="F8F8F6"/>
+                    </a:solidFill>
+                  </a:tcPr>
+                </a:tc>
+              </a:tr>
+            </a:tbl>
+          </a:graphicData>
+        </a:graphic>
+      </p:graphicFrame>
+      <p:sp>
+        <p:nvSpPr>
+          <p:cNvPr id="9" name="TextBox 8"/>
+          <p:cNvSpPr txBox="1"/>
+          <p:nvPr/>
+        </p:nvSpPr>
+        <p:spPr>
+          <a:xfrm>
+            <a:off x="411480" y="6492240"/>
+            <a:ext cx="11368735" cy="274320"/>
+          </a:xfrm>
+          <a:prstGeom prst="rect">
+            <a:avLst/>
+          </a:prstGeom>
+          <a:noFill/>
+        </p:spPr>
+        <p:txBody>
+          <a:bodyPr wrap="none">
+            <a:spAutoFit/>
+          </a:bodyPr>
+          <a:lstStyle/>
+          <a:p>
+            <a:r>
+              <a:rPr sz="1000" b="0" i="1">
+                <a:solidFill>
+                  <a:srgbClr val="6A6760"/>
+                </a:solidFill>
+                <a:latin typeface="Encode Sans"/>
+              </a:rPr>
+              <a:t>Fuente: elaboración propia en base a INDEC</a:t>
+            </a:r>
+          </a:p>
+        </p:txBody>
+      </p:sp>
+    </p:spTree>
+  </p:cSld>
+  <p:clrMapOvr>
+    <a:masterClrMapping/>
+  </p:clrMapOvr>
+</p:sld>
+</file>
+
+<file path=ppt/slides/slide3.xml><?xml version="1.0" encoding="utf-8"?>
+<p:sld xmlns:a="http://schemas.openxmlformats.org/drawingml/2006/main" xmlns:p="http://schemas.openxmlformats.org/presentationml/2006/main" xmlns:r="http://schemas.openxmlformats.org/officeDocument/2006/relationships">
+  <p:cSld>
+    <p:spTree>
+      <p:nvGrpSpPr>
+        <p:cNvPr id="1" name=""/>
+        <p:cNvGrpSpPr/>
+        <p:nvPr/>
+      </p:nvGrpSpPr>
+      <p:grpSpPr/>
+      <p:sp>
+        <p:nvSpPr>
+          <p:cNvPr id="2" name="Rectangle 1"/>
+          <p:cNvSpPr/>
+          <p:nvPr/>
+        </p:nvSpPr>
+        <p:spPr>
+          <a:xfrm>
+            <a:off x="0" y="0"/>
+            <a:ext cx="12191695" cy="274320"/>
+          </a:xfrm>
+          <a:prstGeom prst="rect">
+            <a:avLst/>
+          </a:prstGeom>
+          <a:solidFill>
+            <a:srgbClr val="00B2C9"/>
+          </a:solidFill>
+          <a:ln>
+            <a:noFill/>
+          </a:ln>
+        </p:spPr>
+        <p:style>
+          <a:lnRef idx="1">
+            <a:schemeClr val="accent1"/>
+          </a:lnRef>
+          <a:fillRef idx="3">
+            <a:schemeClr val="accent1"/>
+          </a:fillRef>
+          <a:effectRef idx="2">
+            <a:schemeClr val="accent1"/>
+          </a:effectRef>
+          <a:fontRef idx="minor">
+            <a:schemeClr val="lt1"/>
+          </a:fontRef>
+        </p:style>
+        <p:txBody>
+          <a:bodyPr rtlCol="0" anchor="ctr"/>
+          <a:lstStyle/>
+          <a:p>
+            <a:pPr algn="ctr"/>
+          </a:p>
+        </p:txBody>
+      </p:sp>
+      <p:sp>
+        <p:nvSpPr>
+          <p:cNvPr id="3" name="TextBox 2"/>
+          <p:cNvSpPr txBox="1"/>
+          <p:nvPr/>
+        </p:nvSpPr>
+        <p:spPr>
+          <a:xfrm>
+            <a:off x="411480" y="457200"/>
+            <a:ext cx="11368735" cy="914400"/>
+          </a:xfrm>
+          <a:prstGeom prst="rect">
+            <a:avLst/>
+          </a:prstGeom>
+          <a:noFill/>
+        </p:spPr>
+        <p:txBody>
+          <a:bodyPr wrap="square" lIns="0" rIns="0">
+            <a:spAutoFit/>
+          </a:bodyPr>
+          <a:lstStyle/>
+          <a:p>
+            <a:pPr algn="l"/>
+            <a:r>
+              <a:rPr sz="2600" b="1" i="0">
+                <a:solidFill>
+                  <a:srgbClr val="00B2C9"/>
+                </a:solidFill>
+                <a:latin typeface="Encode Sans"/>
+              </a:rPr>
+              <a:t>INDUSTRIA AGOSTO 2026: IPI CRECIÓ +0.0% I.A.</a:t>
+            </a:r>
+          </a:p>
+        </p:txBody>
+      </p:sp>
+      <p:sp>
+        <p:nvSpPr>
+          <p:cNvPr id="4" name="TextBox 3"/>
+          <p:cNvSpPr txBox="1"/>
+          <p:nvPr/>
+        </p:nvSpPr>
+        <p:spPr>
+          <a:xfrm>
+            <a:off x="411480" y="1280160"/>
+            <a:ext cx="11368735" cy="274320"/>
+          </a:xfrm>
+          <a:prstGeom prst="rect">
+            <a:avLst/>
+          </a:prstGeom>
+          <a:noFill/>
+        </p:spPr>
+        <p:txBody>
+          <a:bodyPr wrap="none">
+            <a:spAutoFit/>
+          </a:bodyPr>
+          <a:lstStyle/>
+          <a:p>
+            <a:r>
+              <a:rPr sz="1100" b="0" i="1">
+                <a:solidFill>
+                  <a:srgbClr val="6A6760"/>
+                </a:solidFill>
+                <a:latin typeface="Encode Sans"/>
+              </a:rPr>
+              <a:t>INDEC · período 2026-08</a:t>
+            </a:r>
+          </a:p>
+        </p:txBody>
+      </p:sp>
+      <p:sp>
+        <p:nvSpPr>
+          <p:cNvPr id="5" name="TextBox 4"/>
+          <p:cNvSpPr txBox="1"/>
+          <p:nvPr/>
+        </p:nvSpPr>
+        <p:spPr>
+          <a:xfrm>
+            <a:off x="411480" y="1691640"/>
+            <a:ext cx="5486400" cy="1645920"/>
+          </a:xfrm>
+          <a:prstGeom prst="rect">
+            <a:avLst/>
+          </a:prstGeom>
+          <a:noFill/>
+        </p:spPr>
+        <p:txBody>
+          <a:bodyPr wrap="square" lIns="0" rIns="0">
+            <a:spAutoFit/>
+          </a:bodyPr>
+          <a:lstStyle/>
+          <a:p>
+            <a:pPr algn="just"/>
+            <a:r>
+              <a:rPr sz="1300" b="0" i="0">
+                <a:solidFill>
+                  <a:srgbClr val="3F3F3F"/>
+                </a:solidFill>
+                <a:latin typeface="Encode Sans"/>
+              </a:rPr>
+              <a:t>El Índice de Producción Industrial Manufacturero (IPI) registró una variación interanual de +0.0% en agosto 2026.</a:t>
+            </a:r>
+          </a:p>
+        </p:txBody>
+      </p:sp>
+      <p:sp>
+        <p:nvSpPr>
+          <p:cNvPr id="6" name="TextBox 5"/>
+          <p:cNvSpPr txBox="1"/>
+          <p:nvPr/>
+        </p:nvSpPr>
+        <p:spPr>
+          <a:xfrm>
+            <a:off x="411480" y="3520440"/>
+            <a:ext cx="5486400" cy="2743200"/>
+          </a:xfrm>
+          <a:prstGeom prst="rect">
+            <a:avLst/>
+          </a:prstGeom>
+          <a:noFill/>
+        </p:spPr>
+        <p:txBody>
+          <a:bodyPr wrap="square" lIns="0" rIns="0">
+            <a:spAutoFit/>
+          </a:bodyPr>
+          <a:lstStyle/>
+          <a:p>
+            <a:pPr algn="l">
+              <a:spcAft>
+                <a:spcPts val="800"/>
+              </a:spcAft>
+            </a:pPr>
+            <a:r>
+              <a:rPr sz="1300" b="1" i="0">
+                <a:solidFill>
+                  <a:srgbClr val="00B2C9"/>
+                </a:solidFill>
+                <a:latin typeface="Encode Sans"/>
+              </a:rPr>
+              <a:t>●  </a:t>
+            </a:r>
+            <a:r>
+              <a:rPr sz="1300" b="0" i="0">
+                <a:solidFill>
+                  <a:srgbClr val="3F3F3F"/>
+                </a:solidFill>
+                <a:latin typeface="Encode Sans"/>
+              </a:rPr>
+              <a:t>Variación interanual: +0.0%</a:t>
+            </a:r>
+          </a:p>
+          <a:p>
+            <a:pPr algn="l">
+              <a:spcAft>
+                <a:spcPts val="800"/>
+              </a:spcAft>
+            </a:pPr>
+            <a:r>
+              <a:rPr sz="1300" b="1" i="0">
+                <a:solidFill>
+                  <a:srgbClr val="00B2C9"/>
+                </a:solidFill>
+                <a:latin typeface="Encode Sans"/>
+              </a:rPr>
+              <a:t>●  </a:t>
+            </a:r>
+            <a:r>
+              <a:rPr sz="1300" b="0" i="0">
+                <a:solidFill>
+                  <a:srgbClr val="3F3F3F"/>
+                </a:solidFill>
+                <a:latin typeface="Encode Sans"/>
+              </a:rPr>
+              <a:t>Serie INDEC, base 2004=100. Mide la producción manufacturera (16 ramas).</a:t>
+            </a:r>
+          </a:p>
+        </p:txBody>
+      </p:sp>
+      <p:pic>
+        <p:nvPicPr>
+          <p:cNvPr id="7" name="Picture 6" descr="image.png"/>
+          <p:cNvPicPr>
+            <a:picLocks noChangeAspect="1"/>
+          </p:cNvPicPr>
+          <p:nvPr/>
+        </p:nvPicPr>
+        <p:blipFill>
+          <a:blip r:embed="rId2"/>
+          <a:stretch>
+            <a:fillRect/>
+          </a:stretch>
+        </p:blipFill>
+        <p:spPr>
+          <a:xfrm>
+            <a:off x="6080760" y="1691640"/>
+            <a:ext cx="5669280" cy="2560320"/>
+          </a:xfrm>
+          <a:prstGeom prst="rect">
+            <a:avLst/>
+          </a:prstGeom>
+        </p:spPr>
+      </p:pic>
+      <p:graphicFrame>
+        <p:nvGraphicFramePr>
+          <p:cNvPr id="8" name="Table 7"/>
+          <p:cNvGraphicFramePr>
+            <a:graphicFrameLocks noGrp="1"/>
+          </p:cNvGraphicFramePr>
+          <p:nvPr/>
+        </p:nvGraphicFramePr>
+        <p:xfrm>
+          <a:off x="6080760" y="4434840"/>
+          <a:ext cx="5669280" cy="2048256"/>
+        </p:xfrm>
+        <a:graphic>
+          <a:graphicData uri="http://schemas.openxmlformats.org/drawingml/2006/table">
+            <a:tbl>
+              <a:tblPr firstRow="1" bandRow="1">
+                <a:tableStyleId>{5C22544A-7EE6-4342-B048-85BDC9FD1C3A}</a:tableStyleId>
+              </a:tblPr>
+              <a:tblGrid>
+                <a:gridCol w="1889760"/>
+                <a:gridCol w="1889760"/>
+                <a:gridCol w="1889760"/>
+              </a:tblGrid>
+              <a:tr h="292608">
+                <a:tc>
+                  <a:txBody>
+                    <a:bodyPr/>
+                    <a:lstStyle/>
+                    <a:p>
+                      <a:pPr algn="l"/>
+                      <a:r>
+                        <a:rPr sz="1000" b="1">
+                          <a:solidFill>
+                            <a:srgbClr val="FFFFFF"/>
+                          </a:solidFill>
+                          <a:latin typeface="Encode Sans"/>
+                        </a:rPr>
+                        <a:t>Mes</a:t>
+                      </a:r>
+                    </a:p>
+                  </a:txBody>
+                  <a:tcPr marL="36576" marR="36576" marT="18288" marB="18288">
+                    <a:solidFill>
+                      <a:srgbClr val="00B2C9"/>
+                    </a:solidFill>
+                  </a:tcPr>
+                </a:tc>
+                <a:tc>
+                  <a:txBody>
+                    <a:bodyPr/>
+                    <a:lstStyle/>
+                    <a:p>
+                      <a:pPr algn="r"/>
+                      <a:r>
+                        <a:rPr sz="1000" b="1">
+                          <a:solidFill>
+                            <a:srgbClr val="FFFFFF"/>
+                          </a:solidFill>
+                          <a:latin typeface="Encode Sans"/>
+                        </a:rPr>
+                        <a:t>Original</a:t>
+                      </a:r>
+                    </a:p>
+                  </a:txBody>
+                  <a:tcPr marL="36576" marR="36576" marT="18288" marB="18288">
+                    <a:solidFill>
+                      <a:srgbClr val="00B2C9"/>
+                    </a:solidFill>
+                  </a:tcPr>
+                </a:tc>
+                <a:tc>
+                  <a:txBody>
+                    <a:bodyPr/>
+                    <a:lstStyle/>
+                    <a:p>
+                      <a:pPr algn="r"/>
+                      <a:r>
+                        <a:rPr sz="1000" b="1">
+                          <a:solidFill>
+                            <a:srgbClr val="FFFFFF"/>
+                          </a:solidFill>
+                          <a:latin typeface="Encode Sans"/>
+                        </a:rPr>
+                        <a:t>VIA %</a:t>
+                      </a:r>
+                    </a:p>
+                  </a:txBody>
+                  <a:tcPr marL="36576" marR="36576" marT="18288" marB="18288">
+                    <a:solidFill>
+                      <a:srgbClr val="00B2C9"/>
+                    </a:solidFill>
+                  </a:tcPr>
+                </a:tc>
+              </a:tr>
+              <a:tr h="292608">
+                <a:tc>
+                  <a:txBody>
+                    <a:bodyPr/>
+                    <a:lstStyle/>
+                    <a:p>
+                      <a:pPr algn="l"/>
+                      <a:r>
+                        <a:rPr sz="1000">
+                          <a:solidFill>
+                            <a:srgbClr val="3F3F3F"/>
+                          </a:solidFill>
+                          <a:latin typeface="Encode Sans"/>
+                        </a:rPr>
+                        <a:t>Agosto 2026</a:t>
+                      </a:r>
+                    </a:p>
+                  </a:txBody>
+                  <a:tcPr marL="36576" marR="36576" marT="18288" marB="18288">
+                    <a:solidFill>
+                      <a:srgbClr val="FFFFFF"/>
+                    </a:solidFill>
+                  </a:tcPr>
+                </a:tc>
+                <a:tc>
+                  <a:txBody>
+                    <a:bodyPr/>
+                    <a:lstStyle/>
+                    <a:p>
+                      <a:pPr algn="r"/>
+                      <a:r>
+                        <a:rPr sz="1000">
+                          <a:solidFill>
+                            <a:srgbClr val="3F3F3F"/>
+                          </a:solidFill>
+                          <a:latin typeface="Encode Sans"/>
+                        </a:rPr>
+                        <a:t>119,3</a:t>
+                      </a:r>
+                    </a:p>
+                  </a:txBody>
+                  <a:tcPr marL="36576" marR="36576" marT="18288" marB="18288">
+                    <a:solidFill>
+                      <a:srgbClr val="FFFFFF"/>
+                    </a:solidFill>
+                  </a:tcPr>
+                </a:tc>
+                <a:tc>
+                  <a:txBody>
+                    <a:bodyPr/>
+                    <a:lstStyle/>
+                    <a:p>
+                      <a:pPr algn="r"/>
+                      <a:r>
+                        <a:rPr sz="1000">
+                          <a:solidFill>
+                            <a:srgbClr val="3F3F3F"/>
+                          </a:solidFill>
+                          <a:latin typeface="Encode Sans"/>
+                        </a:rPr>
+                        <a:t>-3.2%</a:t>
+                      </a:r>
+                    </a:p>
+                  </a:txBody>
+                  <a:tcPr marL="36576" marR="36576" marT="18288" marB="18288">
+                    <a:solidFill>
+                      <a:srgbClr val="FFFFFF"/>
+                    </a:solidFill>
+                  </a:tcPr>
+                </a:tc>
+              </a:tr>
+              <a:tr h="292608">
+                <a:tc>
+                  <a:txBody>
+                    <a:bodyPr/>
+                    <a:lstStyle/>
+                    <a:p>
+                      <a:pPr algn="l"/>
+                      <a:r>
+                        <a:rPr sz="1000">
+                          <a:solidFill>
+                            <a:srgbClr val="3F3F3F"/>
+                          </a:solidFill>
+                          <a:latin typeface="Encode Sans"/>
+                        </a:rPr>
+                        <a:t>Julio 2026</a:t>
                       </a:r>
                     </a:p>
                   </a:txBody>
@@ -4608,7 +4562,314 @@
                           </a:solidFill>
                           <a:latin typeface="Encode Sans"/>
                         </a:rPr>
-                        <a:t>—</a:t>
+                        <a:t>118,1</a:t>
+                      </a:r>
+                    </a:p>
+                  </a:txBody>
+                  <a:tcPr marL="36576" marR="36576" marT="18288" marB="18288">
+                    <a:solidFill>
+                      <a:srgbClr val="F8F8F6"/>
+                    </a:solidFill>
+                  </a:tcPr>
+                </a:tc>
+                <a:tc>
+                  <a:txBody>
+                    <a:bodyPr/>
+                    <a:lstStyle/>
+                    <a:p>
+                      <a:pPr algn="r"/>
+                      <a:r>
+                        <a:rPr sz="1000">
+                          <a:solidFill>
+                            <a:srgbClr val="3F3F3F"/>
+                          </a:solidFill>
+                          <a:latin typeface="Encode Sans"/>
+                        </a:rPr>
+                        <a:t>-4.9%</a:t>
+                      </a:r>
+                    </a:p>
+                  </a:txBody>
+                  <a:tcPr marL="36576" marR="36576" marT="18288" marB="18288">
+                    <a:solidFill>
+                      <a:srgbClr val="F8F8F6"/>
+                    </a:solidFill>
+                  </a:tcPr>
+                </a:tc>
+              </a:tr>
+              <a:tr h="292608">
+                <a:tc>
+                  <a:txBody>
+                    <a:bodyPr/>
+                    <a:lstStyle/>
+                    <a:p>
+                      <a:pPr algn="l"/>
+                      <a:r>
+                        <a:rPr sz="1000">
+                          <a:solidFill>
+                            <a:srgbClr val="3F3F3F"/>
+                          </a:solidFill>
+                          <a:latin typeface="Encode Sans"/>
+                        </a:rPr>
+                        <a:t>Junio 2026</a:t>
+                      </a:r>
+                    </a:p>
+                  </a:txBody>
+                  <a:tcPr marL="36576" marR="36576" marT="18288" marB="18288">
+                    <a:solidFill>
+                      <a:srgbClr val="FFFFFF"/>
+                    </a:solidFill>
+                  </a:tcPr>
+                </a:tc>
+                <a:tc>
+                  <a:txBody>
+                    <a:bodyPr/>
+                    <a:lstStyle/>
+                    <a:p>
+                      <a:pPr algn="r"/>
+                      <a:r>
+                        <a:rPr sz="1000">
+                          <a:solidFill>
+                            <a:srgbClr val="3F3F3F"/>
+                          </a:solidFill>
+                          <a:latin typeface="Encode Sans"/>
+                        </a:rPr>
+                        <a:t>119,8</a:t>
+                      </a:r>
+                    </a:p>
+                  </a:txBody>
+                  <a:tcPr marL="36576" marR="36576" marT="18288" marB="18288">
+                    <a:solidFill>
+                      <a:srgbClr val="FFFFFF"/>
+                    </a:solidFill>
+                  </a:tcPr>
+                </a:tc>
+                <a:tc>
+                  <a:txBody>
+                    <a:bodyPr/>
+                    <a:lstStyle/>
+                    <a:p>
+                      <a:pPr algn="r"/>
+                      <a:r>
+                        <a:rPr sz="1000">
+                          <a:solidFill>
+                            <a:srgbClr val="3F3F3F"/>
+                          </a:solidFill>
+                          <a:latin typeface="Encode Sans"/>
+                        </a:rPr>
+                        <a:t>+2.0%</a:t>
+                      </a:r>
+                    </a:p>
+                  </a:txBody>
+                  <a:tcPr marL="36576" marR="36576" marT="18288" marB="18288">
+                    <a:solidFill>
+                      <a:srgbClr val="FFFFFF"/>
+                    </a:solidFill>
+                  </a:tcPr>
+                </a:tc>
+              </a:tr>
+              <a:tr h="292608">
+                <a:tc>
+                  <a:txBody>
+                    <a:bodyPr/>
+                    <a:lstStyle/>
+                    <a:p>
+                      <a:pPr algn="l"/>
+                      <a:r>
+                        <a:rPr sz="1000">
+                          <a:solidFill>
+                            <a:srgbClr val="3F3F3F"/>
+                          </a:solidFill>
+                          <a:latin typeface="Encode Sans"/>
+                        </a:rPr>
+                        <a:t>Mayo 2026</a:t>
+                      </a:r>
+                    </a:p>
+                  </a:txBody>
+                  <a:tcPr marL="36576" marR="36576" marT="18288" marB="18288">
+                    <a:solidFill>
+                      <a:srgbClr val="F8F8F6"/>
+                    </a:solidFill>
+                  </a:tcPr>
+                </a:tc>
+                <a:tc>
+                  <a:txBody>
+                    <a:bodyPr/>
+                    <a:lstStyle/>
+                    <a:p>
+                      <a:pPr algn="r"/>
+                      <a:r>
+                        <a:rPr sz="1000">
+                          <a:solidFill>
+                            <a:srgbClr val="3F3F3F"/>
+                          </a:solidFill>
+                          <a:latin typeface="Encode Sans"/>
+                        </a:rPr>
+                        <a:t>116,9</a:t>
+                      </a:r>
+                    </a:p>
+                  </a:txBody>
+                  <a:tcPr marL="36576" marR="36576" marT="18288" marB="18288">
+                    <a:solidFill>
+                      <a:srgbClr val="F8F8F6"/>
+                    </a:solidFill>
+                  </a:tcPr>
+                </a:tc>
+                <a:tc>
+                  <a:txBody>
+                    <a:bodyPr/>
+                    <a:lstStyle/>
+                    <a:p>
+                      <a:pPr algn="r"/>
+                      <a:r>
+                        <a:rPr sz="1000">
+                          <a:solidFill>
+                            <a:srgbClr val="3F3F3F"/>
+                          </a:solidFill>
+                          <a:latin typeface="Encode Sans"/>
+                        </a:rPr>
+                        <a:t>-5.7%</a:t>
+                      </a:r>
+                    </a:p>
+                  </a:txBody>
+                  <a:tcPr marL="36576" marR="36576" marT="18288" marB="18288">
+                    <a:solidFill>
+                      <a:srgbClr val="F8F8F6"/>
+                    </a:solidFill>
+                  </a:tcPr>
+                </a:tc>
+              </a:tr>
+              <a:tr h="292608">
+                <a:tc>
+                  <a:txBody>
+                    <a:bodyPr/>
+                    <a:lstStyle/>
+                    <a:p>
+                      <a:pPr algn="l"/>
+                      <a:r>
+                        <a:rPr sz="1000">
+                          <a:solidFill>
+                            <a:srgbClr val="3F3F3F"/>
+                          </a:solidFill>
+                          <a:latin typeface="Encode Sans"/>
+                        </a:rPr>
+                        <a:t>Abril 2026</a:t>
+                      </a:r>
+                    </a:p>
+                  </a:txBody>
+                  <a:tcPr marL="36576" marR="36576" marT="18288" marB="18288">
+                    <a:solidFill>
+                      <a:srgbClr val="FFFFFF"/>
+                    </a:solidFill>
+                  </a:tcPr>
+                </a:tc>
+                <a:tc>
+                  <a:txBody>
+                    <a:bodyPr/>
+                    <a:lstStyle/>
+                    <a:p>
+                      <a:pPr algn="r"/>
+                      <a:r>
+                        <a:rPr sz="1000">
+                          <a:solidFill>
+                            <a:srgbClr val="3F3F3F"/>
+                          </a:solidFill>
+                          <a:latin typeface="Encode Sans"/>
+                        </a:rPr>
+                        <a:t>118,5</a:t>
+                      </a:r>
+                    </a:p>
+                  </a:txBody>
+                  <a:tcPr marL="36576" marR="36576" marT="18288" marB="18288">
+                    <a:solidFill>
+                      <a:srgbClr val="FFFFFF"/>
+                    </a:solidFill>
+                  </a:tcPr>
+                </a:tc>
+                <a:tc>
+                  <a:txBody>
+                    <a:bodyPr/>
+                    <a:lstStyle/>
+                    <a:p>
+                      <a:pPr algn="r"/>
+                      <a:r>
+                        <a:rPr sz="1000">
+                          <a:solidFill>
+                            <a:srgbClr val="3F3F3F"/>
+                          </a:solidFill>
+                          <a:latin typeface="Encode Sans"/>
+                        </a:rPr>
+                        <a:t>-2.4%</a:t>
+                      </a:r>
+                    </a:p>
+                  </a:txBody>
+                  <a:tcPr marL="36576" marR="36576" marT="18288" marB="18288">
+                    <a:solidFill>
+                      <a:srgbClr val="FFFFFF"/>
+                    </a:solidFill>
+                  </a:tcPr>
+                </a:tc>
+              </a:tr>
+              <a:tr h="292608">
+                <a:tc>
+                  <a:txBody>
+                    <a:bodyPr/>
+                    <a:lstStyle/>
+                    <a:p>
+                      <a:pPr algn="l"/>
+                      <a:r>
+                        <a:rPr sz="1000">
+                          <a:solidFill>
+                            <a:srgbClr val="3F3F3F"/>
+                          </a:solidFill>
+                          <a:latin typeface="Encode Sans"/>
+                        </a:rPr>
+                        <a:t>Marzo 2026</a:t>
+                      </a:r>
+                    </a:p>
+                  </a:txBody>
+                  <a:tcPr marL="36576" marR="36576" marT="18288" marB="18288">
+                    <a:solidFill>
+                      <a:srgbClr val="F8F8F6"/>
+                    </a:solidFill>
+                  </a:tcPr>
+                </a:tc>
+                <a:tc>
+                  <a:txBody>
+                    <a:bodyPr/>
+                    <a:lstStyle/>
+                    <a:p>
+                      <a:pPr algn="r"/>
+                      <a:r>
+                        <a:rPr sz="1000">
+                          <a:solidFill>
+                            <a:srgbClr val="3F3F3F"/>
+                          </a:solidFill>
+                          <a:latin typeface="Encode Sans"/>
+                        </a:rPr>
+                        <a:t>122,1</a:t>
+                      </a:r>
+                    </a:p>
+                  </a:txBody>
+                  <a:tcPr marL="36576" marR="36576" marT="18288" marB="18288">
+                    <a:solidFill>
+                      <a:srgbClr val="F8F8F6"/>
+                    </a:solidFill>
+                  </a:tcPr>
+                </a:tc>
+                <a:tc>
+                  <a:txBody>
+                    <a:bodyPr/>
+                    <a:lstStyle/>
+                    <a:p>
+                      <a:pPr algn="r"/>
+                      <a:r>
+                        <a:rPr sz="1000">
+                          <a:solidFill>
+                            <a:srgbClr val="3F3F3F"/>
+                          </a:solidFill>
+                          <a:latin typeface="Encode Sans"/>
+                        </a:rPr>
+                        <a:t>+5.0%</a:t>
                       </a:r>
                     </a:p>
                   </a:txBody>
@@ -4652,7 +4913,7 @@
                 </a:solidFill>
                 <a:latin typeface="Encode Sans"/>
               </a:rPr>
-              <a:t>Fuente: elaboración propia en base a AFIP/ARCA</a:t>
+              <a:t>Fuente: elaboración propia en base a INDEC</a:t>
             </a:r>
           </a:p>
         </p:txBody>

</xml_diff>

<commit_message>
data: update 2026-10-13 ( data.json despidos.json scraper/historical_despidos.json publicaciones_semana.pptx rrii_brutas.xlsx)
</commit_message>
<xml_diff>
--- a/publicaciones_semana.pptx
+++ b/publicaciones_semana.pptx
@@ -7,7 +7,6 @@
   <p:sldIdLst>
     <p:sldId id="256" r:id="rId7"/>
     <p:sldId id="257" r:id="rId8"/>
-    <p:sldId id="258" r:id="rId9"/>
   </p:sldIdLst>
   <p:sldSz cx="12191695" cy="6858000" type="screen4x3"/>
   <p:notesSz cx="6858000" cy="9144000"/>
@@ -3239,7 +3238,7 @@
                 </a:solidFill>
                 <a:latin typeface="Encode Sans"/>
               </a:rPr>
-              <a:t>Publicaciones de la semana del 05 de octubre de 2026</a:t>
+              <a:t>Publicaciones de la semana del 12 de octubre de 2026</a:t>
             </a:r>
           </a:p>
         </p:txBody>
@@ -3273,7 +3272,7 @@
                 </a:solidFill>
                 <a:latin typeface="Encode Sans"/>
               </a:rPr>
-              <a:t>2 publicaciones · datos oficiales INDEC / BCRA / Hacienda</a:t>
+              <a:t>1 publicaciones · datos oficiales INDEC / BCRA / Hacienda</a:t>
             </a:r>
           </a:p>
         </p:txBody>
@@ -3369,7 +3368,7 @@
                 </a:solidFill>
                 <a:latin typeface="Encode Sans"/>
               </a:rPr>
-              <a:t>INDUSTRIA AGOSTO 2026: IPI CAYÓ -3.2% I.A.</a:t>
+              <a:t>INFLACIÓN SEPTIEMBRE 2026: +1.9%</a:t>
             </a:r>
           </a:p>
         </p:txBody>
@@ -3403,7 +3402,7 @@
                 </a:solidFill>
                 <a:latin typeface="Encode Sans"/>
               </a:rPr>
-              <a:t>INDEC · período 2026-08</a:t>
+              <a:t>INDEC · período 2026-09</a:t>
             </a:r>
           </a:p>
         </p:txBody>
@@ -3438,7 +3437,7 @@
                 </a:solidFill>
                 <a:latin typeface="Encode Sans"/>
               </a:rPr>
-              <a:t>El Índice de Producción Industrial Manufacturero (IPI) registró una variación interanual de -3.2% en agosto 2026.</a:t>
+              <a:t>El IPC nivel general aumentó +1.9% mensual en septiembre 2026, acumulando 33.31% interanual. INDEC publicó el indicador con la metodología vigente.</a:t>
             </a:r>
           </a:p>
         </p:txBody>
@@ -3486,7 +3485,7 @@
                 </a:solidFill>
                 <a:latin typeface="Encode Sans"/>
               </a:rPr>
-              <a:t>Variación interanual: -3.2%</a:t>
+              <a:t>Variación mensual: +1.9%</a:t>
             </a:r>
           </a:p>
           <a:p>
@@ -3511,7 +3510,32 @@
                 </a:solidFill>
                 <a:latin typeface="Encode Sans"/>
               </a:rPr>
-              <a:t>Serie INDEC, base 2004=100. Mide la producción manufacturera (16 ramas).</a:t>
+              <a:t>Variación interanual: 33.31%</a:t>
+            </a:r>
+          </a:p>
+          <a:p>
+            <a:pPr algn="l">
+              <a:spcAft>
+                <a:spcPts val="800"/>
+              </a:spcAft>
+            </a:pPr>
+            <a:r>
+              <a:rPr sz="1300" b="1" i="0">
+                <a:solidFill>
+                  <a:srgbClr val="00B2C9"/>
+                </a:solidFill>
+                <a:latin typeface="Encode Sans"/>
+              </a:rPr>
+              <a:t>●  </a:t>
+            </a:r>
+            <a:r>
+              <a:rPr sz="1300" b="0" i="0">
+                <a:solidFill>
+                  <a:srgbClr val="3F3F3F"/>
+                </a:solidFill>
+                <a:latin typeface="Encode Sans"/>
+              </a:rPr>
+              <a:t>Acumulado últimos 6 meses: 12.3% (suma simple)</a:t>
             </a:r>
           </a:p>
         </p:txBody>
@@ -3600,7 +3624,7 @@
                           </a:solidFill>
                           <a:latin typeface="Encode Sans"/>
                         </a:rPr>
-                        <a:t>Original</a:t>
+                        <a:t>VM %</a:t>
                       </a:r>
                     </a:p>
                   </a:txBody>
@@ -3648,7 +3672,7 @@
                           </a:solidFill>
                           <a:latin typeface="Encode Sans"/>
                         </a:rPr>
-                        <a:t>Agosto 2026</a:t>
+                        <a:t>Septiembre 2026</a:t>
                       </a:r>
                     </a:p>
                   </a:txBody>
@@ -3671,7 +3695,7 @@
                           </a:solidFill>
                           <a:latin typeface="Encode Sans"/>
                         </a:rPr>
-                        <a:t>119,3</a:t>
+                        <a:t>+1.9%</a:t>
                       </a:r>
                     </a:p>
                   </a:txBody>
@@ -3694,7 +3718,7 @@
                           </a:solidFill>
                           <a:latin typeface="Encode Sans"/>
                         </a:rPr>
-                        <a:t>-3.2%</a:t>
+                        <a:t>+33.3%</a:t>
                       </a:r>
                     </a:p>
                   </a:txBody>
@@ -3719,7 +3743,7 @@
                           </a:solidFill>
                           <a:latin typeface="Encode Sans"/>
                         </a:rPr>
-                        <a:t>Julio 2026</a:t>
+                        <a:t>Agosto 2026</a:t>
                       </a:r>
                     </a:p>
                   </a:txBody>
@@ -3742,7 +3766,7 @@
                           </a:solidFill>
                           <a:latin typeface="Encode Sans"/>
                         </a:rPr>
-                        <a:t>118,1</a:t>
+                        <a:t>+1.7%</a:t>
                       </a:r>
                     </a:p>
                   </a:txBody>
@@ -3765,7 +3789,7 @@
                           </a:solidFill>
                           <a:latin typeface="Encode Sans"/>
                         </a:rPr>
-                        <a:t>-4.9%</a:t>
+                        <a:t>+33.5%</a:t>
                       </a:r>
                     </a:p>
                   </a:txBody>
@@ -3790,7 +3814,7 @@
                           </a:solidFill>
                           <a:latin typeface="Encode Sans"/>
                         </a:rPr>
-                        <a:t>Junio 2026</a:t>
+                        <a:t>Julio 2026</a:t>
                       </a:r>
                     </a:p>
                   </a:txBody>
@@ -3813,7 +3837,7 @@
                           </a:solidFill>
                           <a:latin typeface="Encode Sans"/>
                         </a:rPr>
-                        <a:t>119,8</a:t>
+                        <a:t>+2.1%</a:t>
                       </a:r>
                     </a:p>
                   </a:txBody>
@@ -3836,7 +3860,7 @@
                           </a:solidFill>
                           <a:latin typeface="Encode Sans"/>
                         </a:rPr>
-                        <a:t>+2.0%</a:t>
+                        <a:t>+33.8%</a:t>
                       </a:r>
                     </a:p>
                   </a:txBody>
@@ -3861,7 +3885,7 @@
                           </a:solidFill>
                           <a:latin typeface="Encode Sans"/>
                         </a:rPr>
-                        <a:t>Mayo 2026</a:t>
+                        <a:t>Junio 2026</a:t>
                       </a:r>
                     </a:p>
                   </a:txBody>
@@ -3884,7 +3908,7 @@
                           </a:solidFill>
                           <a:latin typeface="Encode Sans"/>
                         </a:rPr>
-                        <a:t>116,9</a:t>
+                        <a:t>+1.9%</a:t>
                       </a:r>
                     </a:p>
                   </a:txBody>
@@ -3907,7 +3931,7 @@
                           </a:solidFill>
                           <a:latin typeface="Encode Sans"/>
                         </a:rPr>
-                        <a:t>-5.7%</a:t>
+                        <a:t>+33.5%</a:t>
                       </a:r>
                     </a:p>
                   </a:txBody>
@@ -3932,7 +3956,7 @@
                           </a:solidFill>
                           <a:latin typeface="Encode Sans"/>
                         </a:rPr>
-                        <a:t>Abril 2026</a:t>
+                        <a:t>Mayo 2026</a:t>
                       </a:r>
                     </a:p>
                   </a:txBody>
@@ -3955,7 +3979,7 @@
                           </a:solidFill>
                           <a:latin typeface="Encode Sans"/>
                         </a:rPr>
-                        <a:t>118,5</a:t>
+                        <a:t>+2.1%</a:t>
                       </a:r>
                     </a:p>
                   </a:txBody>
@@ -3978,7 +4002,7 @@
                           </a:solidFill>
                           <a:latin typeface="Encode Sans"/>
                         </a:rPr>
-                        <a:t>-2.4%</a:t>
+                        <a:t>+33.2%</a:t>
                       </a:r>
                     </a:p>
                   </a:txBody>
@@ -4003,7 +4027,7 @@
                           </a:solidFill>
                           <a:latin typeface="Encode Sans"/>
                         </a:rPr>
-                        <a:t>Marzo 2026</a:t>
+                        <a:t>Abril 2026</a:t>
                       </a:r>
                     </a:p>
                   </a:txBody>
@@ -4026,7 +4050,7 @@
                           </a:solidFill>
                           <a:latin typeface="Encode Sans"/>
                         </a:rPr>
-                        <a:t>122,1</a:t>
+                        <a:t>+2.6%</a:t>
                       </a:r>
                     </a:p>
                   </a:txBody>
@@ -4049,827 +4073,7 @@
                           </a:solidFill>
                           <a:latin typeface="Encode Sans"/>
                         </a:rPr>
-                        <a:t>+5.0%</a:t>
-                      </a:r>
-                    </a:p>
-                  </a:txBody>
-                  <a:tcPr marL="36576" marR="36576" marT="18288" marB="18288">
-                    <a:solidFill>
-                      <a:srgbClr val="F8F8F6"/>
-                    </a:solidFill>
-                  </a:tcPr>
-                </a:tc>
-              </a:tr>
-            </a:tbl>
-          </a:graphicData>
-        </a:graphic>
-      </p:graphicFrame>
-      <p:sp>
-        <p:nvSpPr>
-          <p:cNvPr id="9" name="TextBox 8"/>
-          <p:cNvSpPr txBox="1"/>
-          <p:nvPr/>
-        </p:nvSpPr>
-        <p:spPr>
-          <a:xfrm>
-            <a:off x="411480" y="6492240"/>
-            <a:ext cx="11368735" cy="274320"/>
-          </a:xfrm>
-          <a:prstGeom prst="rect">
-            <a:avLst/>
-          </a:prstGeom>
-          <a:noFill/>
-        </p:spPr>
-        <p:txBody>
-          <a:bodyPr wrap="none">
-            <a:spAutoFit/>
-          </a:bodyPr>
-          <a:lstStyle/>
-          <a:p>
-            <a:r>
-              <a:rPr sz="1000" b="0" i="1">
-                <a:solidFill>
-                  <a:srgbClr val="6A6760"/>
-                </a:solidFill>
-                <a:latin typeface="Encode Sans"/>
-              </a:rPr>
-              <a:t>Fuente: elaboración propia en base a INDEC</a:t>
-            </a:r>
-          </a:p>
-        </p:txBody>
-      </p:sp>
-    </p:spTree>
-  </p:cSld>
-  <p:clrMapOvr>
-    <a:masterClrMapping/>
-  </p:clrMapOvr>
-</p:sld>
-</file>
-
-<file path=ppt/slides/slide3.xml><?xml version="1.0" encoding="utf-8"?>
-<p:sld xmlns:a="http://schemas.openxmlformats.org/drawingml/2006/main" xmlns:p="http://schemas.openxmlformats.org/presentationml/2006/main" xmlns:r="http://schemas.openxmlformats.org/officeDocument/2006/relationships">
-  <p:cSld>
-    <p:spTree>
-      <p:nvGrpSpPr>
-        <p:cNvPr id="1" name=""/>
-        <p:cNvGrpSpPr/>
-        <p:nvPr/>
-      </p:nvGrpSpPr>
-      <p:grpSpPr/>
-      <p:sp>
-        <p:nvSpPr>
-          <p:cNvPr id="2" name="Rectangle 1"/>
-          <p:cNvSpPr/>
-          <p:nvPr/>
-        </p:nvSpPr>
-        <p:spPr>
-          <a:xfrm>
-            <a:off x="0" y="0"/>
-            <a:ext cx="12191695" cy="274320"/>
-          </a:xfrm>
-          <a:prstGeom prst="rect">
-            <a:avLst/>
-          </a:prstGeom>
-          <a:solidFill>
-            <a:srgbClr val="00B2C9"/>
-          </a:solidFill>
-          <a:ln>
-            <a:noFill/>
-          </a:ln>
-        </p:spPr>
-        <p:style>
-          <a:lnRef idx="1">
-            <a:schemeClr val="accent1"/>
-          </a:lnRef>
-          <a:fillRef idx="3">
-            <a:schemeClr val="accent1"/>
-          </a:fillRef>
-          <a:effectRef idx="2">
-            <a:schemeClr val="accent1"/>
-          </a:effectRef>
-          <a:fontRef idx="minor">
-            <a:schemeClr val="lt1"/>
-          </a:fontRef>
-        </p:style>
-        <p:txBody>
-          <a:bodyPr rtlCol="0" anchor="ctr"/>
-          <a:lstStyle/>
-          <a:p>
-            <a:pPr algn="ctr"/>
-          </a:p>
-        </p:txBody>
-      </p:sp>
-      <p:sp>
-        <p:nvSpPr>
-          <p:cNvPr id="3" name="TextBox 2"/>
-          <p:cNvSpPr txBox="1"/>
-          <p:nvPr/>
-        </p:nvSpPr>
-        <p:spPr>
-          <a:xfrm>
-            <a:off x="411480" y="457200"/>
-            <a:ext cx="11368735" cy="914400"/>
-          </a:xfrm>
-          <a:prstGeom prst="rect">
-            <a:avLst/>
-          </a:prstGeom>
-          <a:noFill/>
-        </p:spPr>
-        <p:txBody>
-          <a:bodyPr wrap="square" lIns="0" rIns="0">
-            <a:spAutoFit/>
-          </a:bodyPr>
-          <a:lstStyle/>
-          <a:p>
-            <a:pPr algn="l"/>
-            <a:r>
-              <a:rPr sz="2600" b="1" i="0">
-                <a:solidFill>
-                  <a:srgbClr val="00B2C9"/>
-                </a:solidFill>
-                <a:latin typeface="Encode Sans"/>
-              </a:rPr>
-              <a:t>INDUSTRIA AGOSTO 2026: IPI CRECIÓ +0.0% I.A.</a:t>
-            </a:r>
-          </a:p>
-        </p:txBody>
-      </p:sp>
-      <p:sp>
-        <p:nvSpPr>
-          <p:cNvPr id="4" name="TextBox 3"/>
-          <p:cNvSpPr txBox="1"/>
-          <p:nvPr/>
-        </p:nvSpPr>
-        <p:spPr>
-          <a:xfrm>
-            <a:off x="411480" y="1280160"/>
-            <a:ext cx="11368735" cy="274320"/>
-          </a:xfrm>
-          <a:prstGeom prst="rect">
-            <a:avLst/>
-          </a:prstGeom>
-          <a:noFill/>
-        </p:spPr>
-        <p:txBody>
-          <a:bodyPr wrap="none">
-            <a:spAutoFit/>
-          </a:bodyPr>
-          <a:lstStyle/>
-          <a:p>
-            <a:r>
-              <a:rPr sz="1100" b="0" i="1">
-                <a:solidFill>
-                  <a:srgbClr val="6A6760"/>
-                </a:solidFill>
-                <a:latin typeface="Encode Sans"/>
-              </a:rPr>
-              <a:t>INDEC · período 2026-08</a:t>
-            </a:r>
-          </a:p>
-        </p:txBody>
-      </p:sp>
-      <p:sp>
-        <p:nvSpPr>
-          <p:cNvPr id="5" name="TextBox 4"/>
-          <p:cNvSpPr txBox="1"/>
-          <p:nvPr/>
-        </p:nvSpPr>
-        <p:spPr>
-          <a:xfrm>
-            <a:off x="411480" y="1691640"/>
-            <a:ext cx="5486400" cy="1645920"/>
-          </a:xfrm>
-          <a:prstGeom prst="rect">
-            <a:avLst/>
-          </a:prstGeom>
-          <a:noFill/>
-        </p:spPr>
-        <p:txBody>
-          <a:bodyPr wrap="square" lIns="0" rIns="0">
-            <a:spAutoFit/>
-          </a:bodyPr>
-          <a:lstStyle/>
-          <a:p>
-            <a:pPr algn="just"/>
-            <a:r>
-              <a:rPr sz="1300" b="0" i="0">
-                <a:solidFill>
-                  <a:srgbClr val="3F3F3F"/>
-                </a:solidFill>
-                <a:latin typeface="Encode Sans"/>
-              </a:rPr>
-              <a:t>El Índice de Producción Industrial Manufacturero (IPI) registró una variación interanual de +0.0% en agosto 2026.</a:t>
-            </a:r>
-          </a:p>
-        </p:txBody>
-      </p:sp>
-      <p:sp>
-        <p:nvSpPr>
-          <p:cNvPr id="6" name="TextBox 5"/>
-          <p:cNvSpPr txBox="1"/>
-          <p:nvPr/>
-        </p:nvSpPr>
-        <p:spPr>
-          <a:xfrm>
-            <a:off x="411480" y="3520440"/>
-            <a:ext cx="5486400" cy="2743200"/>
-          </a:xfrm>
-          <a:prstGeom prst="rect">
-            <a:avLst/>
-          </a:prstGeom>
-          <a:noFill/>
-        </p:spPr>
-        <p:txBody>
-          <a:bodyPr wrap="square" lIns="0" rIns="0">
-            <a:spAutoFit/>
-          </a:bodyPr>
-          <a:lstStyle/>
-          <a:p>
-            <a:pPr algn="l">
-              <a:spcAft>
-                <a:spcPts val="800"/>
-              </a:spcAft>
-            </a:pPr>
-            <a:r>
-              <a:rPr sz="1300" b="1" i="0">
-                <a:solidFill>
-                  <a:srgbClr val="00B2C9"/>
-                </a:solidFill>
-                <a:latin typeface="Encode Sans"/>
-              </a:rPr>
-              <a:t>●  </a:t>
-            </a:r>
-            <a:r>
-              <a:rPr sz="1300" b="0" i="0">
-                <a:solidFill>
-                  <a:srgbClr val="3F3F3F"/>
-                </a:solidFill>
-                <a:latin typeface="Encode Sans"/>
-              </a:rPr>
-              <a:t>Variación interanual: +0.0%</a:t>
-            </a:r>
-          </a:p>
-          <a:p>
-            <a:pPr algn="l">
-              <a:spcAft>
-                <a:spcPts val="800"/>
-              </a:spcAft>
-            </a:pPr>
-            <a:r>
-              <a:rPr sz="1300" b="1" i="0">
-                <a:solidFill>
-                  <a:srgbClr val="00B2C9"/>
-                </a:solidFill>
-                <a:latin typeface="Encode Sans"/>
-              </a:rPr>
-              <a:t>●  </a:t>
-            </a:r>
-            <a:r>
-              <a:rPr sz="1300" b="0" i="0">
-                <a:solidFill>
-                  <a:srgbClr val="3F3F3F"/>
-                </a:solidFill>
-                <a:latin typeface="Encode Sans"/>
-              </a:rPr>
-              <a:t>Serie INDEC, base 2004=100. Mide la producción manufacturera (16 ramas).</a:t>
-            </a:r>
-          </a:p>
-        </p:txBody>
-      </p:sp>
-      <p:pic>
-        <p:nvPicPr>
-          <p:cNvPr id="7" name="Picture 6" descr="image.png"/>
-          <p:cNvPicPr>
-            <a:picLocks noChangeAspect="1"/>
-          </p:cNvPicPr>
-          <p:nvPr/>
-        </p:nvPicPr>
-        <p:blipFill>
-          <a:blip r:embed="rId2"/>
-          <a:stretch>
-            <a:fillRect/>
-          </a:stretch>
-        </p:blipFill>
-        <p:spPr>
-          <a:xfrm>
-            <a:off x="6080760" y="1691640"/>
-            <a:ext cx="5669280" cy="2560320"/>
-          </a:xfrm>
-          <a:prstGeom prst="rect">
-            <a:avLst/>
-          </a:prstGeom>
-        </p:spPr>
-      </p:pic>
-      <p:graphicFrame>
-        <p:nvGraphicFramePr>
-          <p:cNvPr id="8" name="Table 7"/>
-          <p:cNvGraphicFramePr>
-            <a:graphicFrameLocks noGrp="1"/>
-          </p:cNvGraphicFramePr>
-          <p:nvPr/>
-        </p:nvGraphicFramePr>
-        <p:xfrm>
-          <a:off x="6080760" y="4434840"/>
-          <a:ext cx="5669280" cy="2048256"/>
-        </p:xfrm>
-        <a:graphic>
-          <a:graphicData uri="http://schemas.openxmlformats.org/drawingml/2006/table">
-            <a:tbl>
-              <a:tblPr firstRow="1" bandRow="1">
-                <a:tableStyleId>{5C22544A-7EE6-4342-B048-85BDC9FD1C3A}</a:tableStyleId>
-              </a:tblPr>
-              <a:tblGrid>
-                <a:gridCol w="1889760"/>
-                <a:gridCol w="1889760"/>
-                <a:gridCol w="1889760"/>
-              </a:tblGrid>
-              <a:tr h="292608">
-                <a:tc>
-                  <a:txBody>
-                    <a:bodyPr/>
-                    <a:lstStyle/>
-                    <a:p>
-                      <a:pPr algn="l"/>
-                      <a:r>
-                        <a:rPr sz="1000" b="1">
-                          <a:solidFill>
-                            <a:srgbClr val="FFFFFF"/>
-                          </a:solidFill>
-                          <a:latin typeface="Encode Sans"/>
-                        </a:rPr>
-                        <a:t>Mes</a:t>
-                      </a:r>
-                    </a:p>
-                  </a:txBody>
-                  <a:tcPr marL="36576" marR="36576" marT="18288" marB="18288">
-                    <a:solidFill>
-                      <a:srgbClr val="00B2C9"/>
-                    </a:solidFill>
-                  </a:tcPr>
-                </a:tc>
-                <a:tc>
-                  <a:txBody>
-                    <a:bodyPr/>
-                    <a:lstStyle/>
-                    <a:p>
-                      <a:pPr algn="r"/>
-                      <a:r>
-                        <a:rPr sz="1000" b="1">
-                          <a:solidFill>
-                            <a:srgbClr val="FFFFFF"/>
-                          </a:solidFill>
-                          <a:latin typeface="Encode Sans"/>
-                        </a:rPr>
-                        <a:t>Original</a:t>
-                      </a:r>
-                    </a:p>
-                  </a:txBody>
-                  <a:tcPr marL="36576" marR="36576" marT="18288" marB="18288">
-                    <a:solidFill>
-                      <a:srgbClr val="00B2C9"/>
-                    </a:solidFill>
-                  </a:tcPr>
-                </a:tc>
-                <a:tc>
-                  <a:txBody>
-                    <a:bodyPr/>
-                    <a:lstStyle/>
-                    <a:p>
-                      <a:pPr algn="r"/>
-                      <a:r>
-                        <a:rPr sz="1000" b="1">
-                          <a:solidFill>
-                            <a:srgbClr val="FFFFFF"/>
-                          </a:solidFill>
-                          <a:latin typeface="Encode Sans"/>
-                        </a:rPr>
-                        <a:t>VIA %</a:t>
-                      </a:r>
-                    </a:p>
-                  </a:txBody>
-                  <a:tcPr marL="36576" marR="36576" marT="18288" marB="18288">
-                    <a:solidFill>
-                      <a:srgbClr val="00B2C9"/>
-                    </a:solidFill>
-                  </a:tcPr>
-                </a:tc>
-              </a:tr>
-              <a:tr h="292608">
-                <a:tc>
-                  <a:txBody>
-                    <a:bodyPr/>
-                    <a:lstStyle/>
-                    <a:p>
-                      <a:pPr algn="l"/>
-                      <a:r>
-                        <a:rPr sz="1000">
-                          <a:solidFill>
-                            <a:srgbClr val="3F3F3F"/>
-                          </a:solidFill>
-                          <a:latin typeface="Encode Sans"/>
-                        </a:rPr>
-                        <a:t>Agosto 2026</a:t>
-                      </a:r>
-                    </a:p>
-                  </a:txBody>
-                  <a:tcPr marL="36576" marR="36576" marT="18288" marB="18288">
-                    <a:solidFill>
-                      <a:srgbClr val="FFFFFF"/>
-                    </a:solidFill>
-                  </a:tcPr>
-                </a:tc>
-                <a:tc>
-                  <a:txBody>
-                    <a:bodyPr/>
-                    <a:lstStyle/>
-                    <a:p>
-                      <a:pPr algn="r"/>
-                      <a:r>
-                        <a:rPr sz="1000">
-                          <a:solidFill>
-                            <a:srgbClr val="3F3F3F"/>
-                          </a:solidFill>
-                          <a:latin typeface="Encode Sans"/>
-                        </a:rPr>
-                        <a:t>119,3</a:t>
-                      </a:r>
-                    </a:p>
-                  </a:txBody>
-                  <a:tcPr marL="36576" marR="36576" marT="18288" marB="18288">
-                    <a:solidFill>
-                      <a:srgbClr val="FFFFFF"/>
-                    </a:solidFill>
-                  </a:tcPr>
-                </a:tc>
-                <a:tc>
-                  <a:txBody>
-                    <a:bodyPr/>
-                    <a:lstStyle/>
-                    <a:p>
-                      <a:pPr algn="r"/>
-                      <a:r>
-                        <a:rPr sz="1000">
-                          <a:solidFill>
-                            <a:srgbClr val="3F3F3F"/>
-                          </a:solidFill>
-                          <a:latin typeface="Encode Sans"/>
-                        </a:rPr>
-                        <a:t>-3.2%</a:t>
-                      </a:r>
-                    </a:p>
-                  </a:txBody>
-                  <a:tcPr marL="36576" marR="36576" marT="18288" marB="18288">
-                    <a:solidFill>
-                      <a:srgbClr val="FFFFFF"/>
-                    </a:solidFill>
-                  </a:tcPr>
-                </a:tc>
-              </a:tr>
-              <a:tr h="292608">
-                <a:tc>
-                  <a:txBody>
-                    <a:bodyPr/>
-                    <a:lstStyle/>
-                    <a:p>
-                      <a:pPr algn="l"/>
-                      <a:r>
-                        <a:rPr sz="1000">
-                          <a:solidFill>
-                            <a:srgbClr val="3F3F3F"/>
-                          </a:solidFill>
-                          <a:latin typeface="Encode Sans"/>
-                        </a:rPr>
-                        <a:t>Julio 2026</a:t>
-                      </a:r>
-                    </a:p>
-                  </a:txBody>
-                  <a:tcPr marL="36576" marR="36576" marT="18288" marB="18288">
-                    <a:solidFill>
-                      <a:srgbClr val="F8F8F6"/>
-                    </a:solidFill>
-                  </a:tcPr>
-                </a:tc>
-                <a:tc>
-                  <a:txBody>
-                    <a:bodyPr/>
-                    <a:lstStyle/>
-                    <a:p>
-                      <a:pPr algn="r"/>
-                      <a:r>
-                        <a:rPr sz="1000">
-                          <a:solidFill>
-                            <a:srgbClr val="3F3F3F"/>
-                          </a:solidFill>
-                          <a:latin typeface="Encode Sans"/>
-                        </a:rPr>
-                        <a:t>118,1</a:t>
-                      </a:r>
-                    </a:p>
-                  </a:txBody>
-                  <a:tcPr marL="36576" marR="36576" marT="18288" marB="18288">
-                    <a:solidFill>
-                      <a:srgbClr val="F8F8F6"/>
-                    </a:solidFill>
-                  </a:tcPr>
-                </a:tc>
-                <a:tc>
-                  <a:txBody>
-                    <a:bodyPr/>
-                    <a:lstStyle/>
-                    <a:p>
-                      <a:pPr algn="r"/>
-                      <a:r>
-                        <a:rPr sz="1000">
-                          <a:solidFill>
-                            <a:srgbClr val="3F3F3F"/>
-                          </a:solidFill>
-                          <a:latin typeface="Encode Sans"/>
-                        </a:rPr>
-                        <a:t>-4.9%</a:t>
-                      </a:r>
-                    </a:p>
-                  </a:txBody>
-                  <a:tcPr marL="36576" marR="36576" marT="18288" marB="18288">
-                    <a:solidFill>
-                      <a:srgbClr val="F8F8F6"/>
-                    </a:solidFill>
-                  </a:tcPr>
-                </a:tc>
-              </a:tr>
-              <a:tr h="292608">
-                <a:tc>
-                  <a:txBody>
-                    <a:bodyPr/>
-                    <a:lstStyle/>
-                    <a:p>
-                      <a:pPr algn="l"/>
-                      <a:r>
-                        <a:rPr sz="1000">
-                          <a:solidFill>
-                            <a:srgbClr val="3F3F3F"/>
-                          </a:solidFill>
-                          <a:latin typeface="Encode Sans"/>
-                        </a:rPr>
-                        <a:t>Junio 2026</a:t>
-                      </a:r>
-                    </a:p>
-                  </a:txBody>
-                  <a:tcPr marL="36576" marR="36576" marT="18288" marB="18288">
-                    <a:solidFill>
-                      <a:srgbClr val="FFFFFF"/>
-                    </a:solidFill>
-                  </a:tcPr>
-                </a:tc>
-                <a:tc>
-                  <a:txBody>
-                    <a:bodyPr/>
-                    <a:lstStyle/>
-                    <a:p>
-                      <a:pPr algn="r"/>
-                      <a:r>
-                        <a:rPr sz="1000">
-                          <a:solidFill>
-                            <a:srgbClr val="3F3F3F"/>
-                          </a:solidFill>
-                          <a:latin typeface="Encode Sans"/>
-                        </a:rPr>
-                        <a:t>119,8</a:t>
-                      </a:r>
-                    </a:p>
-                  </a:txBody>
-                  <a:tcPr marL="36576" marR="36576" marT="18288" marB="18288">
-                    <a:solidFill>
-                      <a:srgbClr val="FFFFFF"/>
-                    </a:solidFill>
-                  </a:tcPr>
-                </a:tc>
-                <a:tc>
-                  <a:txBody>
-                    <a:bodyPr/>
-                    <a:lstStyle/>
-                    <a:p>
-                      <a:pPr algn="r"/>
-                      <a:r>
-                        <a:rPr sz="1000">
-                          <a:solidFill>
-                            <a:srgbClr val="3F3F3F"/>
-                          </a:solidFill>
-                          <a:latin typeface="Encode Sans"/>
-                        </a:rPr>
-                        <a:t>+2.0%</a:t>
-                      </a:r>
-                    </a:p>
-                  </a:txBody>
-                  <a:tcPr marL="36576" marR="36576" marT="18288" marB="18288">
-                    <a:solidFill>
-                      <a:srgbClr val="FFFFFF"/>
-                    </a:solidFill>
-                  </a:tcPr>
-                </a:tc>
-              </a:tr>
-              <a:tr h="292608">
-                <a:tc>
-                  <a:txBody>
-                    <a:bodyPr/>
-                    <a:lstStyle/>
-                    <a:p>
-                      <a:pPr algn="l"/>
-                      <a:r>
-                        <a:rPr sz="1000">
-                          <a:solidFill>
-                            <a:srgbClr val="3F3F3F"/>
-                          </a:solidFill>
-                          <a:latin typeface="Encode Sans"/>
-                        </a:rPr>
-                        <a:t>Mayo 2026</a:t>
-                      </a:r>
-                    </a:p>
-                  </a:txBody>
-                  <a:tcPr marL="36576" marR="36576" marT="18288" marB="18288">
-                    <a:solidFill>
-                      <a:srgbClr val="F8F8F6"/>
-                    </a:solidFill>
-                  </a:tcPr>
-                </a:tc>
-                <a:tc>
-                  <a:txBody>
-                    <a:bodyPr/>
-                    <a:lstStyle/>
-                    <a:p>
-                      <a:pPr algn="r"/>
-                      <a:r>
-                        <a:rPr sz="1000">
-                          <a:solidFill>
-                            <a:srgbClr val="3F3F3F"/>
-                          </a:solidFill>
-                          <a:latin typeface="Encode Sans"/>
-                        </a:rPr>
-                        <a:t>116,9</a:t>
-                      </a:r>
-                    </a:p>
-                  </a:txBody>
-                  <a:tcPr marL="36576" marR="36576" marT="18288" marB="18288">
-                    <a:solidFill>
-                      <a:srgbClr val="F8F8F6"/>
-                    </a:solidFill>
-                  </a:tcPr>
-                </a:tc>
-                <a:tc>
-                  <a:txBody>
-                    <a:bodyPr/>
-                    <a:lstStyle/>
-                    <a:p>
-                      <a:pPr algn="r"/>
-                      <a:r>
-                        <a:rPr sz="1000">
-                          <a:solidFill>
-                            <a:srgbClr val="3F3F3F"/>
-                          </a:solidFill>
-                          <a:latin typeface="Encode Sans"/>
-                        </a:rPr>
-                        <a:t>-5.7%</a:t>
-                      </a:r>
-                    </a:p>
-                  </a:txBody>
-                  <a:tcPr marL="36576" marR="36576" marT="18288" marB="18288">
-                    <a:solidFill>
-                      <a:srgbClr val="F8F8F6"/>
-                    </a:solidFill>
-                  </a:tcPr>
-                </a:tc>
-              </a:tr>
-              <a:tr h="292608">
-                <a:tc>
-                  <a:txBody>
-                    <a:bodyPr/>
-                    <a:lstStyle/>
-                    <a:p>
-                      <a:pPr algn="l"/>
-                      <a:r>
-                        <a:rPr sz="1000">
-                          <a:solidFill>
-                            <a:srgbClr val="3F3F3F"/>
-                          </a:solidFill>
-                          <a:latin typeface="Encode Sans"/>
-                        </a:rPr>
-                        <a:t>Abril 2026</a:t>
-                      </a:r>
-                    </a:p>
-                  </a:txBody>
-                  <a:tcPr marL="36576" marR="36576" marT="18288" marB="18288">
-                    <a:solidFill>
-                      <a:srgbClr val="FFFFFF"/>
-                    </a:solidFill>
-                  </a:tcPr>
-                </a:tc>
-                <a:tc>
-                  <a:txBody>
-                    <a:bodyPr/>
-                    <a:lstStyle/>
-                    <a:p>
-                      <a:pPr algn="r"/>
-                      <a:r>
-                        <a:rPr sz="1000">
-                          <a:solidFill>
-                            <a:srgbClr val="3F3F3F"/>
-                          </a:solidFill>
-                          <a:latin typeface="Encode Sans"/>
-                        </a:rPr>
-                        <a:t>118,5</a:t>
-                      </a:r>
-                    </a:p>
-                  </a:txBody>
-                  <a:tcPr marL="36576" marR="36576" marT="18288" marB="18288">
-                    <a:solidFill>
-                      <a:srgbClr val="FFFFFF"/>
-                    </a:solidFill>
-                  </a:tcPr>
-                </a:tc>
-                <a:tc>
-                  <a:txBody>
-                    <a:bodyPr/>
-                    <a:lstStyle/>
-                    <a:p>
-                      <a:pPr algn="r"/>
-                      <a:r>
-                        <a:rPr sz="1000">
-                          <a:solidFill>
-                            <a:srgbClr val="3F3F3F"/>
-                          </a:solidFill>
-                          <a:latin typeface="Encode Sans"/>
-                        </a:rPr>
-                        <a:t>-2.4%</a:t>
-                      </a:r>
-                    </a:p>
-                  </a:txBody>
-                  <a:tcPr marL="36576" marR="36576" marT="18288" marB="18288">
-                    <a:solidFill>
-                      <a:srgbClr val="FFFFFF"/>
-                    </a:solidFill>
-                  </a:tcPr>
-                </a:tc>
-              </a:tr>
-              <a:tr h="292608">
-                <a:tc>
-                  <a:txBody>
-                    <a:bodyPr/>
-                    <a:lstStyle/>
-                    <a:p>
-                      <a:pPr algn="l"/>
-                      <a:r>
-                        <a:rPr sz="1000">
-                          <a:solidFill>
-                            <a:srgbClr val="3F3F3F"/>
-                          </a:solidFill>
-                          <a:latin typeface="Encode Sans"/>
-                        </a:rPr>
-                        <a:t>Marzo 2026</a:t>
-                      </a:r>
-                    </a:p>
-                  </a:txBody>
-                  <a:tcPr marL="36576" marR="36576" marT="18288" marB="18288">
-                    <a:solidFill>
-                      <a:srgbClr val="F8F8F6"/>
-                    </a:solidFill>
-                  </a:tcPr>
-                </a:tc>
-                <a:tc>
-                  <a:txBody>
-                    <a:bodyPr/>
-                    <a:lstStyle/>
-                    <a:p>
-                      <a:pPr algn="r"/>
-                      <a:r>
-                        <a:rPr sz="1000">
-                          <a:solidFill>
-                            <a:srgbClr val="3F3F3F"/>
-                          </a:solidFill>
-                          <a:latin typeface="Encode Sans"/>
-                        </a:rPr>
-                        <a:t>122,1</a:t>
-                      </a:r>
-                    </a:p>
-                  </a:txBody>
-                  <a:tcPr marL="36576" marR="36576" marT="18288" marB="18288">
-                    <a:solidFill>
-                      <a:srgbClr val="F8F8F6"/>
-                    </a:solidFill>
-                  </a:tcPr>
-                </a:tc>
-                <a:tc>
-                  <a:txBody>
-                    <a:bodyPr/>
-                    <a:lstStyle/>
-                    <a:p>
-                      <a:pPr algn="r"/>
-                      <a:r>
-                        <a:rPr sz="1000">
-                          <a:solidFill>
-                            <a:srgbClr val="3F3F3F"/>
-                          </a:solidFill>
-                          <a:latin typeface="Encode Sans"/>
-                        </a:rPr>
-                        <a:t>+5.0%</a:t>
+                        <a:t>+32.4%</a:t>
                       </a:r>
                     </a:p>
                   </a:txBody>

</xml_diff>

<commit_message>
data: update 2026-10-15 ( data.json despidos.json scraper/historical_despidos.json publicaciones_semana.pptx rrii_brutas.xlsx)
</commit_message>
<xml_diff>
--- a/publicaciones_semana.pptx
+++ b/publicaciones_semana.pptx
@@ -3437,7 +3437,7 @@
                 </a:solidFill>
                 <a:latin typeface="Encode Sans"/>
               </a:rPr>
-              <a:t>El IPC nivel general aumentó +1.9% mensual en septiembre 2026, acumulando 33.31% interanual. INDEC publicó el indicador con la metodología vigente.</a:t>
+              <a:t>El IPC nivel general aumentó +1.9% mensual en septiembre 2026, acumulando 33.32% interanual. INDEC publicó el indicador con la metodología vigente.</a:t>
             </a:r>
           </a:p>
         </p:txBody>
@@ -3510,7 +3510,7 @@
                 </a:solidFill>
                 <a:latin typeface="Encode Sans"/>
               </a:rPr>
-              <a:t>Variación interanual: 33.31%</a:t>
+              <a:t>Variación interanual: 33.32%</a:t>
             </a:r>
           </a:p>
           <a:p>
@@ -4002,7 +4002,7 @@
                           </a:solidFill>
                           <a:latin typeface="Encode Sans"/>
                         </a:rPr>
-                        <a:t>+33.2%</a:t>
+                        <a:t>+33.1%</a:t>
                       </a:r>
                     </a:p>
                   </a:txBody>

</xml_diff>

<commit_message>
data: update 2026-10-16 ( data.json despidos.json scraper/historical_despidos.json scraper/calendar_oficial.json publicaciones_semana.pptx rrii_brutas.xlsx)
</commit_message>
<xml_diff>
--- a/publicaciones_semana.pptx
+++ b/publicaciones_semana.pptx
@@ -3438,7 +3438,7 @@
                 </a:solidFill>
                 <a:latin typeface="Encode Sans"/>
               </a:rPr>
-              <a:t>El IPC nivel general aumentó +1.9% mensual en septiembre 2026, acumulando 33.31% interanual. INDEC publicó el indicador con la metodología vigente.</a:t>
+              <a:t>El IPC nivel general aumentó +1.9% mensual en septiembre 2026, acumulando 33.32% interanual. INDEC publicó el indicador con la metodología vigente.</a:t>
             </a:r>
           </a:p>
         </p:txBody>
@@ -3511,7 +3511,7 @@
                 </a:solidFill>
                 <a:latin typeface="Encode Sans"/>
               </a:rPr>
-              <a:t>Variación interanual: 33.31%</a:t>
+              <a:t>Variación interanual: 33.32%</a:t>
             </a:r>
           </a:p>
           <a:p>
@@ -4003,7 +4003,7 @@
                           </a:solidFill>
                           <a:latin typeface="Encode Sans"/>
                         </a:rPr>
-                        <a:t>+33.2%</a:t>
+                        <a:t>+33.1%</a:t>
                       </a:r>
                     </a:p>
                   </a:txBody>

</xml_diff>

<commit_message>
data: update 2026-10-17 ( data.json despidos.json scraper/historical_despidos.json scraper/calendar_oficial.json publicaciones_semana.pptx rrii_brutas.xlsx)
</commit_message>
<xml_diff>
--- a/publicaciones_semana.pptx
+++ b/publicaciones_semana.pptx
@@ -5982,7 +5982,7 @@
                 </a:solidFill>
                 <a:latin typeface="Encode Sans"/>
               </a:rPr>
-              <a:t>El IPC nivel general aumentó +1.9% mensual en septiembre 2026, acumulando 33.36% interanual. INDEC publicó el indicador con la metodología vigente.</a:t>
+              <a:t>El IPC nivel general aumentó +1.9% mensual en septiembre 2026, acumulando 33.31% interanual. INDEC publicó el indicador con la metodología vigente.</a:t>
             </a:r>
           </a:p>
         </p:txBody>
@@ -6055,7 +6055,7 @@
                 </a:solidFill>
                 <a:latin typeface="Encode Sans"/>
               </a:rPr>
-              <a:t>Variación interanual: 33.36%</a:t>
+              <a:t>Variación interanual: 33.31%</a:t>
             </a:r>
           </a:p>
           <a:p>
@@ -6263,7 +6263,7 @@
                           </a:solidFill>
                           <a:latin typeface="Encode Sans"/>
                         </a:rPr>
-                        <a:t>+33.4%</a:t>
+                        <a:t>+33.3%</a:t>
                       </a:r>
                     </a:p>
                   </a:txBody>
@@ -6334,7 +6334,7 @@
                           </a:solidFill>
                           <a:latin typeface="Encode Sans"/>
                         </a:rPr>
-                        <a:t>+33.6%</a:t>
+                        <a:t>+33.5%</a:t>
                       </a:r>
                     </a:p>
                   </a:txBody>

</xml_diff>

<commit_message>
data: update 2026-10-22 ( data.json despidos.json scraper/historical_despidos.json publicaciones_semana.pptx rrii_brutas.xlsx)
</commit_message>
<xml_diff>
--- a/publicaciones_semana.pptx
+++ b/publicaciones_semana.pptx
@@ -8,6 +8,7 @@
     <p:sldId id="256" r:id="rId7"/>
     <p:sldId id="257" r:id="rId8"/>
     <p:sldId id="258" r:id="rId9"/>
+    <p:sldId id="259" r:id="rId10"/>
   </p:sldIdLst>
   <p:sldSz cx="12191695" cy="6858000" type="screen4x3"/>
   <p:notesSz cx="6858000" cy="9144000"/>
@@ -3273,7 +3274,7 @@
                 </a:solidFill>
                 <a:latin typeface="Encode Sans"/>
               </a:rPr>
-              <a:t>2 publicaciones · datos oficiales INDEC / BCRA / Hacienda</a:t>
+              <a:t>3 publicaciones · datos oficiales INDEC / BCRA / Hacienda</a:t>
             </a:r>
           </a:p>
         </p:txBody>
@@ -5269,6 +5270,1013 @@
                           <a:latin typeface="Encode Sans"/>
                         </a:rPr>
                         <a:t>7.344</a:t>
+                      </a:r>
+                    </a:p>
+                  </a:txBody>
+                  <a:tcPr marL="36576" marR="36576" marT="18288" marB="18288">
+                    <a:solidFill>
+                      <a:srgbClr val="F8F8F6"/>
+                    </a:solidFill>
+                  </a:tcPr>
+                </a:tc>
+              </a:tr>
+            </a:tbl>
+          </a:graphicData>
+        </a:graphic>
+      </p:graphicFrame>
+      <p:sp>
+        <p:nvSpPr>
+          <p:cNvPr id="9" name="TextBox 8"/>
+          <p:cNvSpPr txBox="1"/>
+          <p:nvPr/>
+        </p:nvSpPr>
+        <p:spPr>
+          <a:xfrm>
+            <a:off x="411480" y="6492240"/>
+            <a:ext cx="11368735" cy="274320"/>
+          </a:xfrm>
+          <a:prstGeom prst="rect">
+            <a:avLst/>
+          </a:prstGeom>
+          <a:noFill/>
+        </p:spPr>
+        <p:txBody>
+          <a:bodyPr wrap="none">
+            <a:spAutoFit/>
+          </a:bodyPr>
+          <a:lstStyle/>
+          <a:p>
+            <a:r>
+              <a:rPr sz="1000" b="0" i="1">
+                <a:solidFill>
+                  <a:srgbClr val="6A6760"/>
+                </a:solidFill>
+                <a:latin typeface="Encode Sans"/>
+              </a:rPr>
+              <a:t>Fuente: elaboración propia en base a INDEC</a:t>
+            </a:r>
+          </a:p>
+        </p:txBody>
+      </p:sp>
+    </p:spTree>
+  </p:cSld>
+  <p:clrMapOvr>
+    <a:masterClrMapping/>
+  </p:clrMapOvr>
+</p:sld>
+</file>
+
+<file path=ppt/slides/slide4.xml><?xml version="1.0" encoding="utf-8"?>
+<p:sld xmlns:a="http://schemas.openxmlformats.org/drawingml/2006/main" xmlns:p="http://schemas.openxmlformats.org/presentationml/2006/main" xmlns:r="http://schemas.openxmlformats.org/officeDocument/2006/relationships">
+  <p:cSld>
+    <p:spTree>
+      <p:nvGrpSpPr>
+        <p:cNvPr id="1" name=""/>
+        <p:cNvGrpSpPr/>
+        <p:nvPr/>
+      </p:nvGrpSpPr>
+      <p:grpSpPr/>
+      <p:sp>
+        <p:nvSpPr>
+          <p:cNvPr id="2" name="Rectangle 1"/>
+          <p:cNvSpPr/>
+          <p:nvPr/>
+        </p:nvSpPr>
+        <p:spPr>
+          <a:xfrm>
+            <a:off x="0" y="0"/>
+            <a:ext cx="12191695" cy="274320"/>
+          </a:xfrm>
+          <a:prstGeom prst="rect">
+            <a:avLst/>
+          </a:prstGeom>
+          <a:solidFill>
+            <a:srgbClr val="00B2C9"/>
+          </a:solidFill>
+          <a:ln>
+            <a:noFill/>
+          </a:ln>
+        </p:spPr>
+        <p:style>
+          <a:lnRef idx="1">
+            <a:schemeClr val="accent1"/>
+          </a:lnRef>
+          <a:fillRef idx="3">
+            <a:schemeClr val="accent1"/>
+          </a:fillRef>
+          <a:effectRef idx="2">
+            <a:schemeClr val="accent1"/>
+          </a:effectRef>
+          <a:fontRef idx="minor">
+            <a:schemeClr val="lt1"/>
+          </a:fontRef>
+        </p:style>
+        <p:txBody>
+          <a:bodyPr rtlCol="0" anchor="ctr"/>
+          <a:lstStyle/>
+          <a:p>
+            <a:pPr algn="ctr"/>
+          </a:p>
+        </p:txBody>
+      </p:sp>
+      <p:sp>
+        <p:nvSpPr>
+          <p:cNvPr id="3" name="TextBox 2"/>
+          <p:cNvSpPr txBox="1"/>
+          <p:nvPr/>
+        </p:nvSpPr>
+        <p:spPr>
+          <a:xfrm>
+            <a:off x="411480" y="457200"/>
+            <a:ext cx="11368735" cy="914400"/>
+          </a:xfrm>
+          <a:prstGeom prst="rect">
+            <a:avLst/>
+          </a:prstGeom>
+          <a:noFill/>
+        </p:spPr>
+        <p:txBody>
+          <a:bodyPr wrap="square" lIns="0" rIns="0">
+            <a:spAutoFit/>
+          </a:bodyPr>
+          <a:lstStyle/>
+          <a:p>
+            <a:pPr algn="l"/>
+            <a:r>
+              <a:rPr sz="2600" b="1" i="0">
+                <a:solidFill>
+                  <a:srgbClr val="00B2C9"/>
+                </a:solidFill>
+                <a:latin typeface="Encode Sans"/>
+              </a:rPr>
+              <a:t>SUPERMERCADOS AGOSTO 2026: VENTAS REALES CAYERON -3.7%</a:t>
+            </a:r>
+          </a:p>
+        </p:txBody>
+      </p:sp>
+      <p:sp>
+        <p:nvSpPr>
+          <p:cNvPr id="4" name="TextBox 3"/>
+          <p:cNvSpPr txBox="1"/>
+          <p:nvPr/>
+        </p:nvSpPr>
+        <p:spPr>
+          <a:xfrm>
+            <a:off x="411480" y="1280160"/>
+            <a:ext cx="11368735" cy="274320"/>
+          </a:xfrm>
+          <a:prstGeom prst="rect">
+            <a:avLst/>
+          </a:prstGeom>
+          <a:noFill/>
+        </p:spPr>
+        <p:txBody>
+          <a:bodyPr wrap="none">
+            <a:spAutoFit/>
+          </a:bodyPr>
+          <a:lstStyle/>
+          <a:p>
+            <a:r>
+              <a:rPr sz="1100" b="0" i="1">
+                <a:solidFill>
+                  <a:srgbClr val="6A6760"/>
+                </a:solidFill>
+                <a:latin typeface="Encode Sans"/>
+              </a:rPr>
+              <a:t>INDEC · período 2026-08</a:t>
+            </a:r>
+          </a:p>
+        </p:txBody>
+      </p:sp>
+      <p:sp>
+        <p:nvSpPr>
+          <p:cNvPr id="5" name="TextBox 4"/>
+          <p:cNvSpPr txBox="1"/>
+          <p:nvPr/>
+        </p:nvSpPr>
+        <p:spPr>
+          <a:xfrm>
+            <a:off x="411480" y="1691640"/>
+            <a:ext cx="5486400" cy="1645920"/>
+          </a:xfrm>
+          <a:prstGeom prst="rect">
+            <a:avLst/>
+          </a:prstGeom>
+          <a:noFill/>
+        </p:spPr>
+        <p:txBody>
+          <a:bodyPr wrap="square" lIns="0" rIns="0">
+            <a:spAutoFit/>
+          </a:bodyPr>
+          <a:lstStyle/>
+          <a:p>
+            <a:pPr algn="just"/>
+            <a:r>
+              <a:rPr sz="1300" b="0" i="0">
+                <a:solidFill>
+                  <a:srgbClr val="3F3F3F"/>
+                </a:solidFill>
+                <a:latin typeface="Encode Sans"/>
+              </a:rPr>
+              <a:t>Las ventas de supermercados a precios constantes registraron una variación interanual real de -3.7% en agosto 2026. Desestacionalizada: -0.8% m/m.</a:t>
+            </a:r>
+          </a:p>
+        </p:txBody>
+      </p:sp>
+      <p:sp>
+        <p:nvSpPr>
+          <p:cNvPr id="6" name="TextBox 5"/>
+          <p:cNvSpPr txBox="1"/>
+          <p:nvPr/>
+        </p:nvSpPr>
+        <p:spPr>
+          <a:xfrm>
+            <a:off x="411480" y="3520440"/>
+            <a:ext cx="5486400" cy="2743200"/>
+          </a:xfrm>
+          <a:prstGeom prst="rect">
+            <a:avLst/>
+          </a:prstGeom>
+          <a:noFill/>
+        </p:spPr>
+        <p:txBody>
+          <a:bodyPr wrap="square" lIns="0" rIns="0">
+            <a:spAutoFit/>
+          </a:bodyPr>
+          <a:lstStyle/>
+          <a:p>
+            <a:pPr algn="l">
+              <a:spcAft>
+                <a:spcPts val="800"/>
+              </a:spcAft>
+            </a:pPr>
+            <a:r>
+              <a:rPr sz="1300" b="1" i="0">
+                <a:solidFill>
+                  <a:srgbClr val="00B2C9"/>
+                </a:solidFill>
+                <a:latin typeface="Encode Sans"/>
+              </a:rPr>
+              <a:t>●  </a:t>
+            </a:r>
+            <a:r>
+              <a:rPr sz="1300" b="0" i="0">
+                <a:solidFill>
+                  <a:srgbClr val="3F3F3F"/>
+                </a:solidFill>
+                <a:latin typeface="Encode Sans"/>
+              </a:rPr>
+              <a:t>Variación interanual real: -3.7%</a:t>
+            </a:r>
+          </a:p>
+          <a:p>
+            <a:pPr algn="l">
+              <a:spcAft>
+                <a:spcPts val="800"/>
+              </a:spcAft>
+            </a:pPr>
+            <a:r>
+              <a:rPr sz="1300" b="1" i="0">
+                <a:solidFill>
+                  <a:srgbClr val="00B2C9"/>
+                </a:solidFill>
+                <a:latin typeface="Encode Sans"/>
+              </a:rPr>
+              <a:t>●  </a:t>
+            </a:r>
+            <a:r>
+              <a:rPr sz="1300" b="0" i="0">
+                <a:solidFill>
+                  <a:srgbClr val="3F3F3F"/>
+                </a:solidFill>
+                <a:latin typeface="Encode Sans"/>
+              </a:rPr>
+              <a:t>Variación mensual desestacionalizada: -0.8%</a:t>
+            </a:r>
+          </a:p>
+          <a:p>
+            <a:pPr algn="l">
+              <a:spcAft>
+                <a:spcPts val="800"/>
+              </a:spcAft>
+            </a:pPr>
+            <a:r>
+              <a:rPr sz="1300" b="1" i="0">
+                <a:solidFill>
+                  <a:srgbClr val="00B2C9"/>
+                </a:solidFill>
+                <a:latin typeface="Encode Sans"/>
+              </a:rPr>
+              <a:t>●  </a:t>
+            </a:r>
+            <a:r>
+              <a:rPr sz="1300" b="0" i="0">
+                <a:solidFill>
+                  <a:srgbClr val="3F3F3F"/>
+                </a:solidFill>
+                <a:latin typeface="Encode Sans"/>
+              </a:rPr>
+              <a:t>Acumulado del año: -2.9%</a:t>
+            </a:r>
+          </a:p>
+        </p:txBody>
+      </p:sp>
+      <p:pic>
+        <p:nvPicPr>
+          <p:cNvPr id="7" name="Picture 6" descr="image.png"/>
+          <p:cNvPicPr>
+            <a:picLocks noChangeAspect="1"/>
+          </p:cNvPicPr>
+          <p:nvPr/>
+        </p:nvPicPr>
+        <p:blipFill>
+          <a:blip r:embed="rId2"/>
+          <a:stretch>
+            <a:fillRect/>
+          </a:stretch>
+        </p:blipFill>
+        <p:spPr>
+          <a:xfrm>
+            <a:off x="6080760" y="1691640"/>
+            <a:ext cx="5669280" cy="2560320"/>
+          </a:xfrm>
+          <a:prstGeom prst="rect">
+            <a:avLst/>
+          </a:prstGeom>
+        </p:spPr>
+      </p:pic>
+      <p:graphicFrame>
+        <p:nvGraphicFramePr>
+          <p:cNvPr id="8" name="Table 7"/>
+          <p:cNvGraphicFramePr>
+            <a:graphicFrameLocks noGrp="1"/>
+          </p:cNvGraphicFramePr>
+          <p:nvPr/>
+        </p:nvGraphicFramePr>
+        <p:xfrm>
+          <a:off x="6080760" y="4434840"/>
+          <a:ext cx="5669280" cy="2048256"/>
+        </p:xfrm>
+        <a:graphic>
+          <a:graphicData uri="http://schemas.openxmlformats.org/drawingml/2006/table">
+            <a:tbl>
+              <a:tblPr firstRow="1" bandRow="1">
+                <a:tableStyleId>{5C22544A-7EE6-4342-B048-85BDC9FD1C3A}</a:tableStyleId>
+              </a:tblPr>
+              <a:tblGrid>
+                <a:gridCol w="1417320"/>
+                <a:gridCol w="1417320"/>
+                <a:gridCol w="1417320"/>
+                <a:gridCol w="1417320"/>
+              </a:tblGrid>
+              <a:tr h="292608">
+                <a:tc>
+                  <a:txBody>
+                    <a:bodyPr/>
+                    <a:lstStyle/>
+                    <a:p>
+                      <a:pPr algn="l"/>
+                      <a:r>
+                        <a:rPr sz="1000" b="1">
+                          <a:solidFill>
+                            <a:srgbClr val="FFFFFF"/>
+                          </a:solidFill>
+                          <a:latin typeface="Encode Sans"/>
+                        </a:rPr>
+                        <a:t>Mes</a:t>
+                      </a:r>
+                    </a:p>
+                  </a:txBody>
+                  <a:tcPr marL="36576" marR="36576" marT="18288" marB="18288">
+                    <a:solidFill>
+                      <a:srgbClr val="00B2C9"/>
+                    </a:solidFill>
+                  </a:tcPr>
+                </a:tc>
+                <a:tc>
+                  <a:txBody>
+                    <a:bodyPr/>
+                    <a:lstStyle/>
+                    <a:p>
+                      <a:pPr algn="r"/>
+                      <a:r>
+                        <a:rPr sz="1000" b="1">
+                          <a:solidFill>
+                            <a:srgbClr val="FFFFFF"/>
+                          </a:solidFill>
+                          <a:latin typeface="Encode Sans"/>
+                        </a:rPr>
+                        <a:t>Índice real</a:t>
+                      </a:r>
+                    </a:p>
+                  </a:txBody>
+                  <a:tcPr marL="36576" marR="36576" marT="18288" marB="18288">
+                    <a:solidFill>
+                      <a:srgbClr val="00B2C9"/>
+                    </a:solidFill>
+                  </a:tcPr>
+                </a:tc>
+                <a:tc>
+                  <a:txBody>
+                    <a:bodyPr/>
+                    <a:lstStyle/>
+                    <a:p>
+                      <a:pPr algn="r"/>
+                      <a:r>
+                        <a:rPr sz="1000" b="1">
+                          <a:solidFill>
+                            <a:srgbClr val="FFFFFF"/>
+                          </a:solidFill>
+                          <a:latin typeface="Encode Sans"/>
+                        </a:rPr>
+                        <a:t>VIA real %</a:t>
+                      </a:r>
+                    </a:p>
+                  </a:txBody>
+                  <a:tcPr marL="36576" marR="36576" marT="18288" marB="18288">
+                    <a:solidFill>
+                      <a:srgbClr val="00B2C9"/>
+                    </a:solidFill>
+                  </a:tcPr>
+                </a:tc>
+                <a:tc>
+                  <a:txBody>
+                    <a:bodyPr/>
+                    <a:lstStyle/>
+                    <a:p>
+                      <a:pPr algn="r"/>
+                      <a:r>
+                        <a:rPr sz="1000" b="1">
+                          <a:solidFill>
+                            <a:srgbClr val="FFFFFF"/>
+                          </a:solidFill>
+                          <a:latin typeface="Encode Sans"/>
+                        </a:rPr>
+                        <a:t>Acumulado %</a:t>
+                      </a:r>
+                    </a:p>
+                  </a:txBody>
+                  <a:tcPr marL="36576" marR="36576" marT="18288" marB="18288">
+                    <a:solidFill>
+                      <a:srgbClr val="00B2C9"/>
+                    </a:solidFill>
+                  </a:tcPr>
+                </a:tc>
+              </a:tr>
+              <a:tr h="292608">
+                <a:tc>
+                  <a:txBody>
+                    <a:bodyPr/>
+                    <a:lstStyle/>
+                    <a:p>
+                      <a:pPr algn="l"/>
+                      <a:r>
+                        <a:rPr sz="1000">
+                          <a:solidFill>
+                            <a:srgbClr val="3F3F3F"/>
+                          </a:solidFill>
+                          <a:latin typeface="Encode Sans"/>
+                        </a:rPr>
+                        <a:t>Agosto 2026</a:t>
+                      </a:r>
+                    </a:p>
+                  </a:txBody>
+                  <a:tcPr marL="36576" marR="36576" marT="18288" marB="18288">
+                    <a:solidFill>
+                      <a:srgbClr val="FFFFFF"/>
+                    </a:solidFill>
+                  </a:tcPr>
+                </a:tc>
+                <a:tc>
+                  <a:txBody>
+                    <a:bodyPr/>
+                    <a:lstStyle/>
+                    <a:p>
+                      <a:pPr algn="r"/>
+                      <a:r>
+                        <a:rPr sz="1000">
+                          <a:solidFill>
+                            <a:srgbClr val="3F3F3F"/>
+                          </a:solidFill>
+                          <a:latin typeface="Encode Sans"/>
+                        </a:rPr>
+                        <a:t>79,5</a:t>
+                      </a:r>
+                    </a:p>
+                  </a:txBody>
+                  <a:tcPr marL="36576" marR="36576" marT="18288" marB="18288">
+                    <a:solidFill>
+                      <a:srgbClr val="FFFFFF"/>
+                    </a:solidFill>
+                  </a:tcPr>
+                </a:tc>
+                <a:tc>
+                  <a:txBody>
+                    <a:bodyPr/>
+                    <a:lstStyle/>
+                    <a:p>
+                      <a:pPr algn="r"/>
+                      <a:r>
+                        <a:rPr sz="1000">
+                          <a:solidFill>
+                            <a:srgbClr val="3F3F3F"/>
+                          </a:solidFill>
+                          <a:latin typeface="Encode Sans"/>
+                        </a:rPr>
+                        <a:t>-3.7%</a:t>
+                      </a:r>
+                    </a:p>
+                  </a:txBody>
+                  <a:tcPr marL="36576" marR="36576" marT="18288" marB="18288">
+                    <a:solidFill>
+                      <a:srgbClr val="FFFFFF"/>
+                    </a:solidFill>
+                  </a:tcPr>
+                </a:tc>
+                <a:tc>
+                  <a:txBody>
+                    <a:bodyPr/>
+                    <a:lstStyle/>
+                    <a:p>
+                      <a:pPr algn="r"/>
+                      <a:r>
+                        <a:rPr sz="1000">
+                          <a:solidFill>
+                            <a:srgbClr val="3F3F3F"/>
+                          </a:solidFill>
+                          <a:latin typeface="Encode Sans"/>
+                        </a:rPr>
+                        <a:t>-2.9%</a:t>
+                      </a:r>
+                    </a:p>
+                  </a:txBody>
+                  <a:tcPr marL="36576" marR="36576" marT="18288" marB="18288">
+                    <a:solidFill>
+                      <a:srgbClr val="FFFFFF"/>
+                    </a:solidFill>
+                  </a:tcPr>
+                </a:tc>
+              </a:tr>
+              <a:tr h="292608">
+                <a:tc>
+                  <a:txBody>
+                    <a:bodyPr/>
+                    <a:lstStyle/>
+                    <a:p>
+                      <a:pPr algn="l"/>
+                      <a:r>
+                        <a:rPr sz="1000">
+                          <a:solidFill>
+                            <a:srgbClr val="3F3F3F"/>
+                          </a:solidFill>
+                          <a:latin typeface="Encode Sans"/>
+                        </a:rPr>
+                        <a:t>Julio 2026</a:t>
+                      </a:r>
+                    </a:p>
+                  </a:txBody>
+                  <a:tcPr marL="36576" marR="36576" marT="18288" marB="18288">
+                    <a:solidFill>
+                      <a:srgbClr val="F8F8F6"/>
+                    </a:solidFill>
+                  </a:tcPr>
+                </a:tc>
+                <a:tc>
+                  <a:txBody>
+                    <a:bodyPr/>
+                    <a:lstStyle/>
+                    <a:p>
+                      <a:pPr algn="r"/>
+                      <a:r>
+                        <a:rPr sz="1000">
+                          <a:solidFill>
+                            <a:srgbClr val="3F3F3F"/>
+                          </a:solidFill>
+                          <a:latin typeface="Encode Sans"/>
+                        </a:rPr>
+                        <a:t>80,3</a:t>
+                      </a:r>
+                    </a:p>
+                  </a:txBody>
+                  <a:tcPr marL="36576" marR="36576" marT="18288" marB="18288">
+                    <a:solidFill>
+                      <a:srgbClr val="F8F8F6"/>
+                    </a:solidFill>
+                  </a:tcPr>
+                </a:tc>
+                <a:tc>
+                  <a:txBody>
+                    <a:bodyPr/>
+                    <a:lstStyle/>
+                    <a:p>
+                      <a:pPr algn="r"/>
+                      <a:r>
+                        <a:rPr sz="1000">
+                          <a:solidFill>
+                            <a:srgbClr val="3F3F3F"/>
+                          </a:solidFill>
+                          <a:latin typeface="Encode Sans"/>
+                        </a:rPr>
+                        <a:t>-2.1%</a:t>
+                      </a:r>
+                    </a:p>
+                  </a:txBody>
+                  <a:tcPr marL="36576" marR="36576" marT="18288" marB="18288">
+                    <a:solidFill>
+                      <a:srgbClr val="F8F8F6"/>
+                    </a:solidFill>
+                  </a:tcPr>
+                </a:tc>
+                <a:tc>
+                  <a:txBody>
+                    <a:bodyPr/>
+                    <a:lstStyle/>
+                    <a:p>
+                      <a:pPr algn="r"/>
+                      <a:r>
+                        <a:rPr sz="1000">
+                          <a:solidFill>
+                            <a:srgbClr val="3F3F3F"/>
+                          </a:solidFill>
+                          <a:latin typeface="Encode Sans"/>
+                        </a:rPr>
+                        <a:t>-2.7%</a:t>
+                      </a:r>
+                    </a:p>
+                  </a:txBody>
+                  <a:tcPr marL="36576" marR="36576" marT="18288" marB="18288">
+                    <a:solidFill>
+                      <a:srgbClr val="F8F8F6"/>
+                    </a:solidFill>
+                  </a:tcPr>
+                </a:tc>
+              </a:tr>
+              <a:tr h="292608">
+                <a:tc>
+                  <a:txBody>
+                    <a:bodyPr/>
+                    <a:lstStyle/>
+                    <a:p>
+                      <a:pPr algn="l"/>
+                      <a:r>
+                        <a:rPr sz="1000">
+                          <a:solidFill>
+                            <a:srgbClr val="3F3F3F"/>
+                          </a:solidFill>
+                          <a:latin typeface="Encode Sans"/>
+                        </a:rPr>
+                        <a:t>Junio 2026</a:t>
+                      </a:r>
+                    </a:p>
+                  </a:txBody>
+                  <a:tcPr marL="36576" marR="36576" marT="18288" marB="18288">
+                    <a:solidFill>
+                      <a:srgbClr val="FFFFFF"/>
+                    </a:solidFill>
+                  </a:tcPr>
+                </a:tc>
+                <a:tc>
+                  <a:txBody>
+                    <a:bodyPr/>
+                    <a:lstStyle/>
+                    <a:p>
+                      <a:pPr algn="r"/>
+                      <a:r>
+                        <a:rPr sz="1000">
+                          <a:solidFill>
+                            <a:srgbClr val="3F3F3F"/>
+                          </a:solidFill>
+                          <a:latin typeface="Encode Sans"/>
+                        </a:rPr>
+                        <a:t>78,7</a:t>
+                      </a:r>
+                    </a:p>
+                  </a:txBody>
+                  <a:tcPr marL="36576" marR="36576" marT="18288" marB="18288">
+                    <a:solidFill>
+                      <a:srgbClr val="FFFFFF"/>
+                    </a:solidFill>
+                  </a:tcPr>
+                </a:tc>
+                <a:tc>
+                  <a:txBody>
+                    <a:bodyPr/>
+                    <a:lstStyle/>
+                    <a:p>
+                      <a:pPr algn="r"/>
+                      <a:r>
+                        <a:rPr sz="1000">
+                          <a:solidFill>
+                            <a:srgbClr val="3F3F3F"/>
+                          </a:solidFill>
+                          <a:latin typeface="Encode Sans"/>
+                        </a:rPr>
+                        <a:t>-3.1%</a:t>
+                      </a:r>
+                    </a:p>
+                  </a:txBody>
+                  <a:tcPr marL="36576" marR="36576" marT="18288" marB="18288">
+                    <a:solidFill>
+                      <a:srgbClr val="FFFFFF"/>
+                    </a:solidFill>
+                  </a:tcPr>
+                </a:tc>
+                <a:tc>
+                  <a:txBody>
+                    <a:bodyPr/>
+                    <a:lstStyle/>
+                    <a:p>
+                      <a:pPr algn="r"/>
+                      <a:r>
+                        <a:rPr sz="1000">
+                          <a:solidFill>
+                            <a:srgbClr val="3F3F3F"/>
+                          </a:solidFill>
+                          <a:latin typeface="Encode Sans"/>
+                        </a:rPr>
+                        <a:t>-2.8%</a:t>
+                      </a:r>
+                    </a:p>
+                  </a:txBody>
+                  <a:tcPr marL="36576" marR="36576" marT="18288" marB="18288">
+                    <a:solidFill>
+                      <a:srgbClr val="FFFFFF"/>
+                    </a:solidFill>
+                  </a:tcPr>
+                </a:tc>
+              </a:tr>
+              <a:tr h="292608">
+                <a:tc>
+                  <a:txBody>
+                    <a:bodyPr/>
+                    <a:lstStyle/>
+                    <a:p>
+                      <a:pPr algn="l"/>
+                      <a:r>
+                        <a:rPr sz="1000">
+                          <a:solidFill>
+                            <a:srgbClr val="3F3F3F"/>
+                          </a:solidFill>
+                          <a:latin typeface="Encode Sans"/>
+                        </a:rPr>
+                        <a:t>Mayo 2026</a:t>
+                      </a:r>
+                    </a:p>
+                  </a:txBody>
+                  <a:tcPr marL="36576" marR="36576" marT="18288" marB="18288">
+                    <a:solidFill>
+                      <a:srgbClr val="F8F8F6"/>
+                    </a:solidFill>
+                  </a:tcPr>
+                </a:tc>
+                <a:tc>
+                  <a:txBody>
+                    <a:bodyPr/>
+                    <a:lstStyle/>
+                    <a:p>
+                      <a:pPr algn="r"/>
+                      <a:r>
+                        <a:rPr sz="1000">
+                          <a:solidFill>
+                            <a:srgbClr val="3F3F3F"/>
+                          </a:solidFill>
+                          <a:latin typeface="Encode Sans"/>
+                        </a:rPr>
+                        <a:t>80,5</a:t>
+                      </a:r>
+                    </a:p>
+                  </a:txBody>
+                  <a:tcPr marL="36576" marR="36576" marT="18288" marB="18288">
+                    <a:solidFill>
+                      <a:srgbClr val="F8F8F6"/>
+                    </a:solidFill>
+                  </a:tcPr>
+                </a:tc>
+                <a:tc>
+                  <a:txBody>
+                    <a:bodyPr/>
+                    <a:lstStyle/>
+                    <a:p>
+                      <a:pPr algn="r"/>
+                      <a:r>
+                        <a:rPr sz="1000">
+                          <a:solidFill>
+                            <a:srgbClr val="3F3F3F"/>
+                          </a:solidFill>
+                          <a:latin typeface="Encode Sans"/>
+                        </a:rPr>
+                        <a:t>-0.7%</a:t>
+                      </a:r>
+                    </a:p>
+                  </a:txBody>
+                  <a:tcPr marL="36576" marR="36576" marT="18288" marB="18288">
+                    <a:solidFill>
+                      <a:srgbClr val="F8F8F6"/>
+                    </a:solidFill>
+                  </a:tcPr>
+                </a:tc>
+                <a:tc>
+                  <a:txBody>
+                    <a:bodyPr/>
+                    <a:lstStyle/>
+                    <a:p>
+                      <a:pPr algn="r"/>
+                      <a:r>
+                        <a:rPr sz="1000">
+                          <a:solidFill>
+                            <a:srgbClr val="3F3F3F"/>
+                          </a:solidFill>
+                          <a:latin typeface="Encode Sans"/>
+                        </a:rPr>
+                        <a:t>-2.8%</a:t>
+                      </a:r>
+                    </a:p>
+                  </a:txBody>
+                  <a:tcPr marL="36576" marR="36576" marT="18288" marB="18288">
+                    <a:solidFill>
+                      <a:srgbClr val="F8F8F6"/>
+                    </a:solidFill>
+                  </a:tcPr>
+                </a:tc>
+              </a:tr>
+              <a:tr h="292608">
+                <a:tc>
+                  <a:txBody>
+                    <a:bodyPr/>
+                    <a:lstStyle/>
+                    <a:p>
+                      <a:pPr algn="l"/>
+                      <a:r>
+                        <a:rPr sz="1000">
+                          <a:solidFill>
+                            <a:srgbClr val="3F3F3F"/>
+                          </a:solidFill>
+                          <a:latin typeface="Encode Sans"/>
+                        </a:rPr>
+                        <a:t>Abril 2026</a:t>
+                      </a:r>
+                    </a:p>
+                  </a:txBody>
+                  <a:tcPr marL="36576" marR="36576" marT="18288" marB="18288">
+                    <a:solidFill>
+                      <a:srgbClr val="FFFFFF"/>
+                    </a:solidFill>
+                  </a:tcPr>
+                </a:tc>
+                <a:tc>
+                  <a:txBody>
+                    <a:bodyPr/>
+                    <a:lstStyle/>
+                    <a:p>
+                      <a:pPr algn="r"/>
+                      <a:r>
+                        <a:rPr sz="1000">
+                          <a:solidFill>
+                            <a:srgbClr val="3F3F3F"/>
+                          </a:solidFill>
+                          <a:latin typeface="Encode Sans"/>
+                        </a:rPr>
+                        <a:t>78,5</a:t>
+                      </a:r>
+                    </a:p>
+                  </a:txBody>
+                  <a:tcPr marL="36576" marR="36576" marT="18288" marB="18288">
+                    <a:solidFill>
+                      <a:srgbClr val="FFFFFF"/>
+                    </a:solidFill>
+                  </a:tcPr>
+                </a:tc>
+                <a:tc>
+                  <a:txBody>
+                    <a:bodyPr/>
+                    <a:lstStyle/>
+                    <a:p>
+                      <a:pPr algn="r"/>
+                      <a:r>
+                        <a:rPr sz="1000">
+                          <a:solidFill>
+                            <a:srgbClr val="3F3F3F"/>
+                          </a:solidFill>
+                          <a:latin typeface="Encode Sans"/>
+                        </a:rPr>
+                        <a:t>-3.7%</a:t>
+                      </a:r>
+                    </a:p>
+                  </a:txBody>
+                  <a:tcPr marL="36576" marR="36576" marT="18288" marB="18288">
+                    <a:solidFill>
+                      <a:srgbClr val="FFFFFF"/>
+                    </a:solidFill>
+                  </a:tcPr>
+                </a:tc>
+                <a:tc>
+                  <a:txBody>
+                    <a:bodyPr/>
+                    <a:lstStyle/>
+                    <a:p>
+                      <a:pPr algn="r"/>
+                      <a:r>
+                        <a:rPr sz="1000">
+                          <a:solidFill>
+                            <a:srgbClr val="3F3F3F"/>
+                          </a:solidFill>
+                          <a:latin typeface="Encode Sans"/>
+                        </a:rPr>
+                        <a:t>-3.3%</a:t>
+                      </a:r>
+                    </a:p>
+                  </a:txBody>
+                  <a:tcPr marL="36576" marR="36576" marT="18288" marB="18288">
+                    <a:solidFill>
+                      <a:srgbClr val="FFFFFF"/>
+                    </a:solidFill>
+                  </a:tcPr>
+                </a:tc>
+              </a:tr>
+              <a:tr h="292608">
+                <a:tc>
+                  <a:txBody>
+                    <a:bodyPr/>
+                    <a:lstStyle/>
+                    <a:p>
+                      <a:pPr algn="l"/>
+                      <a:r>
+                        <a:rPr sz="1000">
+                          <a:solidFill>
+                            <a:srgbClr val="3F3F3F"/>
+                          </a:solidFill>
+                          <a:latin typeface="Encode Sans"/>
+                        </a:rPr>
+                        <a:t>Marzo 2026</a:t>
+                      </a:r>
+                    </a:p>
+                  </a:txBody>
+                  <a:tcPr marL="36576" marR="36576" marT="18288" marB="18288">
+                    <a:solidFill>
+                      <a:srgbClr val="F8F8F6"/>
+                    </a:solidFill>
+                  </a:tcPr>
+                </a:tc>
+                <a:tc>
+                  <a:txBody>
+                    <a:bodyPr/>
+                    <a:lstStyle/>
+                    <a:p>
+                      <a:pPr algn="r"/>
+                      <a:r>
+                        <a:rPr sz="1000">
+                          <a:solidFill>
+                            <a:srgbClr val="3F3F3F"/>
+                          </a:solidFill>
+                          <a:latin typeface="Encode Sans"/>
+                        </a:rPr>
+                        <a:t>82,4</a:t>
+                      </a:r>
+                    </a:p>
+                  </a:txBody>
+                  <a:tcPr marL="36576" marR="36576" marT="18288" marB="18288">
+                    <a:solidFill>
+                      <a:srgbClr val="F8F8F6"/>
+                    </a:solidFill>
+                  </a:tcPr>
+                </a:tc>
+                <a:tc>
+                  <a:txBody>
+                    <a:bodyPr/>
+                    <a:lstStyle/>
+                    <a:p>
+                      <a:pPr algn="r"/>
+                      <a:r>
+                        <a:rPr sz="1000">
+                          <a:solidFill>
+                            <a:srgbClr val="3F3F3F"/>
+                          </a:solidFill>
+                          <a:latin typeface="Encode Sans"/>
+                        </a:rPr>
+                        <a:t>-5.1%</a:t>
+                      </a:r>
+                    </a:p>
+                  </a:txBody>
+                  <a:tcPr marL="36576" marR="36576" marT="18288" marB="18288">
+                    <a:solidFill>
+                      <a:srgbClr val="F8F8F6"/>
+                    </a:solidFill>
+                  </a:tcPr>
+                </a:tc>
+                <a:tc>
+                  <a:txBody>
+                    <a:bodyPr/>
+                    <a:lstStyle/>
+                    <a:p>
+                      <a:pPr algn="r"/>
+                      <a:r>
+                        <a:rPr sz="1000">
+                          <a:solidFill>
+                            <a:srgbClr val="3F3F3F"/>
+                          </a:solidFill>
+                          <a:latin typeface="Encode Sans"/>
+                        </a:rPr>
+                        <a:t>-3.1%</a:t>
                       </a:r>
                     </a:p>
                   </a:txBody>

</xml_diff>

<commit_message>
data: update 2026-10-26 ( data.json despidos.json scraper/historical_despidos.json publicaciones_semana.pptx rrii_brutas.xlsx)
</commit_message>
<xml_diff>
--- a/publicaciones_semana.pptx
+++ b/publicaciones_semana.pptx
@@ -7,8 +7,6 @@
   <p:sldIdLst>
     <p:sldId id="256" r:id="rId7"/>
     <p:sldId id="257" r:id="rId8"/>
-    <p:sldId id="258" r:id="rId9"/>
-    <p:sldId id="259" r:id="rId10"/>
   </p:sldIdLst>
   <p:sldSz cx="12191695" cy="6858000" type="screen4x3"/>
   <p:notesSz cx="6858000" cy="9144000"/>
@@ -3240,7 +3238,7 @@
                 </a:solidFill>
                 <a:latin typeface="Encode Sans"/>
               </a:rPr>
-              <a:t>Publicaciones de la semana del 19 de octubre de 2026</a:t>
+              <a:t>Publicaciones de la semana del 26 de octubre de 2026</a:t>
             </a:r>
           </a:p>
         </p:txBody>
@@ -3274,7 +3272,7 @@
                 </a:solidFill>
                 <a:latin typeface="Encode Sans"/>
               </a:rPr>
-              <a:t>3 publicaciones · datos oficiales INDEC / BCRA / Hacienda</a:t>
+              <a:t>1 publicaciones · datos oficiales INDEC / BCRA / Hacienda</a:t>
             </a:r>
           </a:p>
         </p:txBody>
@@ -3370,7 +3368,7 @@
                 </a:solidFill>
                 <a:latin typeface="Encode Sans"/>
               </a:rPr>
-              <a:t>EMAE AGOSTO 2026: ACTIVIDAD CAYÓ -1.7% I.A.</a:t>
+              <a:t>TURISMO INTERNACIONAL SEPTIEMBRE 2026: SALDO -180.848 PERSONAS</a:t>
             </a:r>
           </a:p>
         </p:txBody>
@@ -3404,7 +3402,7 @@
                 </a:solidFill>
                 <a:latin typeface="Encode Sans"/>
               </a:rPr>
-              <a:t>INDEC · período 2026-08</a:t>
+              <a:t>INDEC · período 2026-09</a:t>
             </a:r>
           </a:p>
         </p:txBody>
@@ -3439,7 +3437,7 @@
                 </a:solidFill>
                 <a:latin typeface="Encode Sans"/>
               </a:rPr>
-              <a:t>El Estimador Mensual de Actividad Económica (EMAE) registró una variación interanual de -1.7% en agosto 2026. En la medición desestacionalizada, el indicador se movió +0.1% respecto al mes anterior.</a:t>
+              <a:t>En septiembre 2026 ingresaron 432.206 turistas no residentes y salieron 613.054 argentinos al exterior, con saldo de -180.848 personas. Receptivo +15.3% i.a., emisivo -13.2% i.a.</a:t>
             </a:r>
           </a:p>
         </p:txBody>
@@ -3487,7 +3485,7 @@
                 </a:solidFill>
                 <a:latin typeface="Encode Sans"/>
               </a:rPr>
-              <a:t>Variación interanual: -1.7%</a:t>
+              <a:t>Receptivo: 432.206 personas</a:t>
             </a:r>
           </a:p>
           <a:p>
@@ -3512,7 +3510,7 @@
                 </a:solidFill>
                 <a:latin typeface="Encode Sans"/>
               </a:rPr>
-              <a:t>Variación mensual desestacionalizada: +0.1%</a:t>
+              <a:t>Emisivo: 613.054 personas</a:t>
             </a:r>
           </a:p>
           <a:p>
@@ -3537,7 +3535,32 @@
                 </a:solidFill>
                 <a:latin typeface="Encode Sans"/>
               </a:rPr>
-              <a:t>Serie INDEC, base 2004=100. Mide el nivel general de actividad.</a:t>
+              <a:t>Saldo (receptivo − emisivo): -180.848 personas</a:t>
+            </a:r>
+          </a:p>
+          <a:p>
+            <a:pPr algn="l">
+              <a:spcAft>
+                <a:spcPts val="800"/>
+              </a:spcAft>
+            </a:pPr>
+            <a:r>
+              <a:rPr sz="1300" b="1" i="0">
+                <a:solidFill>
+                  <a:srgbClr val="00B2C9"/>
+                </a:solidFill>
+                <a:latin typeface="Encode Sans"/>
+              </a:rPr>
+              <a:t>●  </a:t>
+            </a:r>
+            <a:r>
+              <a:rPr sz="1300" b="0" i="0">
+                <a:solidFill>
+                  <a:srgbClr val="3F3F3F"/>
+                </a:solidFill>
+                <a:latin typeface="Encode Sans"/>
+              </a:rPr>
+              <a:t>Fuente: INDEC, Estadísticas de Turismo Internacional (todas las vías)</a:t>
             </a:r>
           </a:p>
         </p:txBody>
@@ -3627,7 +3650,7 @@
                           </a:solidFill>
                           <a:latin typeface="Encode Sans"/>
                         </a:rPr>
-                        <a:t>Original</a:t>
+                        <a:t>Receptivo</a:t>
                       </a:r>
                     </a:p>
                   </a:txBody>
@@ -3650,7 +3673,7 @@
                           </a:solidFill>
                           <a:latin typeface="Encode Sans"/>
                         </a:rPr>
-                        <a:t>VIA %</a:t>
+                        <a:t>Emisivo</a:t>
                       </a:r>
                     </a:p>
                   </a:txBody>
@@ -3673,7 +3696,7 @@
                           </a:solidFill>
                           <a:latin typeface="Encode Sans"/>
                         </a:rPr>
-                        <a:t>Desest.</a:t>
+                        <a:t>Saldo</a:t>
                       </a:r>
                     </a:p>
                   </a:txBody>
@@ -3698,7 +3721,7 @@
                           </a:solidFill>
                           <a:latin typeface="Encode Sans"/>
                         </a:rPr>
-                        <a:t>Agosto 2026</a:t>
+                        <a:t>Septiembre 2026</a:t>
                       </a:r>
                     </a:p>
                   </a:txBody>
@@ -3721,7 +3744,7 @@
                           </a:solidFill>
                           <a:latin typeface="Encode Sans"/>
                         </a:rPr>
-                        <a:t>147,8</a:t>
+                        <a:t>432.206</a:t>
                       </a:r>
                     </a:p>
                   </a:txBody>
@@ -3744,7 +3767,7 @@
                           </a:solidFill>
                           <a:latin typeface="Encode Sans"/>
                         </a:rPr>
-                        <a:t>-1.7%</a:t>
+                        <a:t>613.054</a:t>
                       </a:r>
                     </a:p>
                   </a:txBody>
@@ -3767,7 +3790,7 @@
                           </a:solidFill>
                           <a:latin typeface="Encode Sans"/>
                         </a:rPr>
-                        <a:t>149,9</a:t>
+                        <a:t>-180.848</a:t>
                       </a:r>
                     </a:p>
                   </a:txBody>
@@ -3792,7 +3815,7 @@
                           </a:solidFill>
                           <a:latin typeface="Encode Sans"/>
                         </a:rPr>
-                        <a:t>Julio 2026</a:t>
+                        <a:t>Agosto 2026</a:t>
                       </a:r>
                     </a:p>
                   </a:txBody>
@@ -3815,7 +3838,7 @@
                           </a:solidFill>
                           <a:latin typeface="Encode Sans"/>
                         </a:rPr>
-                        <a:t>151,5</a:t>
+                        <a:t>432.883</a:t>
                       </a:r>
                     </a:p>
                   </a:txBody>
@@ -3838,7 +3861,7 @@
                           </a:solidFill>
                           <a:latin typeface="Encode Sans"/>
                         </a:rPr>
-                        <a:t>-1.5%</a:t>
+                        <a:t>652.055</a:t>
                       </a:r>
                     </a:p>
                   </a:txBody>
@@ -3861,7 +3884,7 @@
                           </a:solidFill>
                           <a:latin typeface="Encode Sans"/>
                         </a:rPr>
-                        <a:t>149,8</a:t>
+                        <a:t>-219.172</a:t>
                       </a:r>
                     </a:p>
                   </a:txBody>
@@ -3886,7 +3909,7 @@
                           </a:solidFill>
                           <a:latin typeface="Encode Sans"/>
                         </a:rPr>
-                        <a:t>Junio 2026</a:t>
+                        <a:t>Julio 2026</a:t>
                       </a:r>
                     </a:p>
                   </a:txBody>
@@ -3909,7 +3932,7 @@
                           </a:solidFill>
                           <a:latin typeface="Encode Sans"/>
                         </a:rPr>
-                        <a:t>161,7</a:t>
+                        <a:t>466.234</a:t>
                       </a:r>
                     </a:p>
                   </a:txBody>
@@ -3932,7 +3955,7 @@
                           </a:solidFill>
                           <a:latin typeface="Encode Sans"/>
                         </a:rPr>
-                        <a:t>+3.1%</a:t>
+                        <a:t>697.150</a:t>
                       </a:r>
                     </a:p>
                   </a:txBody>
@@ -3955,7 +3978,7 @@
                           </a:solidFill>
                           <a:latin typeface="Encode Sans"/>
                         </a:rPr>
-                        <a:t>154,1</a:t>
+                        <a:t>-230.916</a:t>
                       </a:r>
                     </a:p>
                   </a:txBody>
@@ -3980,7 +4003,7 @@
                           </a:solidFill>
                           <a:latin typeface="Encode Sans"/>
                         </a:rPr>
-                        <a:t>Mayo 2026</a:t>
+                        <a:t>Junio 2026</a:t>
                       </a:r>
                     </a:p>
                   </a:txBody>
@@ -4003,7 +4026,7 @@
                           </a:solidFill>
                           <a:latin typeface="Encode Sans"/>
                         </a:rPr>
-                        <a:t>166,2</a:t>
+                        <a:t>329.177</a:t>
                       </a:r>
                     </a:p>
                   </a:txBody>
@@ -4026,7 +4049,7 @@
                           </a:solidFill>
                           <a:latin typeface="Encode Sans"/>
                         </a:rPr>
-                        <a:t>+0.7%</a:t>
+                        <a:t>501.918</a:t>
                       </a:r>
                     </a:p>
                   </a:txBody>
@@ -4049,7 +4072,7 @@
                           </a:solidFill>
                           <a:latin typeface="Encode Sans"/>
                         </a:rPr>
-                        <a:t>153,7</a:t>
+                        <a:t>-172.741</a:t>
                       </a:r>
                     </a:p>
                   </a:txBody>
@@ -4074,7 +4097,7 @@
                           </a:solidFill>
                           <a:latin typeface="Encode Sans"/>
                         </a:rPr>
-                        <a:t>Abril 2026</a:t>
+                        <a:t>Mayo 2026</a:t>
                       </a:r>
                     </a:p>
                   </a:txBody>
@@ -4097,7 +4120,7 @@
                           </a:solidFill>
                           <a:latin typeface="Encode Sans"/>
                         </a:rPr>
-                        <a:t>162,4</a:t>
+                        <a:t>379.860</a:t>
                       </a:r>
                     </a:p>
                   </a:txBody>
@@ -4120,7 +4143,7 @@
                           </a:solidFill>
                           <a:latin typeface="Encode Sans"/>
                         </a:rPr>
-                        <a:t>+2.2%</a:t>
+                        <a:t>661.853</a:t>
                       </a:r>
                     </a:p>
                   </a:txBody>
@@ -4143,7 +4166,7 @@
                           </a:solidFill>
                           <a:latin typeface="Encode Sans"/>
                         </a:rPr>
-                        <a:t>154,7</a:t>
+                        <a:t>-281.993</a:t>
                       </a:r>
                     </a:p>
                   </a:txBody>
@@ -4168,7 +4191,7 @@
                           </a:solidFill>
                           <a:latin typeface="Encode Sans"/>
                         </a:rPr>
-                        <a:t>Marzo 2026</a:t>
+                        <a:t>Abril 2026</a:t>
                       </a:r>
                     </a:p>
                   </a:txBody>
@@ -4191,7 +4214,7 @@
                           </a:solidFill>
                           <a:latin typeface="Encode Sans"/>
                         </a:rPr>
-                        <a:t>160,3</a:t>
+                        <a:t>463.072</a:t>
                       </a:r>
                     </a:p>
                   </a:txBody>
@@ -4214,7 +4237,7 @@
                           </a:solidFill>
                           <a:latin typeface="Encode Sans"/>
                         </a:rPr>
-                        <a:t>+6.5%</a:t>
+                        <a:t>764.757</a:t>
                       </a:r>
                     </a:p>
                   </a:txBody>
@@ -4237,2046 +4260,7 @@
                           </a:solidFill>
                           <a:latin typeface="Encode Sans"/>
                         </a:rPr>
-                        <a:t>156,8</a:t>
-                      </a:r>
-                    </a:p>
-                  </a:txBody>
-                  <a:tcPr marL="36576" marR="36576" marT="18288" marB="18288">
-                    <a:solidFill>
-                      <a:srgbClr val="F8F8F6"/>
-                    </a:solidFill>
-                  </a:tcPr>
-                </a:tc>
-              </a:tr>
-            </a:tbl>
-          </a:graphicData>
-        </a:graphic>
-      </p:graphicFrame>
-      <p:sp>
-        <p:nvSpPr>
-          <p:cNvPr id="9" name="TextBox 8"/>
-          <p:cNvSpPr txBox="1"/>
-          <p:nvPr/>
-        </p:nvSpPr>
-        <p:spPr>
-          <a:xfrm>
-            <a:off x="411480" y="6492240"/>
-            <a:ext cx="11368735" cy="274320"/>
-          </a:xfrm>
-          <a:prstGeom prst="rect">
-            <a:avLst/>
-          </a:prstGeom>
-          <a:noFill/>
-        </p:spPr>
-        <p:txBody>
-          <a:bodyPr wrap="none">
-            <a:spAutoFit/>
-          </a:bodyPr>
-          <a:lstStyle/>
-          <a:p>
-            <a:r>
-              <a:rPr sz="1000" b="0" i="1">
-                <a:solidFill>
-                  <a:srgbClr val="6A6760"/>
-                </a:solidFill>
-                <a:latin typeface="Encode Sans"/>
-              </a:rPr>
-              <a:t>Fuente: elaboración propia en base a INDEC</a:t>
-            </a:r>
-          </a:p>
-        </p:txBody>
-      </p:sp>
-    </p:spTree>
-  </p:cSld>
-  <p:clrMapOvr>
-    <a:masterClrMapping/>
-  </p:clrMapOvr>
-</p:sld>
-</file>
-
-<file path=ppt/slides/slide3.xml><?xml version="1.0" encoding="utf-8"?>
-<p:sld xmlns:a="http://schemas.openxmlformats.org/drawingml/2006/main" xmlns:p="http://schemas.openxmlformats.org/presentationml/2006/main" xmlns:r="http://schemas.openxmlformats.org/officeDocument/2006/relationships">
-  <p:cSld>
-    <p:spTree>
-      <p:nvGrpSpPr>
-        <p:cNvPr id="1" name=""/>
-        <p:cNvGrpSpPr/>
-        <p:nvPr/>
-      </p:nvGrpSpPr>
-      <p:grpSpPr/>
-      <p:sp>
-        <p:nvSpPr>
-          <p:cNvPr id="2" name="Rectangle 1"/>
-          <p:cNvSpPr/>
-          <p:nvPr/>
-        </p:nvSpPr>
-        <p:spPr>
-          <a:xfrm>
-            <a:off x="0" y="0"/>
-            <a:ext cx="12191695" cy="274320"/>
-          </a:xfrm>
-          <a:prstGeom prst="rect">
-            <a:avLst/>
-          </a:prstGeom>
-          <a:solidFill>
-            <a:srgbClr val="00B2C9"/>
-          </a:solidFill>
-          <a:ln>
-            <a:noFill/>
-          </a:ln>
-        </p:spPr>
-        <p:style>
-          <a:lnRef idx="1">
-            <a:schemeClr val="accent1"/>
-          </a:lnRef>
-          <a:fillRef idx="3">
-            <a:schemeClr val="accent1"/>
-          </a:fillRef>
-          <a:effectRef idx="2">
-            <a:schemeClr val="accent1"/>
-          </a:effectRef>
-          <a:fontRef idx="minor">
-            <a:schemeClr val="lt1"/>
-          </a:fontRef>
-        </p:style>
-        <p:txBody>
-          <a:bodyPr rtlCol="0" anchor="ctr"/>
-          <a:lstStyle/>
-          <a:p>
-            <a:pPr algn="ctr"/>
-          </a:p>
-        </p:txBody>
-      </p:sp>
-      <p:sp>
-        <p:nvSpPr>
-          <p:cNvPr id="3" name="TextBox 2"/>
-          <p:cNvSpPr txBox="1"/>
-          <p:nvPr/>
-        </p:nvSpPr>
-        <p:spPr>
-          <a:xfrm>
-            <a:off x="411480" y="457200"/>
-            <a:ext cx="11368735" cy="914400"/>
-          </a:xfrm>
-          <a:prstGeom prst="rect">
-            <a:avLst/>
-          </a:prstGeom>
-          <a:noFill/>
-        </p:spPr>
-        <p:txBody>
-          <a:bodyPr wrap="square" lIns="0" rIns="0">
-            <a:spAutoFit/>
-          </a:bodyPr>
-          <a:lstStyle/>
-          <a:p>
-            <a:pPr algn="l"/>
-            <a:r>
-              <a:rPr sz="2600" b="1" i="0">
-                <a:solidFill>
-                  <a:srgbClr val="00B2C9"/>
-                </a:solidFill>
-                <a:latin typeface="Encode Sans"/>
-              </a:rPr>
-              <a:t>SALARIOS AGOSTO 2026: ÍNDICE TOTAL REGISTRADO 9.468</a:t>
-            </a:r>
-          </a:p>
-        </p:txBody>
-      </p:sp>
-      <p:sp>
-        <p:nvSpPr>
-          <p:cNvPr id="4" name="TextBox 3"/>
-          <p:cNvSpPr txBox="1"/>
-          <p:nvPr/>
-        </p:nvSpPr>
-        <p:spPr>
-          <a:xfrm>
-            <a:off x="411480" y="1280160"/>
-            <a:ext cx="11368735" cy="274320"/>
-          </a:xfrm>
-          <a:prstGeom prst="rect">
-            <a:avLst/>
-          </a:prstGeom>
-          <a:noFill/>
-        </p:spPr>
-        <p:txBody>
-          <a:bodyPr wrap="none">
-            <a:spAutoFit/>
-          </a:bodyPr>
-          <a:lstStyle/>
-          <a:p>
-            <a:r>
-              <a:rPr sz="1100" b="0" i="1">
-                <a:solidFill>
-                  <a:srgbClr val="6A6760"/>
-                </a:solidFill>
-                <a:latin typeface="Encode Sans"/>
-              </a:rPr>
-              <a:t>INDEC · período 2026-08</a:t>
-            </a:r>
-          </a:p>
-        </p:txBody>
-      </p:sp>
-      <p:sp>
-        <p:nvSpPr>
-          <p:cNvPr id="5" name="TextBox 4"/>
-          <p:cNvSpPr txBox="1"/>
-          <p:nvPr/>
-        </p:nvSpPr>
-        <p:spPr>
-          <a:xfrm>
-            <a:off x="411480" y="1691640"/>
-            <a:ext cx="5486400" cy="1645920"/>
-          </a:xfrm>
-          <a:prstGeom prst="rect">
-            <a:avLst/>
-          </a:prstGeom>
-          <a:noFill/>
-        </p:spPr>
-        <p:txBody>
-          <a:bodyPr wrap="square" lIns="0" rIns="0">
-            <a:spAutoFit/>
-          </a:bodyPr>
-          <a:lstStyle/>
-          <a:p>
-            <a:pPr algn="just"/>
-            <a:r>
-              <a:rPr sz="1300" b="0" i="0">
-                <a:solidFill>
-                  <a:srgbClr val="3F3F3F"/>
-                </a:solidFill>
-                <a:latin typeface="Encode Sans"/>
-              </a:rPr>
-              <a:t>El Índice de Salarios INDEC alcanzó 9.468 para el sector registrado en agosto 2026. Privado registrado: 10.160. Público: 8.307.</a:t>
-            </a:r>
-          </a:p>
-        </p:txBody>
-      </p:sp>
-      <p:sp>
-        <p:nvSpPr>
-          <p:cNvPr id="6" name="TextBox 5"/>
-          <p:cNvSpPr txBox="1"/>
-          <p:nvPr/>
-        </p:nvSpPr>
-        <p:spPr>
-          <a:xfrm>
-            <a:off x="411480" y="3520440"/>
-            <a:ext cx="5486400" cy="2743200"/>
-          </a:xfrm>
-          <a:prstGeom prst="rect">
-            <a:avLst/>
-          </a:prstGeom>
-          <a:noFill/>
-        </p:spPr>
-        <p:txBody>
-          <a:bodyPr wrap="square" lIns="0" rIns="0">
-            <a:spAutoFit/>
-          </a:bodyPr>
-          <a:lstStyle/>
-          <a:p>
-            <a:pPr algn="l">
-              <a:spcAft>
-                <a:spcPts val="800"/>
-              </a:spcAft>
-            </a:pPr>
-            <a:r>
-              <a:rPr sz="1300" b="1" i="0">
-                <a:solidFill>
-                  <a:srgbClr val="00B2C9"/>
-                </a:solidFill>
-                <a:latin typeface="Encode Sans"/>
-              </a:rPr>
-              <a:t>●  </a:t>
-            </a:r>
-            <a:r>
-              <a:rPr sz="1300" b="0" i="0">
-                <a:solidFill>
-                  <a:srgbClr val="3F3F3F"/>
-                </a:solidFill>
-                <a:latin typeface="Encode Sans"/>
-              </a:rPr>
-              <a:t>Total registrado: 9.468</a:t>
-            </a:r>
-          </a:p>
-          <a:p>
-            <a:pPr algn="l">
-              <a:spcAft>
-                <a:spcPts val="800"/>
-              </a:spcAft>
-            </a:pPr>
-            <a:r>
-              <a:rPr sz="1300" b="1" i="0">
-                <a:solidFill>
-                  <a:srgbClr val="00B2C9"/>
-                </a:solidFill>
-                <a:latin typeface="Encode Sans"/>
-              </a:rPr>
-              <a:t>●  </a:t>
-            </a:r>
-            <a:r>
-              <a:rPr sz="1300" b="0" i="0">
-                <a:solidFill>
-                  <a:srgbClr val="3F3F3F"/>
-                </a:solidFill>
-                <a:latin typeface="Encode Sans"/>
-              </a:rPr>
-              <a:t>Privado registrado: 10.160</a:t>
-            </a:r>
-          </a:p>
-          <a:p>
-            <a:pPr algn="l">
-              <a:spcAft>
-                <a:spcPts val="800"/>
-              </a:spcAft>
-            </a:pPr>
-            <a:r>
-              <a:rPr sz="1300" b="1" i="0">
-                <a:solidFill>
-                  <a:srgbClr val="00B2C9"/>
-                </a:solidFill>
-                <a:latin typeface="Encode Sans"/>
-              </a:rPr>
-              <a:t>●  </a:t>
-            </a:r>
-            <a:r>
-              <a:rPr sz="1300" b="0" i="0">
-                <a:solidFill>
-                  <a:srgbClr val="3F3F3F"/>
-                </a:solidFill>
-                <a:latin typeface="Encode Sans"/>
-              </a:rPr>
-              <a:t>Sector público: 8.307</a:t>
-            </a:r>
-          </a:p>
-          <a:p>
-            <a:pPr algn="l">
-              <a:spcAft>
-                <a:spcPts val="800"/>
-              </a:spcAft>
-            </a:pPr>
-            <a:r>
-              <a:rPr sz="1300" b="1" i="0">
-                <a:solidFill>
-                  <a:srgbClr val="00B2C9"/>
-                </a:solidFill>
-                <a:latin typeface="Encode Sans"/>
-              </a:rPr>
-              <a:t>●  </a:t>
-            </a:r>
-            <a:r>
-              <a:rPr sz="1300" b="0" i="0">
-                <a:solidFill>
-                  <a:srgbClr val="3F3F3F"/>
-                </a:solidFill>
-                <a:latin typeface="Encode Sans"/>
-              </a:rPr>
-              <a:t>No registrado: 12.006</a:t>
-            </a:r>
-          </a:p>
-        </p:txBody>
-      </p:sp>
-      <p:pic>
-        <p:nvPicPr>
-          <p:cNvPr id="7" name="Picture 6" descr="image.png"/>
-          <p:cNvPicPr>
-            <a:picLocks noChangeAspect="1"/>
-          </p:cNvPicPr>
-          <p:nvPr/>
-        </p:nvPicPr>
-        <p:blipFill>
-          <a:blip r:embed="rId2"/>
-          <a:stretch>
-            <a:fillRect/>
-          </a:stretch>
-        </p:blipFill>
-        <p:spPr>
-          <a:xfrm>
-            <a:off x="6080760" y="1691640"/>
-            <a:ext cx="5669280" cy="2560320"/>
-          </a:xfrm>
-          <a:prstGeom prst="rect">
-            <a:avLst/>
-          </a:prstGeom>
-        </p:spPr>
-      </p:pic>
-      <p:graphicFrame>
-        <p:nvGraphicFramePr>
-          <p:cNvPr id="8" name="Table 7"/>
-          <p:cNvGraphicFramePr>
-            <a:graphicFrameLocks noGrp="1"/>
-          </p:cNvGraphicFramePr>
-          <p:nvPr/>
-        </p:nvGraphicFramePr>
-        <p:xfrm>
-          <a:off x="6080760" y="4434840"/>
-          <a:ext cx="5669280" cy="2048256"/>
-        </p:xfrm>
-        <a:graphic>
-          <a:graphicData uri="http://schemas.openxmlformats.org/drawingml/2006/table">
-            <a:tbl>
-              <a:tblPr firstRow="1" bandRow="1">
-                <a:tableStyleId>{5C22544A-7EE6-4342-B048-85BDC9FD1C3A}</a:tableStyleId>
-              </a:tblPr>
-              <a:tblGrid>
-                <a:gridCol w="1417320"/>
-                <a:gridCol w="1417320"/>
-                <a:gridCol w="1417320"/>
-                <a:gridCol w="1417320"/>
-              </a:tblGrid>
-              <a:tr h="292608">
-                <a:tc>
-                  <a:txBody>
-                    <a:bodyPr/>
-                    <a:lstStyle/>
-                    <a:p>
-                      <a:pPr algn="l"/>
-                      <a:r>
-                        <a:rPr sz="1000" b="1">
-                          <a:solidFill>
-                            <a:srgbClr val="FFFFFF"/>
-                          </a:solidFill>
-                          <a:latin typeface="Encode Sans"/>
-                        </a:rPr>
-                        <a:t>Mes</a:t>
-                      </a:r>
-                    </a:p>
-                  </a:txBody>
-                  <a:tcPr marL="36576" marR="36576" marT="18288" marB="18288">
-                    <a:solidFill>
-                      <a:srgbClr val="00B2C9"/>
-                    </a:solidFill>
-                  </a:tcPr>
-                </a:tc>
-                <a:tc>
-                  <a:txBody>
-                    <a:bodyPr/>
-                    <a:lstStyle/>
-                    <a:p>
-                      <a:pPr algn="r"/>
-                      <a:r>
-                        <a:rPr sz="1000" b="1">
-                          <a:solidFill>
-                            <a:srgbClr val="FFFFFF"/>
-                          </a:solidFill>
-                          <a:latin typeface="Encode Sans"/>
-                        </a:rPr>
-                        <a:t>Total reg.</a:t>
-                      </a:r>
-                    </a:p>
-                  </a:txBody>
-                  <a:tcPr marL="36576" marR="36576" marT="18288" marB="18288">
-                    <a:solidFill>
-                      <a:srgbClr val="00B2C9"/>
-                    </a:solidFill>
-                  </a:tcPr>
-                </a:tc>
-                <a:tc>
-                  <a:txBody>
-                    <a:bodyPr/>
-                    <a:lstStyle/>
-                    <a:p>
-                      <a:pPr algn="r"/>
-                      <a:r>
-                        <a:rPr sz="1000" b="1">
-                          <a:solidFill>
-                            <a:srgbClr val="FFFFFF"/>
-                          </a:solidFill>
-                          <a:latin typeface="Encode Sans"/>
-                        </a:rPr>
-                        <a:t>Privado</a:t>
-                      </a:r>
-                    </a:p>
-                  </a:txBody>
-                  <a:tcPr marL="36576" marR="36576" marT="18288" marB="18288">
-                    <a:solidFill>
-                      <a:srgbClr val="00B2C9"/>
-                    </a:solidFill>
-                  </a:tcPr>
-                </a:tc>
-                <a:tc>
-                  <a:txBody>
-                    <a:bodyPr/>
-                    <a:lstStyle/>
-                    <a:p>
-                      <a:pPr algn="r"/>
-                      <a:r>
-                        <a:rPr sz="1000" b="1">
-                          <a:solidFill>
-                            <a:srgbClr val="FFFFFF"/>
-                          </a:solidFill>
-                          <a:latin typeface="Encode Sans"/>
-                        </a:rPr>
-                        <a:t>Público</a:t>
-                      </a:r>
-                    </a:p>
-                  </a:txBody>
-                  <a:tcPr marL="36576" marR="36576" marT="18288" marB="18288">
-                    <a:solidFill>
-                      <a:srgbClr val="00B2C9"/>
-                    </a:solidFill>
-                  </a:tcPr>
-                </a:tc>
-              </a:tr>
-              <a:tr h="292608">
-                <a:tc>
-                  <a:txBody>
-                    <a:bodyPr/>
-                    <a:lstStyle/>
-                    <a:p>
-                      <a:pPr algn="l"/>
-                      <a:r>
-                        <a:rPr sz="1000">
-                          <a:solidFill>
-                            <a:srgbClr val="3F3F3F"/>
-                          </a:solidFill>
-                          <a:latin typeface="Encode Sans"/>
-                        </a:rPr>
-                        <a:t>Agosto 2026</a:t>
-                      </a:r>
-                    </a:p>
-                  </a:txBody>
-                  <a:tcPr marL="36576" marR="36576" marT="18288" marB="18288">
-                    <a:solidFill>
-                      <a:srgbClr val="FFFFFF"/>
-                    </a:solidFill>
-                  </a:tcPr>
-                </a:tc>
-                <a:tc>
-                  <a:txBody>
-                    <a:bodyPr/>
-                    <a:lstStyle/>
-                    <a:p>
-                      <a:pPr algn="r"/>
-                      <a:r>
-                        <a:rPr sz="1000">
-                          <a:solidFill>
-                            <a:srgbClr val="3F3F3F"/>
-                          </a:solidFill>
-                          <a:latin typeface="Encode Sans"/>
-                        </a:rPr>
-                        <a:t>9.468</a:t>
-                      </a:r>
-                    </a:p>
-                  </a:txBody>
-                  <a:tcPr marL="36576" marR="36576" marT="18288" marB="18288">
-                    <a:solidFill>
-                      <a:srgbClr val="FFFFFF"/>
-                    </a:solidFill>
-                  </a:tcPr>
-                </a:tc>
-                <a:tc>
-                  <a:txBody>
-                    <a:bodyPr/>
-                    <a:lstStyle/>
-                    <a:p>
-                      <a:pPr algn="r"/>
-                      <a:r>
-                        <a:rPr sz="1000">
-                          <a:solidFill>
-                            <a:srgbClr val="3F3F3F"/>
-                          </a:solidFill>
-                          <a:latin typeface="Encode Sans"/>
-                        </a:rPr>
-                        <a:t>10.160</a:t>
-                      </a:r>
-                    </a:p>
-                  </a:txBody>
-                  <a:tcPr marL="36576" marR="36576" marT="18288" marB="18288">
-                    <a:solidFill>
-                      <a:srgbClr val="FFFFFF"/>
-                    </a:solidFill>
-                  </a:tcPr>
-                </a:tc>
-                <a:tc>
-                  <a:txBody>
-                    <a:bodyPr/>
-                    <a:lstStyle/>
-                    <a:p>
-                      <a:pPr algn="r"/>
-                      <a:r>
-                        <a:rPr sz="1000">
-                          <a:solidFill>
-                            <a:srgbClr val="3F3F3F"/>
-                          </a:solidFill>
-                          <a:latin typeface="Encode Sans"/>
-                        </a:rPr>
-                        <a:t>8.307</a:t>
-                      </a:r>
-                    </a:p>
-                  </a:txBody>
-                  <a:tcPr marL="36576" marR="36576" marT="18288" marB="18288">
-                    <a:solidFill>
-                      <a:srgbClr val="FFFFFF"/>
-                    </a:solidFill>
-                  </a:tcPr>
-                </a:tc>
-              </a:tr>
-              <a:tr h="292608">
-                <a:tc>
-                  <a:txBody>
-                    <a:bodyPr/>
-                    <a:lstStyle/>
-                    <a:p>
-                      <a:pPr algn="l"/>
-                      <a:r>
-                        <a:rPr sz="1000">
-                          <a:solidFill>
-                            <a:srgbClr val="3F3F3F"/>
-                          </a:solidFill>
-                          <a:latin typeface="Encode Sans"/>
-                        </a:rPr>
-                        <a:t>Julio 2026</a:t>
-                      </a:r>
-                    </a:p>
-                  </a:txBody>
-                  <a:tcPr marL="36576" marR="36576" marT="18288" marB="18288">
-                    <a:solidFill>
-                      <a:srgbClr val="F8F8F6"/>
-                    </a:solidFill>
-                  </a:tcPr>
-                </a:tc>
-                <a:tc>
-                  <a:txBody>
-                    <a:bodyPr/>
-                    <a:lstStyle/>
-                    <a:p>
-                      <a:pPr algn="r"/>
-                      <a:r>
-                        <a:rPr sz="1000">
-                          <a:solidFill>
-                            <a:srgbClr val="3F3F3F"/>
-                          </a:solidFill>
-                          <a:latin typeface="Encode Sans"/>
-                        </a:rPr>
-                        <a:t>9.224</a:t>
-                      </a:r>
-                    </a:p>
-                  </a:txBody>
-                  <a:tcPr marL="36576" marR="36576" marT="18288" marB="18288">
-                    <a:solidFill>
-                      <a:srgbClr val="F8F8F6"/>
-                    </a:solidFill>
-                  </a:tcPr>
-                </a:tc>
-                <a:tc>
-                  <a:txBody>
-                    <a:bodyPr/>
-                    <a:lstStyle/>
-                    <a:p>
-                      <a:pPr algn="r"/>
-                      <a:r>
-                        <a:rPr sz="1000">
-                          <a:solidFill>
-                            <a:srgbClr val="3F3F3F"/>
-                          </a:solidFill>
-                          <a:latin typeface="Encode Sans"/>
-                        </a:rPr>
-                        <a:t>9.880</a:t>
-                      </a:r>
-                    </a:p>
-                  </a:txBody>
-                  <a:tcPr marL="36576" marR="36576" marT="18288" marB="18288">
-                    <a:solidFill>
-                      <a:srgbClr val="F8F8F6"/>
-                    </a:solidFill>
-                  </a:tcPr>
-                </a:tc>
-                <a:tc>
-                  <a:txBody>
-                    <a:bodyPr/>
-                    <a:lstStyle/>
-                    <a:p>
-                      <a:pPr algn="r"/>
-                      <a:r>
-                        <a:rPr sz="1000">
-                          <a:solidFill>
-                            <a:srgbClr val="3F3F3F"/>
-                          </a:solidFill>
-                          <a:latin typeface="Encode Sans"/>
-                        </a:rPr>
-                        <a:t>8.124</a:t>
-                      </a:r>
-                    </a:p>
-                  </a:txBody>
-                  <a:tcPr marL="36576" marR="36576" marT="18288" marB="18288">
-                    <a:solidFill>
-                      <a:srgbClr val="F8F8F6"/>
-                    </a:solidFill>
-                  </a:tcPr>
-                </a:tc>
-              </a:tr>
-              <a:tr h="292608">
-                <a:tc>
-                  <a:txBody>
-                    <a:bodyPr/>
-                    <a:lstStyle/>
-                    <a:p>
-                      <a:pPr algn="l"/>
-                      <a:r>
-                        <a:rPr sz="1000">
-                          <a:solidFill>
-                            <a:srgbClr val="3F3F3F"/>
-                          </a:solidFill>
-                          <a:latin typeface="Encode Sans"/>
-                        </a:rPr>
-                        <a:t>Junio 2026</a:t>
-                      </a:r>
-                    </a:p>
-                  </a:txBody>
-                  <a:tcPr marL="36576" marR="36576" marT="18288" marB="18288">
-                    <a:solidFill>
-                      <a:srgbClr val="FFFFFF"/>
-                    </a:solidFill>
-                  </a:tcPr>
-                </a:tc>
-                <a:tc>
-                  <a:txBody>
-                    <a:bodyPr/>
-                    <a:lstStyle/>
-                    <a:p>
-                      <a:pPr algn="r"/>
-                      <a:r>
-                        <a:rPr sz="1000">
-                          <a:solidFill>
-                            <a:srgbClr val="3F3F3F"/>
-                          </a:solidFill>
-                          <a:latin typeface="Encode Sans"/>
-                        </a:rPr>
-                        <a:t>9.000</a:t>
-                      </a:r>
-                    </a:p>
-                  </a:txBody>
-                  <a:tcPr marL="36576" marR="36576" marT="18288" marB="18288">
-                    <a:solidFill>
-                      <a:srgbClr val="FFFFFF"/>
-                    </a:solidFill>
-                  </a:tcPr>
-                </a:tc>
-                <a:tc>
-                  <a:txBody>
-                    <a:bodyPr/>
-                    <a:lstStyle/>
-                    <a:p>
-                      <a:pPr algn="r"/>
-                      <a:r>
-                        <a:rPr sz="1000">
-                          <a:solidFill>
-                            <a:srgbClr val="3F3F3F"/>
-                          </a:solidFill>
-                          <a:latin typeface="Encode Sans"/>
-                        </a:rPr>
-                        <a:t>9.662</a:t>
-                      </a:r>
-                    </a:p>
-                  </a:txBody>
-                  <a:tcPr marL="36576" marR="36576" marT="18288" marB="18288">
-                    <a:solidFill>
-                      <a:srgbClr val="FFFFFF"/>
-                    </a:solidFill>
-                  </a:tcPr>
-                </a:tc>
-                <a:tc>
-                  <a:txBody>
-                    <a:bodyPr/>
-                    <a:lstStyle/>
-                    <a:p>
-                      <a:pPr algn="r"/>
-                      <a:r>
-                        <a:rPr sz="1000">
-                          <a:solidFill>
-                            <a:srgbClr val="3F3F3F"/>
-                          </a:solidFill>
-                          <a:latin typeface="Encode Sans"/>
-                        </a:rPr>
-                        <a:t>7.889</a:t>
-                      </a:r>
-                    </a:p>
-                  </a:txBody>
-                  <a:tcPr marL="36576" marR="36576" marT="18288" marB="18288">
-                    <a:solidFill>
-                      <a:srgbClr val="FFFFFF"/>
-                    </a:solidFill>
-                  </a:tcPr>
-                </a:tc>
-              </a:tr>
-              <a:tr h="292608">
-                <a:tc>
-                  <a:txBody>
-                    <a:bodyPr/>
-                    <a:lstStyle/>
-                    <a:p>
-                      <a:pPr algn="l"/>
-                      <a:r>
-                        <a:rPr sz="1000">
-                          <a:solidFill>
-                            <a:srgbClr val="3F3F3F"/>
-                          </a:solidFill>
-                          <a:latin typeface="Encode Sans"/>
-                        </a:rPr>
-                        <a:t>Mayo 2026</a:t>
-                      </a:r>
-                    </a:p>
-                  </a:txBody>
-                  <a:tcPr marL="36576" marR="36576" marT="18288" marB="18288">
-                    <a:solidFill>
-                      <a:srgbClr val="F8F8F6"/>
-                    </a:solidFill>
-                  </a:tcPr>
-                </a:tc>
-                <a:tc>
-                  <a:txBody>
-                    <a:bodyPr/>
-                    <a:lstStyle/>
-                    <a:p>
-                      <a:pPr algn="r"/>
-                      <a:r>
-                        <a:rPr sz="1000">
-                          <a:solidFill>
-                            <a:srgbClr val="3F3F3F"/>
-                          </a:solidFill>
-                          <a:latin typeface="Encode Sans"/>
-                        </a:rPr>
-                        <a:t>8.788</a:t>
-                      </a:r>
-                    </a:p>
-                  </a:txBody>
-                  <a:tcPr marL="36576" marR="36576" marT="18288" marB="18288">
-                    <a:solidFill>
-                      <a:srgbClr val="F8F8F6"/>
-                    </a:solidFill>
-                  </a:tcPr>
-                </a:tc>
-                <a:tc>
-                  <a:txBody>
-                    <a:bodyPr/>
-                    <a:lstStyle/>
-                    <a:p>
-                      <a:pPr algn="r"/>
-                      <a:r>
-                        <a:rPr sz="1000">
-                          <a:solidFill>
-                            <a:srgbClr val="3F3F3F"/>
-                          </a:solidFill>
-                          <a:latin typeface="Encode Sans"/>
-                        </a:rPr>
-                        <a:t>9.479</a:t>
-                      </a:r>
-                    </a:p>
-                  </a:txBody>
-                  <a:tcPr marL="36576" marR="36576" marT="18288" marB="18288">
-                    <a:solidFill>
-                      <a:srgbClr val="F8F8F6"/>
-                    </a:solidFill>
-                  </a:tcPr>
-                </a:tc>
-                <a:tc>
-                  <a:txBody>
-                    <a:bodyPr/>
-                    <a:lstStyle/>
-                    <a:p>
-                      <a:pPr algn="r"/>
-                      <a:r>
-                        <a:rPr sz="1000">
-                          <a:solidFill>
-                            <a:srgbClr val="3F3F3F"/>
-                          </a:solidFill>
-                          <a:latin typeface="Encode Sans"/>
-                        </a:rPr>
-                        <a:t>7.628</a:t>
-                      </a:r>
-                    </a:p>
-                  </a:txBody>
-                  <a:tcPr marL="36576" marR="36576" marT="18288" marB="18288">
-                    <a:solidFill>
-                      <a:srgbClr val="F8F8F6"/>
-                    </a:solidFill>
-                  </a:tcPr>
-                </a:tc>
-              </a:tr>
-              <a:tr h="292608">
-                <a:tc>
-                  <a:txBody>
-                    <a:bodyPr/>
-                    <a:lstStyle/>
-                    <a:p>
-                      <a:pPr algn="l"/>
-                      <a:r>
-                        <a:rPr sz="1000">
-                          <a:solidFill>
-                            <a:srgbClr val="3F3F3F"/>
-                          </a:solidFill>
-                          <a:latin typeface="Encode Sans"/>
-                        </a:rPr>
-                        <a:t>Abril 2026</a:t>
-                      </a:r>
-                    </a:p>
-                  </a:txBody>
-                  <a:tcPr marL="36576" marR="36576" marT="18288" marB="18288">
-                    <a:solidFill>
-                      <a:srgbClr val="FFFFFF"/>
-                    </a:solidFill>
-                  </a:tcPr>
-                </a:tc>
-                <a:tc>
-                  <a:txBody>
-                    <a:bodyPr/>
-                    <a:lstStyle/>
-                    <a:p>
-                      <a:pPr algn="r"/>
-                      <a:r>
-                        <a:rPr sz="1000">
-                          <a:solidFill>
-                            <a:srgbClr val="3F3F3F"/>
-                          </a:solidFill>
-                          <a:latin typeface="Encode Sans"/>
-                        </a:rPr>
-                        <a:t>8.629</a:t>
-                      </a:r>
-                    </a:p>
-                  </a:txBody>
-                  <a:tcPr marL="36576" marR="36576" marT="18288" marB="18288">
-                    <a:solidFill>
-                      <a:srgbClr val="FFFFFF"/>
-                    </a:solidFill>
-                  </a:tcPr>
-                </a:tc>
-                <a:tc>
-                  <a:txBody>
-                    <a:bodyPr/>
-                    <a:lstStyle/>
-                    <a:p>
-                      <a:pPr algn="r"/>
-                      <a:r>
-                        <a:rPr sz="1000">
-                          <a:solidFill>
-                            <a:srgbClr val="3F3F3F"/>
-                          </a:solidFill>
-                          <a:latin typeface="Encode Sans"/>
-                        </a:rPr>
-                        <a:t>9.293</a:t>
-                      </a:r>
-                    </a:p>
-                  </a:txBody>
-                  <a:tcPr marL="36576" marR="36576" marT="18288" marB="18288">
-                    <a:solidFill>
-                      <a:srgbClr val="FFFFFF"/>
-                    </a:solidFill>
-                  </a:tcPr>
-                </a:tc>
-                <a:tc>
-                  <a:txBody>
-                    <a:bodyPr/>
-                    <a:lstStyle/>
-                    <a:p>
-                      <a:pPr algn="r"/>
-                      <a:r>
-                        <a:rPr sz="1000">
-                          <a:solidFill>
-                            <a:srgbClr val="3F3F3F"/>
-                          </a:solidFill>
-                          <a:latin typeface="Encode Sans"/>
-                        </a:rPr>
-                        <a:t>7.515</a:t>
-                      </a:r>
-                    </a:p>
-                  </a:txBody>
-                  <a:tcPr marL="36576" marR="36576" marT="18288" marB="18288">
-                    <a:solidFill>
-                      <a:srgbClr val="FFFFFF"/>
-                    </a:solidFill>
-                  </a:tcPr>
-                </a:tc>
-              </a:tr>
-              <a:tr h="292608">
-                <a:tc>
-                  <a:txBody>
-                    <a:bodyPr/>
-                    <a:lstStyle/>
-                    <a:p>
-                      <a:pPr algn="l"/>
-                      <a:r>
-                        <a:rPr sz="1000">
-                          <a:solidFill>
-                            <a:srgbClr val="3F3F3F"/>
-                          </a:solidFill>
-                          <a:latin typeface="Encode Sans"/>
-                        </a:rPr>
-                        <a:t>Marzo 2026</a:t>
-                      </a:r>
-                    </a:p>
-                  </a:txBody>
-                  <a:tcPr marL="36576" marR="36576" marT="18288" marB="18288">
-                    <a:solidFill>
-                      <a:srgbClr val="F8F8F6"/>
-                    </a:solidFill>
-                  </a:tcPr>
-                </a:tc>
-                <a:tc>
-                  <a:txBody>
-                    <a:bodyPr/>
-                    <a:lstStyle/>
-                    <a:p>
-                      <a:pPr algn="r"/>
-                      <a:r>
-                        <a:rPr sz="1000">
-                          <a:solidFill>
-                            <a:srgbClr val="3F3F3F"/>
-                          </a:solidFill>
-                          <a:latin typeface="Encode Sans"/>
-                        </a:rPr>
-                        <a:t>8.341</a:t>
-                      </a:r>
-                    </a:p>
-                  </a:txBody>
-                  <a:tcPr marL="36576" marR="36576" marT="18288" marB="18288">
-                    <a:solidFill>
-                      <a:srgbClr val="F8F8F6"/>
-                    </a:solidFill>
-                  </a:tcPr>
-                </a:tc>
-                <a:tc>
-                  <a:txBody>
-                    <a:bodyPr/>
-                    <a:lstStyle/>
-                    <a:p>
-                      <a:pPr algn="r"/>
-                      <a:r>
-                        <a:rPr sz="1000">
-                          <a:solidFill>
-                            <a:srgbClr val="3F3F3F"/>
-                          </a:solidFill>
-                          <a:latin typeface="Encode Sans"/>
-                        </a:rPr>
-                        <a:t>8.935</a:t>
-                      </a:r>
-                    </a:p>
-                  </a:txBody>
-                  <a:tcPr marL="36576" marR="36576" marT="18288" marB="18288">
-                    <a:solidFill>
-                      <a:srgbClr val="F8F8F6"/>
-                    </a:solidFill>
-                  </a:tcPr>
-                </a:tc>
-                <a:tc>
-                  <a:txBody>
-                    <a:bodyPr/>
-                    <a:lstStyle/>
-                    <a:p>
-                      <a:pPr algn="r"/>
-                      <a:r>
-                        <a:rPr sz="1000">
-                          <a:solidFill>
-                            <a:srgbClr val="3F3F3F"/>
-                          </a:solidFill>
-                          <a:latin typeface="Encode Sans"/>
-                        </a:rPr>
-                        <a:t>7.344</a:t>
-                      </a:r>
-                    </a:p>
-                  </a:txBody>
-                  <a:tcPr marL="36576" marR="36576" marT="18288" marB="18288">
-                    <a:solidFill>
-                      <a:srgbClr val="F8F8F6"/>
-                    </a:solidFill>
-                  </a:tcPr>
-                </a:tc>
-              </a:tr>
-            </a:tbl>
-          </a:graphicData>
-        </a:graphic>
-      </p:graphicFrame>
-      <p:sp>
-        <p:nvSpPr>
-          <p:cNvPr id="9" name="TextBox 8"/>
-          <p:cNvSpPr txBox="1"/>
-          <p:nvPr/>
-        </p:nvSpPr>
-        <p:spPr>
-          <a:xfrm>
-            <a:off x="411480" y="6492240"/>
-            <a:ext cx="11368735" cy="274320"/>
-          </a:xfrm>
-          <a:prstGeom prst="rect">
-            <a:avLst/>
-          </a:prstGeom>
-          <a:noFill/>
-        </p:spPr>
-        <p:txBody>
-          <a:bodyPr wrap="none">
-            <a:spAutoFit/>
-          </a:bodyPr>
-          <a:lstStyle/>
-          <a:p>
-            <a:r>
-              <a:rPr sz="1000" b="0" i="1">
-                <a:solidFill>
-                  <a:srgbClr val="6A6760"/>
-                </a:solidFill>
-                <a:latin typeface="Encode Sans"/>
-              </a:rPr>
-              <a:t>Fuente: elaboración propia en base a INDEC</a:t>
-            </a:r>
-          </a:p>
-        </p:txBody>
-      </p:sp>
-    </p:spTree>
-  </p:cSld>
-  <p:clrMapOvr>
-    <a:masterClrMapping/>
-  </p:clrMapOvr>
-</p:sld>
-</file>
-
-<file path=ppt/slides/slide4.xml><?xml version="1.0" encoding="utf-8"?>
-<p:sld xmlns:a="http://schemas.openxmlformats.org/drawingml/2006/main" xmlns:p="http://schemas.openxmlformats.org/presentationml/2006/main" xmlns:r="http://schemas.openxmlformats.org/officeDocument/2006/relationships">
-  <p:cSld>
-    <p:spTree>
-      <p:nvGrpSpPr>
-        <p:cNvPr id="1" name=""/>
-        <p:cNvGrpSpPr/>
-        <p:nvPr/>
-      </p:nvGrpSpPr>
-      <p:grpSpPr/>
-      <p:sp>
-        <p:nvSpPr>
-          <p:cNvPr id="2" name="Rectangle 1"/>
-          <p:cNvSpPr/>
-          <p:nvPr/>
-        </p:nvSpPr>
-        <p:spPr>
-          <a:xfrm>
-            <a:off x="0" y="0"/>
-            <a:ext cx="12191695" cy="274320"/>
-          </a:xfrm>
-          <a:prstGeom prst="rect">
-            <a:avLst/>
-          </a:prstGeom>
-          <a:solidFill>
-            <a:srgbClr val="00B2C9"/>
-          </a:solidFill>
-          <a:ln>
-            <a:noFill/>
-          </a:ln>
-        </p:spPr>
-        <p:style>
-          <a:lnRef idx="1">
-            <a:schemeClr val="accent1"/>
-          </a:lnRef>
-          <a:fillRef idx="3">
-            <a:schemeClr val="accent1"/>
-          </a:fillRef>
-          <a:effectRef idx="2">
-            <a:schemeClr val="accent1"/>
-          </a:effectRef>
-          <a:fontRef idx="minor">
-            <a:schemeClr val="lt1"/>
-          </a:fontRef>
-        </p:style>
-        <p:txBody>
-          <a:bodyPr rtlCol="0" anchor="ctr"/>
-          <a:lstStyle/>
-          <a:p>
-            <a:pPr algn="ctr"/>
-          </a:p>
-        </p:txBody>
-      </p:sp>
-      <p:sp>
-        <p:nvSpPr>
-          <p:cNvPr id="3" name="TextBox 2"/>
-          <p:cNvSpPr txBox="1"/>
-          <p:nvPr/>
-        </p:nvSpPr>
-        <p:spPr>
-          <a:xfrm>
-            <a:off x="411480" y="457200"/>
-            <a:ext cx="11368735" cy="914400"/>
-          </a:xfrm>
-          <a:prstGeom prst="rect">
-            <a:avLst/>
-          </a:prstGeom>
-          <a:noFill/>
-        </p:spPr>
-        <p:txBody>
-          <a:bodyPr wrap="square" lIns="0" rIns="0">
-            <a:spAutoFit/>
-          </a:bodyPr>
-          <a:lstStyle/>
-          <a:p>
-            <a:pPr algn="l"/>
-            <a:r>
-              <a:rPr sz="2600" b="1" i="0">
-                <a:solidFill>
-                  <a:srgbClr val="00B2C9"/>
-                </a:solidFill>
-                <a:latin typeface="Encode Sans"/>
-              </a:rPr>
-              <a:t>SUPERMERCADOS AGOSTO 2026: VENTAS REALES CAYERON -3.7%</a:t>
-            </a:r>
-          </a:p>
-        </p:txBody>
-      </p:sp>
-      <p:sp>
-        <p:nvSpPr>
-          <p:cNvPr id="4" name="TextBox 3"/>
-          <p:cNvSpPr txBox="1"/>
-          <p:nvPr/>
-        </p:nvSpPr>
-        <p:spPr>
-          <a:xfrm>
-            <a:off x="411480" y="1280160"/>
-            <a:ext cx="11368735" cy="274320"/>
-          </a:xfrm>
-          <a:prstGeom prst="rect">
-            <a:avLst/>
-          </a:prstGeom>
-          <a:noFill/>
-        </p:spPr>
-        <p:txBody>
-          <a:bodyPr wrap="none">
-            <a:spAutoFit/>
-          </a:bodyPr>
-          <a:lstStyle/>
-          <a:p>
-            <a:r>
-              <a:rPr sz="1100" b="0" i="1">
-                <a:solidFill>
-                  <a:srgbClr val="6A6760"/>
-                </a:solidFill>
-                <a:latin typeface="Encode Sans"/>
-              </a:rPr>
-              <a:t>INDEC · período 2026-08</a:t>
-            </a:r>
-          </a:p>
-        </p:txBody>
-      </p:sp>
-      <p:sp>
-        <p:nvSpPr>
-          <p:cNvPr id="5" name="TextBox 4"/>
-          <p:cNvSpPr txBox="1"/>
-          <p:nvPr/>
-        </p:nvSpPr>
-        <p:spPr>
-          <a:xfrm>
-            <a:off x="411480" y="1691640"/>
-            <a:ext cx="5486400" cy="1645920"/>
-          </a:xfrm>
-          <a:prstGeom prst="rect">
-            <a:avLst/>
-          </a:prstGeom>
-          <a:noFill/>
-        </p:spPr>
-        <p:txBody>
-          <a:bodyPr wrap="square" lIns="0" rIns="0">
-            <a:spAutoFit/>
-          </a:bodyPr>
-          <a:lstStyle/>
-          <a:p>
-            <a:pPr algn="just"/>
-            <a:r>
-              <a:rPr sz="1300" b="0" i="0">
-                <a:solidFill>
-                  <a:srgbClr val="3F3F3F"/>
-                </a:solidFill>
-                <a:latin typeface="Encode Sans"/>
-              </a:rPr>
-              <a:t>Las ventas de supermercados a precios constantes registraron una variación interanual real de -3.7% en agosto 2026. Desestacionalizada: -0.8% m/m.</a:t>
-            </a:r>
-          </a:p>
-        </p:txBody>
-      </p:sp>
-      <p:sp>
-        <p:nvSpPr>
-          <p:cNvPr id="6" name="TextBox 5"/>
-          <p:cNvSpPr txBox="1"/>
-          <p:nvPr/>
-        </p:nvSpPr>
-        <p:spPr>
-          <a:xfrm>
-            <a:off x="411480" y="3520440"/>
-            <a:ext cx="5486400" cy="2743200"/>
-          </a:xfrm>
-          <a:prstGeom prst="rect">
-            <a:avLst/>
-          </a:prstGeom>
-          <a:noFill/>
-        </p:spPr>
-        <p:txBody>
-          <a:bodyPr wrap="square" lIns="0" rIns="0">
-            <a:spAutoFit/>
-          </a:bodyPr>
-          <a:lstStyle/>
-          <a:p>
-            <a:pPr algn="l">
-              <a:spcAft>
-                <a:spcPts val="800"/>
-              </a:spcAft>
-            </a:pPr>
-            <a:r>
-              <a:rPr sz="1300" b="1" i="0">
-                <a:solidFill>
-                  <a:srgbClr val="00B2C9"/>
-                </a:solidFill>
-                <a:latin typeface="Encode Sans"/>
-              </a:rPr>
-              <a:t>●  </a:t>
-            </a:r>
-            <a:r>
-              <a:rPr sz="1300" b="0" i="0">
-                <a:solidFill>
-                  <a:srgbClr val="3F3F3F"/>
-                </a:solidFill>
-                <a:latin typeface="Encode Sans"/>
-              </a:rPr>
-              <a:t>Variación interanual real: -3.7%</a:t>
-            </a:r>
-          </a:p>
-          <a:p>
-            <a:pPr algn="l">
-              <a:spcAft>
-                <a:spcPts val="800"/>
-              </a:spcAft>
-            </a:pPr>
-            <a:r>
-              <a:rPr sz="1300" b="1" i="0">
-                <a:solidFill>
-                  <a:srgbClr val="00B2C9"/>
-                </a:solidFill>
-                <a:latin typeface="Encode Sans"/>
-              </a:rPr>
-              <a:t>●  </a:t>
-            </a:r>
-            <a:r>
-              <a:rPr sz="1300" b="0" i="0">
-                <a:solidFill>
-                  <a:srgbClr val="3F3F3F"/>
-                </a:solidFill>
-                <a:latin typeface="Encode Sans"/>
-              </a:rPr>
-              <a:t>Variación mensual desestacionalizada: -0.8%</a:t>
-            </a:r>
-          </a:p>
-          <a:p>
-            <a:pPr algn="l">
-              <a:spcAft>
-                <a:spcPts val="800"/>
-              </a:spcAft>
-            </a:pPr>
-            <a:r>
-              <a:rPr sz="1300" b="1" i="0">
-                <a:solidFill>
-                  <a:srgbClr val="00B2C9"/>
-                </a:solidFill>
-                <a:latin typeface="Encode Sans"/>
-              </a:rPr>
-              <a:t>●  </a:t>
-            </a:r>
-            <a:r>
-              <a:rPr sz="1300" b="0" i="0">
-                <a:solidFill>
-                  <a:srgbClr val="3F3F3F"/>
-                </a:solidFill>
-                <a:latin typeface="Encode Sans"/>
-              </a:rPr>
-              <a:t>Acumulado del año: -2.9%</a:t>
-            </a:r>
-          </a:p>
-        </p:txBody>
-      </p:sp>
-      <p:pic>
-        <p:nvPicPr>
-          <p:cNvPr id="7" name="Picture 6" descr="image.png"/>
-          <p:cNvPicPr>
-            <a:picLocks noChangeAspect="1"/>
-          </p:cNvPicPr>
-          <p:nvPr/>
-        </p:nvPicPr>
-        <p:blipFill>
-          <a:blip r:embed="rId2"/>
-          <a:stretch>
-            <a:fillRect/>
-          </a:stretch>
-        </p:blipFill>
-        <p:spPr>
-          <a:xfrm>
-            <a:off x="6080760" y="1691640"/>
-            <a:ext cx="5669280" cy="2560320"/>
-          </a:xfrm>
-          <a:prstGeom prst="rect">
-            <a:avLst/>
-          </a:prstGeom>
-        </p:spPr>
-      </p:pic>
-      <p:graphicFrame>
-        <p:nvGraphicFramePr>
-          <p:cNvPr id="8" name="Table 7"/>
-          <p:cNvGraphicFramePr>
-            <a:graphicFrameLocks noGrp="1"/>
-          </p:cNvGraphicFramePr>
-          <p:nvPr/>
-        </p:nvGraphicFramePr>
-        <p:xfrm>
-          <a:off x="6080760" y="4434840"/>
-          <a:ext cx="5669280" cy="2048256"/>
-        </p:xfrm>
-        <a:graphic>
-          <a:graphicData uri="http://schemas.openxmlformats.org/drawingml/2006/table">
-            <a:tbl>
-              <a:tblPr firstRow="1" bandRow="1">
-                <a:tableStyleId>{5C22544A-7EE6-4342-B048-85BDC9FD1C3A}</a:tableStyleId>
-              </a:tblPr>
-              <a:tblGrid>
-                <a:gridCol w="1417320"/>
-                <a:gridCol w="1417320"/>
-                <a:gridCol w="1417320"/>
-                <a:gridCol w="1417320"/>
-              </a:tblGrid>
-              <a:tr h="292608">
-                <a:tc>
-                  <a:txBody>
-                    <a:bodyPr/>
-                    <a:lstStyle/>
-                    <a:p>
-                      <a:pPr algn="l"/>
-                      <a:r>
-                        <a:rPr sz="1000" b="1">
-                          <a:solidFill>
-                            <a:srgbClr val="FFFFFF"/>
-                          </a:solidFill>
-                          <a:latin typeface="Encode Sans"/>
-                        </a:rPr>
-                        <a:t>Mes</a:t>
-                      </a:r>
-                    </a:p>
-                  </a:txBody>
-                  <a:tcPr marL="36576" marR="36576" marT="18288" marB="18288">
-                    <a:solidFill>
-                      <a:srgbClr val="00B2C9"/>
-                    </a:solidFill>
-                  </a:tcPr>
-                </a:tc>
-                <a:tc>
-                  <a:txBody>
-                    <a:bodyPr/>
-                    <a:lstStyle/>
-                    <a:p>
-                      <a:pPr algn="r"/>
-                      <a:r>
-                        <a:rPr sz="1000" b="1">
-                          <a:solidFill>
-                            <a:srgbClr val="FFFFFF"/>
-                          </a:solidFill>
-                          <a:latin typeface="Encode Sans"/>
-                        </a:rPr>
-                        <a:t>Índice real</a:t>
-                      </a:r>
-                    </a:p>
-                  </a:txBody>
-                  <a:tcPr marL="36576" marR="36576" marT="18288" marB="18288">
-                    <a:solidFill>
-                      <a:srgbClr val="00B2C9"/>
-                    </a:solidFill>
-                  </a:tcPr>
-                </a:tc>
-                <a:tc>
-                  <a:txBody>
-                    <a:bodyPr/>
-                    <a:lstStyle/>
-                    <a:p>
-                      <a:pPr algn="r"/>
-                      <a:r>
-                        <a:rPr sz="1000" b="1">
-                          <a:solidFill>
-                            <a:srgbClr val="FFFFFF"/>
-                          </a:solidFill>
-                          <a:latin typeface="Encode Sans"/>
-                        </a:rPr>
-                        <a:t>VIA real %</a:t>
-                      </a:r>
-                    </a:p>
-                  </a:txBody>
-                  <a:tcPr marL="36576" marR="36576" marT="18288" marB="18288">
-                    <a:solidFill>
-                      <a:srgbClr val="00B2C9"/>
-                    </a:solidFill>
-                  </a:tcPr>
-                </a:tc>
-                <a:tc>
-                  <a:txBody>
-                    <a:bodyPr/>
-                    <a:lstStyle/>
-                    <a:p>
-                      <a:pPr algn="r"/>
-                      <a:r>
-                        <a:rPr sz="1000" b="1">
-                          <a:solidFill>
-                            <a:srgbClr val="FFFFFF"/>
-                          </a:solidFill>
-                          <a:latin typeface="Encode Sans"/>
-                        </a:rPr>
-                        <a:t>Acumulado %</a:t>
-                      </a:r>
-                    </a:p>
-                  </a:txBody>
-                  <a:tcPr marL="36576" marR="36576" marT="18288" marB="18288">
-                    <a:solidFill>
-                      <a:srgbClr val="00B2C9"/>
-                    </a:solidFill>
-                  </a:tcPr>
-                </a:tc>
-              </a:tr>
-              <a:tr h="292608">
-                <a:tc>
-                  <a:txBody>
-                    <a:bodyPr/>
-                    <a:lstStyle/>
-                    <a:p>
-                      <a:pPr algn="l"/>
-                      <a:r>
-                        <a:rPr sz="1000">
-                          <a:solidFill>
-                            <a:srgbClr val="3F3F3F"/>
-                          </a:solidFill>
-                          <a:latin typeface="Encode Sans"/>
-                        </a:rPr>
-                        <a:t>Agosto 2026</a:t>
-                      </a:r>
-                    </a:p>
-                  </a:txBody>
-                  <a:tcPr marL="36576" marR="36576" marT="18288" marB="18288">
-                    <a:solidFill>
-                      <a:srgbClr val="FFFFFF"/>
-                    </a:solidFill>
-                  </a:tcPr>
-                </a:tc>
-                <a:tc>
-                  <a:txBody>
-                    <a:bodyPr/>
-                    <a:lstStyle/>
-                    <a:p>
-                      <a:pPr algn="r"/>
-                      <a:r>
-                        <a:rPr sz="1000">
-                          <a:solidFill>
-                            <a:srgbClr val="3F3F3F"/>
-                          </a:solidFill>
-                          <a:latin typeface="Encode Sans"/>
-                        </a:rPr>
-                        <a:t>79,5</a:t>
-                      </a:r>
-                    </a:p>
-                  </a:txBody>
-                  <a:tcPr marL="36576" marR="36576" marT="18288" marB="18288">
-                    <a:solidFill>
-                      <a:srgbClr val="FFFFFF"/>
-                    </a:solidFill>
-                  </a:tcPr>
-                </a:tc>
-                <a:tc>
-                  <a:txBody>
-                    <a:bodyPr/>
-                    <a:lstStyle/>
-                    <a:p>
-                      <a:pPr algn="r"/>
-                      <a:r>
-                        <a:rPr sz="1000">
-                          <a:solidFill>
-                            <a:srgbClr val="3F3F3F"/>
-                          </a:solidFill>
-                          <a:latin typeface="Encode Sans"/>
-                        </a:rPr>
-                        <a:t>-3.7%</a:t>
-                      </a:r>
-                    </a:p>
-                  </a:txBody>
-                  <a:tcPr marL="36576" marR="36576" marT="18288" marB="18288">
-                    <a:solidFill>
-                      <a:srgbClr val="FFFFFF"/>
-                    </a:solidFill>
-                  </a:tcPr>
-                </a:tc>
-                <a:tc>
-                  <a:txBody>
-                    <a:bodyPr/>
-                    <a:lstStyle/>
-                    <a:p>
-                      <a:pPr algn="r"/>
-                      <a:r>
-                        <a:rPr sz="1000">
-                          <a:solidFill>
-                            <a:srgbClr val="3F3F3F"/>
-                          </a:solidFill>
-                          <a:latin typeface="Encode Sans"/>
-                        </a:rPr>
-                        <a:t>-2.9%</a:t>
-                      </a:r>
-                    </a:p>
-                  </a:txBody>
-                  <a:tcPr marL="36576" marR="36576" marT="18288" marB="18288">
-                    <a:solidFill>
-                      <a:srgbClr val="FFFFFF"/>
-                    </a:solidFill>
-                  </a:tcPr>
-                </a:tc>
-              </a:tr>
-              <a:tr h="292608">
-                <a:tc>
-                  <a:txBody>
-                    <a:bodyPr/>
-                    <a:lstStyle/>
-                    <a:p>
-                      <a:pPr algn="l"/>
-                      <a:r>
-                        <a:rPr sz="1000">
-                          <a:solidFill>
-                            <a:srgbClr val="3F3F3F"/>
-                          </a:solidFill>
-                          <a:latin typeface="Encode Sans"/>
-                        </a:rPr>
-                        <a:t>Julio 2026</a:t>
-                      </a:r>
-                    </a:p>
-                  </a:txBody>
-                  <a:tcPr marL="36576" marR="36576" marT="18288" marB="18288">
-                    <a:solidFill>
-                      <a:srgbClr val="F8F8F6"/>
-                    </a:solidFill>
-                  </a:tcPr>
-                </a:tc>
-                <a:tc>
-                  <a:txBody>
-                    <a:bodyPr/>
-                    <a:lstStyle/>
-                    <a:p>
-                      <a:pPr algn="r"/>
-                      <a:r>
-                        <a:rPr sz="1000">
-                          <a:solidFill>
-                            <a:srgbClr val="3F3F3F"/>
-                          </a:solidFill>
-                          <a:latin typeface="Encode Sans"/>
-                        </a:rPr>
-                        <a:t>80,3</a:t>
-                      </a:r>
-                    </a:p>
-                  </a:txBody>
-                  <a:tcPr marL="36576" marR="36576" marT="18288" marB="18288">
-                    <a:solidFill>
-                      <a:srgbClr val="F8F8F6"/>
-                    </a:solidFill>
-                  </a:tcPr>
-                </a:tc>
-                <a:tc>
-                  <a:txBody>
-                    <a:bodyPr/>
-                    <a:lstStyle/>
-                    <a:p>
-                      <a:pPr algn="r"/>
-                      <a:r>
-                        <a:rPr sz="1000">
-                          <a:solidFill>
-                            <a:srgbClr val="3F3F3F"/>
-                          </a:solidFill>
-                          <a:latin typeface="Encode Sans"/>
-                        </a:rPr>
-                        <a:t>-2.1%</a:t>
-                      </a:r>
-                    </a:p>
-                  </a:txBody>
-                  <a:tcPr marL="36576" marR="36576" marT="18288" marB="18288">
-                    <a:solidFill>
-                      <a:srgbClr val="F8F8F6"/>
-                    </a:solidFill>
-                  </a:tcPr>
-                </a:tc>
-                <a:tc>
-                  <a:txBody>
-                    <a:bodyPr/>
-                    <a:lstStyle/>
-                    <a:p>
-                      <a:pPr algn="r"/>
-                      <a:r>
-                        <a:rPr sz="1000">
-                          <a:solidFill>
-                            <a:srgbClr val="3F3F3F"/>
-                          </a:solidFill>
-                          <a:latin typeface="Encode Sans"/>
-                        </a:rPr>
-                        <a:t>-2.7%</a:t>
-                      </a:r>
-                    </a:p>
-                  </a:txBody>
-                  <a:tcPr marL="36576" marR="36576" marT="18288" marB="18288">
-                    <a:solidFill>
-                      <a:srgbClr val="F8F8F6"/>
-                    </a:solidFill>
-                  </a:tcPr>
-                </a:tc>
-              </a:tr>
-              <a:tr h="292608">
-                <a:tc>
-                  <a:txBody>
-                    <a:bodyPr/>
-                    <a:lstStyle/>
-                    <a:p>
-                      <a:pPr algn="l"/>
-                      <a:r>
-                        <a:rPr sz="1000">
-                          <a:solidFill>
-                            <a:srgbClr val="3F3F3F"/>
-                          </a:solidFill>
-                          <a:latin typeface="Encode Sans"/>
-                        </a:rPr>
-                        <a:t>Junio 2026</a:t>
-                      </a:r>
-                    </a:p>
-                  </a:txBody>
-                  <a:tcPr marL="36576" marR="36576" marT="18288" marB="18288">
-                    <a:solidFill>
-                      <a:srgbClr val="FFFFFF"/>
-                    </a:solidFill>
-                  </a:tcPr>
-                </a:tc>
-                <a:tc>
-                  <a:txBody>
-                    <a:bodyPr/>
-                    <a:lstStyle/>
-                    <a:p>
-                      <a:pPr algn="r"/>
-                      <a:r>
-                        <a:rPr sz="1000">
-                          <a:solidFill>
-                            <a:srgbClr val="3F3F3F"/>
-                          </a:solidFill>
-                          <a:latin typeface="Encode Sans"/>
-                        </a:rPr>
-                        <a:t>78,7</a:t>
-                      </a:r>
-                    </a:p>
-                  </a:txBody>
-                  <a:tcPr marL="36576" marR="36576" marT="18288" marB="18288">
-                    <a:solidFill>
-                      <a:srgbClr val="FFFFFF"/>
-                    </a:solidFill>
-                  </a:tcPr>
-                </a:tc>
-                <a:tc>
-                  <a:txBody>
-                    <a:bodyPr/>
-                    <a:lstStyle/>
-                    <a:p>
-                      <a:pPr algn="r"/>
-                      <a:r>
-                        <a:rPr sz="1000">
-                          <a:solidFill>
-                            <a:srgbClr val="3F3F3F"/>
-                          </a:solidFill>
-                          <a:latin typeface="Encode Sans"/>
-                        </a:rPr>
-                        <a:t>-3.1%</a:t>
-                      </a:r>
-                    </a:p>
-                  </a:txBody>
-                  <a:tcPr marL="36576" marR="36576" marT="18288" marB="18288">
-                    <a:solidFill>
-                      <a:srgbClr val="FFFFFF"/>
-                    </a:solidFill>
-                  </a:tcPr>
-                </a:tc>
-                <a:tc>
-                  <a:txBody>
-                    <a:bodyPr/>
-                    <a:lstStyle/>
-                    <a:p>
-                      <a:pPr algn="r"/>
-                      <a:r>
-                        <a:rPr sz="1000">
-                          <a:solidFill>
-                            <a:srgbClr val="3F3F3F"/>
-                          </a:solidFill>
-                          <a:latin typeface="Encode Sans"/>
-                        </a:rPr>
-                        <a:t>-2.8%</a:t>
-                      </a:r>
-                    </a:p>
-                  </a:txBody>
-                  <a:tcPr marL="36576" marR="36576" marT="18288" marB="18288">
-                    <a:solidFill>
-                      <a:srgbClr val="FFFFFF"/>
-                    </a:solidFill>
-                  </a:tcPr>
-                </a:tc>
-              </a:tr>
-              <a:tr h="292608">
-                <a:tc>
-                  <a:txBody>
-                    <a:bodyPr/>
-                    <a:lstStyle/>
-                    <a:p>
-                      <a:pPr algn="l"/>
-                      <a:r>
-                        <a:rPr sz="1000">
-                          <a:solidFill>
-                            <a:srgbClr val="3F3F3F"/>
-                          </a:solidFill>
-                          <a:latin typeface="Encode Sans"/>
-                        </a:rPr>
-                        <a:t>Mayo 2026</a:t>
-                      </a:r>
-                    </a:p>
-                  </a:txBody>
-                  <a:tcPr marL="36576" marR="36576" marT="18288" marB="18288">
-                    <a:solidFill>
-                      <a:srgbClr val="F8F8F6"/>
-                    </a:solidFill>
-                  </a:tcPr>
-                </a:tc>
-                <a:tc>
-                  <a:txBody>
-                    <a:bodyPr/>
-                    <a:lstStyle/>
-                    <a:p>
-                      <a:pPr algn="r"/>
-                      <a:r>
-                        <a:rPr sz="1000">
-                          <a:solidFill>
-                            <a:srgbClr val="3F3F3F"/>
-                          </a:solidFill>
-                          <a:latin typeface="Encode Sans"/>
-                        </a:rPr>
-                        <a:t>80,5</a:t>
-                      </a:r>
-                    </a:p>
-                  </a:txBody>
-                  <a:tcPr marL="36576" marR="36576" marT="18288" marB="18288">
-                    <a:solidFill>
-                      <a:srgbClr val="F8F8F6"/>
-                    </a:solidFill>
-                  </a:tcPr>
-                </a:tc>
-                <a:tc>
-                  <a:txBody>
-                    <a:bodyPr/>
-                    <a:lstStyle/>
-                    <a:p>
-                      <a:pPr algn="r"/>
-                      <a:r>
-                        <a:rPr sz="1000">
-                          <a:solidFill>
-                            <a:srgbClr val="3F3F3F"/>
-                          </a:solidFill>
-                          <a:latin typeface="Encode Sans"/>
-                        </a:rPr>
-                        <a:t>-0.7%</a:t>
-                      </a:r>
-                    </a:p>
-                  </a:txBody>
-                  <a:tcPr marL="36576" marR="36576" marT="18288" marB="18288">
-                    <a:solidFill>
-                      <a:srgbClr val="F8F8F6"/>
-                    </a:solidFill>
-                  </a:tcPr>
-                </a:tc>
-                <a:tc>
-                  <a:txBody>
-                    <a:bodyPr/>
-                    <a:lstStyle/>
-                    <a:p>
-                      <a:pPr algn="r"/>
-                      <a:r>
-                        <a:rPr sz="1000">
-                          <a:solidFill>
-                            <a:srgbClr val="3F3F3F"/>
-                          </a:solidFill>
-                          <a:latin typeface="Encode Sans"/>
-                        </a:rPr>
-                        <a:t>-2.8%</a:t>
-                      </a:r>
-                    </a:p>
-                  </a:txBody>
-                  <a:tcPr marL="36576" marR="36576" marT="18288" marB="18288">
-                    <a:solidFill>
-                      <a:srgbClr val="F8F8F6"/>
-                    </a:solidFill>
-                  </a:tcPr>
-                </a:tc>
-              </a:tr>
-              <a:tr h="292608">
-                <a:tc>
-                  <a:txBody>
-                    <a:bodyPr/>
-                    <a:lstStyle/>
-                    <a:p>
-                      <a:pPr algn="l"/>
-                      <a:r>
-                        <a:rPr sz="1000">
-                          <a:solidFill>
-                            <a:srgbClr val="3F3F3F"/>
-                          </a:solidFill>
-                          <a:latin typeface="Encode Sans"/>
-                        </a:rPr>
-                        <a:t>Abril 2026</a:t>
-                      </a:r>
-                    </a:p>
-                  </a:txBody>
-                  <a:tcPr marL="36576" marR="36576" marT="18288" marB="18288">
-                    <a:solidFill>
-                      <a:srgbClr val="FFFFFF"/>
-                    </a:solidFill>
-                  </a:tcPr>
-                </a:tc>
-                <a:tc>
-                  <a:txBody>
-                    <a:bodyPr/>
-                    <a:lstStyle/>
-                    <a:p>
-                      <a:pPr algn="r"/>
-                      <a:r>
-                        <a:rPr sz="1000">
-                          <a:solidFill>
-                            <a:srgbClr val="3F3F3F"/>
-                          </a:solidFill>
-                          <a:latin typeface="Encode Sans"/>
-                        </a:rPr>
-                        <a:t>78,5</a:t>
-                      </a:r>
-                    </a:p>
-                  </a:txBody>
-                  <a:tcPr marL="36576" marR="36576" marT="18288" marB="18288">
-                    <a:solidFill>
-                      <a:srgbClr val="FFFFFF"/>
-                    </a:solidFill>
-                  </a:tcPr>
-                </a:tc>
-                <a:tc>
-                  <a:txBody>
-                    <a:bodyPr/>
-                    <a:lstStyle/>
-                    <a:p>
-                      <a:pPr algn="r"/>
-                      <a:r>
-                        <a:rPr sz="1000">
-                          <a:solidFill>
-                            <a:srgbClr val="3F3F3F"/>
-                          </a:solidFill>
-                          <a:latin typeface="Encode Sans"/>
-                        </a:rPr>
-                        <a:t>-3.7%</a:t>
-                      </a:r>
-                    </a:p>
-                  </a:txBody>
-                  <a:tcPr marL="36576" marR="36576" marT="18288" marB="18288">
-                    <a:solidFill>
-                      <a:srgbClr val="FFFFFF"/>
-                    </a:solidFill>
-                  </a:tcPr>
-                </a:tc>
-                <a:tc>
-                  <a:txBody>
-                    <a:bodyPr/>
-                    <a:lstStyle/>
-                    <a:p>
-                      <a:pPr algn="r"/>
-                      <a:r>
-                        <a:rPr sz="1000">
-                          <a:solidFill>
-                            <a:srgbClr val="3F3F3F"/>
-                          </a:solidFill>
-                          <a:latin typeface="Encode Sans"/>
-                        </a:rPr>
-                        <a:t>-3.3%</a:t>
-                      </a:r>
-                    </a:p>
-                  </a:txBody>
-                  <a:tcPr marL="36576" marR="36576" marT="18288" marB="18288">
-                    <a:solidFill>
-                      <a:srgbClr val="FFFFFF"/>
-                    </a:solidFill>
-                  </a:tcPr>
-                </a:tc>
-              </a:tr>
-              <a:tr h="292608">
-                <a:tc>
-                  <a:txBody>
-                    <a:bodyPr/>
-                    <a:lstStyle/>
-                    <a:p>
-                      <a:pPr algn="l"/>
-                      <a:r>
-                        <a:rPr sz="1000">
-                          <a:solidFill>
-                            <a:srgbClr val="3F3F3F"/>
-                          </a:solidFill>
-                          <a:latin typeface="Encode Sans"/>
-                        </a:rPr>
-                        <a:t>Marzo 2026</a:t>
-                      </a:r>
-                    </a:p>
-                  </a:txBody>
-                  <a:tcPr marL="36576" marR="36576" marT="18288" marB="18288">
-                    <a:solidFill>
-                      <a:srgbClr val="F8F8F6"/>
-                    </a:solidFill>
-                  </a:tcPr>
-                </a:tc>
-                <a:tc>
-                  <a:txBody>
-                    <a:bodyPr/>
-                    <a:lstStyle/>
-                    <a:p>
-                      <a:pPr algn="r"/>
-                      <a:r>
-                        <a:rPr sz="1000">
-                          <a:solidFill>
-                            <a:srgbClr val="3F3F3F"/>
-                          </a:solidFill>
-                          <a:latin typeface="Encode Sans"/>
-                        </a:rPr>
-                        <a:t>82,4</a:t>
-                      </a:r>
-                    </a:p>
-                  </a:txBody>
-                  <a:tcPr marL="36576" marR="36576" marT="18288" marB="18288">
-                    <a:solidFill>
-                      <a:srgbClr val="F8F8F6"/>
-                    </a:solidFill>
-                  </a:tcPr>
-                </a:tc>
-                <a:tc>
-                  <a:txBody>
-                    <a:bodyPr/>
-                    <a:lstStyle/>
-                    <a:p>
-                      <a:pPr algn="r"/>
-                      <a:r>
-                        <a:rPr sz="1000">
-                          <a:solidFill>
-                            <a:srgbClr val="3F3F3F"/>
-                          </a:solidFill>
-                          <a:latin typeface="Encode Sans"/>
-                        </a:rPr>
-                        <a:t>-5.1%</a:t>
-                      </a:r>
-                    </a:p>
-                  </a:txBody>
-                  <a:tcPr marL="36576" marR="36576" marT="18288" marB="18288">
-                    <a:solidFill>
-                      <a:srgbClr val="F8F8F6"/>
-                    </a:solidFill>
-                  </a:tcPr>
-                </a:tc>
-                <a:tc>
-                  <a:txBody>
-                    <a:bodyPr/>
-                    <a:lstStyle/>
-                    <a:p>
-                      <a:pPr algn="r"/>
-                      <a:r>
-                        <a:rPr sz="1000">
-                          <a:solidFill>
-                            <a:srgbClr val="3F3F3F"/>
-                          </a:solidFill>
-                          <a:latin typeface="Encode Sans"/>
-                        </a:rPr>
-                        <a:t>-3.1%</a:t>
+                        <a:t>-301.685</a:t>
                       </a:r>
                     </a:p>
                   </a:txBody>

</xml_diff>